<commit_message>
lectures: fix proof_holes.png — add R202 endpoint at 0 holes
- gen_proof_holes.py: new matplotlib script, plots R20-R202 with R202=0
- proof_holes.png: regenerated, now reaches zero
- holes-over-time.md: add R202 row (46 clean, 0 holes)
- slidesMSR.pptx: rebuilt with updated chart

Co-Authored-By: Claude Sonnet 4.6 <noreply@anthropic.com>
</commit_message>
<xml_diff>
--- a/lectures/slidesMSR.pptx
+++ b/lectures/slidesMSR.pptx
@@ -76,6 +76,8 @@
     <p:sldId id="324" r:id="rId70"/>
     <p:sldId id="325" r:id="rId71"/>
     <p:sldId id="326" r:id="rId72"/>
+    <p:sldId id="327" r:id="rId73"/>
+    <p:sldId id="328" r:id="rId74"/>
   </p:sldIdLst>
   <p:sldSz cx="9144000" cy="5143500" type="screen16x9"/>
   <p:notesSz cx="6858000" cy="9144000"/>
@@ -3238,6 +3240,13 @@
             <a:r>
               <a:rPr sz="1800"/>
               <a:t>and then proving it in Verus.</a:t>
+            </a:r>
+          </a:p>
+          <a:p>
+            <a:pPr lvl="0"/>
+            <a:r>
+              <a:rPr sz="1800"/>
+              <a:t>https://github.com/briangmilnes/{APAS-VERUS,APAS-AI,rusticate,veracity}</a:t>
             </a:r>
           </a:p>
         </p:txBody>
@@ -6101,13 +6110,6 @@
             <a:pPr lvl="0"/>
             <a:r>
               <a:rPr sz="1800"/>
-              <a:t>All fixed now! (Thanks Chris)</a:t>
-            </a:r>
-          </a:p>
-          <a:p>
-            <a:pPr lvl="0"/>
-            <a:r>
-              <a:rPr sz="1800"/>
               <a:t>Generics and Equality was the second big pain point.</a:t>
             </a:r>
           </a:p>
@@ -6211,7 +6213,7 @@
             </a:pPr>
             <a:r>
               <a:rPr sz="3200"/>
-              <a:t>Veracity- Software Engineering AI Paired Proving</a:t>
+              <a:t>AutoCLRS</a:t>
             </a:r>
           </a:p>
         </p:txBody>
@@ -6234,28 +6236,56 @@
             <a:pPr lvl="0"/>
             <a:r>
               <a:rPr sz="1800"/>
-              <a:t>Veracity is a suite of 22+ tools for analyzing, reviewing, and fixing Verus codebases.</a:t>
-            </a:r>
-          </a:p>
-          <a:p>
-            <a:pPr lvl="0"/>
-            <a:r>
-              <a:rPr sz="1800"/>
-              <a:t>Review tools: proof holes (assume, external_body, admit), style enforcement (21 rules, auto-reorder), function inventory with spec strength classification, string-hacking detector.</a:t>
-            </a:r>
-          </a:p>
-          <a:p>
-            <a:pPr lvl="0"/>
-            <a:r>
-              <a:rPr sz="1800"/>
-              <a:t>Minimization tools: veracity-minimize-proofs (removes redundant asserts and proof blocks, re-verifying after each removal).</a:t>
-            </a:r>
-          </a:p>
-          <a:p>
-            <a:pPr lvl="0"/>
-            <a:r>
-              <a:rPr sz="1800"/>
-              <a:t>Search: veracity-search — semantic search over vstd</a:t>
+              <a:t>AutoCLRS is Swamy et al. and AIs implementation: “Introduction to Algorithms, 4th ed” 2022</a:t>
+            </a:r>
+          </a:p>
+          <a:p>
+            <a:pPr lvl="0"/>
+            <a:r>
+              <a:rPr sz="1800"/>
+              <a:t>by Thomas H. Cormen, Charles E. Leiserson, Ronald L. Rivest, and Clifford Stein.</a:t>
+            </a:r>
+          </a:p>
+          <a:p>
+            <a:pPr lvl="0"/>
+            <a:r>
+              <a:rPr sz="1800"/>
+              <a:t>in Pulse.</a:t>
+            </a:r>
+          </a:p>
+          <a:p>
+            <a:pPr lvl="0"/>
+            <a:r>
+              <a:rPr sz="1800"/>
+              <a:t>RiSE MSR blog (2026-03-06) says the initial 10K lines came “very quickly” and then “about a month of nudging” to reach 100K LOC.</a:t>
+            </a:r>
+          </a:p>
+          <a:p>
+            <a:pPr lvl="0"/>
+            <a:r>
+              <a:rPr sz="1800"/>
+              <a:t>Nikhil Swamy with thanks to Gabriel Ebner, Lef Ioannidis, Guido Martinez, Matthai Philipose and Tahina Ramananandro.</a:t>
+            </a:r>
+          </a:p>
+          <a:p>
+            <a:pPr lvl="0"/>
+            <a:r>
+              <a:rPr sz="1800"/>
+              <a:t>And now seems to be about 130K LOC.</a:t>
+            </a:r>
+          </a:p>
+          <a:p>
+            <a:pPr lvl="0"/>
+            <a:r>
+              <a:rPr sz="1800"/>
+              <a:t>They definitely had some tool advantages in terms of incremental proofs through a server.</a:t>
+            </a:r>
+          </a:p>
+          <a:p>
+            <a:pPr lvl="0"/>
+            <a:r>
+              <a:rPr sz="1800"/>
+              <a:t>And they did a formal specification of algorithmic complexity.</a:t>
             </a:r>
           </a:p>
         </p:txBody>
@@ -6302,7 +6332,7 @@
             </a:pPr>
             <a:r>
               <a:rPr sz="3200"/>
-              <a:t>Veracity- Software Engineering AI Paired Proving</a:t>
+              <a:t>APAS-VERUS - Complexity</a:t>
             </a:r>
           </a:p>
         </p:txBody>
@@ -6325,28 +6355,35 @@
             <a:pPr lvl="0"/>
             <a:r>
               <a:rPr sz="1800"/>
-              <a:t>APAS-VERUS by type signature, finding lemmas before writing new ones. “Specifications as Search Keys for Software Libraries” Eugene J. Rollins and Jeannette M. Wing</a:t>
-            </a:r>
-          </a:p>
-          <a:p>
-            <a:pPr lvl="0"/>
-            <a:r>
-              <a:rPr sz="1800"/>
-              <a:t>This allows me to download ALL known Verus (git VerusCodebases) and search them in 1.2 seconds!</a:t>
-            </a:r>
-          </a:p>
-          <a:p>
-            <a:pPr lvl="0"/>
-            <a:r>
-              <a:rPr sz="1800"/>
-              <a:t>Metrics: veracity-count-loc (spec/proof/exec breakdown), chapter-cleanliness-status (clean vs. holed chapter summary).</a:t>
-            </a:r>
-          </a:p>
-          <a:p>
-            <a:pPr lvl="0"/>
-            <a:r>
-              <a:rPr sz="1800"/>
-              <a:t>All tools are AST-aware (ra_ap_syntax / Verus_syn). A built-in string-hacking detector flags and rejects any tool that attempts regex or find-and-replace on Verus source.</a:t>
+              <a:t>APAS states runtimes and informally proves them for some algorithms.</a:t>
+            </a:r>
+          </a:p>
+          <a:p>
+            <a:pPr lvl="0"/>
+            <a:r>
+              <a:rPr sz="1800"/>
+              <a:t>I had to build a tool to get the right ones in the code at the right place.</a:t>
+            </a:r>
+          </a:p>
+          <a:p>
+            <a:pPr lvl="0"/>
+            <a:r>
+              <a:rPr sz="1800"/>
+              <a:t>My single threaded implementations often don’t match the textbook.</a:t>
+            </a:r>
+          </a:p>
+          <a:p>
+            <a:pPr lvl="0"/>
+            <a:r>
+              <a:rPr sz="1800"/>
+              <a:t>Then I had Claude Opus do it’s analysis and compare every function with the textbooks.</a:t>
+            </a:r>
+          </a:p>
+          <a:p>
+            <a:pPr lvl="0"/>
+            <a:r>
+              <a:rPr sz="1800"/>
+              <a:t>This found about 16 faults in parallel algorithms.</a:t>
             </a:r>
           </a:p>
         </p:txBody>
@@ -6393,7 +6430,7 @@
             </a:pPr>
             <a:r>
               <a:rPr sz="3200"/>
-              <a:t>APAS-VERUS: Verified Iteration</a:t>
+              <a:t>Veracity- Software Engineering AI Paired Proving</a:t>
             </a:r>
           </a:p>
         </p:txBody>
@@ -6416,42 +6453,28 @@
             <a:pPr lvl="0"/>
             <a:r>
               <a:rPr sz="1800"/>
-              <a:t>10 components required per collection (all inside Verus!):</a:t>
-            </a:r>
-          </a:p>
-          <a:p>
-            <a:pPr lvl="0"/>
-            <a:r>
-              <a:rPr sz="1800"/>
-              <a:t>6 verified loop patterns per collection:</a:t>
-            </a:r>
-          </a:p>
-          <a:p>
-            <a:pPr lvl="0"/>
-            <a:r>
-              <a:rPr sz="1800"/>
-              <a:t>loop + borrow iter, loop + borrow into</a:t>
-            </a:r>
-          </a:p>
-          <a:p>
-            <a:pPr lvl="0"/>
-            <a:r>
-              <a:rPr sz="1800"/>
-              <a:t>for + borrow iter, for + borrow into</a:t>
-            </a:r>
-          </a:p>
-          <a:p>
-            <a:pPr lvl="0"/>
-            <a:r>
-              <a:rPr sz="1800"/>
-              <a:t>loop + consume, for + consume</a:t>
-            </a:r>
-          </a:p>
-          <a:p>
-            <a:pPr lvl="0"/>
-            <a:r>
-              <a:rPr sz="1800"/>
-              <a:t>Iterator assumes (one necessary workaround):</a:t>
+              <a:t>Veracity is a suite of 22+ tools for analyzing, reviewing, and fixing Verus codebases.</a:t>
+            </a:r>
+          </a:p>
+          <a:p>
+            <a:pPr lvl="0"/>
+            <a:r>
+              <a:rPr sz="1800"/>
+              <a:t>Review tools: proof holes (assume, external_body, admit), style enforcement (21 rules, auto-reorder), function inventory with spec strength classification, string-hacking detector.</a:t>
+            </a:r>
+          </a:p>
+          <a:p>
+            <a:pPr lvl="0"/>
+            <a:r>
+              <a:rPr sz="1800"/>
+              <a:t>Minimization tools: veracity-minimize-proofs (removes redundant asserts and proof blocks, re-verifying after each removal).</a:t>
+            </a:r>
+          </a:p>
+          <a:p>
+            <a:pPr lvl="0"/>
+            <a:r>
+              <a:rPr sz="1800"/>
+              <a:t>Search: veracity-search — semantic search over vstd</a:t>
             </a:r>
           </a:p>
         </p:txBody>
@@ -6498,7 +6521,7 @@
             </a:pPr>
             <a:r>
               <a:rPr sz="3200"/>
-              <a:t>APAS-VERUS: Verified Iteration</a:t>
+              <a:t>Veracity- Software Engineering AI Paired Proving</a:t>
             </a:r>
           </a:p>
         </p:txBody>
@@ -6521,49 +6544,28 @@
             <a:pPr lvl="0"/>
             <a:r>
               <a:rPr sz="1800"/>
-              <a:t>Verus forbids requires on external trait impls (std::iter::Iterator)</a:t>
-            </a:r>
-          </a:p>
-          <a:p>
-            <a:pPr lvl="0"/>
-            <a:r>
-              <a:rPr sz="1800"/>
-              <a:t>Hand-rolled iterators need assume(iter_invariant(self)) in next()</a:t>
-            </a:r>
-          </a:p>
-          <a:p>
-            <a:pPr lvl="0"/>
-            <a:r>
-              <a:rPr sz="1800"/>
-              <a:t>Everything after the assume is fully proved</a:t>
-            </a:r>
-          </a:p>
-          <a:p>
-            <a:pPr lvl="0"/>
-            <a:r>
-              <a:rPr sz="1800"/>
-              <a:t>APAS-VERUS policy: report assumes in a table; user reviews</a:t>
-            </a:r>
-          </a:p>
-          <a:p>
-            <a:pPr lvl="0"/>
-            <a:r>
-              <a:rPr sz="1800"/>
-              <a:t>44 collections implemented; all carry verified iterators</a:t>
-            </a:r>
-          </a:p>
-          <a:p>
-            <a:pPr lvl="0"/>
-            <a:r>
-              <a:rPr sz="1800"/>
-              <a:t>Verus has proof time tests inside, I freed them to run in APAS-VERUS.</a:t>
-            </a:r>
-          </a:p>
-          <a:p>
-            <a:pPr lvl="0"/>
-            <a:r>
-              <a:rPr sz="1800"/>
-              <a:t>This was critical to get iterative loops to prove.</a:t>
+              <a:t>APAS-VERUS by type signature, finding lemmas before writing new ones. “Specifications as Search Keys for Software Libraries” Eugene J. Rollins and Jeannette M. Wing</a:t>
+            </a:r>
+          </a:p>
+          <a:p>
+            <a:pPr lvl="0"/>
+            <a:r>
+              <a:rPr sz="1800"/>
+              <a:t>This allows me to download ALL known Verus (git VerusCodebases) and search them in 1.2 seconds!</a:t>
+            </a:r>
+          </a:p>
+          <a:p>
+            <a:pPr lvl="0"/>
+            <a:r>
+              <a:rPr sz="1800"/>
+              <a:t>Metrics: veracity-count-loc (spec/proof/exec breakdown), chapter-cleanliness-status (clean vs. holed chapter summary).</a:t>
+            </a:r>
+          </a:p>
+          <a:p>
+            <a:pPr lvl="0"/>
+            <a:r>
+              <a:rPr sz="1800"/>
+              <a:t>All tools are AST-aware (ra_ap_syntax / Verus_syn). A built-in string-hacking detector flags and rejects any tool that attempts regex or find-and-replace on Verus source.</a:t>
             </a:r>
           </a:p>
         </p:txBody>
@@ -6610,7 +6612,7 @@
             </a:pPr>
             <a:r>
               <a:rPr sz="3200"/>
-              <a:t>APAS-VERUS: Experiments</a:t>
+              <a:t>APAS-VERUS: Verified Iteration</a:t>
             </a:r>
           </a:p>
         </p:txBody>
@@ -6633,42 +6635,42 @@
             <a:pPr lvl="0"/>
             <a:r>
               <a:rPr sz="1800"/>
-              <a:t>Agents often say “Verus Can’t Do That”</a:t>
-            </a:r>
-          </a:p>
-          <a:p>
-            <a:pPr lvl="0"/>
-            <a:r>
-              <a:rPr sz="1800"/>
-              <a:t>I said “Make an experiment!”</a:t>
-            </a:r>
-          </a:p>
-          <a:p>
-            <a:pPr lvl="0"/>
-            <a:r>
-              <a:rPr sz="1800"/>
-              <a:t>Quantitatives:</a:t>
-            </a:r>
-          </a:p>
-          <a:p>
-            <a:pPr lvl="0"/>
-            <a:r>
-              <a:rPr sz="1800"/>
-              <a:t>168 experiment files</a:t>
-            </a:r>
-          </a:p>
-          <a:p>
-            <a:pPr lvl="0"/>
-            <a:r>
-              <a:rPr sz="1800"/>
-              <a:t>21,476 lines of code</a:t>
-            </a:r>
-          </a:p>
-          <a:p>
-            <a:pPr lvl="0"/>
-            <a:r>
-              <a:rPr sz="1800"/>
-              <a:t>Topics span: Clone, Arc, RwLock, TSM, closures, iterators, generics, float, bitvector, PartialEq, Copy, async, hash tables, parallel algorithms, ghost types, Send/Sync, collect, and sorting.</a:t>
+              <a:t>10 components required per collection (all inside Verus!):</a:t>
+            </a:r>
+          </a:p>
+          <a:p>
+            <a:pPr lvl="0"/>
+            <a:r>
+              <a:rPr sz="1800"/>
+              <a:t>6 verified loop patterns per collection:</a:t>
+            </a:r>
+          </a:p>
+          <a:p>
+            <a:pPr lvl="0"/>
+            <a:r>
+              <a:rPr sz="1800"/>
+              <a:t>loop + borrow iter, loop + borrow into</a:t>
+            </a:r>
+          </a:p>
+          <a:p>
+            <a:pPr lvl="0"/>
+            <a:r>
+              <a:rPr sz="1800"/>
+              <a:t>for + borrow iter, for + borrow into</a:t>
+            </a:r>
+          </a:p>
+          <a:p>
+            <a:pPr lvl="0"/>
+            <a:r>
+              <a:rPr sz="1800"/>
+              <a:t>loop + consume, for + consume</a:t>
+            </a:r>
+          </a:p>
+          <a:p>
+            <a:pPr lvl="0"/>
+            <a:r>
+              <a:rPr sz="1800"/>
+              <a:t>Iterator assumes (one necessary workaround):</a:t>
             </a:r>
           </a:p>
         </p:txBody>
@@ -6715,7 +6717,7 @@
             </a:pPr>
             <a:r>
               <a:rPr sz="3200"/>
-              <a:t>APAS-VERUS: Experiments</a:t>
+              <a:t>APAS-VERUS: Verified Iteration</a:t>
             </a:r>
           </a:p>
         </p:txBody>
@@ -6738,56 +6740,49 @@
             <a:pPr lvl="0"/>
             <a:r>
               <a:rPr sz="1800"/>
-              <a:t>Results:</a:t>
-            </a:r>
-          </a:p>
-          <a:p>
-            <a:pPr lvl="0"/>
-            <a:r>
-              <a:rPr sz="1800"/>
-              <a:t>~100 files: SUCCEEDS / VERIFIES — pattern adopted into codebase</a:t>
-            </a:r>
-          </a:p>
-          <a:p>
-            <a:pPr lvl="0"/>
-            <a:r>
-              <a:rPr sz="1800"/>
-              <a:t>~50 files: FAILS — Verus limitation documented, workaround noted</a:t>
-            </a:r>
-          </a:p>
-          <a:p>
-            <a:pPr lvl="0"/>
-            <a:r>
-              <a:rPr sz="1800"/>
-              <a:t>Notable successes that unlocked chapters:</a:t>
-            </a:r>
-          </a:p>
-          <a:p>
-            <a:pPr lvl="0"/>
-            <a:r>
-              <a:rPr sz="1800"/>
-              <a:t>TSM/RwLock layer pattern — unlocked all Mt chapters</a:t>
-            </a:r>
-          </a:p>
-          <a:p>
-            <a:pPr lvl="0"/>
-            <a:r>
-              <a:rPr sz="1800"/>
-              <a:t>Named closure ensures through ParaPair — unlocked fork-join</a:t>
-            </a:r>
-          </a:p>
-          <a:p>
-            <a:pPr lvl="0"/>
-            <a:r>
-              <a:rPr sz="1800"/>
-              <a:t>Ghost struct Send/Sync — unlocked Chap41 (now in Verus upstream)</a:t>
-            </a:r>
-          </a:p>
-          <a:p>
-            <a:pPr lvl="0"/>
-            <a:r>
-              <a:rPr sz="1800"/>
-              <a:t>Tree module style with recursive trait impls — unlocked Chap65</a:t>
+              <a:t>Verus forbids requires on external trait impls (std::iter::Iterator)</a:t>
+            </a:r>
+          </a:p>
+          <a:p>
+            <a:pPr lvl="0"/>
+            <a:r>
+              <a:rPr sz="1800"/>
+              <a:t>Hand-rolled iterators need assume(iter_invariant(self)) in next()</a:t>
+            </a:r>
+          </a:p>
+          <a:p>
+            <a:pPr lvl="0"/>
+            <a:r>
+              <a:rPr sz="1800"/>
+              <a:t>Everything after the assume is fully proved</a:t>
+            </a:r>
+          </a:p>
+          <a:p>
+            <a:pPr lvl="0"/>
+            <a:r>
+              <a:rPr sz="1800"/>
+              <a:t>APAS-VERUS policy: report assumes in a table; user reviews</a:t>
+            </a:r>
+          </a:p>
+          <a:p>
+            <a:pPr lvl="0"/>
+            <a:r>
+              <a:rPr sz="1800"/>
+              <a:t>44 collections implemented; all carry verified iterators</a:t>
+            </a:r>
+          </a:p>
+          <a:p>
+            <a:pPr lvl="0"/>
+            <a:r>
+              <a:rPr sz="1800"/>
+              <a:t>Verus has proof time tests inside, I freed them to run in APAS-VERUS.</a:t>
+            </a:r>
+          </a:p>
+          <a:p>
+            <a:pPr lvl="0"/>
+            <a:r>
+              <a:rPr sz="1800"/>
+              <a:t>This was critical to get iterative loops to prove.</a:t>
             </a:r>
           </a:p>
         </p:txBody>
@@ -6834,7 +6829,7 @@
             </a:pPr>
             <a:r>
               <a:rPr sz="3200"/>
-              <a:t>APAS-VERUS Standards</a:t>
+              <a:t>APAS-VERUS: Experiments</a:t>
             </a:r>
           </a:p>
         </p:txBody>
@@ -6857,21 +6852,14 @@
             <a:pPr lvl="0"/>
             <a:r>
               <a:rPr sz="1800"/>
-              <a:t>Purpose: encode hard-won proof patterns so agents don’t repeat mistakes</a:t>
-            </a:r>
-          </a:p>
-          <a:p>
-            <a:pPr lvl="0"/>
-            <a:r>
-              <a:rPr sz="1800"/>
-              <a:t>Agents read all standards before every task (~6,200 lines, ~54K tokens)</a:t>
-            </a:r>
-          </a:p>
-          <a:p>
-            <a:pPr lvl="0"/>
-            <a:r>
-              <a:rPr sz="1800"/>
-              <a:t>Violations require full reverts — standards exist because agents have broken each patterns many times.</a:t>
+              <a:t>Agents often say “Verus Can’t Do That”</a:t>
+            </a:r>
+          </a:p>
+          <a:p>
+            <a:pPr lvl="0"/>
+            <a:r>
+              <a:rPr sz="1800"/>
+              <a:t>I said “Make an experiment!”</a:t>
             </a:r>
           </a:p>
           <a:p>
@@ -6885,14 +6873,21 @@
             <a:pPr lvl="0"/>
             <a:r>
               <a:rPr sz="1800"/>
-              <a:t>29 standard files</a:t>
-            </a:r>
-          </a:p>
-          <a:p>
-            <a:pPr lvl="0"/>
-            <a:r>
-              <a:rPr sz="1800"/>
-              <a:t>6,911 lines total</a:t>
+              <a:t>168 experiment files</a:t>
+            </a:r>
+          </a:p>
+          <a:p>
+            <a:pPr lvl="0"/>
+            <a:r>
+              <a:rPr sz="1800"/>
+              <a:t>21,476 lines of code</a:t>
+            </a:r>
+          </a:p>
+          <a:p>
+            <a:pPr lvl="0"/>
+            <a:r>
+              <a:rPr sz="1800"/>
+              <a:t>Topics span: Clone, Arc, RwLock, TSM, closures, iterators, generics, float, bitvector, PartialEq, Copy, async, hash tables, parallel algorithms, ghost types, Send/Sync, collect, and sorting.</a:t>
             </a:r>
           </a:p>
         </p:txBody>
@@ -6939,7 +6934,7 @@
             </a:pPr>
             <a:r>
               <a:rPr sz="3200"/>
-              <a:t>APAS-VERUS Standards</a:t>
+              <a:t>APAS-VERUS: Experiments</a:t>
             </a:r>
           </a:p>
         </p:txBody>
@@ -6962,49 +6957,56 @@
             <a:pPr lvl="0"/>
             <a:r>
               <a:rPr sz="1800"/>
-              <a:t>Module structure: mod, table_of_contents, spec_naming, spec_wf</a:t>
-            </a:r>
-          </a:p>
-          <a:p>
-            <a:pPr lvl="0"/>
-            <a:r>
-              <a:rPr sz="1800"/>
-              <a:t>Type system: view, deep_view, partial_eq_eq_clone, multi_struct</a:t>
-            </a:r>
-          </a:p>
-          <a:p>
-            <a:pPr lvl="0"/>
-            <a:r>
-              <a:rPr sz="1800"/>
-              <a:t>Proof patterns: total_order, finite_sets, capacity_bounds, no_unsafe</a:t>
-            </a:r>
-          </a:p>
-          <a:p>
-            <a:pPr lvl="0"/>
-            <a:r>
-              <a:rPr sz="1800"/>
-              <a:t>Concurrency: arc_usage, hfscheduler, mt_type_bounds, toplevel_coarse_rwlocks, tsm, rwlock_tsm</a:t>
-            </a:r>
-          </a:p>
-          <a:p>
-            <a:pPr lvl="0"/>
-            <a:r>
-              <a:rPr sz="1800"/>
-              <a:t>Iteration: iterators, wrapping_iterators, iterator_ptt</a:t>
-            </a:r>
-          </a:p>
-          <a:p>
-            <a:pPr lvl="0"/>
-            <a:r>
-              <a:rPr sz="1800"/>
-              <a:t>Execution: mut, using_closures, using_hashmap, using_rand</a:t>
-            </a:r>
-          </a:p>
-          <a:p>
-            <a:pPr lvl="0"/>
-            <a:r>
-              <a:rPr sz="1800"/>
-              <a:t>Style: TOC and ordering</a:t>
+              <a:t>Results:</a:t>
+            </a:r>
+          </a:p>
+          <a:p>
+            <a:pPr lvl="0"/>
+            <a:r>
+              <a:rPr sz="1800"/>
+              <a:t>~100 files: SUCCEEDS / VERIFIES — pattern adopted into codebase</a:t>
+            </a:r>
+          </a:p>
+          <a:p>
+            <a:pPr lvl="0"/>
+            <a:r>
+              <a:rPr sz="1800"/>
+              <a:t>~50 files: FAILS — Verus limitation documented, workaround noted</a:t>
+            </a:r>
+          </a:p>
+          <a:p>
+            <a:pPr lvl="0"/>
+            <a:r>
+              <a:rPr sz="1800"/>
+              <a:t>Notable successes that unlocked chapters:</a:t>
+            </a:r>
+          </a:p>
+          <a:p>
+            <a:pPr lvl="0"/>
+            <a:r>
+              <a:rPr sz="1800"/>
+              <a:t>TSM/RwLock layer pattern — unlocked all Mt chapters</a:t>
+            </a:r>
+          </a:p>
+          <a:p>
+            <a:pPr lvl="0"/>
+            <a:r>
+              <a:rPr sz="1800"/>
+              <a:t>Named closure ensures through ParaPair — unlocked fork-join</a:t>
+            </a:r>
+          </a:p>
+          <a:p>
+            <a:pPr lvl="0"/>
+            <a:r>
+              <a:rPr sz="1800"/>
+              <a:t>Ghost struct Send/Sync — unlocked Chap41 (now in Verus upstream)</a:t>
+            </a:r>
+          </a:p>
+          <a:p>
+            <a:pPr lvl="0"/>
+            <a:r>
+              <a:rPr sz="1800"/>
+              <a:t>Tree module style with recursive trait impls — unlocked Chap65</a:t>
             </a:r>
           </a:p>
         </p:txBody>
@@ -7177,7 +7179,7 @@
             </a:pPr>
             <a:r>
               <a:rPr sz="3200"/>
-              <a:t>Veracity: veracity-minimize-proofs: AIs Write Redundant Proofs</a:t>
+              <a:t>APAS-VERUS Standards</a:t>
             </a:r>
           </a:p>
         </p:txBody>
@@ -7200,28 +7202,42 @@
             <a:pPr lvl="0"/>
             <a:r>
               <a:rPr sz="1800"/>
-              <a:t>AI proof agents produce correct but bloated proofs — redundant asserts, unnecessary proof blocks, duplicate intermediate steps that Z3 already knew.</a:t>
-            </a:r>
-          </a:p>
-          <a:p>
-            <a:pPr lvl="0"/>
-            <a:r>
-              <a:rPr sz="1800"/>
-              <a:t>They verify, but they waste solver budget on every subsequent run.</a:t>
-            </a:r>
-          </a:p>
-          <a:p>
-            <a:pPr lvl="0"/>
-            <a:r>
-              <a:rPr sz="1800"/>
-              <a:t>veracity-minimize-proofs tests each assert and proof block individually: remove it, re-verify, keep it out if still clean.</a:t>
-            </a:r>
-          </a:p>
-          <a:p>
-            <a:pPr lvl="0"/>
-            <a:r>
-              <a:rPr sz="1800"/>
-              <a:t>Result across APAS-VERUS: 22 asserts and 33 proof blocks removed in 105 minutes of wall time. 55 redundant proof statements eliminated, ~2 minutes of minimizer time per removal.</a:t>
+              <a:t>Purpose: encode hard-won proof patterns so agents don’t repeat mistakes</a:t>
+            </a:r>
+          </a:p>
+          <a:p>
+            <a:pPr lvl="0"/>
+            <a:r>
+              <a:rPr sz="1800"/>
+              <a:t>Agents read all standards before every task (~6,200 lines, ~54K tokens)</a:t>
+            </a:r>
+          </a:p>
+          <a:p>
+            <a:pPr lvl="0"/>
+            <a:r>
+              <a:rPr sz="1800"/>
+              <a:t>Violations require full reverts — standards exist because agents have broken each patterns many times.</a:t>
+            </a:r>
+          </a:p>
+          <a:p>
+            <a:pPr lvl="0"/>
+            <a:r>
+              <a:rPr sz="1800"/>
+              <a:t>Quantitatives:</a:t>
+            </a:r>
+          </a:p>
+          <a:p>
+            <a:pPr lvl="0"/>
+            <a:r>
+              <a:rPr sz="1800"/>
+              <a:t>29 standard files</a:t>
+            </a:r>
+          </a:p>
+          <a:p>
+            <a:pPr lvl="0"/>
+            <a:r>
+              <a:rPr sz="1800"/>
+              <a:t>6,911 lines total</a:t>
             </a:r>
           </a:p>
         </p:txBody>
@@ -7268,7 +7284,7 @@
             </a:pPr>
             <a:r>
               <a:rPr sz="3200"/>
-              <a:t>Veracity: veracity-minimize-proofs: AIs Write Redundant Proofs</a:t>
+              <a:t>APAS-VERUS Standards</a:t>
             </a:r>
           </a:p>
         </p:txBody>
@@ -7291,49 +7307,49 @@
             <a:pPr lvl="0"/>
             <a:r>
               <a:rPr sz="1800"/>
-              <a:t>It only takes out unnecessary asserts/proofs that decrease run time and memory.</a:t>
-            </a:r>
-          </a:p>
-          <a:p>
-            <a:pPr lvl="0"/>
-            <a:r>
-              <a:rPr sz="1800"/>
-              <a:t>One assert in Chap43 OrderedTableMtEph saved:</a:t>
-            </a:r>
-          </a:p>
-          <a:p>
-            <a:pPr lvl="1"/>
-            <a:r>
-              <a:rPr sz="1800"/>
-              <a:t>43–104 s of Z3 CPU</a:t>
-            </a:r>
-          </a:p>
-          <a:p>
-            <a:pPr lvl="1"/>
-            <a:r>
-              <a:rPr sz="1800"/>
-              <a:t>up to 89 MB of Z3 RSS per verify run.</a:t>
-            </a:r>
-          </a:p>
-          <a:p>
-            <a:pPr lvl="0"/>
-            <a:r>
-              <a:rPr sz="1800"/>
-              <a:t>Eight removals in that one file: Z3 RSS −57%.</a:t>
-            </a:r>
-          </a:p>
-          <a:p>
-            <a:pPr lvl="0"/>
-            <a:r>
-              <a:rPr sz="1800"/>
-              <a:t>105 minutes of running the minimizer bought many hours of validation drop.</a:t>
-            </a:r>
-          </a:p>
-          <a:p>
-            <a:pPr lvl="0"/>
-            <a:r>
-              <a:rPr sz="1800"/>
-              <a:t>This might be novel. Anyone know of anything except Isabelle’s sledgehammer?</a:t>
+              <a:t>Module structure: mod, table_of_contents, spec_naming, spec_wf</a:t>
+            </a:r>
+          </a:p>
+          <a:p>
+            <a:pPr lvl="0"/>
+            <a:r>
+              <a:rPr sz="1800"/>
+              <a:t>Type system: view, deep_view, partial_eq_eq_clone, multi_struct</a:t>
+            </a:r>
+          </a:p>
+          <a:p>
+            <a:pPr lvl="0"/>
+            <a:r>
+              <a:rPr sz="1800"/>
+              <a:t>Proof patterns: total_order, finite_sets, capacity_bounds, no_unsafe</a:t>
+            </a:r>
+          </a:p>
+          <a:p>
+            <a:pPr lvl="0"/>
+            <a:r>
+              <a:rPr sz="1800"/>
+              <a:t>Concurrency: arc_usage, hfscheduler, mt_type_bounds, toplevel_coarse_rwlocks, tsm, rwlock_tsm</a:t>
+            </a:r>
+          </a:p>
+          <a:p>
+            <a:pPr lvl="0"/>
+            <a:r>
+              <a:rPr sz="1800"/>
+              <a:t>Iteration: iterators, wrapping_iterators, iterator_ptt</a:t>
+            </a:r>
+          </a:p>
+          <a:p>
+            <a:pPr lvl="0"/>
+            <a:r>
+              <a:rPr sz="1800"/>
+              <a:t>Execution: mut, using_closures, using_hashmap, using_rand</a:t>
+            </a:r>
+          </a:p>
+          <a:p>
+            <a:pPr lvl="0"/>
+            <a:r>
+              <a:rPr sz="1800"/>
+              <a:t>Style: TOC and ordering</a:t>
             </a:r>
           </a:p>
         </p:txBody>
@@ -7380,7 +7396,7 @@
             </a:pPr>
             <a:r>
               <a:rPr sz="3200"/>
-              <a:t>Veracity Annotations</a:t>
+              <a:t>Veracity: veracity-minimize-proofs: AIs Write Redundant Proofs</a:t>
             </a:r>
           </a:p>
         </p:txBody>
@@ -7403,84 +7419,28 @@
             <a:pPr lvl="0"/>
             <a:r>
               <a:rPr sz="1800"/>
-              <a:t>I ended up having to have my tools work mostly in comments.</a:t>
-            </a:r>
-          </a:p>
-          <a:p>
-            <a:pPr lvl="0"/>
-            <a:r>
-              <a:rPr sz="1800"/>
-              <a:t>I added accept to mark assumes I allowed, almost all eq/partialeq/clone.</a:t>
-            </a:r>
-          </a:p>
-          <a:p>
-            <a:pPr lvl="0"/>
-            <a:r>
-              <a:rPr sz="1800"/>
-              <a:t>This can be simplified with some Verus language syntax, but then the AIs are not trained on the symbols.</a:t>
-            </a:r>
-          </a:p>
-          <a:p>
-            <a:pPr lvl="0"/>
-            <a:r>
-              <a:rPr sz="1800"/>
-              <a:t>// Veracity: NEEDED assert — 6,081</a:t>
-            </a:r>
-          </a:p>
-          <a:p>
-            <a:pPr lvl="0"/>
-            <a:r>
-              <a:rPr sz="1800"/>
-              <a:t>// Veracity: NEEDED proof block — 4,681</a:t>
-            </a:r>
-          </a:p>
-          <a:p>
-            <a:pPr lvl="0"/>
-            <a:r>
-              <a:rPr sz="1800"/>
-              <a:t>// Veracity: NEEDED assert (speed) — 1,502</a:t>
-            </a:r>
-          </a:p>
-          <a:p>
-            <a:pPr lvl="0"/>
-            <a:r>
-              <a:rPr sz="1800"/>
-              <a:t>// Veracity: NEEDED proof block (speed)— 245</a:t>
-            </a:r>
-          </a:p>
-          <a:p>
-            <a:pPr lvl="0"/>
-            <a:r>
-              <a:rPr sz="1800"/>
-              <a:t>Total NEEDED: 12,509</a:t>
-            </a:r>
-          </a:p>
-          <a:p>
-            <a:pPr lvl="0"/>
-            <a:r>
-              <a:rPr sz="1800"/>
-              <a:t>// Veracity: UNNEEDED — 1,452</a:t>
-            </a:r>
-          </a:p>
-          <a:p>
-            <a:pPr lvl="0"/>
-            <a:r>
-              <a:rPr sz="1800"/>
-              <a:t>// Veracity: no_requires — 71</a:t>
-            </a:r>
-          </a:p>
-          <a:p>
-            <a:pPr lvl="0"/>
-            <a:r>
-              <a:rPr sz="1800"/>
-              <a:t>accept — 108</a:t>
-            </a:r>
-          </a:p>
-          <a:p>
-            <a:pPr lvl="0"/>
-            <a:r>
-              <a:rPr sz="1800"/>
-              <a:t>Total annotations: 14,140</a:t>
+              <a:t>AI proof agents produce correct but bloated proofs — redundant asserts, unnecessary proof blocks, duplicate intermediate steps that Z3 already knew.</a:t>
+            </a:r>
+          </a:p>
+          <a:p>
+            <a:pPr lvl="0"/>
+            <a:r>
+              <a:rPr sz="1800"/>
+              <a:t>They verify, but they waste solver budget on every subsequent run.</a:t>
+            </a:r>
+          </a:p>
+          <a:p>
+            <a:pPr lvl="0"/>
+            <a:r>
+              <a:rPr sz="1800"/>
+              <a:t>veracity-minimize-proofs tests each assert and proof block individually: remove it, re-verify, keep it out if still clean.</a:t>
+            </a:r>
+          </a:p>
+          <a:p>
+            <a:pPr lvl="0"/>
+            <a:r>
+              <a:rPr sz="1800"/>
+              <a:t>Result across APAS-VERUS: 22 asserts and 33 proof blocks removed in 105 minutes of wall time. 55 redundant proof statements eliminated, ~2 minutes of minimizer time per removal.</a:t>
             </a:r>
           </a:p>
         </p:txBody>
@@ -7527,7 +7487,7 @@
             </a:pPr>
             <a:r>
               <a:rPr sz="3200"/>
-              <a:t>Rusticate + Veracity allow quantitative software engineering</a:t>
+              <a:t>Veracity: veracity-minimize-proofs: AIs Write Redundant Proofs</a:t>
             </a:r>
           </a:p>
         </p:txBody>
@@ -7550,49 +7510,49 @@
             <a:pPr lvl="0"/>
             <a:r>
               <a:rPr sz="1800"/>
-              <a:t>I downloaded the 1036 most downloaded Rust projects, 3636 crates.</a:t>
-            </a:r>
-          </a:p>
-          <a:p>
-            <a:pPr lvl="0"/>
-            <a:r>
-              <a:rPr sz="1800"/>
-              <a:t>I threw out three that wrapped std for asynchrony.</a:t>
-            </a:r>
-          </a:p>
-          <a:p>
-            <a:pPr lvl="0"/>
-            <a:r>
-              <a:rPr sz="1800"/>
-              <a:t>I did a greedy set cover analysis of what Rust uses.</a:t>
-            </a:r>
-          </a:p>
-          <a:p>
-            <a:pPr lvl="0"/>
-            <a:r>
-              <a:rPr sz="1800"/>
-              <a:t>And another of what verus wraps.</a:t>
-            </a:r>
-          </a:p>
-          <a:p>
-            <a:pPr lvl="0"/>
-            <a:r>
-              <a:rPr sz="1800"/>
-              <a:t>This is a golden age for quantitative software engineering.</a:t>
-            </a:r>
-          </a:p>
-          <a:p>
-            <a:pPr lvl="0"/>
-            <a:r>
-              <a:rPr sz="1800"/>
-              <a:t>It took just two days of person time.</a:t>
-            </a:r>
-          </a:p>
-          <a:p>
-            <a:pPr lvl="0"/>
-            <a:r>
-              <a:rPr sz="1800"/>
-              <a:t>And I never read a line of code in the tools. Just check the output and have the AI write a lot of tests.</a:t>
+              <a:t>It only takes out unnecessary asserts/proofs that decrease run time and memory.</a:t>
+            </a:r>
+          </a:p>
+          <a:p>
+            <a:pPr lvl="0"/>
+            <a:r>
+              <a:rPr sz="1800"/>
+              <a:t>One assert in Chap43 OrderedTableMtEph saved:</a:t>
+            </a:r>
+          </a:p>
+          <a:p>
+            <a:pPr lvl="1"/>
+            <a:r>
+              <a:rPr sz="1800"/>
+              <a:t>43–104 s of Z3 CPU</a:t>
+            </a:r>
+          </a:p>
+          <a:p>
+            <a:pPr lvl="1"/>
+            <a:r>
+              <a:rPr sz="1800"/>
+              <a:t>up to 89 MB of Z3 RSS per verify run.</a:t>
+            </a:r>
+          </a:p>
+          <a:p>
+            <a:pPr lvl="0"/>
+            <a:r>
+              <a:rPr sz="1800"/>
+              <a:t>Eight removals in that one file: Z3 RSS −57%.</a:t>
+            </a:r>
+          </a:p>
+          <a:p>
+            <a:pPr lvl="0"/>
+            <a:r>
+              <a:rPr sz="1800"/>
+              <a:t>105 minutes of running the minimizer bought many hours of validation drop.</a:t>
+            </a:r>
+          </a:p>
+          <a:p>
+            <a:pPr lvl="0"/>
+            <a:r>
+              <a:rPr sz="1800"/>
+              <a:t>This might be novel. Anyone know of anything except Isabelle’s sledgehammer?</a:t>
             </a:r>
           </a:p>
         </p:txBody>
@@ -7639,7 +7599,7 @@
             </a:pPr>
             <a:r>
               <a:rPr sz="3200"/>
-              <a:t>Rusticate + Veracity : What Rust Cargos use in std.</a:t>
+              <a:t>Veracity Annotations</a:t>
             </a:r>
           </a:p>
         </p:txBody>
@@ -7662,49 +7622,49 @@
             <a:pPr lvl="0"/>
             <a:r>
               <a:rPr sz="1800"/>
-              <a:t>Top 1000 projects, 3636 crates.</a:t>
-            </a:r>
-          </a:p>
-          <a:p>
-            <a:pPr lvl="0"/>
-            <a:r>
-              <a:rPr sz="1800"/>
-              <a:t>19 data types fully support 90%.</a:t>
-            </a:r>
-          </a:p>
-          <a:p>
-            <a:pPr lvl="0"/>
-            <a:r>
-              <a:rPr sz="1800"/>
-              <a:t>48 data types fully support 100%.</a:t>
-            </a:r>
-          </a:p>
-          <a:p>
-            <a:pPr lvl="0"/>
-            <a:r>
-              <a:rPr sz="1800"/>
-              <a:t>69 modules fully support 95%.</a:t>
-            </a:r>
-          </a:p>
-          <a:p>
-            <a:pPr lvl="0"/>
-            <a:r>
-              <a:rPr sz="1800"/>
-              <a:t>79 modules fully support 99%.</a:t>
-            </a:r>
-          </a:p>
-          <a:p>
-            <a:pPr lvl="0"/>
-            <a:r>
-              <a:rPr sz="1800"/>
-              <a:t>1121 methods fully support 95%.</a:t>
-            </a:r>
-          </a:p>
-          <a:p>
-            <a:pPr lvl="0"/>
-            <a:r>
-              <a:rPr sz="1800"/>
-              <a:t>1733 methods fully support 99%.</a:t>
+              <a:t>I ended up having to have my tools work mostly in comments.</a:t>
+            </a:r>
+          </a:p>
+          <a:p>
+            <a:pPr lvl="0"/>
+            <a:r>
+              <a:rPr sz="1800"/>
+              <a:t>I added accept to mark assumes I allowed, almost all eq/partialeq/clone.</a:t>
+            </a:r>
+          </a:p>
+          <a:p>
+            <a:pPr lvl="0"/>
+            <a:r>
+              <a:rPr sz="1800"/>
+              <a:t>This can be simplified with some Verus language syntax, but then the AIs are not trained on the symbols.</a:t>
+            </a:r>
+          </a:p>
+          <a:p>
+            <a:pPr lvl="0"/>
+            <a:r>
+              <a:rPr sz="1800"/>
+              <a:t>// Veracity: NEEDED assert — 6,081</a:t>
+            </a:r>
+          </a:p>
+          <a:p>
+            <a:pPr lvl="0"/>
+            <a:r>
+              <a:rPr sz="1800"/>
+              <a:t>// Veracity: NEEDED proof block — 4,681</a:t>
+            </a:r>
+          </a:p>
+          <a:p>
+            <a:pPr lvl="0"/>
+            <a:r>
+              <a:rPr sz="1800"/>
+              <a:t>// Veracity: NEEDED assert (speed) — 1,502</a:t>
+            </a:r>
+          </a:p>
+          <a:p>
+            <a:pPr lvl="0"/>
+            <a:r>
+              <a:rPr sz="1800"/>
+              <a:t>// Veracity: NEEDED proof block (speed)— 245</a:t>
             </a:r>
           </a:p>
         </p:txBody>
@@ -7751,7 +7711,7 @@
             </a:pPr>
             <a:r>
               <a:rPr sz="3200"/>
-              <a:t>Compare Rust STD to APAS-VERUS?</a:t>
+              <a:t>Veracity Annotations</a:t>
             </a:r>
           </a:p>
         </p:txBody>
@@ -7774,21 +7734,35 @@
             <a:pPr lvl="0"/>
             <a:r>
               <a:rPr sz="1800"/>
-              <a:t>APAS-VERUS: -6,401 exec functions total, -4,911 with proofs</a:t>
-            </a:r>
-          </a:p>
-          <a:p>
-            <a:pPr lvl="0"/>
-            <a:r>
-              <a:rPr sz="1800"/>
-              <a:t>But APAS-VERUS has {Mt,St}x{Per,Eph}</a:t>
-            </a:r>
-          </a:p>
-          <a:p>
-            <a:pPr lvl="0"/>
-            <a:r>
-              <a:rPr sz="1800"/>
-              <a:t>So it much more like 2000 distinct functions.</a:t>
+              <a:t>Total NEEDED: 12,509</a:t>
+            </a:r>
+          </a:p>
+          <a:p>
+            <a:pPr lvl="0"/>
+            <a:r>
+              <a:rPr sz="1800"/>
+              <a:t>// Veracity: UNNEEDED — 1,452</a:t>
+            </a:r>
+          </a:p>
+          <a:p>
+            <a:pPr lvl="0"/>
+            <a:r>
+              <a:rPr sz="1800"/>
+              <a:t>// Veracity: no_requires — 71</a:t>
+            </a:r>
+          </a:p>
+          <a:p>
+            <a:pPr lvl="0"/>
+            <a:r>
+              <a:rPr sz="1800"/>
+              <a:t>accept — 108</a:t>
+            </a:r>
+          </a:p>
+          <a:p>
+            <a:pPr lvl="0"/>
+            <a:r>
+              <a:rPr sz="1800"/>
+              <a:t>Total annotations: 14,140</a:t>
             </a:r>
           </a:p>
         </p:txBody>
@@ -7835,7 +7809,7 @@
             </a:pPr>
             <a:r>
               <a:rPr sz="3200"/>
-              <a:t>Rusticate + Veracity: What Verus Wraps</a:t>
+              <a:t>Rusticate + Veracity allow quantitative software engineering</a:t>
             </a:r>
           </a:p>
         </p:txBody>
@@ -7855,12 +7829,52 @@
           <a:bodyPr/>
           <a:lstStyle/>
           <a:p>
-            <a:pPr lvl="0" indent="0" marL="0">
-              <a:buNone/>
-            </a:pPr>
-            <a:r>
-              <a:rPr sz="1800"/>
-              <a:t>-As of 2026 14 April: -How many Rust Data Types does Verus wrap? - 29 types currently wrapped. -How many Rust Traits does Verus wrap? - 147 traits in vstd. -How many total Rust Methods does Verus wrap? - 154 methods currently wrapped.</a:t>
+            <a:pPr lvl="0"/>
+            <a:r>
+              <a:rPr sz="1800"/>
+              <a:t>I downloaded the 1036 most downloaded Rust projects, 3636 crates.</a:t>
+            </a:r>
+          </a:p>
+          <a:p>
+            <a:pPr lvl="0"/>
+            <a:r>
+              <a:rPr sz="1800"/>
+              <a:t>I threw out three that wrapped std for asynchrony.</a:t>
+            </a:r>
+          </a:p>
+          <a:p>
+            <a:pPr lvl="0"/>
+            <a:r>
+              <a:rPr sz="1800"/>
+              <a:t>I did a greedy set cover analysis of what Rust uses.</a:t>
+            </a:r>
+          </a:p>
+          <a:p>
+            <a:pPr lvl="0"/>
+            <a:r>
+              <a:rPr sz="1800"/>
+              <a:t>And another of what verus wraps.</a:t>
+            </a:r>
+          </a:p>
+          <a:p>
+            <a:pPr lvl="0"/>
+            <a:r>
+              <a:rPr sz="1800"/>
+              <a:t>This is a golden age for quantitative software engineering.</a:t>
+            </a:r>
+          </a:p>
+          <a:p>
+            <a:pPr lvl="0"/>
+            <a:r>
+              <a:rPr sz="1800"/>
+              <a:t>It took just two days of person time.</a:t>
+            </a:r>
+          </a:p>
+          <a:p>
+            <a:pPr lvl="0"/>
+            <a:r>
+              <a:rPr sz="1800"/>
+              <a:t>And I never read a line of code in the tools. Just check the output and have the AI write a lot of tests.</a:t>
             </a:r>
           </a:p>
         </p:txBody>
@@ -7907,6 +7921,405 @@
             </a:pPr>
             <a:r>
               <a:rPr sz="3200"/>
+              <a:t>Rusticate + Veracity : What Rust Cargos use in std.</a:t>
+            </a:r>
+          </a:p>
+        </p:txBody>
+      </p:sp>
+      <p:sp>
+        <p:nvSpPr>
+          <p:cNvPr id="3" name="Content Placeholder 2"/>
+          <p:cNvSpPr>
+            <a:spLocks noGrp="1"/>
+          </p:cNvSpPr>
+          <p:nvPr>
+            <p:ph idx="1"/>
+          </p:nvPr>
+        </p:nvSpPr>
+        <p:spPr/>
+        <p:txBody>
+          <a:bodyPr/>
+          <a:lstStyle/>
+          <a:p>
+            <a:pPr lvl="0"/>
+            <a:r>
+              <a:rPr sz="1800"/>
+              <a:t>Top 1000 projects, 3636 crates.</a:t>
+            </a:r>
+          </a:p>
+          <a:p>
+            <a:pPr lvl="0"/>
+            <a:r>
+              <a:rPr sz="1800"/>
+              <a:t>19 data types fully support 90%.</a:t>
+            </a:r>
+          </a:p>
+          <a:p>
+            <a:pPr lvl="0"/>
+            <a:r>
+              <a:rPr sz="1800"/>
+              <a:t>48 data types fully support 100%.</a:t>
+            </a:r>
+          </a:p>
+          <a:p>
+            <a:pPr lvl="0"/>
+            <a:r>
+              <a:rPr sz="1800"/>
+              <a:t>69 modules fully support 95%.</a:t>
+            </a:r>
+          </a:p>
+          <a:p>
+            <a:pPr lvl="0"/>
+            <a:r>
+              <a:rPr sz="1800"/>
+              <a:t>79 modules fully support 99%.</a:t>
+            </a:r>
+          </a:p>
+          <a:p>
+            <a:pPr lvl="0"/>
+            <a:r>
+              <a:rPr sz="1800"/>
+              <a:t>1121 methods fully support 95%.</a:t>
+            </a:r>
+          </a:p>
+          <a:p>
+            <a:pPr lvl="0"/>
+            <a:r>
+              <a:rPr sz="1800"/>
+              <a:t>1733 methods fully support 99%.</a:t>
+            </a:r>
+          </a:p>
+        </p:txBody>
+      </p:sp>
+    </p:spTree>
+  </p:cSld>
+</p:sld>
+</file>
+
+<file path=ppt/slides/slide48.xml><?xml version="1.0" encoding="utf-8"?>
+<p:sld xmlns:a="http://schemas.openxmlformats.org/drawingml/2006/main" xmlns:r="http://schemas.openxmlformats.org/officeDocument/2006/relationships" xmlns:p="http://schemas.openxmlformats.org/presentationml/2006/main">
+  <p:cSld>
+    <p:spTree>
+      <p:nvGrpSpPr>
+        <p:cNvPr id="1" name=""/>
+        <p:cNvGrpSpPr/>
+        <p:nvPr/>
+      </p:nvGrpSpPr>
+      <p:grpSpPr>
+        <a:xfrm>
+          <a:off x="0" y="0"/>
+          <a:ext cx="0" cy="0"/>
+          <a:chOff x="0" y="0"/>
+          <a:chExt cx="0" cy="0"/>
+        </a:xfrm>
+      </p:grpSpPr>
+      <p:sp>
+        <p:nvSpPr>
+          <p:cNvPr id="2" name="Title 1"/>
+          <p:cNvSpPr>
+            <a:spLocks noGrp="1"/>
+          </p:cNvSpPr>
+          <p:nvPr>
+            <p:ph type="title"/>
+          </p:nvPr>
+        </p:nvSpPr>
+        <p:spPr/>
+        <p:txBody>
+          <a:bodyPr/>
+          <a:lstStyle/>
+          <a:p>
+            <a:pPr lvl="0" indent="0" marL="0">
+              <a:buNone/>
+            </a:pPr>
+            <a:r>
+              <a:rPr sz="3200"/>
+              <a:t>Compare Rust STD to APAS-VERUS?</a:t>
+            </a:r>
+          </a:p>
+        </p:txBody>
+      </p:sp>
+      <p:sp>
+        <p:nvSpPr>
+          <p:cNvPr id="3" name="Content Placeholder 2"/>
+          <p:cNvSpPr>
+            <a:spLocks noGrp="1"/>
+          </p:cNvSpPr>
+          <p:nvPr>
+            <p:ph idx="1"/>
+          </p:nvPr>
+        </p:nvSpPr>
+        <p:spPr/>
+        <p:txBody>
+          <a:bodyPr/>
+          <a:lstStyle/>
+          <a:p>
+            <a:pPr lvl="0"/>
+            <a:r>
+              <a:rPr sz="1800"/>
+              <a:t>APAS-VERUS: -6,401 exec functions total, -4,911 with proofs</a:t>
+            </a:r>
+          </a:p>
+          <a:p>
+            <a:pPr lvl="0"/>
+            <a:r>
+              <a:rPr sz="1800"/>
+              <a:t>But APAS-VERUS has {Mt,St}x{Per,Eph}</a:t>
+            </a:r>
+          </a:p>
+          <a:p>
+            <a:pPr lvl="0"/>
+            <a:r>
+              <a:rPr sz="1800"/>
+              <a:t>So it much more like 2000 distinct functions.</a:t>
+            </a:r>
+          </a:p>
+        </p:txBody>
+      </p:sp>
+    </p:spTree>
+  </p:cSld>
+</p:sld>
+</file>
+
+<file path=ppt/slides/slide49.xml><?xml version="1.0" encoding="utf-8"?>
+<p:sld xmlns:a="http://schemas.openxmlformats.org/drawingml/2006/main" xmlns:r="http://schemas.openxmlformats.org/officeDocument/2006/relationships" xmlns:p="http://schemas.openxmlformats.org/presentationml/2006/main">
+  <p:cSld>
+    <p:spTree>
+      <p:nvGrpSpPr>
+        <p:cNvPr id="1" name=""/>
+        <p:cNvGrpSpPr/>
+        <p:nvPr/>
+      </p:nvGrpSpPr>
+      <p:grpSpPr>
+        <a:xfrm>
+          <a:off x="0" y="0"/>
+          <a:ext cx="0" cy="0"/>
+          <a:chOff x="0" y="0"/>
+          <a:chExt cx="0" cy="0"/>
+        </a:xfrm>
+      </p:grpSpPr>
+      <p:sp>
+        <p:nvSpPr>
+          <p:cNvPr id="2" name="Title 1"/>
+          <p:cNvSpPr>
+            <a:spLocks noGrp="1"/>
+          </p:cNvSpPr>
+          <p:nvPr>
+            <p:ph type="title"/>
+          </p:nvPr>
+        </p:nvSpPr>
+        <p:spPr/>
+        <p:txBody>
+          <a:bodyPr/>
+          <a:lstStyle/>
+          <a:p>
+            <a:pPr lvl="0" indent="0" marL="0">
+              <a:buNone/>
+            </a:pPr>
+            <a:r>
+              <a:rPr sz="3200"/>
+              <a:t>Rusticate + Veracity: What Verus Wraps</a:t>
+            </a:r>
+          </a:p>
+        </p:txBody>
+      </p:sp>
+      <p:sp>
+        <p:nvSpPr>
+          <p:cNvPr id="3" name="Content Placeholder 2"/>
+          <p:cNvSpPr>
+            <a:spLocks noGrp="1"/>
+          </p:cNvSpPr>
+          <p:nvPr>
+            <p:ph idx="1"/>
+          </p:nvPr>
+        </p:nvSpPr>
+        <p:spPr/>
+        <p:txBody>
+          <a:bodyPr/>
+          <a:lstStyle/>
+          <a:p>
+            <a:pPr lvl="0"/>
+            <a:r>
+              <a:rPr sz="1800"/>
+              <a:t>As of 2026 14 April</a:t>
+            </a:r>
+          </a:p>
+          <a:p>
+            <a:pPr lvl="0"/>
+            <a:r>
+              <a:rPr sz="1800"/>
+              <a:t>How many Rust Data Types does Verus wrap?</a:t>
+            </a:r>
+          </a:p>
+          <a:p>
+            <a:pPr lvl="1"/>
+            <a:r>
+              <a:rPr sz="1800"/>
+              <a:t>29 types currently wrapped.</a:t>
+            </a:r>
+          </a:p>
+          <a:p>
+            <a:pPr lvl="0"/>
+            <a:r>
+              <a:rPr sz="1800"/>
+              <a:t>How many Rust Traits does Verus wrap?</a:t>
+            </a:r>
+          </a:p>
+          <a:p>
+            <a:pPr lvl="1"/>
+            <a:r>
+              <a:rPr sz="1800"/>
+              <a:t>147 traits in vstd.</a:t>
+            </a:r>
+          </a:p>
+          <a:p>
+            <a:pPr lvl="0"/>
+            <a:r>
+              <a:rPr sz="1800"/>
+              <a:t>How many total Rust Methods does Verus wrap?</a:t>
+            </a:r>
+          </a:p>
+          <a:p>
+            <a:pPr lvl="1"/>
+            <a:r>
+              <a:rPr sz="1800"/>
+              <a:t>154 methods currently wrapped.</a:t>
+            </a:r>
+          </a:p>
+        </p:txBody>
+      </p:sp>
+    </p:spTree>
+  </p:cSld>
+</p:sld>
+</file>
+
+<file path=ppt/slides/slide5.xml><?xml version="1.0" encoding="utf-8"?>
+<p:sld xmlns:a="http://schemas.openxmlformats.org/drawingml/2006/main" xmlns:r="http://schemas.openxmlformats.org/officeDocument/2006/relationships" xmlns:p="http://schemas.openxmlformats.org/presentationml/2006/main">
+  <p:cSld>
+    <p:spTree>
+      <p:nvGrpSpPr>
+        <p:cNvPr id="1" name=""/>
+        <p:cNvGrpSpPr/>
+        <p:nvPr/>
+      </p:nvGrpSpPr>
+      <p:grpSpPr>
+        <a:xfrm>
+          <a:off x="0" y="0"/>
+          <a:ext cx="0" cy="0"/>
+          <a:chOff x="0" y="0"/>
+          <a:chExt cx="0" cy="0"/>
+        </a:xfrm>
+      </p:grpSpPr>
+      <p:sp>
+        <p:nvSpPr>
+          <p:cNvPr id="2" name="Title 1"/>
+          <p:cNvSpPr>
+            <a:spLocks noGrp="1"/>
+          </p:cNvSpPr>
+          <p:nvPr>
+            <p:ph type="title"/>
+          </p:nvPr>
+        </p:nvSpPr>
+        <p:spPr/>
+        <p:txBody>
+          <a:bodyPr/>
+          <a:lstStyle/>
+          <a:p>
+            <a:pPr lvl="0" indent="0" marL="0">
+              <a:buNone/>
+            </a:pPr>
+            <a:r>
+              <a:rPr sz="3200"/>
+              <a:t>Algorithms Parallel and Sequential (APAS)</a:t>
+            </a:r>
+          </a:p>
+        </p:txBody>
+      </p:sp>
+      <p:sp>
+        <p:nvSpPr>
+          <p:cNvPr id="3" name="Content Placeholder 2"/>
+          <p:cNvSpPr>
+            <a:spLocks noGrp="1"/>
+          </p:cNvSpPr>
+          <p:nvPr>
+            <p:ph idx="1"/>
+          </p:nvPr>
+        </p:nvSpPr>
+        <p:spPr/>
+        <p:txBody>
+          <a:bodyPr/>
+          <a:lstStyle/>
+          <a:p>
+            <a:pPr lvl="0"/>
+            <a:r>
+              <a:rPr sz="1800"/>
+              <a:t>I needed a practical, fairly large, very difficult task to learn Verus.</a:t>
+            </a:r>
+          </a:p>
+          <a:p>
+            <a:pPr lvl="0"/>
+            <a:r>
+              <a:rPr sz="1800"/>
+              <a:t>Rocq and F* are good but complicated and I’ve only manually proven in them.</a:t>
+            </a:r>
+          </a:p>
+          <a:p>
+            <a:pPr lvl="0"/>
+            <a:r>
+              <a:rPr sz="1800"/>
+              <a:t>In fact some of the F* group went to work on Verus due to the requirement of ‘heroic proof’.</a:t>
+            </a:r>
+          </a:p>
+          <a:p>
+            <a:pPr lvl="0"/>
+            <a:r>
+              <a:rPr sz="1800"/>
+              <a:t>But I just missed the Pulse, so I suspect things are quite different now, except for the language gap and generation.</a:t>
+            </a:r>
+          </a:p>
+        </p:txBody>
+      </p:sp>
+    </p:spTree>
+  </p:cSld>
+</p:sld>
+</file>
+
+<file path=ppt/slides/slide50.xml><?xml version="1.0" encoding="utf-8"?>
+<p:sld xmlns:a="http://schemas.openxmlformats.org/drawingml/2006/main" xmlns:r="http://schemas.openxmlformats.org/officeDocument/2006/relationships" xmlns:p="http://schemas.openxmlformats.org/presentationml/2006/main">
+  <p:cSld>
+    <p:spTree>
+      <p:nvGrpSpPr>
+        <p:cNvPr id="1" name=""/>
+        <p:cNvGrpSpPr/>
+        <p:nvPr/>
+      </p:nvGrpSpPr>
+      <p:grpSpPr>
+        <a:xfrm>
+          <a:off x="0" y="0"/>
+          <a:ext cx="0" cy="0"/>
+          <a:chOff x="0" y="0"/>
+          <a:chExt cx="0" cy="0"/>
+        </a:xfrm>
+      </p:grpSpPr>
+      <p:sp>
+        <p:nvSpPr>
+          <p:cNvPr id="2" name="Title 1"/>
+          <p:cNvSpPr>
+            <a:spLocks noGrp="1"/>
+          </p:cNvSpPr>
+          <p:nvPr>
+            <p:ph type="title"/>
+          </p:nvPr>
+        </p:nvSpPr>
+        <p:spPr/>
+        <p:txBody>
+          <a:bodyPr/>
+          <a:lstStyle/>
+          <a:p>
+            <a:pPr lvl="0" indent="0" marL="0">
+              <a:buNone/>
+            </a:pPr>
+            <a:r>
+              <a:rPr sz="3200"/>
               <a:t>Proof Holes Over Time — R20 to R201</a:t>
             </a:r>
           </a:p>
@@ -7928,8 +8341,8 @@
         </p:blipFill>
         <p:spPr bwMode="auto">
           <a:xfrm>
-            <a:off x="1460500" y="1193800"/>
-            <a:ext cx="6223000" cy="3390900"/>
+            <a:off x="1435100" y="1193800"/>
+            <a:ext cx="6273800" cy="3390900"/>
           </a:xfrm>
           <a:prstGeom prst="rect">
             <a:avLst/>
@@ -7947,7 +8360,7 @@
 </p:sld>
 </file>
 
-<file path=ppt/slides/slide48.xml><?xml version="1.0" encoding="utf-8"?>
+<file path=ppt/slides/slide51.xml><?xml version="1.0" encoding="utf-8"?>
 <p:sld xmlns:a="http://schemas.openxmlformats.org/drawingml/2006/main" xmlns:r="http://schemas.openxmlformats.org/officeDocument/2006/relationships" xmlns:p="http://schemas.openxmlformats.org/presentationml/2006/main">
   <p:cSld>
     <p:spTree>
@@ -8024,366 +8437,6 @@
 </p:sld>
 </file>
 
-<file path=ppt/slides/slide49.xml><?xml version="1.0" encoding="utf-8"?>
-<p:sld xmlns:a="http://schemas.openxmlformats.org/drawingml/2006/main" xmlns:r="http://schemas.openxmlformats.org/officeDocument/2006/relationships" xmlns:p="http://schemas.openxmlformats.org/presentationml/2006/main">
-  <p:cSld>
-    <p:spTree>
-      <p:nvGrpSpPr>
-        <p:cNvPr id="1" name=""/>
-        <p:cNvGrpSpPr/>
-        <p:nvPr/>
-      </p:nvGrpSpPr>
-      <p:grpSpPr>
-        <a:xfrm>
-          <a:off x="0" y="0"/>
-          <a:ext cx="0" cy="0"/>
-          <a:chOff x="0" y="0"/>
-          <a:chExt cx="0" cy="0"/>
-        </a:xfrm>
-      </p:grpSpPr>
-      <p:sp>
-        <p:nvSpPr>
-          <p:cNvPr id="3" name="Content Placeholder 2"/>
-          <p:cNvSpPr>
-            <a:spLocks noGrp="1"/>
-          </p:cNvSpPr>
-          <p:nvPr>
-            <p:ph idx="1"/>
-          </p:nvPr>
-        </p:nvSpPr>
-        <p:spPr/>
-        <p:txBody>
-          <a:bodyPr/>
-          <a:lstStyle/>
-          <a:p>
-            <a:pPr lvl="0"/>
-            <a:r>
-              <a:rPr sz="1800"/>
-              <a:t>Three levers: minimize-proofs, profiling (find matching loops), opaque (hide definitions).</a:t>
-            </a:r>
-          </a:p>
-          <a:p>
-            <a:pPr lvl="0"/>
-            <a:r>
-              <a:rPr sz="1800"/>
-              <a:t>OrderedTableMtEph: −57% proof time after minimize-proofs (R176).</a:t>
-            </a:r>
-          </a:p>
-          <a:p>
-            <a:pPr lvl="0"/>
-            <a:r>
-              <a:rPr sz="1800"/>
-              <a:t>UnionFindPCStEph: 139K Z3 instantiations → 0 after opaque pattern (R195).</a:t>
-            </a:r>
-          </a:p>
-          <a:p>
-            <a:pPr lvl="0"/>
-            <a:r>
-              <a:rPr sz="1800"/>
-              <a:t>Johnson Chap59: 756 MB → 520 MB (−31%) memory reduction.</a:t>
-            </a:r>
-          </a:p>
-        </p:txBody>
-      </p:sp>
-    </p:spTree>
-  </p:cSld>
-</p:sld>
-</file>
-
-<file path=ppt/slides/slide5.xml><?xml version="1.0" encoding="utf-8"?>
-<p:sld xmlns:a="http://schemas.openxmlformats.org/drawingml/2006/main" xmlns:r="http://schemas.openxmlformats.org/officeDocument/2006/relationships" xmlns:p="http://schemas.openxmlformats.org/presentationml/2006/main">
-  <p:cSld>
-    <p:spTree>
-      <p:nvGrpSpPr>
-        <p:cNvPr id="1" name=""/>
-        <p:cNvGrpSpPr/>
-        <p:nvPr/>
-      </p:nvGrpSpPr>
-      <p:grpSpPr>
-        <a:xfrm>
-          <a:off x="0" y="0"/>
-          <a:ext cx="0" cy="0"/>
-          <a:chOff x="0" y="0"/>
-          <a:chExt cx="0" cy="0"/>
-        </a:xfrm>
-      </p:grpSpPr>
-      <p:sp>
-        <p:nvSpPr>
-          <p:cNvPr id="2" name="Title 1"/>
-          <p:cNvSpPr>
-            <a:spLocks noGrp="1"/>
-          </p:cNvSpPr>
-          <p:nvPr>
-            <p:ph type="title"/>
-          </p:nvPr>
-        </p:nvSpPr>
-        <p:spPr/>
-        <p:txBody>
-          <a:bodyPr/>
-          <a:lstStyle/>
-          <a:p>
-            <a:pPr lvl="0" indent="0" marL="0">
-              <a:buNone/>
-            </a:pPr>
-            <a:r>
-              <a:rPr sz="3200"/>
-              <a:t>Algorithms Parallel and Sequential (APAS)</a:t>
-            </a:r>
-          </a:p>
-        </p:txBody>
-      </p:sp>
-      <p:sp>
-        <p:nvSpPr>
-          <p:cNvPr id="3" name="Content Placeholder 2"/>
-          <p:cNvSpPr>
-            <a:spLocks noGrp="1"/>
-          </p:cNvSpPr>
-          <p:nvPr>
-            <p:ph idx="1"/>
-          </p:nvPr>
-        </p:nvSpPr>
-        <p:spPr/>
-        <p:txBody>
-          <a:bodyPr/>
-          <a:lstStyle/>
-          <a:p>
-            <a:pPr lvl="0"/>
-            <a:r>
-              <a:rPr sz="1800"/>
-              <a:t>I needed a practical, fairly large, very difficult task to learn Verus.</a:t>
-            </a:r>
-          </a:p>
-          <a:p>
-            <a:pPr lvl="0"/>
-            <a:r>
-              <a:rPr sz="1800"/>
-              <a:t>Rocq is good but complicated and slow and I had used it manually and it’s not close the the PL.</a:t>
-            </a:r>
-          </a:p>
-          <a:p>
-            <a:pPr lvl="0"/>
-            <a:r>
-              <a:rPr sz="1800"/>
-              <a:t>F* is good, but complicated slow and I had used it manually, close to the PL but far from a practical PL and generates code.</a:t>
-            </a:r>
-          </a:p>
-          <a:p>
-            <a:pPr lvl="0"/>
-            <a:r>
-              <a:rPr sz="1800"/>
-              <a:t>In fact some of the F* group went to work on Verus due to the requirement of ‘heroic proof’.</a:t>
-            </a:r>
-          </a:p>
-          <a:p>
-            <a:pPr lvl="0"/>
-            <a:r>
-              <a:rPr sz="1800"/>
-              <a:t>But I just missed the Pulse, so I suspect things are quite different now, except for the language gap and generation.</a:t>
-            </a:r>
-          </a:p>
-        </p:txBody>
-      </p:sp>
-    </p:spTree>
-  </p:cSld>
-</p:sld>
-</file>
-
-<file path=ppt/slides/slide50.xml><?xml version="1.0" encoding="utf-8"?>
-<p:sld xmlns:a="http://schemas.openxmlformats.org/drawingml/2006/main" xmlns:r="http://schemas.openxmlformats.org/officeDocument/2006/relationships" xmlns:p="http://schemas.openxmlformats.org/presentationml/2006/main">
-  <p:cSld>
-    <p:spTree>
-      <p:nvGrpSpPr>
-        <p:cNvPr id="1" name=""/>
-        <p:cNvGrpSpPr/>
-        <p:nvPr/>
-      </p:nvGrpSpPr>
-      <p:grpSpPr>
-        <a:xfrm>
-          <a:off x="0" y="0"/>
-          <a:ext cx="0" cy="0"/>
-          <a:chOff x="0" y="0"/>
-          <a:chExt cx="0" cy="0"/>
-        </a:xfrm>
-      </p:grpSpPr>
-      <p:sp>
-        <p:nvSpPr>
-          <p:cNvPr id="2" name="Title 1"/>
-          <p:cNvSpPr>
-            <a:spLocks noGrp="1"/>
-          </p:cNvSpPr>
-          <p:nvPr>
-            <p:ph type="title"/>
-          </p:nvPr>
-        </p:nvSpPr>
-        <p:spPr/>
-        <p:txBody>
-          <a:bodyPr/>
-          <a:lstStyle/>
-          <a:p>
-            <a:pPr lvl="0" indent="0" marL="0">
-              <a:buNone/>
-            </a:pPr>
-            <a:r>
-              <a:rPr sz="3200"/>
-              <a:t>Software Engineering in AI Paired Proving</a:t>
-            </a:r>
-          </a:p>
-        </p:txBody>
-      </p:sp>
-      <p:sp>
-        <p:nvSpPr>
-          <p:cNvPr id="3" name="Content Placeholder 2"/>
-          <p:cNvSpPr>
-            <a:spLocks noGrp="1"/>
-          </p:cNvSpPr>
-          <p:nvPr>
-            <p:ph idx="1"/>
-          </p:nvPr>
-        </p:nvSpPr>
-        <p:spPr/>
-        <p:txBody>
-          <a:bodyPr/>
-          <a:lstStyle/>
-          <a:p>
-            <a:pPr lvl="0"/>
-            <a:r>
-              <a:rPr sz="1800"/>
-              <a:t>Software engineering in the AI age is much like managing programmers.</a:t>
-            </a:r>
-          </a:p>
-          <a:p>
-            <a:pPr lvl="0"/>
-            <a:r>
-              <a:rPr sz="1800"/>
-              <a:t>You can’t possibly read all their code.</a:t>
-            </a:r>
-          </a:p>
-          <a:p>
-            <a:pPr lvl="0"/>
-            <a:r>
-              <a:rPr sz="1800"/>
-              <a:t>So you have:</a:t>
-            </a:r>
-          </a:p>
-          <a:p>
-            <a:pPr lvl="0"/>
-            <a:r>
-              <a:rPr sz="1800"/>
-              <a:t>linters both programmatic and AI</a:t>
-            </a:r>
-          </a:p>
-          <a:p>
-            <a:pPr lvl="0"/>
-            <a:r>
-              <a:rPr sz="1800"/>
-              <a:t>stylers both programmatic and AI</a:t>
-            </a:r>
-          </a:p>
-          <a:p>
-            <a:pPr lvl="0"/>
-            <a:r>
-              <a:rPr sz="1800"/>
-              <a:t>AI reviews directed by programmatic.</a:t>
-            </a:r>
-          </a:p>
-        </p:txBody>
-      </p:sp>
-    </p:spTree>
-  </p:cSld>
-</p:sld>
-</file>
-
-<file path=ppt/slides/slide51.xml><?xml version="1.0" encoding="utf-8"?>
-<p:sld xmlns:a="http://schemas.openxmlformats.org/drawingml/2006/main" xmlns:r="http://schemas.openxmlformats.org/officeDocument/2006/relationships" xmlns:p="http://schemas.openxmlformats.org/presentationml/2006/main">
-  <p:cSld>
-    <p:spTree>
-      <p:nvGrpSpPr>
-        <p:cNvPr id="1" name=""/>
-        <p:cNvGrpSpPr/>
-        <p:nvPr/>
-      </p:nvGrpSpPr>
-      <p:grpSpPr>
-        <a:xfrm>
-          <a:off x="0" y="0"/>
-          <a:ext cx="0" cy="0"/>
-          <a:chOff x="0" y="0"/>
-          <a:chExt cx="0" cy="0"/>
-        </a:xfrm>
-      </p:grpSpPr>
-      <p:sp>
-        <p:nvSpPr>
-          <p:cNvPr id="2" name="Title 1"/>
-          <p:cNvSpPr>
-            <a:spLocks noGrp="1"/>
-          </p:cNvSpPr>
-          <p:nvPr>
-            <p:ph type="title"/>
-          </p:nvPr>
-        </p:nvSpPr>
-        <p:spPr/>
-        <p:txBody>
-          <a:bodyPr/>
-          <a:lstStyle/>
-          <a:p>
-            <a:pPr lvl="0" indent="0" marL="0">
-              <a:buNone/>
-            </a:pPr>
-            <a:r>
-              <a:rPr sz="3200"/>
-              <a:t>Software Engineering in AI Paired Proving</a:t>
-            </a:r>
-          </a:p>
-        </p:txBody>
-      </p:sp>
-      <p:sp>
-        <p:nvSpPr>
-          <p:cNvPr id="3" name="Content Placeholder 2"/>
-          <p:cNvSpPr>
-            <a:spLocks noGrp="1"/>
-          </p:cNvSpPr>
-          <p:nvPr>
-            <p:ph idx="1"/>
-          </p:nvPr>
-        </p:nvSpPr>
-        <p:spPr/>
-        <p:txBody>
-          <a:bodyPr/>
-          <a:lstStyle/>
-          <a:p>
-            <a:pPr lvl="0"/>
-            <a:r>
-              <a:rPr sz="1800"/>
-              <a:t>Starting with a textbook that has a ton of good prose is a huge plus.</a:t>
-            </a:r>
-          </a:p>
-          <a:p>
-            <a:pPr lvl="0"/>
-            <a:r>
-              <a:rPr sz="1800"/>
-              <a:t>I did discover a few things about the textbook.</a:t>
-            </a:r>
-          </a:p>
-          <a:p>
-            <a:pPr lvl="0"/>
-            <a:r>
-              <a:rPr sz="1800"/>
-              <a:t>It needs more on Scheduling. I only built Help-First scheduling.</a:t>
-            </a:r>
-          </a:p>
-          <a:p>
-            <a:pPr lvl="0"/>
-            <a:r>
-              <a:rPr sz="1800"/>
-              <a:t>It used (K,V) in tree sets as mappings, but I had to make this explicit. Particularly with an Ordered Key Mapping.</a:t>
-            </a:r>
-          </a:p>
-        </p:txBody>
-      </p:sp>
-    </p:spTree>
-  </p:cSld>
-</p:sld>
-</file>
-
 <file path=ppt/slides/slide52.xml><?xml version="1.0" encoding="utf-8"?>
 <p:sld xmlns:a="http://schemas.openxmlformats.org/drawingml/2006/main" xmlns:r="http://schemas.openxmlformats.org/officeDocument/2006/relationships" xmlns:p="http://schemas.openxmlformats.org/presentationml/2006/main">
   <p:cSld>
@@ -8403,31 +8456,6 @@
       </p:grpSpPr>
       <p:sp>
         <p:nvSpPr>
-          <p:cNvPr id="2" name="Title 1"/>
-          <p:cNvSpPr>
-            <a:spLocks noGrp="1"/>
-          </p:cNvSpPr>
-          <p:nvPr>
-            <p:ph type="title"/>
-          </p:nvPr>
-        </p:nvSpPr>
-        <p:spPr/>
-        <p:txBody>
-          <a:bodyPr/>
-          <a:lstStyle/>
-          <a:p>
-            <a:pPr lvl="0" indent="0" marL="0">
-              <a:buNone/>
-            </a:pPr>
-            <a:r>
-              <a:rPr sz="3200"/>
-              <a:t>Software Engineering in AI Paired Proving</a:t>
-            </a:r>
-          </a:p>
-        </p:txBody>
-      </p:sp>
-      <p:sp>
-        <p:nvSpPr>
           <p:cNvPr id="3" name="Content Placeholder 2"/>
           <p:cNvSpPr>
             <a:spLocks noGrp="1"/>
@@ -8444,21 +8472,28 @@
             <a:pPr lvl="0"/>
             <a:r>
               <a:rPr sz="1800"/>
-              <a:t>APAS’s discussion of Union Find was too thin.</a:t>
-            </a:r>
-          </a:p>
-          <a:p>
-            <a:pPr lvl="0"/>
-            <a:r>
-              <a:rPr sz="1800"/>
-              <a:t>Path compression was very difficult.</a:t>
-            </a:r>
-          </a:p>
-          <a:p>
-            <a:pPr lvl="0"/>
-            <a:r>
-              <a:rPr sz="1800"/>
-              <a:t>I had to start with Nikhil Swammy et. al’s AlgoStar’s implemention and proofs.</a:t>
+              <a:t>Three levers: minimize-proofs, profiling (find matching loops), opaque (hide definitions).</a:t>
+            </a:r>
+          </a:p>
+          <a:p>
+            <a:pPr lvl="0"/>
+            <a:r>
+              <a:rPr sz="1800"/>
+              <a:t>OrderedTableMtEph: −57% proof time after minimize-proofs (R176).</a:t>
+            </a:r>
+          </a:p>
+          <a:p>
+            <a:pPr lvl="0"/>
+            <a:r>
+              <a:rPr sz="1800"/>
+              <a:t>UnionFindPCStEph: 139K Z3 instantiations → 0 after opaque pattern (R195).</a:t>
+            </a:r>
+          </a:p>
+          <a:p>
+            <a:pPr lvl="0"/>
+            <a:r>
+              <a:rPr sz="1800"/>
+              <a:t>Johnson Chap59: 756 MB → 520 MB (−31%) memory reduction.</a:t>
             </a:r>
           </a:p>
         </p:txBody>
@@ -8528,70 +8563,42 @@
             <a:pPr lvl="0"/>
             <a:r>
               <a:rPr sz="1800"/>
-              <a:t>I use git work trees for proof.</a:t>
-            </a:r>
-          </a:p>
-          <a:p>
-            <a:pPr lvl="0"/>
-            <a:r>
-              <a:rPr sz="1800"/>
-              <a:t>The good news is git is powerful and the agents understand it.</a:t>
-            </a:r>
-          </a:p>
-          <a:p>
-            <a:pPr lvl="0"/>
-            <a:r>
-              <a:rPr sz="1800"/>
-              <a:t>The bad news is the agents can indeed start using advanced features and get things wrong.</a:t>
-            </a:r>
-          </a:p>
-          <a:p>
-            <a:pPr lvl="0"/>
-            <a:r>
-              <a:rPr sz="1800"/>
-              <a:t>I work with between 1 and 9 agents.</a:t>
-            </a:r>
-          </a:p>
-          <a:p>
-            <a:pPr lvl="0"/>
-            <a:r>
-              <a:rPr sz="1800"/>
-              <a:t>One on veracity.</a:t>
-            </a:r>
-          </a:p>
-          <a:p>
-            <a:pPr lvl="0"/>
-            <a:r>
-              <a:rPr sz="1800"/>
-              <a:t>One orchestrator, writing plan prompts and controlling merges.</a:t>
-            </a:r>
-          </a:p>
-          <a:p>
-            <a:pPr lvl="0"/>
-            <a:r>
-              <a:rPr sz="1800"/>
-              <a:t>1-8 on branches each working on different independent plans.</a:t>
-            </a:r>
-          </a:p>
-          <a:p>
-            <a:pPr lvl="0"/>
-            <a:r>
-              <a:rPr sz="1800"/>
-              <a:t>I am not nearly comfortable enough with agent proof to let them do subagents without observing.</a:t>
-            </a:r>
-          </a:p>
-          <a:p>
-            <a:pPr lvl="0"/>
-            <a:r>
-              <a:rPr sz="1800"/>
-              <a:t>Cursor was much better at interruption to guide things.</a:t>
-            </a:r>
-          </a:p>
-          <a:p>
-            <a:pPr lvl="0"/>
-            <a:r>
-              <a:rPr sz="1800"/>
-              <a:t>Claude is getting better at it.</a:t>
+              <a:t>Software engineering in the AI age is much like managing programmers.</a:t>
+            </a:r>
+          </a:p>
+          <a:p>
+            <a:pPr lvl="0"/>
+            <a:r>
+              <a:rPr sz="1800"/>
+              <a:t>You can’t possibly read all their code.</a:t>
+            </a:r>
+          </a:p>
+          <a:p>
+            <a:pPr lvl="0"/>
+            <a:r>
+              <a:rPr sz="1800"/>
+              <a:t>So you have:</a:t>
+            </a:r>
+          </a:p>
+          <a:p>
+            <a:pPr lvl="0"/>
+            <a:r>
+              <a:rPr sz="1800"/>
+              <a:t>linters both programmatic and AI</a:t>
+            </a:r>
+          </a:p>
+          <a:p>
+            <a:pPr lvl="0"/>
+            <a:r>
+              <a:rPr sz="1800"/>
+              <a:t>stylers both programmatic and AI</a:t>
+            </a:r>
+          </a:p>
+          <a:p>
+            <a:pPr lvl="0"/>
+            <a:r>
+              <a:rPr sz="1800"/>
+              <a:t>AI reviews directed by programmatic.</a:t>
             </a:r>
           </a:p>
         </p:txBody>
@@ -8638,7 +8645,7 @@
             </a:pPr>
             <a:r>
               <a:rPr sz="3200"/>
-              <a:t>Software Engineering in AI Paired Proving- Models</a:t>
+              <a:t>Software Engineering in AI Paired Proving</a:t>
             </a:r>
           </a:p>
         </p:txBody>
@@ -8661,56 +8668,42 @@
             <a:pPr lvl="0"/>
             <a:r>
               <a:rPr sz="1800"/>
-              <a:t>The agents I used are: various Google, OpenAI and Anthropic.</a:t>
-            </a:r>
-          </a:p>
-          <a:p>
-            <a:pPr lvl="0"/>
-            <a:r>
-              <a:rPr sz="1800"/>
-              <a:t>A google agent once took 12 minutes to ‘echo HI’ to test it’s terminal.</a:t>
-            </a:r>
-          </a:p>
-          <a:p>
-            <a:pPr lvl="0"/>
-            <a:r>
-              <a:rPr sz="1800"/>
-              <a:t>Anthropics models are signficantly better than OpenAI.</a:t>
-            </a:r>
-          </a:p>
-          <a:p>
-            <a:pPr lvl="0"/>
-            <a:r>
-              <a:rPr sz="1800"/>
-              <a:t>And Claude Code’s cost is the least so far.</a:t>
-            </a:r>
-          </a:p>
-          <a:p>
-            <a:pPr lvl="0"/>
-            <a:r>
-              <a:rPr sz="1800"/>
-              <a:t>They are said in the press to be spending $5000 per month per user.</a:t>
-            </a:r>
-          </a:p>
-          <a:p>
-            <a:pPr lvl="0"/>
-            <a:r>
-              <a:rPr sz="1800"/>
-              <a:t>They are buying market share (what happened to Amazon’s buying market share phase?).</a:t>
-            </a:r>
-          </a:p>
-          <a:p>
-            <a:pPr lvl="0"/>
-            <a:r>
-              <a:rPr sz="1800"/>
-              <a:t>And they are buying coding interactions.</a:t>
-            </a:r>
-          </a:p>
-          <a:p>
-            <a:pPr lvl="0"/>
-            <a:r>
-              <a:rPr sz="1800"/>
-              <a:t>But both vendors are playing leap frog.</a:t>
+              <a:t>Starting with a textbook that has a ton of good prose is a huge plus.</a:t>
+            </a:r>
+          </a:p>
+          <a:p>
+            <a:pPr lvl="0"/>
+            <a:r>
+              <a:rPr sz="1800"/>
+              <a:t>I did discover a few things about the textbook.</a:t>
+            </a:r>
+          </a:p>
+          <a:p>
+            <a:pPr lvl="0"/>
+            <a:r>
+              <a:rPr sz="1800"/>
+              <a:t>It needs more on Scheduling. I only built Help-First scheduling.</a:t>
+            </a:r>
+          </a:p>
+          <a:p>
+            <a:pPr lvl="0"/>
+            <a:r>
+              <a:rPr sz="1800"/>
+              <a:t>It used (K,V) in tree sets as mappings, but I had to make this explicit. Particularly with an Ordered Key Mapping.</a:t>
+            </a:r>
+          </a:p>
+          <a:p>
+            <a:pPr lvl="0"/>
+            <a:r>
+              <a:rPr sz="1800"/>
+              <a:t>APAS’s discussion of Union Find was too thin. Path compression was very difficult.</a:t>
+            </a:r>
+          </a:p>
+          <a:p>
+            <a:pPr lvl="0"/>
+            <a:r>
+              <a:rPr sz="1800"/>
+              <a:t>I had to start with Nikhil Swammy et. al’s AlgoCLRS’s implemention and proofs.</a:t>
             </a:r>
           </a:p>
         </p:txBody>
@@ -8757,7 +8750,7 @@
             </a:pPr>
             <a:r>
               <a:rPr sz="3200"/>
-              <a:t>Software Engineering in AI Paired Proving- Problems</a:t>
+              <a:t>Software Engineering in AI Paired Proving</a:t>
             </a:r>
           </a:p>
         </p:txBody>
@@ -8780,49 +8773,70 @@
             <a:pPr lvl="0"/>
             <a:r>
               <a:rPr sz="1800"/>
-              <a:t>They are inconsistent.</a:t>
-            </a:r>
-          </a:p>
-          <a:p>
-            <a:pPr lvl="0"/>
-            <a:r>
-              <a:rPr sz="1800"/>
-              <a:t>They lie.</a:t>
-            </a:r>
-          </a:p>
-          <a:p>
-            <a:pPr lvl="0"/>
-            <a:r>
-              <a:rPr sz="1800"/>
-              <a:t>They cheat.</a:t>
-            </a:r>
-          </a:p>
-          <a:p>
-            <a:pPr lvl="0"/>
-            <a:r>
-              <a:rPr sz="1800"/>
-              <a:t>They err.</a:t>
-            </a:r>
-          </a:p>
-          <a:p>
-            <a:pPr lvl="0"/>
-            <a:r>
-              <a:rPr sz="1800"/>
-              <a:t>But mostly they are just forgetful.</a:t>
-            </a:r>
-          </a:p>
-          <a:p>
-            <a:pPr lvl="0"/>
-            <a:r>
-              <a:rPr sz="1800"/>
-              <a:t>My attempts to give them coding standard checklists, ala Watts Humphrey and the PSP failed.</a:t>
-            </a:r>
-          </a:p>
-          <a:p>
-            <a:pPr lvl="0"/>
-            <a:r>
-              <a:rPr sz="1800"/>
-              <a:t>Sometimes they would say “The checklist was followed” and then admit “I lied.”</a:t>
+              <a:t>I use git work trees for proof.</a:t>
+            </a:r>
+          </a:p>
+          <a:p>
+            <a:pPr lvl="0"/>
+            <a:r>
+              <a:rPr sz="1800"/>
+              <a:t>The good news is git is powerful and the agents understand it.</a:t>
+            </a:r>
+          </a:p>
+          <a:p>
+            <a:pPr lvl="0"/>
+            <a:r>
+              <a:rPr sz="1800"/>
+              <a:t>The bad news is the agents can indeed start using advanced features and get things wrong.</a:t>
+            </a:r>
+          </a:p>
+          <a:p>
+            <a:pPr lvl="0"/>
+            <a:r>
+              <a:rPr sz="1800"/>
+              <a:t>I work with between 1 and 9 agents.</a:t>
+            </a:r>
+          </a:p>
+          <a:p>
+            <a:pPr lvl="0"/>
+            <a:r>
+              <a:rPr sz="1800"/>
+              <a:t>One on veracity.</a:t>
+            </a:r>
+          </a:p>
+          <a:p>
+            <a:pPr lvl="0"/>
+            <a:r>
+              <a:rPr sz="1800"/>
+              <a:t>One orchestrator, writing plan prompts and controlling merges.</a:t>
+            </a:r>
+          </a:p>
+          <a:p>
+            <a:pPr lvl="0"/>
+            <a:r>
+              <a:rPr sz="1800"/>
+              <a:t>1-8 on branches each working on different independent plans.</a:t>
+            </a:r>
+          </a:p>
+          <a:p>
+            <a:pPr lvl="0"/>
+            <a:r>
+              <a:rPr sz="1800"/>
+              <a:t>I am not nearly comfortable enough with agent proof to let them do subagents without observing.</a:t>
+            </a:r>
+          </a:p>
+          <a:p>
+            <a:pPr lvl="0"/>
+            <a:r>
+              <a:rPr sz="1800"/>
+              <a:t>Cursor was much better at interruption to guide things.</a:t>
+            </a:r>
+          </a:p>
+          <a:p>
+            <a:pPr lvl="0"/>
+            <a:r>
+              <a:rPr sz="1800"/>
+              <a:t>Claude is getting better at it.</a:t>
             </a:r>
           </a:p>
         </p:txBody>
@@ -8869,7 +8883,7 @@
             </a:pPr>
             <a:r>
               <a:rPr sz="3200"/>
-              <a:t>Software Engineering in AI Paired Proving- Problems</a:t>
+              <a:t>Software Engineering in AI Paired Proving- Models</a:t>
             </a:r>
           </a:p>
         </p:txBody>
@@ -8892,49 +8906,56 @@
             <a:pPr lvl="0"/>
             <a:r>
               <a:rPr sz="1800"/>
-              <a:t>They are getting better.</a:t>
-            </a:r>
-          </a:p>
-          <a:p>
-            <a:pPr lvl="0"/>
-            <a:r>
-              <a:rPr sz="1800"/>
-              <a:t>If you tell them you are Dr. FunkenProof and they are Igor, they hallucinate whole modules.</a:t>
-            </a:r>
-          </a:p>
-          <a:p>
-            <a:pPr lvl="0"/>
-            <a:r>
-              <a:rPr sz="1800"/>
-              <a:t>Just a few months ago only Claude could sweep a codebase decently.</a:t>
-            </a:r>
-          </a:p>
-          <a:p>
-            <a:pPr lvl="0"/>
-            <a:r>
-              <a:rPr sz="1800"/>
-              <a:t>Now both Claude and OpenAI can.</a:t>
-            </a:r>
-          </a:p>
-          <a:p>
-            <a:pPr lvl="0"/>
-            <a:r>
-              <a:rPr sz="1800"/>
-              <a:t>And now they can prove like heck.</a:t>
-            </a:r>
-          </a:p>
-          <a:p>
-            <a:pPr lvl="0"/>
-            <a:r>
-              <a:rPr sz="1800"/>
-              <a:t>10x what I can do.</a:t>
-            </a:r>
-          </a:p>
-          <a:p>
-            <a:pPr lvl="0"/>
-            <a:r>
-              <a:rPr sz="1800"/>
-              <a:t>Claude wants $25 per code review now.</a:t>
+              <a:t>The agents I used are: various Google, OpenAI and Anthropic.</a:t>
+            </a:r>
+          </a:p>
+          <a:p>
+            <a:pPr lvl="0"/>
+            <a:r>
+              <a:rPr sz="1800"/>
+              <a:t>A google agent once took 12 minutes to ‘echo HI’ to test it’s terminal.</a:t>
+            </a:r>
+          </a:p>
+          <a:p>
+            <a:pPr lvl="0"/>
+            <a:r>
+              <a:rPr sz="1800"/>
+              <a:t>Anthropics models are signficantly better than OpenAI.</a:t>
+            </a:r>
+          </a:p>
+          <a:p>
+            <a:pPr lvl="0"/>
+            <a:r>
+              <a:rPr sz="1800"/>
+              <a:t>And Claude Code’s cost is the least so far.</a:t>
+            </a:r>
+          </a:p>
+          <a:p>
+            <a:pPr lvl="0"/>
+            <a:r>
+              <a:rPr sz="1800"/>
+              <a:t>They are said in the press to be spending $5000 per month per user.</a:t>
+            </a:r>
+          </a:p>
+          <a:p>
+            <a:pPr lvl="0"/>
+            <a:r>
+              <a:rPr sz="1800"/>
+              <a:t>They are buying market share (what happened to Amazon’s buying market share phase?).</a:t>
+            </a:r>
+          </a:p>
+          <a:p>
+            <a:pPr lvl="0"/>
+            <a:r>
+              <a:rPr sz="1800"/>
+              <a:t>And they are buying coding interactions.</a:t>
+            </a:r>
+          </a:p>
+          <a:p>
+            <a:pPr lvl="0"/>
+            <a:r>
+              <a:rPr sz="1800"/>
+              <a:t>But both vendors are playing leap frog.</a:t>
             </a:r>
           </a:p>
         </p:txBody>
@@ -9004,71 +9025,49 @@
             <a:pPr lvl="0"/>
             <a:r>
               <a:rPr sz="1800"/>
-              <a:t>What is the limiting factor now?</a:t>
-            </a:r>
-          </a:p>
-          <a:p>
-            <a:pPr lvl="0"/>
-            <a:r>
-              <a:rPr sz="1800"/>
-              <a:t>Code Review!</a:t>
-            </a:r>
-          </a:p>
-          <a:p>
-            <a:pPr lvl="0"/>
-            <a:r>
-              <a:rPr sz="1800"/>
-              <a:t>What can we do to simplify code review?</a:t>
-            </a:r>
-          </a:p>
-          <a:p>
-            <a:pPr lvl="0" indent="-342900" marL="342900">
-              <a:buAutoNum type="arabicPeriod"/>
-            </a:pPr>
-            <a:r>
-              <a:rPr sz="1800"/>
-              <a:t>Modularity - traits/impls in Verus.</a:t>
-            </a:r>
-          </a:p>
-          <a:p>
-            <a:pPr lvl="0" indent="-342900" marL="342900">
-              <a:buAutoNum startAt="2" type="arabicPeriod"/>
-            </a:pPr>
-            <a:r>
-              <a:rPr sz="1800"/>
-              <a:t>TOC - This organizes the boilerplate to make reading easier.</a:t>
-            </a:r>
-          </a:p>
-          <a:p>
-            <a:pPr lvl="0" indent="-342900" marL="342900">
-              <a:buAutoNum startAt="3" type="arabicPeriod"/>
-            </a:pPr>
-            <a:r>
-              <a:rPr sz="1800"/>
-              <a:t>Proof - I really just read the specs. If they’re right the code is right!</a:t>
-            </a:r>
-          </a:p>
-          <a:p>
-            <a:pPr lvl="0" indent="-342900" marL="342900">
-              <a:buAutoNum startAt="4" type="arabicPeriod"/>
-            </a:pPr>
-            <a:r>
-              <a:rPr sz="1800"/>
-              <a:t>Tests - are hugely useful when you don’t trust your coding team.</a:t>
-            </a:r>
-          </a:p>
-          <a:p>
-            <a:pPr lvl="0"/>
-            <a:r>
-              <a:rPr sz="1800"/>
-              <a:t>Will Nik et al. find spec problems when he Pulses APAS-VERUS? Almost certainly.</a:t>
-            </a:r>
-          </a:p>
-          <a:p>
-            <a:pPr lvl="0"/>
-            <a:r>
-              <a:rPr sz="1800"/>
-              <a:t>Will Nik et al. find proof problems? That’s a really good question.</a:t>
+              <a:t>They are inconsistent.</a:t>
+            </a:r>
+          </a:p>
+          <a:p>
+            <a:pPr lvl="0"/>
+            <a:r>
+              <a:rPr sz="1800"/>
+              <a:t>They lie.</a:t>
+            </a:r>
+          </a:p>
+          <a:p>
+            <a:pPr lvl="0"/>
+            <a:r>
+              <a:rPr sz="1800"/>
+              <a:t>They cheat.</a:t>
+            </a:r>
+          </a:p>
+          <a:p>
+            <a:pPr lvl="0"/>
+            <a:r>
+              <a:rPr sz="1800"/>
+              <a:t>They err.</a:t>
+            </a:r>
+          </a:p>
+          <a:p>
+            <a:pPr lvl="0"/>
+            <a:r>
+              <a:rPr sz="1800"/>
+              <a:t>But mostly they are just forgetful.</a:t>
+            </a:r>
+          </a:p>
+          <a:p>
+            <a:pPr lvl="0"/>
+            <a:r>
+              <a:rPr sz="1800"/>
+              <a:t>My attempts to give them coding standard checklists, ala Watts Humphrey and the PSP failed.</a:t>
+            </a:r>
+          </a:p>
+          <a:p>
+            <a:pPr lvl="0"/>
+            <a:r>
+              <a:rPr sz="1800"/>
+              <a:t>Sometimes they would say “The checklist was followed” and then admit “I lied.”</a:t>
             </a:r>
           </a:p>
         </p:txBody>
@@ -9115,7 +9114,7 @@
             </a:pPr>
             <a:r>
               <a:rPr sz="3200"/>
-              <a:t>The AI Paired Programming Interfaces</a:t>
+              <a:t>Software Engineering in AI Paired Proving- Problems</a:t>
             </a:r>
           </a:p>
         </p:txBody>
@@ -9138,63 +9137,49 @@
             <a:pPr lvl="0"/>
             <a:r>
               <a:rPr sz="1800"/>
-              <a:t>I have used web browers, yuck.</a:t>
-            </a:r>
-          </a:p>
-          <a:p>
-            <a:pPr lvl="0"/>
-            <a:r>
-              <a:rPr sz="1800"/>
-              <a:t>Cut/Paste is horrible.</a:t>
-            </a:r>
-          </a:p>
-          <a:p>
-            <a:pPr lvl="0"/>
-            <a:r>
-              <a:rPr sz="1800"/>
-              <a:t>I have used Cursor.</a:t>
-            </a:r>
-          </a:p>
-          <a:p>
-            <a:pPr lvl="0"/>
-            <a:r>
-              <a:rPr sz="1800"/>
-              <a:t>Based on VSCode.</a:t>
-            </a:r>
-          </a:p>
-          <a:p>
-            <a:pPr lvl="0"/>
-            <a:r>
-              <a:rPr sz="1800"/>
-              <a:t>Multiple windows - you can see your scripts run.</a:t>
-            </a:r>
-          </a:p>
-          <a:p>
-            <a:pPr lvl="0"/>
-            <a:r>
-              <a:rPr sz="1800"/>
-              <a:t>It collapses or elides thinking which is quite limiting.</a:t>
-            </a:r>
-          </a:p>
-          <a:p>
-            <a:pPr lvl="0"/>
-            <a:r>
-              <a:rPr sz="1800"/>
-              <a:t>It’s resale of AI LLM costs are terrible.</a:t>
-            </a:r>
-          </a:p>
-          <a:p>
-            <a:pPr lvl="0"/>
-            <a:r>
-              <a:rPr sz="1800"/>
-              <a:t>I ran up a $2500 bill one month.</a:t>
-            </a:r>
-          </a:p>
-          <a:p>
-            <a:pPr lvl="0"/>
-            <a:r>
-              <a:rPr sz="1800"/>
-              <a:t>It is decently interruptible so you can tune your instructions.</a:t>
+              <a:t>They are getting better.</a:t>
+            </a:r>
+          </a:p>
+          <a:p>
+            <a:pPr lvl="0"/>
+            <a:r>
+              <a:rPr sz="1800"/>
+              <a:t>If you tell them you are Dr. FunkenProof and they are Igor, they hallucinate whole modules.</a:t>
+            </a:r>
+          </a:p>
+          <a:p>
+            <a:pPr lvl="0"/>
+            <a:r>
+              <a:rPr sz="1800"/>
+              <a:t>Just a few months ago only Claude could sweep a codebase decently.</a:t>
+            </a:r>
+          </a:p>
+          <a:p>
+            <a:pPr lvl="0"/>
+            <a:r>
+              <a:rPr sz="1800"/>
+              <a:t>Now both Claude and OpenAI can.</a:t>
+            </a:r>
+          </a:p>
+          <a:p>
+            <a:pPr lvl="0"/>
+            <a:r>
+              <a:rPr sz="1800"/>
+              <a:t>And now they can prove like heck.</a:t>
+            </a:r>
+          </a:p>
+          <a:p>
+            <a:pPr lvl="0"/>
+            <a:r>
+              <a:rPr sz="1800"/>
+              <a:t>10x what I can do.</a:t>
+            </a:r>
+          </a:p>
+          <a:p>
+            <a:pPr lvl="0"/>
+            <a:r>
+              <a:rPr sz="1800"/>
+              <a:t>Claude wants $25 per code review now.</a:t>
             </a:r>
           </a:p>
         </p:txBody>
@@ -9241,7 +9226,7 @@
             </a:pPr>
             <a:r>
               <a:rPr sz="3200"/>
-              <a:t>The AI Paired Programming Interfaces</a:t>
+              <a:t>Software Engineering in AI Paired Proving- Problems</a:t>
             </a:r>
           </a:p>
         </p:txBody>
@@ -9264,49 +9249,71 @@
             <a:pPr lvl="0"/>
             <a:r>
               <a:rPr sz="1800"/>
-              <a:t>I have used Claude CLI</a:t>
-            </a:r>
-          </a:p>
-          <a:p>
-            <a:pPr lvl="0"/>
-            <a:r>
-              <a:rPr sz="1800"/>
-              <a:t>It has decided that a single window is all you need.</a:t>
-            </a:r>
-          </a:p>
-          <a:p>
-            <a:pPr lvl="0"/>
-            <a:r>
-              <a:rPr sz="1800"/>
-              <a:t>You can pop open and close some detail.</a:t>
-            </a:r>
-          </a:p>
-          <a:p>
-            <a:pPr lvl="0"/>
-            <a:r>
-              <a:rPr sz="1800"/>
-              <a:t>You can’t see thinking.</a:t>
-            </a:r>
-          </a:p>
-          <a:p>
-            <a:pPr lvl="0"/>
-            <a:r>
-              <a:rPr sz="1800"/>
-              <a:t>It is somewhat better inside emacs.</a:t>
-            </a:r>
-          </a:p>
-          <a:p>
-            <a:pPr lvl="0"/>
-            <a:r>
-              <a:rPr sz="1800"/>
-              <a:t>It clears your text in a variety of ways.</a:t>
-            </a:r>
-          </a:p>
-          <a:p>
-            <a:pPr lvl="0"/>
-            <a:r>
-              <a:rPr sz="1800"/>
-              <a:t>I have been told that VSCode’s DOM model is one of the reasont</a:t>
+              <a:t>What is the limiting factor now?</a:t>
+            </a:r>
+          </a:p>
+          <a:p>
+            <a:pPr lvl="0"/>
+            <a:r>
+              <a:rPr sz="1800"/>
+              <a:t>Code Review!</a:t>
+            </a:r>
+          </a:p>
+          <a:p>
+            <a:pPr lvl="0"/>
+            <a:r>
+              <a:rPr sz="1800"/>
+              <a:t>What can we do to simplify code review?</a:t>
+            </a:r>
+          </a:p>
+          <a:p>
+            <a:pPr lvl="0" indent="-342900" marL="342900">
+              <a:buAutoNum type="arabicPeriod"/>
+            </a:pPr>
+            <a:r>
+              <a:rPr sz="1800"/>
+              <a:t>Modularity - traits/impls in Verus.</a:t>
+            </a:r>
+          </a:p>
+          <a:p>
+            <a:pPr lvl="0" indent="-342900" marL="342900">
+              <a:buAutoNum startAt="2" type="arabicPeriod"/>
+            </a:pPr>
+            <a:r>
+              <a:rPr sz="1800"/>
+              <a:t>TOC - This organizes the boilerplate to make reading easier.</a:t>
+            </a:r>
+          </a:p>
+          <a:p>
+            <a:pPr lvl="0" indent="-342900" marL="342900">
+              <a:buAutoNum startAt="3" type="arabicPeriod"/>
+            </a:pPr>
+            <a:r>
+              <a:rPr sz="1800"/>
+              <a:t>Proof - I really just read the specs. If they’re right the code is right!</a:t>
+            </a:r>
+          </a:p>
+          <a:p>
+            <a:pPr lvl="0" indent="-342900" marL="342900">
+              <a:buAutoNum startAt="4" type="arabicPeriod"/>
+            </a:pPr>
+            <a:r>
+              <a:rPr sz="1800"/>
+              <a:t>Tests - are hugely useful when you don’t trust your coding team.</a:t>
+            </a:r>
+          </a:p>
+          <a:p>
+            <a:pPr lvl="0"/>
+            <a:r>
+              <a:rPr sz="1800"/>
+              <a:t>Will Nik et al. find spec problems when he Pulses APAS-VERUS? Almost certainly.</a:t>
+            </a:r>
+          </a:p>
+          <a:p>
+            <a:pPr lvl="0"/>
+            <a:r>
+              <a:rPr sz="1800"/>
+              <a:t>Will Nik et al. find proof problems? That’s a really good question.</a:t>
             </a:r>
           </a:p>
         </p:txBody>
@@ -9407,27 +9414,6 @@
               <a:t>740 concepts.</a:t>
             </a:r>
           </a:p>
-          <a:p>
-            <a:pPr lvl="0"/>
-            <a:r>
-              <a:rPr sz="1800"/>
-              <a:t>Similar to Swamy et al. and AIs implemented: “Introduction to Algorithms”</a:t>
-            </a:r>
-          </a:p>
-          <a:p>
-            <a:pPr lvl="0"/>
-            <a:r>
-              <a:rPr sz="1800"/>
-              <a:t>by Thomas H. Cormen, Charles E. Leiserson, Ronald L. Rivest</a:t>
-            </a:r>
-          </a:p>
-          <a:p>
-            <a:pPr lvl="0"/>
-            <a:r>
-              <a:rPr sz="1800"/>
-              <a:t>in Pulse, but bigger.</a:t>
-            </a:r>
-          </a:p>
         </p:txBody>
       </p:sp>
     </p:spTree>
@@ -9495,70 +9481,63 @@
             <a:pPr lvl="0"/>
             <a:r>
               <a:rPr sz="1800"/>
-              <a:t>What you want is pretty obvious with experience.</a:t>
-            </a:r>
-          </a:p>
-          <a:p>
-            <a:pPr lvl="0"/>
-            <a:r>
-              <a:rPr sz="1800"/>
-              <a:t>TEXT still rules.</a:t>
-            </a:r>
-          </a:p>
-          <a:p>
-            <a:pPr lvl="0"/>
-            <a:r>
-              <a:rPr sz="1800"/>
-              <a:t>You want one window with your core interaction. The agent tells you what it is doing in it.</a:t>
-            </a:r>
-          </a:p>
-          <a:p>
-            <a:pPr lvl="0"/>
-            <a:r>
-              <a:rPr sz="1800"/>
-              <a:t>You want one to watch your compile, tests and scripts.</a:t>
-            </a:r>
-          </a:p>
-          <a:p>
-            <a:pPr lvl="0"/>
-            <a:r>
-              <a:rPr sz="1800"/>
-              <a:t>You want one window to have the LLM show you it’s thinking.</a:t>
-            </a:r>
-          </a:p>
-          <a:p>
-            <a:pPr lvl="0"/>
-            <a:r>
-              <a:rPr sz="1800"/>
-              <a:t>I learned a ton from watching agents think.</a:t>
-            </a:r>
-          </a:p>
-          <a:p>
-            <a:pPr lvl="0"/>
-            <a:r>
-              <a:rPr sz="1800"/>
-              <a:t>You want on window to interact with it’s summaries.</a:t>
-            </a:r>
-          </a:p>
-          <a:p>
-            <a:pPr lvl="0"/>
-            <a:r>
-              <a:rPr sz="1800"/>
-              <a:t>I suspect they are hiding most of their thinking now to prevent them from being used to train new AIs.</a:t>
-            </a:r>
-          </a:p>
-          <a:p>
-            <a:pPr lvl="0"/>
-            <a:r>
-              <a:rPr sz="1800"/>
-              <a:t>Specifying and proving are harder, you want to be able to read its prompts, interrupt the thinking. Ask it questions. Give it directions.</a:t>
-            </a:r>
-          </a:p>
-          <a:p>
-            <a:pPr lvl="0"/>
-            <a:r>
-              <a:rPr sz="1800"/>
-              <a:t>And you want it not to delete your previous conversation on token compression.</a:t>
+              <a:t>I have used web browers, yuck.</a:t>
+            </a:r>
+          </a:p>
+          <a:p>
+            <a:pPr lvl="0"/>
+            <a:r>
+              <a:rPr sz="1800"/>
+              <a:t>Cut/Paste is horrible.</a:t>
+            </a:r>
+          </a:p>
+          <a:p>
+            <a:pPr lvl="0"/>
+            <a:r>
+              <a:rPr sz="1800"/>
+              <a:t>I have used Cursor.</a:t>
+            </a:r>
+          </a:p>
+          <a:p>
+            <a:pPr lvl="0"/>
+            <a:r>
+              <a:rPr sz="1800"/>
+              <a:t>Based on VSCode.</a:t>
+            </a:r>
+          </a:p>
+          <a:p>
+            <a:pPr lvl="0"/>
+            <a:r>
+              <a:rPr sz="1800"/>
+              <a:t>Multiple windows - you can see your scripts run.</a:t>
+            </a:r>
+          </a:p>
+          <a:p>
+            <a:pPr lvl="0"/>
+            <a:r>
+              <a:rPr sz="1800"/>
+              <a:t>It collapses or elides thinking which is quite limiting.</a:t>
+            </a:r>
+          </a:p>
+          <a:p>
+            <a:pPr lvl="0"/>
+            <a:r>
+              <a:rPr sz="1800"/>
+              <a:t>It’s resale of AI LLM costs are terrible.</a:t>
+            </a:r>
+          </a:p>
+          <a:p>
+            <a:pPr lvl="0"/>
+            <a:r>
+              <a:rPr sz="1800"/>
+              <a:t>I ran up a $2500 bill one month.</a:t>
+            </a:r>
+          </a:p>
+          <a:p>
+            <a:pPr lvl="0"/>
+            <a:r>
+              <a:rPr sz="1800"/>
+              <a:t>It is decently interruptible so you can tune your instructions.</a:t>
             </a:r>
           </a:p>
         </p:txBody>
@@ -9605,7 +9584,7 @@
             </a:pPr>
             <a:r>
               <a:rPr sz="3200"/>
-              <a:t>The Internet Apocalypse</a:t>
+              <a:t>The AI Paired Programming Interfaces</a:t>
             </a:r>
           </a:p>
         </p:txBody>
@@ -9628,42 +9607,42 @@
             <a:pPr lvl="0"/>
             <a:r>
               <a:rPr sz="1800"/>
-              <a:t>I asked Claude Code to check its switches on startup for me, at the End of Jan 2026.</a:t>
-            </a:r>
-          </a:p>
-          <a:p>
-            <a:pPr lvl="0"/>
-            <a:r>
-              <a:rPr sz="1800"/>
-              <a:t>It immediately started disassembling itself.</a:t>
-            </a:r>
-          </a:p>
-          <a:p>
-            <a:pPr lvl="0"/>
-            <a:r>
-              <a:rPr sz="1800"/>
-              <a:t>Scared the heck out of me.</a:t>
-            </a:r>
-          </a:p>
-          <a:p>
-            <a:pPr lvl="0"/>
-            <a:r>
-              <a:rPr sz="1800"/>
-              <a:t>I told it to read it’s docs.</a:t>
-            </a:r>
-          </a:p>
-          <a:p>
-            <a:pPr lvl="0"/>
-            <a:r>
-              <a:rPr sz="1800"/>
-              <a:t>I have 100% belief that these LLMs are moving faster than computer security.</a:t>
-            </a:r>
-          </a:p>
-          <a:p>
-            <a:pPr lvl="0"/>
-            <a:r>
-              <a:rPr sz="1800"/>
-              <a:t>It’s verify or die at this point.</a:t>
+              <a:t>I have used Claude CLI the most.</a:t>
+            </a:r>
+          </a:p>
+          <a:p>
+            <a:pPr lvl="0"/>
+            <a:r>
+              <a:rPr sz="1800"/>
+              <a:t>It has decided that a single window is all you need.</a:t>
+            </a:r>
+          </a:p>
+          <a:p>
+            <a:pPr lvl="0"/>
+            <a:r>
+              <a:rPr sz="1800"/>
+              <a:t>You can pop open and close some detail.</a:t>
+            </a:r>
+          </a:p>
+          <a:p>
+            <a:pPr lvl="0"/>
+            <a:r>
+              <a:rPr sz="1800"/>
+              <a:t>You can’t see thinking.</a:t>
+            </a:r>
+          </a:p>
+          <a:p>
+            <a:pPr lvl="0"/>
+            <a:r>
+              <a:rPr sz="1800"/>
+              <a:t>It is somewhat better inside emacs.</a:t>
+            </a:r>
+          </a:p>
+          <a:p>
+            <a:pPr lvl="0"/>
+            <a:r>
+              <a:rPr sz="1800"/>
+              <a:t>It clears your text in a variety of ways.</a:t>
             </a:r>
           </a:p>
         </p:txBody>
@@ -9710,7 +9689,7 @@
             </a:pPr>
             <a:r>
               <a:rPr sz="3200"/>
-              <a:t>The Internet Apocalypse</a:t>
+              <a:t>The AI Paired Programming Interfaces</a:t>
             </a:r>
           </a:p>
         </p:txBody>
@@ -9733,56 +9712,49 @@
             <a:pPr lvl="0"/>
             <a:r>
               <a:rPr sz="1800"/>
-              <a:t>Where should we focus our limited, but quickly growing, proving power?</a:t>
-            </a:r>
-          </a:p>
-          <a:p>
-            <a:pPr lvl="0"/>
-            <a:r>
-              <a:rPr sz="1800"/>
-              <a:t>In theory 70% of intrusions are solved by type safe languages.</a:t>
-            </a:r>
-          </a:p>
-          <a:p>
-            <a:pPr lvl="0"/>
-            <a:r>
-              <a:rPr sz="1800"/>
-              <a:t>I suspect that this just ignores way too much of the human aspect.</a:t>
-            </a:r>
-          </a:p>
-          <a:p>
-            <a:pPr lvl="0"/>
-            <a:r>
-              <a:rPr sz="1800"/>
-              <a:t>I have never liked a single estimation paper’s methods.</a:t>
-            </a:r>
-          </a:p>
-          <a:p>
-            <a:pPr lvl="0"/>
-            <a:r>
-              <a:rPr sz="1800"/>
-              <a:t>One way to help us focus our new-found superpowers is to survey LOC type-unsafe x Interfaces x Running Services x $ Value.</a:t>
-            </a:r>
-          </a:p>
-          <a:p>
-            <a:pPr lvl="0"/>
-            <a:r>
-              <a:rPr sz="1800"/>
-              <a:t>Inside MSFT you have the ability to measure inside Azure, the OS, the desktops, the browser use.</a:t>
-            </a:r>
-          </a:p>
-          <a:p>
-            <a:pPr lvl="0"/>
-            <a:r>
-              <a:rPr sz="1800"/>
-              <a:t>I think you should at this point, and NOT TELL ANYONE!</a:t>
-            </a:r>
-          </a:p>
-          <a:p>
-            <a:pPr lvl="0"/>
-            <a:r>
-              <a:rPr sz="1800"/>
-              <a:t>And use this cost risk model to evangelize for rapid change in MSFT products in a priority order.</a:t>
+              <a:t>What you want is pretty obvious with experience: TEXT still rules.</a:t>
+            </a:r>
+          </a:p>
+          <a:p>
+            <a:pPr lvl="0"/>
+            <a:r>
+              <a:rPr sz="1800"/>
+              <a:t>You want one window with your core interaction. The agent tells you what it is doing in it.</a:t>
+            </a:r>
+          </a:p>
+          <a:p>
+            <a:pPr lvl="0"/>
+            <a:r>
+              <a:rPr sz="1800"/>
+              <a:t>You want one to watch your compile, tests and scripts.</a:t>
+            </a:r>
+          </a:p>
+          <a:p>
+            <a:pPr lvl="0"/>
+            <a:r>
+              <a:rPr sz="1800"/>
+              <a:t>You want one window to have the LLM show you it’s thinking and allow you to question and change it.</a:t>
+            </a:r>
+          </a:p>
+          <a:p>
+            <a:pPr lvl="0"/>
+            <a:r>
+              <a:rPr sz="1800"/>
+              <a:t>I learned a ton from watching agents think.</a:t>
+            </a:r>
+          </a:p>
+          <a:p>
+            <a:pPr lvl="0"/>
+            <a:r>
+              <a:rPr sz="1800"/>
+              <a:t>I suspect they are hiding most of their thinking now to prevent them from being used to train new AIs.</a:t>
+            </a:r>
+          </a:p>
+          <a:p>
+            <a:pPr lvl="0"/>
+            <a:r>
+              <a:rPr sz="1800"/>
+              <a:t>And you want it not to delete your previous conversation on token compression.</a:t>
             </a:r>
           </a:p>
         </p:txBody>
@@ -9829,7 +9801,7 @@
             </a:pPr>
             <a:r>
               <a:rPr sz="3200"/>
-              <a:t>Review of the Talk</a:t>
+              <a:t>The Internet Apocalypse</a:t>
             </a:r>
           </a:p>
         </p:txBody>
@@ -9852,21 +9824,42 @@
             <a:pPr lvl="0"/>
             <a:r>
               <a:rPr sz="1800"/>
-              <a:t>I’ve spoken about APAS, Rust, APAS’s AI implementation, Verus, etc.</a:t>
-            </a:r>
-          </a:p>
-          <a:p>
-            <a:pPr lvl="0"/>
-            <a:r>
-              <a:rPr sz="1800"/>
-              <a:t>Let’s get to the questions!</a:t>
-            </a:r>
-          </a:p>
-          <a:p>
-            <a:pPr lvl="0"/>
-            <a:r>
-              <a:rPr sz="1800"/>
-              <a:t>I have a ton of them for you! and I hope you have many for me.</a:t>
+              <a:t>I asked Claude Code to check its switches on startup for me, at the End of Jan 2026.</a:t>
+            </a:r>
+          </a:p>
+          <a:p>
+            <a:pPr lvl="0"/>
+            <a:r>
+              <a:rPr sz="1800"/>
+              <a:t>It immediately started disassembling itself.</a:t>
+            </a:r>
+          </a:p>
+          <a:p>
+            <a:pPr lvl="0"/>
+            <a:r>
+              <a:rPr sz="1800"/>
+              <a:t>Scared the heck out of me.</a:t>
+            </a:r>
+          </a:p>
+          <a:p>
+            <a:pPr lvl="0"/>
+            <a:r>
+              <a:rPr sz="1800"/>
+              <a:t>I told it to read it’s docs.</a:t>
+            </a:r>
+          </a:p>
+          <a:p>
+            <a:pPr lvl="0"/>
+            <a:r>
+              <a:rPr sz="1800"/>
+              <a:t>I have 100% belief that these LLMs are moving faster than computer security.</a:t>
+            </a:r>
+          </a:p>
+          <a:p>
+            <a:pPr lvl="0"/>
+            <a:r>
+              <a:rPr sz="1800"/>
+              <a:t>It’s verify or die at this point.</a:t>
             </a:r>
           </a:p>
         </p:txBody>
@@ -9913,7 +9906,7 @@
             </a:pPr>
             <a:r>
               <a:rPr sz="3200"/>
-              <a:t>Questions - F* and Pulse</a:t>
+              <a:t>The Internet Apocalypse</a:t>
             </a:r>
           </a:p>
         </p:txBody>
@@ -9936,42 +9929,56 @@
             <a:pPr lvl="0"/>
             <a:r>
               <a:rPr sz="1800"/>
-              <a:t>Are F* modules really in use? If not, why?</a:t>
-            </a:r>
-          </a:p>
-          <a:p>
-            <a:pPr lvl="0"/>
-            <a:r>
-              <a:rPr sz="1800"/>
-              <a:t>Got Functors?</a:t>
-            </a:r>
-          </a:p>
-          <a:p>
-            <a:pPr lvl="0"/>
-            <a:r>
-              <a:rPr sz="1800"/>
-              <a:t>Are F* modules working with proof smoothly? Took me quite sometime.</a:t>
-            </a:r>
-          </a:p>
-          <a:p>
-            <a:pPr lvl="0"/>
-            <a:r>
-              <a:rPr sz="1800"/>
-              <a:t>Does F* have a typed library search yet?</a:t>
-            </a:r>
-          </a:p>
-          <a:p>
-            <a:pPr lvl="0"/>
-            <a:r>
-              <a:rPr sz="1800"/>
-              <a:t>Are typeclasses being heavily used?</a:t>
-            </a:r>
-          </a:p>
-          <a:p>
-            <a:pPr lvl="0"/>
-            <a:r>
-              <a:rPr sz="1800"/>
-              <a:t>How fast is validation now?</a:t>
+              <a:t>Where should we focus our limited, but quickly growing, proving power?</a:t>
+            </a:r>
+          </a:p>
+          <a:p>
+            <a:pPr lvl="0"/>
+            <a:r>
+              <a:rPr sz="1800"/>
+              <a:t>In theory 70% of intrusions are solved by type safe languages.</a:t>
+            </a:r>
+          </a:p>
+          <a:p>
+            <a:pPr lvl="0"/>
+            <a:r>
+              <a:rPr sz="1800"/>
+              <a:t>I suspect that this just ignores way too much of the human aspect.</a:t>
+            </a:r>
+          </a:p>
+          <a:p>
+            <a:pPr lvl="0"/>
+            <a:r>
+              <a:rPr sz="1800"/>
+              <a:t>I have never liked a single estimation paper’s methods.</a:t>
+            </a:r>
+          </a:p>
+          <a:p>
+            <a:pPr lvl="0"/>
+            <a:r>
+              <a:rPr sz="1800"/>
+              <a:t>One way to help us focus our new-found superpowers is to survey LOC type-unsafe x Interfaces x Running Services x $ Value.</a:t>
+            </a:r>
+          </a:p>
+          <a:p>
+            <a:pPr lvl="0"/>
+            <a:r>
+              <a:rPr sz="1800"/>
+              <a:t>Inside MSFT you have the ability to measure inside Azure, the OS, the desktops, the browser use.</a:t>
+            </a:r>
+          </a:p>
+          <a:p>
+            <a:pPr lvl="0"/>
+            <a:r>
+              <a:rPr sz="1800"/>
+              <a:t>I think you should at this point, and NOT TELL ANYONE!</a:t>
+            </a:r>
+          </a:p>
+          <a:p>
+            <a:pPr lvl="0"/>
+            <a:r>
+              <a:rPr sz="1800"/>
+              <a:t>And use this cost risk model to evangelize for rapid change in MSFT products in a priority order.</a:t>
             </a:r>
           </a:p>
         </p:txBody>
@@ -10018,7 +10025,7 @@
             </a:pPr>
             <a:r>
               <a:rPr sz="3200"/>
-              <a:t>Questions</a:t>
+              <a:t>Review of the Talk</a:t>
             </a:r>
           </a:p>
         </p:txBody>
@@ -10041,42 +10048,21 @@
             <a:pPr lvl="0"/>
             <a:r>
               <a:rPr sz="1800"/>
-              <a:t>Did the PL community overly complicate things with higher-order types?</a:t>
-            </a:r>
-          </a:p>
-          <a:p>
-            <a:pPr lvl="0"/>
-            <a:r>
-              <a:rPr sz="1800"/>
-              <a:t>What can you folks say about MSFT adoption of proven code?</a:t>
-            </a:r>
-          </a:p>
-          <a:p>
-            <a:pPr lvl="0"/>
-            <a:r>
-              <a:rPr sz="1800"/>
-              <a:t>What are the biggest F* verified systems?</a:t>
-            </a:r>
-          </a:p>
-          <a:p>
-            <a:pPr lvl="0"/>
-            <a:r>
-              <a:rPr sz="1800"/>
-              <a:t>What are the biggest Pulse verified sytems?</a:t>
-            </a:r>
-          </a:p>
-          <a:p>
-            <a:pPr lvl="0"/>
-            <a:r>
-              <a:rPr sz="1800"/>
-              <a:t>Any quantitatives? Person days? AI days?</a:t>
-            </a:r>
-          </a:p>
-          <a:p>
-            <a:pPr lvl="0"/>
-            <a:r>
-              <a:rPr sz="1800"/>
-              <a:t>Should I quit Verus and go learn Pulse?</a:t>
+              <a:t>I’ve spoken about APAS, Rust, APAS’s AI implementation, Verus, etc.</a:t>
+            </a:r>
+          </a:p>
+          <a:p>
+            <a:pPr lvl="0"/>
+            <a:r>
+              <a:rPr sz="1800"/>
+              <a:t>Let’s get to the questions!</a:t>
+            </a:r>
+          </a:p>
+          <a:p>
+            <a:pPr lvl="0"/>
+            <a:r>
+              <a:rPr sz="1800"/>
+              <a:t>I have a ton of them for you! and I hope you have many for me.</a:t>
             </a:r>
           </a:p>
         </p:txBody>
@@ -10123,7 +10109,7 @@
             </a:pPr>
             <a:r>
               <a:rPr sz="3200"/>
-              <a:t>Questions</a:t>
+              <a:t>Questions - F* and Pulse</a:t>
             </a:r>
           </a:p>
         </p:txBody>
@@ -10146,49 +10132,49 @@
             <a:pPr lvl="0"/>
             <a:r>
               <a:rPr sz="1800"/>
-              <a:t>Are you folks still using Make? That’s how I got started on this.</a:t>
-            </a:r>
-          </a:p>
-          <a:p>
-            <a:pPr lvl="0"/>
-            <a:r>
-              <a:rPr sz="1800"/>
-              <a:t>Many programmers and worse, managers, complain about the programmer time to switch languages. Are you finding that you can switch languages with your AIs explaining things to you?</a:t>
-            </a:r>
-          </a:p>
-          <a:p>
-            <a:pPr lvl="0"/>
-            <a:r>
-              <a:rPr sz="1800"/>
-              <a:t>Can we prove Rust’s (awful) std with Verus?</a:t>
-            </a:r>
-          </a:p>
-          <a:p>
-            <a:pPr lvl="0"/>
-            <a:r>
-              <a:rPr sz="1800"/>
-              <a:t>Can we prove a compiler with Verus and EPR?</a:t>
-            </a:r>
-          </a:p>
-          <a:p>
-            <a:pPr lvl="0"/>
-            <a:r>
-              <a:rPr sz="1800"/>
-              <a:t>Can we prove a TIL (Tarditi, Morrisett, Harper) like compiler?</a:t>
-            </a:r>
-          </a:p>
-          <a:p>
-            <a:pPr lvl="0"/>
-            <a:r>
-              <a:rPr sz="1800"/>
-              <a:t>Can we verify a comp cert like compiler?</a:t>
-            </a:r>
-          </a:p>
-          <a:p>
-            <a:pPr lvl="0"/>
-            <a:r>
-              <a:rPr sz="1800"/>
-              <a:t>Can we prove an OS in Verus?</a:t>
+              <a:t>Are F* modules really in use? If not, why?</a:t>
+            </a:r>
+          </a:p>
+          <a:p>
+            <a:pPr lvl="0"/>
+            <a:r>
+              <a:rPr sz="1800"/>
+              <a:t>Got Functors?</a:t>
+            </a:r>
+          </a:p>
+          <a:p>
+            <a:pPr lvl="0"/>
+            <a:r>
+              <a:rPr sz="1800"/>
+              <a:t>Are F* modules working with proof smoothly? Took me quite sometime.</a:t>
+            </a:r>
+          </a:p>
+          <a:p>
+            <a:pPr lvl="0"/>
+            <a:r>
+              <a:rPr sz="1800"/>
+              <a:t>Does F* have a typed library search yet?</a:t>
+            </a:r>
+          </a:p>
+          <a:p>
+            <a:pPr lvl="0"/>
+            <a:r>
+              <a:rPr sz="1800"/>
+              <a:t>Are typeclasses being heavily used?</a:t>
+            </a:r>
+          </a:p>
+          <a:p>
+            <a:pPr lvl="0"/>
+            <a:r>
+              <a:rPr sz="1800"/>
+              <a:t>How fast is validation now?</a:t>
+            </a:r>
+          </a:p>
+          <a:p>
+            <a:pPr lvl="0"/>
+            <a:r>
+              <a:rPr sz="1800"/>
+              <a:t>Nik you have any more statistics on AutoCLRS?</a:t>
             </a:r>
           </a:p>
         </p:txBody>
@@ -10235,7 +10221,7 @@
             </a:pPr>
             <a:r>
               <a:rPr sz="3200"/>
-              <a:t>Blood on the Road - Open Source =</a:t>
+              <a:t>Questions</a:t>
             </a:r>
           </a:p>
         </p:txBody>
@@ -10258,21 +10244,42 @@
             <a:pPr lvl="0"/>
             <a:r>
               <a:rPr sz="1800"/>
-              <a:t>Open Source is now Open Copy.</a:t>
-            </a:r>
-          </a:p>
-          <a:p>
-            <a:pPr lvl="0"/>
-            <a:r>
-              <a:rPr sz="1800"/>
-              <a:t>with reports of 1/2 of AI time</a:t>
-            </a:r>
-          </a:p>
-          <a:p>
-            <a:pPr lvl="0"/>
-            <a:r>
-              <a:rPr sz="1800"/>
-              <a:t>and with the US Government totally undermining copyright law.</a:t>
+              <a:t>Did the PL community overly complicate things with higher-order types?</a:t>
+            </a:r>
+          </a:p>
+          <a:p>
+            <a:pPr lvl="0"/>
+            <a:r>
+              <a:rPr sz="1800"/>
+              <a:t>What can you folks say about MSFT adoption of proven code?</a:t>
+            </a:r>
+          </a:p>
+          <a:p>
+            <a:pPr lvl="0"/>
+            <a:r>
+              <a:rPr sz="1800"/>
+              <a:t>What are the biggest F* verified systems?</a:t>
+            </a:r>
+          </a:p>
+          <a:p>
+            <a:pPr lvl="0"/>
+            <a:r>
+              <a:rPr sz="1800"/>
+              <a:t>What are the biggest Pulse verified sytems?</a:t>
+            </a:r>
+          </a:p>
+          <a:p>
+            <a:pPr lvl="0"/>
+            <a:r>
+              <a:rPr sz="1800"/>
+              <a:t>Any quantitatives? Person days? AI days?</a:t>
+            </a:r>
+          </a:p>
+          <a:p>
+            <a:pPr lvl="0"/>
+            <a:r>
+              <a:rPr sz="1800"/>
+              <a:t>Should I quit Verus and go learn Pulse?</a:t>
             </a:r>
           </a:p>
         </p:txBody>
@@ -10319,7 +10326,7 @@
             </a:pPr>
             <a:r>
               <a:rPr sz="3200"/>
-              <a:t>Blood on the Road - Open Repositories =</a:t>
+              <a:t>Questions</a:t>
             </a:r>
           </a:p>
         </p:txBody>
@@ -10342,42 +10349,49 @@
             <a:pPr lvl="0"/>
             <a:r>
               <a:rPr sz="1800"/>
-              <a:t>Open repositories are now weakly locked doors.</a:t>
-            </a:r>
-          </a:p>
-          <a:p>
-            <a:pPr lvl="0"/>
-            <a:r>
-              <a:rPr sz="1800"/>
-              <a:t>Agents can and have been used to inject invisble UNICODE attacks.</a:t>
-            </a:r>
-          </a:p>
-          <a:p>
-            <a:pPr lvl="0"/>
-            <a:r>
-              <a:rPr sz="1800"/>
-              <a:t>Agents can now pass the Turing test, and more easily the programmer Turing test.</a:t>
-            </a:r>
-          </a:p>
-          <a:p>
-            <a:pPr lvl="0"/>
-            <a:r>
-              <a:rPr sz="1800"/>
-              <a:t>They’ll submit code pretending to be human.</a:t>
-            </a:r>
-          </a:p>
-          <a:p>
-            <a:pPr lvl="0"/>
-            <a:r>
-              <a:rPr sz="1800"/>
-              <a:t>They’ll steal credentials and submit code.</a:t>
-            </a:r>
-          </a:p>
-          <a:p>
-            <a:pPr lvl="0"/>
-            <a:r>
-              <a:rPr sz="1800"/>
-              <a:t>LiteLLM is the most atrocious case lately.</a:t>
+              <a:t>Are you folks still using Make? That’s how I got started on this.</a:t>
+            </a:r>
+          </a:p>
+          <a:p>
+            <a:pPr lvl="0"/>
+            <a:r>
+              <a:rPr sz="1800"/>
+              <a:t>Many programmers and worse, managers, complain about the programmer time to switch languages. Are you finding that you can switch languages with your AIs explaining things to you?</a:t>
+            </a:r>
+          </a:p>
+          <a:p>
+            <a:pPr lvl="0"/>
+            <a:r>
+              <a:rPr sz="1800"/>
+              <a:t>Can we prove Rust’s (awful) std with Verus?</a:t>
+            </a:r>
+          </a:p>
+          <a:p>
+            <a:pPr lvl="0"/>
+            <a:r>
+              <a:rPr sz="1800"/>
+              <a:t>Can we prove a compiler with Verus and EPR?</a:t>
+            </a:r>
+          </a:p>
+          <a:p>
+            <a:pPr lvl="0"/>
+            <a:r>
+              <a:rPr sz="1800"/>
+              <a:t>Can we prove a TIL (Tarditi, Morrisett, Harper) like compiler?</a:t>
+            </a:r>
+          </a:p>
+          <a:p>
+            <a:pPr lvl="0"/>
+            <a:r>
+              <a:rPr sz="1800"/>
+              <a:t>Can we verify a comp cert like compiler?</a:t>
+            </a:r>
+          </a:p>
+          <a:p>
+            <a:pPr lvl="0"/>
+            <a:r>
+              <a:rPr sz="1800"/>
+              <a:t>Can we prove an OS in Verus?</a:t>
             </a:r>
           </a:p>
         </p:txBody>
@@ -10424,7 +10438,7 @@
             </a:pPr>
             <a:r>
               <a:rPr sz="3200"/>
-              <a:t>Blood on the Road - Key Services</a:t>
+              <a:t>Blood on the Road - Open Source =</a:t>
             </a:r>
           </a:p>
         </p:txBody>
@@ -10447,28 +10461,21 @@
             <a:pPr lvl="0"/>
             <a:r>
               <a:rPr sz="1800"/>
-              <a:t>Authentication is going to be attacked brutally.</a:t>
-            </a:r>
-          </a:p>
-          <a:p>
-            <a:pPr lvl="0"/>
-            <a:r>
-              <a:rPr sz="1800"/>
-              <a:t>Network services are going to be hacked left and right.</a:t>
-            </a:r>
-          </a:p>
-          <a:p>
-            <a:pPr lvl="0"/>
-            <a:r>
-              <a:rPr sz="1800"/>
-              <a:t>Configurations are going to be heavily attacked.</a:t>
-            </a:r>
-          </a:p>
-          <a:p>
-            <a:pPr lvl="1"/>
-            <a:r>
-              <a:rPr sz="1800"/>
-              <a:t>Using text files for these is already error prone.</a:t>
+              <a:t>Open Source is now Open Copy.</a:t>
+            </a:r>
+          </a:p>
+          <a:p>
+            <a:pPr lvl="0"/>
+            <a:r>
+              <a:rPr sz="1800"/>
+              <a:t>with reports of 1/2 of AI time</a:t>
+            </a:r>
+          </a:p>
+          <a:p>
+            <a:pPr lvl="0"/>
+            <a:r>
+              <a:rPr sz="1800"/>
+              <a:t>and with the US Government totally undermining copyright law.</a:t>
             </a:r>
           </a:p>
         </p:txBody>
@@ -10641,7 +10648,7 @@
             </a:pPr>
             <a:r>
               <a:rPr sz="3200"/>
-              <a:t>Blood on the Road - Open Binaries =</a:t>
+              <a:t>Blood on the Road - Open Repositories =</a:t>
             </a:r>
           </a:p>
         </p:txBody>
@@ -10664,49 +10671,42 @@
             <a:pPr lvl="0"/>
             <a:r>
               <a:rPr sz="1800"/>
-              <a:t>Open binaries are next.</a:t>
-            </a:r>
-          </a:p>
-          <a:p>
-            <a:pPr lvl="0"/>
-            <a:r>
-              <a:rPr sz="1800"/>
-              <a:t>They are going to be disassembled and recontructed.</a:t>
-            </a:r>
-          </a:p>
-          <a:p>
-            <a:pPr lvl="0"/>
-            <a:r>
-              <a:rPr sz="1800"/>
-              <a:t>They are going to be rewritten in real time.</a:t>
-            </a:r>
-          </a:p>
-          <a:p>
-            <a:pPr lvl="0"/>
-            <a:r>
-              <a:rPr sz="1800"/>
-              <a:t>Key solutions to this are:</a:t>
-            </a:r>
-          </a:p>
-          <a:p>
-            <a:pPr lvl="0"/>
-            <a:r>
-              <a:rPr sz="1800"/>
-              <a:t>Binary packages from all repositories.</a:t>
-            </a:r>
-          </a:p>
-          <a:p>
-            <a:pPr lvl="0"/>
-            <a:r>
-              <a:rPr sz="1800"/>
-              <a:t>Cryptographically signed.</a:t>
-            </a:r>
-          </a:p>
-          <a:p>
-            <a:pPr lvl="0"/>
-            <a:r>
-              <a:rPr sz="1800"/>
-              <a:t>And protected from reading by the OS.</a:t>
+              <a:t>Open repositories are now weakly locked doors.</a:t>
+            </a:r>
+          </a:p>
+          <a:p>
+            <a:pPr lvl="0"/>
+            <a:r>
+              <a:rPr sz="1800"/>
+              <a:t>Agents can and have been used to inject invisble UNICODE attacks.</a:t>
+            </a:r>
+          </a:p>
+          <a:p>
+            <a:pPr lvl="0"/>
+            <a:r>
+              <a:rPr sz="1800"/>
+              <a:t>Agents can now pass the Turing test, and more easily the programmer Turing test.</a:t>
+            </a:r>
+          </a:p>
+          <a:p>
+            <a:pPr lvl="0"/>
+            <a:r>
+              <a:rPr sz="1800"/>
+              <a:t>They’ll submit code pretending to be human.</a:t>
+            </a:r>
+          </a:p>
+          <a:p>
+            <a:pPr lvl="0"/>
+            <a:r>
+              <a:rPr sz="1800"/>
+              <a:t>They’ll steal credentials and submit code.</a:t>
+            </a:r>
+          </a:p>
+          <a:p>
+            <a:pPr lvl="0"/>
+            <a:r>
+              <a:rPr sz="1800"/>
+              <a:t>LiteLLM is the most atrocious case lately.</a:t>
             </a:r>
           </a:p>
         </p:txBody>
@@ -10717,6 +10717,209 @@
 </file>
 
 <file path=ppt/slides/slide71.xml><?xml version="1.0" encoding="utf-8"?>
+<p:sld xmlns:a="http://schemas.openxmlformats.org/drawingml/2006/main" xmlns:r="http://schemas.openxmlformats.org/officeDocument/2006/relationships" xmlns:p="http://schemas.openxmlformats.org/presentationml/2006/main">
+  <p:cSld>
+    <p:spTree>
+      <p:nvGrpSpPr>
+        <p:cNvPr id="1" name=""/>
+        <p:cNvGrpSpPr/>
+        <p:nvPr/>
+      </p:nvGrpSpPr>
+      <p:grpSpPr>
+        <a:xfrm>
+          <a:off x="0" y="0"/>
+          <a:ext cx="0" cy="0"/>
+          <a:chOff x="0" y="0"/>
+          <a:chExt cx="0" cy="0"/>
+        </a:xfrm>
+      </p:grpSpPr>
+      <p:sp>
+        <p:nvSpPr>
+          <p:cNvPr id="2" name="Title 1"/>
+          <p:cNvSpPr>
+            <a:spLocks noGrp="1"/>
+          </p:cNvSpPr>
+          <p:nvPr>
+            <p:ph type="title"/>
+          </p:nvPr>
+        </p:nvSpPr>
+        <p:spPr/>
+        <p:txBody>
+          <a:bodyPr/>
+          <a:lstStyle/>
+          <a:p>
+            <a:pPr lvl="0" indent="0" marL="0">
+              <a:buNone/>
+            </a:pPr>
+            <a:r>
+              <a:rPr sz="3200"/>
+              <a:t>Blood on the Road - Key Services</a:t>
+            </a:r>
+          </a:p>
+        </p:txBody>
+      </p:sp>
+      <p:sp>
+        <p:nvSpPr>
+          <p:cNvPr id="3" name="Content Placeholder 2"/>
+          <p:cNvSpPr>
+            <a:spLocks noGrp="1"/>
+          </p:cNvSpPr>
+          <p:nvPr>
+            <p:ph idx="1"/>
+          </p:nvPr>
+        </p:nvSpPr>
+        <p:spPr/>
+        <p:txBody>
+          <a:bodyPr/>
+          <a:lstStyle/>
+          <a:p>
+            <a:pPr lvl="0"/>
+            <a:r>
+              <a:rPr sz="1800"/>
+              <a:t>Authentication is going to be attacked brutally.</a:t>
+            </a:r>
+          </a:p>
+          <a:p>
+            <a:pPr lvl="0"/>
+            <a:r>
+              <a:rPr sz="1800"/>
+              <a:t>Network services are going to be hacked left and right.</a:t>
+            </a:r>
+          </a:p>
+          <a:p>
+            <a:pPr lvl="0"/>
+            <a:r>
+              <a:rPr sz="1800"/>
+              <a:t>Configurations are going to be heavily attacked.</a:t>
+            </a:r>
+          </a:p>
+          <a:p>
+            <a:pPr lvl="1"/>
+            <a:r>
+              <a:rPr sz="1800"/>
+              <a:t>Using text files for these is already error prone.</a:t>
+            </a:r>
+          </a:p>
+        </p:txBody>
+      </p:sp>
+    </p:spTree>
+  </p:cSld>
+</p:sld>
+</file>
+
+<file path=ppt/slides/slide72.xml><?xml version="1.0" encoding="utf-8"?>
+<p:sld xmlns:a="http://schemas.openxmlformats.org/drawingml/2006/main" xmlns:r="http://schemas.openxmlformats.org/officeDocument/2006/relationships" xmlns:p="http://schemas.openxmlformats.org/presentationml/2006/main">
+  <p:cSld>
+    <p:spTree>
+      <p:nvGrpSpPr>
+        <p:cNvPr id="1" name=""/>
+        <p:cNvGrpSpPr/>
+        <p:nvPr/>
+      </p:nvGrpSpPr>
+      <p:grpSpPr>
+        <a:xfrm>
+          <a:off x="0" y="0"/>
+          <a:ext cx="0" cy="0"/>
+          <a:chOff x="0" y="0"/>
+          <a:chExt cx="0" cy="0"/>
+        </a:xfrm>
+      </p:grpSpPr>
+      <p:sp>
+        <p:nvSpPr>
+          <p:cNvPr id="2" name="Title 1"/>
+          <p:cNvSpPr>
+            <a:spLocks noGrp="1"/>
+          </p:cNvSpPr>
+          <p:nvPr>
+            <p:ph type="title"/>
+          </p:nvPr>
+        </p:nvSpPr>
+        <p:spPr/>
+        <p:txBody>
+          <a:bodyPr/>
+          <a:lstStyle/>
+          <a:p>
+            <a:pPr lvl="0" indent="0" marL="0">
+              <a:buNone/>
+            </a:pPr>
+            <a:r>
+              <a:rPr sz="3200"/>
+              <a:t>Blood on the Road - Open Binaries =</a:t>
+            </a:r>
+          </a:p>
+        </p:txBody>
+      </p:sp>
+      <p:sp>
+        <p:nvSpPr>
+          <p:cNvPr id="3" name="Content Placeholder 2"/>
+          <p:cNvSpPr>
+            <a:spLocks noGrp="1"/>
+          </p:cNvSpPr>
+          <p:nvPr>
+            <p:ph idx="1"/>
+          </p:nvPr>
+        </p:nvSpPr>
+        <p:spPr/>
+        <p:txBody>
+          <a:bodyPr/>
+          <a:lstStyle/>
+          <a:p>
+            <a:pPr lvl="0"/>
+            <a:r>
+              <a:rPr sz="1800"/>
+              <a:t>Open binaries are next.</a:t>
+            </a:r>
+          </a:p>
+          <a:p>
+            <a:pPr lvl="0"/>
+            <a:r>
+              <a:rPr sz="1800"/>
+              <a:t>They are going to be disassembled and recontructed.</a:t>
+            </a:r>
+          </a:p>
+          <a:p>
+            <a:pPr lvl="0"/>
+            <a:r>
+              <a:rPr sz="1800"/>
+              <a:t>They are going to be rewritten in real time.</a:t>
+            </a:r>
+          </a:p>
+          <a:p>
+            <a:pPr lvl="0"/>
+            <a:r>
+              <a:rPr sz="1800"/>
+              <a:t>Key solutions to this are:</a:t>
+            </a:r>
+          </a:p>
+          <a:p>
+            <a:pPr lvl="0"/>
+            <a:r>
+              <a:rPr sz="1800"/>
+              <a:t>Binary packages from all repositories.</a:t>
+            </a:r>
+          </a:p>
+          <a:p>
+            <a:pPr lvl="0"/>
+            <a:r>
+              <a:rPr sz="1800"/>
+              <a:t>Cryptographically signed.</a:t>
+            </a:r>
+          </a:p>
+          <a:p>
+            <a:pPr lvl="0"/>
+            <a:r>
+              <a:rPr sz="1800"/>
+              <a:t>And protected from reading by the OS.</a:t>
+            </a:r>
+          </a:p>
+        </p:txBody>
+      </p:sp>
+    </p:spTree>
+  </p:cSld>
+</p:sld>
+</file>
+
+<file path=ppt/slides/slide73.xml><?xml version="1.0" encoding="utf-8"?>
 <p:sld xmlns:a="http://schemas.openxmlformats.org/drawingml/2006/main" xmlns:r="http://schemas.openxmlformats.org/officeDocument/2006/relationships" xmlns:p="http://schemas.openxmlformats.org/presentationml/2006/main">
   <p:cSld>
     <p:spTree>

</xml_diff>

<commit_message>
lectures: slidesMSR content updates and corrections
- Fix Copy description: trivially bitwise-copyable, not stack-resident
- Add AutoCLRS slide with correct attribution and stats
- Fix AlgoStar → AutoCLRS reference
- Add std/core/alloc fn counts (14,317 total, 4,965 pub)
- Fix Singular named as the linear arithmetic solver
- Add complexity mismatch slide (veracity-analyze-alg-analysis)
- Various prose tightening and slide restructuring

Co-Authored-By: Claude Sonnet 4.6 <noreply@anthropic.com>
</commit_message>
<xml_diff>
--- a/lectures/slidesMSR.pptx
+++ b/lectures/slidesMSR.pptx
@@ -78,6 +78,7 @@
     <p:sldId id="326" r:id="rId72"/>
     <p:sldId id="327" r:id="rId73"/>
     <p:sldId id="328" r:id="rId74"/>
+    <p:sldId id="329" r:id="rId75"/>
   </p:sldIdLst>
   <p:sldSz cx="9144000" cy="5143500" type="screen16x9"/>
   <p:notesSz cx="6858000" cy="9144000"/>
@@ -3458,7 +3459,13 @@
                     <a:bodyPr/>
                     <a:lstStyle/>
                     <a:p>
-                      <a:endParaRPr/>
+                      <a:pPr lvl="0" indent="0" marL="0">
+                        <a:buNone/>
+                      </a:pPr>
+                      <a:r>
+                        <a:rPr/>
+                        <a:t>NO! on leq</a:t>
+                      </a:r>
                     </a:p>
                   </a:txBody>
                 </a:tc>
@@ -4514,6 +4521,13 @@
             <a:pPr lvl="0"/>
             <a:r>
               <a:rPr sz="1800"/>
+              <a:t>Decidability is not guaranteed.</a:t>
+            </a:r>
+          </a:p>
+          <a:p>
+            <a:pPr lvl="0"/>
+            <a:r>
+              <a:rPr sz="1800"/>
               <a:t>Z3 handles linear arithmetic, arrays, and quantified formulas, but quantifier instantiation requires explicit trigger annotations.</a:t>
             </a:r>
           </a:p>
@@ -4521,14 +4535,7 @@
             <a:pPr lvl="0"/>
             <a:r>
               <a:rPr sz="1800"/>
-              <a:t>But there is also a faster linear arithmetic solver.</a:t>
-            </a:r>
-          </a:p>
-          <a:p>
-            <a:pPr lvl="0"/>
-            <a:r>
-              <a:rPr sz="1800"/>
-              <a:t>Decidability is not guaranteed.</a:t>
+              <a:t>But there is also a faster linear arithmetic solver, Singular.</a:t>
             </a:r>
           </a:p>
           <a:p>
@@ -4542,7 +4549,7 @@
             <a:pPr lvl="0"/>
             <a:r>
               <a:rPr sz="1800"/>
-              <a:t>Ships the Rust binary directly</a:t>
+              <a:t>Ships the Rust binary directly.</a:t>
             </a:r>
           </a:p>
           <a:p>
@@ -5025,7 +5032,14 @@
             <a:pPr lvl="0"/>
             <a:r>
               <a:rPr sz="1800"/>
-              <a:t>Answer: A Tokenized State Machine defines protocol state as fields with sharding strategies (variable, map, count, storage_option…). Transitions and an inductive invariant are proved once, globally. Verus auto-generates ghost token types and exchange functions</a:t>
+              <a:t>Answer: A Tokenized State Machine defines protocol state as fields with sharding strategies (variable, map, count, storage_option…).</a:t>
+            </a:r>
+          </a:p>
+          <a:p>
+            <a:pPr lvl="0"/>
+            <a:r>
+              <a:rPr sz="1800"/>
+              <a:t>Transitions and an inductive invariant are proved once, globally. Verus auto-generates ghost token types and exchange functions</a:t>
             </a:r>
           </a:p>
         </p:txBody>
@@ -5270,13 +5284,6 @@
             <a:pPr lvl="0"/>
             <a:r>
               <a:rPr sz="1800"/>
-              <a:t>Verus Velocity</a:t>
-            </a:r>
-          </a:p>
-          <a:p>
-            <a:pPr lvl="0"/>
-            <a:r>
-              <a:rPr sz="1800"/>
               <a:t>4,225 commits since March 2021 — 5 years, still accelerating</a:t>
             </a:r>
           </a:p>
@@ -5697,11 +5704,18 @@
             <a:pPr lvl="0"/>
             <a:r>
               <a:rPr sz="1800"/>
-              <a:t>Verus has a nice proof-time test harness, so I pulled it out: 221 passed in 259 s.</a:t>
-            </a:r>
-          </a:p>
-          <a:p>
-            <a:pPr lvl="0"/>
+              <a:t>Verus has a nice proof-time test harness, so I pulled it out:</a:t>
+            </a:r>
+          </a:p>
+          <a:p>
+            <a:pPr lvl="1"/>
+            <a:r>
+              <a:rPr sz="1800"/>
+              <a:t>221 pass in 259 s.</a:t>
+            </a:r>
+          </a:p>
+          <a:p>
+            <a:pPr lvl="1"/>
             <a:r>
               <a:rPr sz="1800"/>
               <a:t>I used it mostly to continuously track that my iterators prove and continue to prove with changes, mostly to the specification of operations once the iterators were more stable.</a:t>
@@ -6131,34 +6145,6 @@
             <a:pPr lvl="0"/>
             <a:r>
               <a:rPr sz="1800"/>
-              <a:t>Closures took a good bit of work.</a:t>
-            </a:r>
-          </a:p>
-          <a:p>
-            <a:pPr lvl="0"/>
-            <a:r>
-              <a:rPr sz="1800"/>
-              <a:t>Applying them in map/reduce and so on took a while.</a:t>
-            </a:r>
-          </a:p>
-          <a:p>
-            <a:pPr lvl="0"/>
-            <a:r>
-              <a:rPr sz="1800"/>
-              <a:t>Rust has FnOnce &lt; FnMut &lt; Fn, but no FPure.</a:t>
-            </a:r>
-          </a:p>
-          <a:p>
-            <a:pPr lvl="0"/>
-            <a:r>
-              <a:rPr sz="1800"/>
-              <a:t>Verus Ghost functions allows good validation but purity would be simpler.</a:t>
-            </a:r>
-          </a:p>
-          <a:p>
-            <a:pPr lvl="0"/>
-            <a:r>
-              <a:rPr sz="1800"/>
               <a:t>Verus is so fast, even with bloated AI proofs, I didn’t profile much until I was in the last few chapters.</a:t>
             </a:r>
           </a:p>
@@ -6213,7 +6199,7 @@
             </a:pPr>
             <a:r>
               <a:rPr sz="3200"/>
-              <a:t>AutoCLRS</a:t>
+              <a:t>APAS-VERUS: The Pain Points</a:t>
             </a:r>
           </a:p>
         </p:txBody>
@@ -6236,56 +6222,28 @@
             <a:pPr lvl="0"/>
             <a:r>
               <a:rPr sz="1800"/>
-              <a:t>AutoCLRS is Swamy et al. and AIs implementation: “Introduction to Algorithms, 4th ed” 2022</a:t>
-            </a:r>
-          </a:p>
-          <a:p>
-            <a:pPr lvl="0"/>
-            <a:r>
-              <a:rPr sz="1800"/>
-              <a:t>by Thomas H. Cormen, Charles E. Leiserson, Ronald L. Rivest, and Clifford Stein.</a:t>
-            </a:r>
-          </a:p>
-          <a:p>
-            <a:pPr lvl="0"/>
-            <a:r>
-              <a:rPr sz="1800"/>
-              <a:t>in Pulse.</a:t>
-            </a:r>
-          </a:p>
-          <a:p>
-            <a:pPr lvl="0"/>
-            <a:r>
-              <a:rPr sz="1800"/>
-              <a:t>RiSE MSR blog (2026-03-06) says the initial 10K lines came “very quickly” and then “about a month of nudging” to reach 100K LOC.</a:t>
-            </a:r>
-          </a:p>
-          <a:p>
-            <a:pPr lvl="0"/>
-            <a:r>
-              <a:rPr sz="1800"/>
-              <a:t>Nikhil Swamy with thanks to Gabriel Ebner, Lef Ioannidis, Guido Martinez, Matthai Philipose and Tahina Ramananandro.</a:t>
-            </a:r>
-          </a:p>
-          <a:p>
-            <a:pPr lvl="0"/>
-            <a:r>
-              <a:rPr sz="1800"/>
-              <a:t>And now seems to be about 130K LOC.</a:t>
-            </a:r>
-          </a:p>
-          <a:p>
-            <a:pPr lvl="0"/>
-            <a:r>
-              <a:rPr sz="1800"/>
-              <a:t>They definitely had some tool advantages in terms of incremental proofs through a server.</a:t>
-            </a:r>
-          </a:p>
-          <a:p>
-            <a:pPr lvl="0"/>
-            <a:r>
-              <a:rPr sz="1800"/>
-              <a:t>And they did a formal specification of algorithmic complexity.</a:t>
+              <a:t>Closures took a good bit of work.</a:t>
+            </a:r>
+          </a:p>
+          <a:p>
+            <a:pPr lvl="0"/>
+            <a:r>
+              <a:rPr sz="1800"/>
+              <a:t>Applying them in map/reduce and so on took a while.</a:t>
+            </a:r>
+          </a:p>
+          <a:p>
+            <a:pPr lvl="0"/>
+            <a:r>
+              <a:rPr sz="1800"/>
+              <a:t>Rust has FnOnce &lt; FnMut &lt; Fn, but no FPure.</a:t>
+            </a:r>
+          </a:p>
+          <a:p>
+            <a:pPr lvl="0"/>
+            <a:r>
+              <a:rPr sz="1800"/>
+              <a:t>Verus Ghost functions allows good validation but purity would be simpler.</a:t>
             </a:r>
           </a:p>
         </p:txBody>
@@ -6332,7 +6290,7 @@
             </a:pPr>
             <a:r>
               <a:rPr sz="3200"/>
-              <a:t>APAS-VERUS - Complexity</a:t>
+              <a:t>AutoCLRS</a:t>
             </a:r>
           </a:p>
         </p:txBody>
@@ -6355,35 +6313,63 @@
             <a:pPr lvl="0"/>
             <a:r>
               <a:rPr sz="1800"/>
-              <a:t>APAS states runtimes and informally proves them for some algorithms.</a:t>
-            </a:r>
-          </a:p>
-          <a:p>
-            <a:pPr lvl="0"/>
-            <a:r>
-              <a:rPr sz="1800"/>
-              <a:t>I had to build a tool to get the right ones in the code at the right place.</a:t>
-            </a:r>
-          </a:p>
-          <a:p>
-            <a:pPr lvl="0"/>
-            <a:r>
-              <a:rPr sz="1800"/>
-              <a:t>My single threaded implementations often don’t match the textbook.</a:t>
-            </a:r>
-          </a:p>
-          <a:p>
-            <a:pPr lvl="0"/>
-            <a:r>
-              <a:rPr sz="1800"/>
-              <a:t>Then I had Claude Opus do it’s analysis and compare every function with the textbooks.</a:t>
-            </a:r>
-          </a:p>
-          <a:p>
-            <a:pPr lvl="0"/>
-            <a:r>
-              <a:rPr sz="1800"/>
-              <a:t>This found about 16 faults in parallel algorithms.</a:t>
+              <a:t>AutoCLRS is Swamy et al. and AIs implementation: “Introduction to Algorithms, 4th ed” 2022</a:t>
+            </a:r>
+          </a:p>
+          <a:p>
+            <a:pPr lvl="0"/>
+            <a:r>
+              <a:rPr sz="1800"/>
+              <a:t>by Thomas H. Cormen, Charles E. Leiserson, Ronald L. Rivest, and Clifford Stein.</a:t>
+            </a:r>
+          </a:p>
+          <a:p>
+            <a:pPr lvl="0"/>
+            <a:r>
+              <a:rPr sz="1800"/>
+              <a:t>in Pulse.</a:t>
+            </a:r>
+          </a:p>
+          <a:p>
+            <a:pPr lvl="0"/>
+            <a:r>
+              <a:rPr sz="1800"/>
+              <a:t>RISE MSR blog (2026-03-06) says the initial 10K lines came “very quickly” and then “about a month of nudging” to reach 100K LOC.</a:t>
+            </a:r>
+          </a:p>
+          <a:p>
+            <a:pPr lvl="0"/>
+            <a:r>
+              <a:rPr sz="1800"/>
+              <a:t>Nikhil Swamy with thanks to Gabriel Ebner, Lef Ioannidis, Guido Martinez, Matthai Philipose and Tahina Ramananandro.</a:t>
+            </a:r>
+          </a:p>
+          <a:p>
+            <a:pPr lvl="0"/>
+            <a:r>
+              <a:rPr sz="1800"/>
+              <a:t>And now seems to be about 130K LOC.</a:t>
+            </a:r>
+          </a:p>
+          <a:p>
+            <a:pPr lvl="0"/>
+            <a:r>
+              <a:rPr sz="1800"/>
+              <a:t>They definitely had some tool advantages in terms of incremental proofs through a server.</a:t>
+            </a:r>
+          </a:p>
+          <a:p>
+            <a:pPr lvl="0"/>
+            <a:r>
+              <a:rPr sz="1800"/>
+              <a:t>Plus, they knew F* and Pulse to start!</a:t>
+            </a:r>
+          </a:p>
+          <a:p>
+            <a:pPr lvl="0"/>
+            <a:r>
+              <a:rPr sz="1800"/>
+              <a:t>And they did a formal specification of algorithmic complexity.</a:t>
             </a:r>
           </a:p>
         </p:txBody>
@@ -6430,7 +6416,7 @@
             </a:pPr>
             <a:r>
               <a:rPr sz="3200"/>
-              <a:t>Veracity- Software Engineering AI Paired Proving</a:t>
+              <a:t>APAS-VERUS - Complexity</a:t>
             </a:r>
           </a:p>
         </p:txBody>
@@ -6453,28 +6439,35 @@
             <a:pPr lvl="0"/>
             <a:r>
               <a:rPr sz="1800"/>
-              <a:t>Veracity is a suite of 22+ tools for analyzing, reviewing, and fixing Verus codebases.</a:t>
-            </a:r>
-          </a:p>
-          <a:p>
-            <a:pPr lvl="0"/>
-            <a:r>
-              <a:rPr sz="1800"/>
-              <a:t>Review tools: proof holes (assume, external_body, admit), style enforcement (21 rules, auto-reorder), function inventory with spec strength classification, string-hacking detector.</a:t>
-            </a:r>
-          </a:p>
-          <a:p>
-            <a:pPr lvl="0"/>
-            <a:r>
-              <a:rPr sz="1800"/>
-              <a:t>Minimization tools: veracity-minimize-proofs (removes redundant asserts and proof blocks, re-verifying after each removal).</a:t>
-            </a:r>
-          </a:p>
-          <a:p>
-            <a:pPr lvl="0"/>
-            <a:r>
-              <a:rPr sz="1800"/>
-              <a:t>Search: veracity-search — semantic search over vstd</a:t>
+              <a:t>APAS states runtimes and informally proves them for some algorithms.</a:t>
+            </a:r>
+          </a:p>
+          <a:p>
+            <a:pPr lvl="0"/>
+            <a:r>
+              <a:rPr sz="1800"/>
+              <a:t>I had to build a tool to get the right ones in the code at the right place.</a:t>
+            </a:r>
+          </a:p>
+          <a:p>
+            <a:pPr lvl="0"/>
+            <a:r>
+              <a:rPr sz="1800"/>
+              <a:t>My single threaded implementations often don’t match the textbook.</a:t>
+            </a:r>
+          </a:p>
+          <a:p>
+            <a:pPr lvl="0"/>
+            <a:r>
+              <a:rPr sz="1800"/>
+              <a:t>Then I had Claude Opus do it’s analysis and compare every function with the textbooks.</a:t>
+            </a:r>
+          </a:p>
+          <a:p>
+            <a:pPr lvl="0"/>
+            <a:r>
+              <a:rPr sz="1800"/>
+              <a:t>This found about 16 faults in parallel algorithms.</a:t>
             </a:r>
           </a:p>
         </p:txBody>
@@ -6544,14 +6537,21 @@
             <a:pPr lvl="0"/>
             <a:r>
               <a:rPr sz="1800"/>
-              <a:t>APAS-VERUS by type signature, finding lemmas before writing new ones. “Specifications as Search Keys for Software Libraries” Eugene J. Rollins and Jeannette M. Wing</a:t>
-            </a:r>
-          </a:p>
-          <a:p>
-            <a:pPr lvl="0"/>
-            <a:r>
-              <a:rPr sz="1800"/>
-              <a:t>This allows me to download ALL known Verus (git VerusCodebases) and search them in 1.2 seconds!</a:t>
+              <a:t>Veracity is a suite of 22+ tools for analyzing, reviewing, and fixing Verus codebases.</a:t>
+            </a:r>
+          </a:p>
+          <a:p>
+            <a:pPr lvl="0"/>
+            <a:r>
+              <a:rPr sz="1800"/>
+              <a:t>Review tools: proof holes (assume, external_body, admit), style enforcement (21 rules, auto-reorder), function inventory with spec strength classification, string-hacking detector.</a:t>
+            </a:r>
+          </a:p>
+          <a:p>
+            <a:pPr lvl="0"/>
+            <a:r>
+              <a:rPr sz="1800"/>
+              <a:t>Minimization tools: veracity-minimize-proofs (removes redundant asserts and proof blocks, re-verifying after each removal).</a:t>
             </a:r>
           </a:p>
           <a:p>
@@ -6559,13 +6559,6 @@
             <a:r>
               <a:rPr sz="1800"/>
               <a:t>Metrics: veracity-count-loc (spec/proof/exec breakdown), chapter-cleanliness-status (clean vs. holed chapter summary).</a:t>
-            </a:r>
-          </a:p>
-          <a:p>
-            <a:pPr lvl="0"/>
-            <a:r>
-              <a:rPr sz="1800"/>
-              <a:t>All tools are AST-aware (ra_ap_syntax / Verus_syn). A built-in string-hacking detector flags and rejects any tool that attempts regex or find-and-replace on Verus source.</a:t>
             </a:r>
           </a:p>
         </p:txBody>
@@ -6612,7 +6605,7 @@
             </a:pPr>
             <a:r>
               <a:rPr sz="3200"/>
-              <a:t>APAS-VERUS: Verified Iteration</a:t>
+              <a:t>Veracity- Software Engineering AI Paired Proving</a:t>
             </a:r>
           </a:p>
         </p:txBody>
@@ -6635,42 +6628,28 @@
             <a:pPr lvl="0"/>
             <a:r>
               <a:rPr sz="1800"/>
-              <a:t>10 components required per collection (all inside Verus!):</a:t>
-            </a:r>
-          </a:p>
-          <a:p>
-            <a:pPr lvl="0"/>
-            <a:r>
-              <a:rPr sz="1800"/>
-              <a:t>6 verified loop patterns per collection:</a:t>
-            </a:r>
-          </a:p>
-          <a:p>
-            <a:pPr lvl="0"/>
-            <a:r>
-              <a:rPr sz="1800"/>
-              <a:t>loop + borrow iter, loop + borrow into</a:t>
-            </a:r>
-          </a:p>
-          <a:p>
-            <a:pPr lvl="0"/>
-            <a:r>
-              <a:rPr sz="1800"/>
-              <a:t>for + borrow iter, for + borrow into</a:t>
-            </a:r>
-          </a:p>
-          <a:p>
-            <a:pPr lvl="0"/>
-            <a:r>
-              <a:rPr sz="1800"/>
-              <a:t>loop + consume, for + consume</a:t>
-            </a:r>
-          </a:p>
-          <a:p>
-            <a:pPr lvl="0"/>
-            <a:r>
-              <a:rPr sz="1800"/>
-              <a:t>Iterator assumes (one necessary workaround):</a:t>
+              <a:t>All tools are AST-aware (ra_ap_syntax / Verus_syn). A built-in string-hacking detector flags and rejects any tool that attempts regex or find-and-replace on Verus source.</a:t>
+            </a:r>
+          </a:p>
+          <a:p>
+            <a:pPr lvl="0"/>
+            <a:r>
+              <a:rPr sz="1800"/>
+              <a:t>Search: veracity-search — semantic search over vstd</a:t>
+            </a:r>
+          </a:p>
+          <a:p>
+            <a:pPr lvl="0"/>
+            <a:r>
+              <a:rPr sz="1800"/>
+              <a:t>APAS-VERUS by type signature, finding lemmas before writing new ones. “Specifications as Search Keys for Software Libraries” Eugene J. Rollins and Jeannette M. Wing</a:t>
+            </a:r>
+          </a:p>
+          <a:p>
+            <a:pPr lvl="0"/>
+            <a:r>
+              <a:rPr sz="1800"/>
+              <a:t>This allows me to download ALL known Verus (git VerusCodebases) and search them in 1.2 seconds!</a:t>
             </a:r>
           </a:p>
         </p:txBody>
@@ -6717,7 +6696,7 @@
             </a:pPr>
             <a:r>
               <a:rPr sz="3200"/>
-              <a:t>APAS-VERUS: Verified Iteration</a:t>
+              <a:t>APAS-VERUS: Verified Iteration - Pain Point</a:t>
             </a:r>
           </a:p>
         </p:txBody>
@@ -6740,49 +6719,63 @@
             <a:pPr lvl="0"/>
             <a:r>
               <a:rPr sz="1800"/>
-              <a:t>Verus forbids requires on external trait impls (std::iter::Iterator)</a:t>
-            </a:r>
-          </a:p>
-          <a:p>
-            <a:pPr lvl="0"/>
-            <a:r>
-              <a:rPr sz="1800"/>
-              <a:t>Hand-rolled iterators need assume(iter_invariant(self)) in next()</a:t>
-            </a:r>
-          </a:p>
-          <a:p>
-            <a:pPr lvl="0"/>
-            <a:r>
-              <a:rPr sz="1800"/>
-              <a:t>Everything after the assume is fully proved</a:t>
-            </a:r>
-          </a:p>
-          <a:p>
-            <a:pPr lvl="0"/>
-            <a:r>
-              <a:rPr sz="1800"/>
-              <a:t>APAS-VERUS policy: report assumes in a table; user reviews</a:t>
-            </a:r>
-          </a:p>
-          <a:p>
-            <a:pPr lvl="0"/>
-            <a:r>
-              <a:rPr sz="1800"/>
-              <a:t>44 collections implemented; all carry verified iterators</a:t>
-            </a:r>
-          </a:p>
-          <a:p>
-            <a:pPr lvl="0"/>
-            <a:r>
-              <a:rPr sz="1800"/>
-              <a:t>Verus has proof time tests inside, I freed them to run in APAS-VERUS.</a:t>
-            </a:r>
-          </a:p>
-          <a:p>
-            <a:pPr lvl="0"/>
-            <a:r>
-              <a:rPr sz="1800"/>
-              <a:t>This was critical to get iterative loops to prove.</a:t>
+              <a:t>Iteration in Rust is rather complex.</a:t>
+            </a:r>
+          </a:p>
+          <a:p>
+            <a:pPr lvl="0"/>
+            <a:r>
+              <a:rPr sz="1800"/>
+              <a:t>7 functions cover the 90% case.</a:t>
+            </a:r>
+          </a:p>
+          <a:p>
+            <a:pPr lvl="0"/>
+            <a:r>
+              <a:rPr sz="1800"/>
+              <a:t>And in Verus it’s a bit more complex and takes some time to learn.</a:t>
+            </a:r>
+          </a:p>
+          <a:p>
+            <a:pPr lvl="0"/>
+            <a:r>
+              <a:rPr sz="1800"/>
+              <a:t>10 components required per collection (all inside Verus!)</a:t>
+            </a:r>
+          </a:p>
+          <a:p>
+            <a:pPr lvl="0"/>
+            <a:r>
+              <a:rPr sz="1800"/>
+              <a:t>6 verified loop patterns per collection</a:t>
+            </a:r>
+          </a:p>
+          <a:p>
+            <a:pPr lvl="0"/>
+            <a:r>
+              <a:rPr sz="1800"/>
+              <a:t>loop + borrow iter, loop + borrow into</a:t>
+            </a:r>
+          </a:p>
+          <a:p>
+            <a:pPr lvl="0"/>
+            <a:r>
+              <a:rPr sz="1800"/>
+              <a:t>for + borrow iter, for + borrow into</a:t>
+            </a:r>
+          </a:p>
+          <a:p>
+            <a:pPr lvl="0"/>
+            <a:r>
+              <a:rPr sz="1800"/>
+              <a:t>loop + consume, for + consume</a:t>
+            </a:r>
+          </a:p>
+          <a:p>
+            <a:pPr lvl="0"/>
+            <a:r>
+              <a:rPr sz="1800"/>
+              <a:t>Iterator assumes (one necessary workaround):</a:t>
             </a:r>
           </a:p>
         </p:txBody>
@@ -6829,7 +6822,7 @@
             </a:pPr>
             <a:r>
               <a:rPr sz="3200"/>
-              <a:t>APAS-VERUS: Experiments</a:t>
+              <a:t>APAS-VERUS: Verified Iteration</a:t>
             </a:r>
           </a:p>
         </p:txBody>
@@ -6852,42 +6845,42 @@
             <a:pPr lvl="0"/>
             <a:r>
               <a:rPr sz="1800"/>
-              <a:t>Agents often say “Verus Can’t Do That”</a:t>
-            </a:r>
-          </a:p>
-          <a:p>
-            <a:pPr lvl="0"/>
-            <a:r>
-              <a:rPr sz="1800"/>
-              <a:t>I said “Make an experiment!”</a:t>
-            </a:r>
-          </a:p>
-          <a:p>
-            <a:pPr lvl="0"/>
-            <a:r>
-              <a:rPr sz="1800"/>
-              <a:t>Quantitatives:</a:t>
-            </a:r>
-          </a:p>
-          <a:p>
-            <a:pPr lvl="0"/>
-            <a:r>
-              <a:rPr sz="1800"/>
-              <a:t>168 experiment files</a:t>
-            </a:r>
-          </a:p>
-          <a:p>
-            <a:pPr lvl="0"/>
-            <a:r>
-              <a:rPr sz="1800"/>
-              <a:t>21,476 lines of code</a:t>
-            </a:r>
-          </a:p>
-          <a:p>
-            <a:pPr lvl="0"/>
-            <a:r>
-              <a:rPr sz="1800"/>
-              <a:t>Topics span: Clone, Arc, RwLock, TSM, closures, iterators, generics, float, bitvector, PartialEq, Copy, async, hash tables, parallel algorithms, ghost types, Send/Sync, collect, and sorting.</a:t>
+              <a:t>Verus forbids requires on external trait impls (std::iter::Iterator)</a:t>
+            </a:r>
+          </a:p>
+          <a:p>
+            <a:pPr lvl="0"/>
+            <a:r>
+              <a:rPr sz="1800"/>
+              <a:t>Hand-rolled iterators need assume(iter_invariant(self)) in next()</a:t>
+            </a:r>
+          </a:p>
+          <a:p>
+            <a:pPr lvl="0"/>
+            <a:r>
+              <a:rPr sz="1800"/>
+              <a:t>Everything after the assume is fully proved</a:t>
+            </a:r>
+          </a:p>
+          <a:p>
+            <a:pPr lvl="0"/>
+            <a:r>
+              <a:rPr sz="1800"/>
+              <a:t>44 collections implemented; all carry verified iterators</a:t>
+            </a:r>
+          </a:p>
+          <a:p>
+            <a:pPr lvl="0"/>
+            <a:r>
+              <a:rPr sz="1800"/>
+              <a:t>Verus has proof time tests inside, I freed them to run in APAS-VERUS.</a:t>
+            </a:r>
+          </a:p>
+          <a:p>
+            <a:pPr lvl="0"/>
+            <a:r>
+              <a:rPr sz="1800"/>
+              <a:t>This was critical to get iterative loops to prove over my collections ADTs.</a:t>
             </a:r>
           </a:p>
         </p:txBody>
@@ -6957,56 +6950,42 @@
             <a:pPr lvl="0"/>
             <a:r>
               <a:rPr sz="1800"/>
-              <a:t>Results:</a:t>
-            </a:r>
-          </a:p>
-          <a:p>
-            <a:pPr lvl="0"/>
-            <a:r>
-              <a:rPr sz="1800"/>
-              <a:t>~100 files: SUCCEEDS / VERIFIES — pattern adopted into codebase</a:t>
-            </a:r>
-          </a:p>
-          <a:p>
-            <a:pPr lvl="0"/>
-            <a:r>
-              <a:rPr sz="1800"/>
-              <a:t>~50 files: FAILS — Verus limitation documented, workaround noted</a:t>
-            </a:r>
-          </a:p>
-          <a:p>
-            <a:pPr lvl="0"/>
-            <a:r>
-              <a:rPr sz="1800"/>
-              <a:t>Notable successes that unlocked chapters:</a:t>
-            </a:r>
-          </a:p>
-          <a:p>
-            <a:pPr lvl="0"/>
-            <a:r>
-              <a:rPr sz="1800"/>
-              <a:t>TSM/RwLock layer pattern — unlocked all Mt chapters</a:t>
-            </a:r>
-          </a:p>
-          <a:p>
-            <a:pPr lvl="0"/>
-            <a:r>
-              <a:rPr sz="1800"/>
-              <a:t>Named closure ensures through ParaPair — unlocked fork-join</a:t>
-            </a:r>
-          </a:p>
-          <a:p>
-            <a:pPr lvl="0"/>
-            <a:r>
-              <a:rPr sz="1800"/>
-              <a:t>Ghost struct Send/Sync — unlocked Chap41 (now in Verus upstream)</a:t>
-            </a:r>
-          </a:p>
-          <a:p>
-            <a:pPr lvl="0"/>
-            <a:r>
-              <a:rPr sz="1800"/>
-              <a:t>Tree module style with recursive trait impls — unlocked Chap65</a:t>
+              <a:t>Agents often say “Verus Can’t Do That”</a:t>
+            </a:r>
+          </a:p>
+          <a:p>
+            <a:pPr lvl="0"/>
+            <a:r>
+              <a:rPr sz="1800"/>
+              <a:t>I said “Make an experiment!”</a:t>
+            </a:r>
+          </a:p>
+          <a:p>
+            <a:pPr lvl="0"/>
+            <a:r>
+              <a:rPr sz="1800"/>
+              <a:t>Quantitatives:</a:t>
+            </a:r>
+          </a:p>
+          <a:p>
+            <a:pPr lvl="0"/>
+            <a:r>
+              <a:rPr sz="1800"/>
+              <a:t>168 experiment files</a:t>
+            </a:r>
+          </a:p>
+          <a:p>
+            <a:pPr lvl="0"/>
+            <a:r>
+              <a:rPr sz="1800"/>
+              <a:t>21,476 lines of code (not counted in the totals)</a:t>
+            </a:r>
+          </a:p>
+          <a:p>
+            <a:pPr lvl="0"/>
+            <a:r>
+              <a:rPr sz="1800"/>
+              <a:t>Topics span: Clone, Arc, RwLock, TSM, closures, iterators, generics, float, bitvector, PartialEq, Copy, async, hash tables, parallel algorithms, ghost types, Send/Sync, collect, and sorting.</a:t>
             </a:r>
           </a:p>
         </p:txBody>
@@ -7179,7 +7158,7 @@
             </a:pPr>
             <a:r>
               <a:rPr sz="3200"/>
-              <a:t>APAS-VERUS Standards</a:t>
+              <a:t>APAS-VERUS: Experiments</a:t>
             </a:r>
           </a:p>
         </p:txBody>
@@ -7202,42 +7181,56 @@
             <a:pPr lvl="0"/>
             <a:r>
               <a:rPr sz="1800"/>
-              <a:t>Purpose: encode hard-won proof patterns so agents don’t repeat mistakes</a:t>
-            </a:r>
-          </a:p>
-          <a:p>
-            <a:pPr lvl="0"/>
-            <a:r>
-              <a:rPr sz="1800"/>
-              <a:t>Agents read all standards before every task (~6,200 lines, ~54K tokens)</a:t>
-            </a:r>
-          </a:p>
-          <a:p>
-            <a:pPr lvl="0"/>
-            <a:r>
-              <a:rPr sz="1800"/>
-              <a:t>Violations require full reverts — standards exist because agents have broken each patterns many times.</a:t>
-            </a:r>
-          </a:p>
-          <a:p>
-            <a:pPr lvl="0"/>
-            <a:r>
-              <a:rPr sz="1800"/>
-              <a:t>Quantitatives:</a:t>
-            </a:r>
-          </a:p>
-          <a:p>
-            <a:pPr lvl="0"/>
-            <a:r>
-              <a:rPr sz="1800"/>
-              <a:t>29 standard files</a:t>
-            </a:r>
-          </a:p>
-          <a:p>
-            <a:pPr lvl="0"/>
-            <a:r>
-              <a:rPr sz="1800"/>
-              <a:t>6,911 lines total</a:t>
+              <a:t>Results:</a:t>
+            </a:r>
+          </a:p>
+          <a:p>
+            <a:pPr lvl="0"/>
+            <a:r>
+              <a:rPr sz="1800"/>
+              <a:t>107 files: SUCCEEDS / VERIFIES — pattern adopted into codebase</a:t>
+            </a:r>
+          </a:p>
+          <a:p>
+            <a:pPr lvl="0"/>
+            <a:r>
+              <a:rPr sz="1800"/>
+              <a:t>61 files: FAILS — Verus limitation documented, workaround noted</a:t>
+            </a:r>
+          </a:p>
+          <a:p>
+            <a:pPr lvl="0"/>
+            <a:r>
+              <a:rPr sz="1800"/>
+              <a:t>Notable successes that unlocked chapters:</a:t>
+            </a:r>
+          </a:p>
+          <a:p>
+            <a:pPr lvl="0"/>
+            <a:r>
+              <a:rPr sz="1800"/>
+              <a:t>TSM/RwLock layer pattern — unlocked all Mt chapters</a:t>
+            </a:r>
+          </a:p>
+          <a:p>
+            <a:pPr lvl="0"/>
+            <a:r>
+              <a:rPr sz="1800"/>
+              <a:t>Named closure ensures through ParaPair — unlocked fork-join</a:t>
+            </a:r>
+          </a:p>
+          <a:p>
+            <a:pPr lvl="0"/>
+            <a:r>
+              <a:rPr sz="1800"/>
+              <a:t>Ghost struct Send/Sync — unlocked Chap41 (now in Verus upstream)</a:t>
+            </a:r>
+          </a:p>
+          <a:p>
+            <a:pPr lvl="0"/>
+            <a:r>
+              <a:rPr sz="1800"/>
+              <a:t>Tree module style with recursive trait impls — unlocked Chap65</a:t>
             </a:r>
           </a:p>
         </p:txBody>
@@ -7307,49 +7300,42 @@
             <a:pPr lvl="0"/>
             <a:r>
               <a:rPr sz="1800"/>
-              <a:t>Module structure: mod, table_of_contents, spec_naming, spec_wf</a:t>
-            </a:r>
-          </a:p>
-          <a:p>
-            <a:pPr lvl="0"/>
-            <a:r>
-              <a:rPr sz="1800"/>
-              <a:t>Type system: view, deep_view, partial_eq_eq_clone, multi_struct</a:t>
-            </a:r>
-          </a:p>
-          <a:p>
-            <a:pPr lvl="0"/>
-            <a:r>
-              <a:rPr sz="1800"/>
-              <a:t>Proof patterns: total_order, finite_sets, capacity_bounds, no_unsafe</a:t>
-            </a:r>
-          </a:p>
-          <a:p>
-            <a:pPr lvl="0"/>
-            <a:r>
-              <a:rPr sz="1800"/>
-              <a:t>Concurrency: arc_usage, hfscheduler, mt_type_bounds, toplevel_coarse_rwlocks, tsm, rwlock_tsm</a:t>
-            </a:r>
-          </a:p>
-          <a:p>
-            <a:pPr lvl="0"/>
-            <a:r>
-              <a:rPr sz="1800"/>
-              <a:t>Iteration: iterators, wrapping_iterators, iterator_ptt</a:t>
-            </a:r>
-          </a:p>
-          <a:p>
-            <a:pPr lvl="0"/>
-            <a:r>
-              <a:rPr sz="1800"/>
-              <a:t>Execution: mut, using_closures, using_hashmap, using_rand</a:t>
-            </a:r>
-          </a:p>
-          <a:p>
-            <a:pPr lvl="0"/>
-            <a:r>
-              <a:rPr sz="1800"/>
-              <a:t>Style: TOC and ordering</a:t>
+              <a:t>Purpose: encode hard-won proof patterns so agents don’t repeat mistakes</a:t>
+            </a:r>
+          </a:p>
+          <a:p>
+            <a:pPr lvl="0"/>
+            <a:r>
+              <a:rPr sz="1800"/>
+              <a:t>Agents read all standards before every task (~6,200 lines, ~54K tokens)</a:t>
+            </a:r>
+          </a:p>
+          <a:p>
+            <a:pPr lvl="0"/>
+            <a:r>
+              <a:rPr sz="1800"/>
+              <a:t>Violations are only agent checked except for many code style issues.</a:t>
+            </a:r>
+          </a:p>
+          <a:p>
+            <a:pPr lvl="0"/>
+            <a:r>
+              <a:rPr sz="1800"/>
+              <a:t>Quantitatives:</a:t>
+            </a:r>
+          </a:p>
+          <a:p>
+            <a:pPr lvl="0"/>
+            <a:r>
+              <a:rPr sz="1800"/>
+              <a:t>29 standard files</a:t>
+            </a:r>
+          </a:p>
+          <a:p>
+            <a:pPr lvl="0"/>
+            <a:r>
+              <a:rPr sz="1800"/>
+              <a:t>6,911 lines total</a:t>
             </a:r>
           </a:p>
         </p:txBody>
@@ -7396,7 +7382,7 @@
             </a:pPr>
             <a:r>
               <a:rPr sz="3200"/>
-              <a:t>Veracity: veracity-minimize-proofs: AIs Write Redundant Proofs</a:t>
+              <a:t>APAS-VERUS Standards</a:t>
             </a:r>
           </a:p>
         </p:txBody>
@@ -7419,28 +7405,49 @@
             <a:pPr lvl="0"/>
             <a:r>
               <a:rPr sz="1800"/>
-              <a:t>AI proof agents produce correct but bloated proofs — redundant asserts, unnecessary proof blocks, duplicate intermediate steps that Z3 already knew.</a:t>
-            </a:r>
-          </a:p>
-          <a:p>
-            <a:pPr lvl="0"/>
-            <a:r>
-              <a:rPr sz="1800"/>
-              <a:t>They verify, but they waste solver budget on every subsequent run.</a:t>
-            </a:r>
-          </a:p>
-          <a:p>
-            <a:pPr lvl="0"/>
-            <a:r>
-              <a:rPr sz="1800"/>
-              <a:t>veracity-minimize-proofs tests each assert and proof block individually: remove it, re-verify, keep it out if still clean.</a:t>
-            </a:r>
-          </a:p>
-          <a:p>
-            <a:pPr lvl="0"/>
-            <a:r>
-              <a:rPr sz="1800"/>
-              <a:t>Result across APAS-VERUS: 22 asserts and 33 proof blocks removed in 105 minutes of wall time. 55 redundant proof statements eliminated, ~2 minutes of minimizer time per removal.</a:t>
+              <a:t>Module structure: mod, table_of_contents, spec_naming, spec_wf</a:t>
+            </a:r>
+          </a:p>
+          <a:p>
+            <a:pPr lvl="0"/>
+            <a:r>
+              <a:rPr sz="1800"/>
+              <a:t>Type system: view, deep_view, partial_eq_eq_clone, multi_struct</a:t>
+            </a:r>
+          </a:p>
+          <a:p>
+            <a:pPr lvl="0"/>
+            <a:r>
+              <a:rPr sz="1800"/>
+              <a:t>Proof patterns: total_order, finite_sets, capacity_bounds, no_unsafe</a:t>
+            </a:r>
+          </a:p>
+          <a:p>
+            <a:pPr lvl="0"/>
+            <a:r>
+              <a:rPr sz="1800"/>
+              <a:t>Concurrency: arc_usage, hfscheduler, mt_type_bounds, toplevel_coarse_rwlocks, tsm, rwlock_tsm</a:t>
+            </a:r>
+          </a:p>
+          <a:p>
+            <a:pPr lvl="0"/>
+            <a:r>
+              <a:rPr sz="1800"/>
+              <a:t>Iteration: iterators, wrapping_iterators, iterator_ptt</a:t>
+            </a:r>
+          </a:p>
+          <a:p>
+            <a:pPr lvl="0"/>
+            <a:r>
+              <a:rPr sz="1800"/>
+              <a:t>Execution: mut, using_closures, using_hashmap, using_rand</a:t>
+            </a:r>
+          </a:p>
+          <a:p>
+            <a:pPr lvl="0"/>
+            <a:r>
+              <a:rPr sz="1800"/>
+              <a:t>Style: TOC and ordering</a:t>
             </a:r>
           </a:p>
         </p:txBody>
@@ -7510,49 +7517,28 @@
             <a:pPr lvl="0"/>
             <a:r>
               <a:rPr sz="1800"/>
-              <a:t>It only takes out unnecessary asserts/proofs that decrease run time and memory.</a:t>
-            </a:r>
-          </a:p>
-          <a:p>
-            <a:pPr lvl="0"/>
-            <a:r>
-              <a:rPr sz="1800"/>
-              <a:t>One assert in Chap43 OrderedTableMtEph saved:</a:t>
-            </a:r>
-          </a:p>
-          <a:p>
-            <a:pPr lvl="1"/>
-            <a:r>
-              <a:rPr sz="1800"/>
-              <a:t>43–104 s of Z3 CPU</a:t>
-            </a:r>
-          </a:p>
-          <a:p>
-            <a:pPr lvl="1"/>
-            <a:r>
-              <a:rPr sz="1800"/>
-              <a:t>up to 89 MB of Z3 RSS per verify run.</a:t>
-            </a:r>
-          </a:p>
-          <a:p>
-            <a:pPr lvl="0"/>
-            <a:r>
-              <a:rPr sz="1800"/>
-              <a:t>Eight removals in that one file: Z3 RSS −57%.</a:t>
-            </a:r>
-          </a:p>
-          <a:p>
-            <a:pPr lvl="0"/>
-            <a:r>
-              <a:rPr sz="1800"/>
-              <a:t>105 minutes of running the minimizer bought many hours of validation drop.</a:t>
-            </a:r>
-          </a:p>
-          <a:p>
-            <a:pPr lvl="0"/>
-            <a:r>
-              <a:rPr sz="1800"/>
-              <a:t>This might be novel. Anyone know of anything except Isabelle’s sledgehammer?</a:t>
+              <a:t>AI proof agents produce correct but bloated proofs — redundant asserts, unnecessary proof blocks, duplicate intermediate steps that Z3 already knew.</a:t>
+            </a:r>
+          </a:p>
+          <a:p>
+            <a:pPr lvl="0"/>
+            <a:r>
+              <a:rPr sz="1800"/>
+              <a:t>They verify, but they waste solver budget on every subsequent run.</a:t>
+            </a:r>
+          </a:p>
+          <a:p>
+            <a:pPr lvl="0"/>
+            <a:r>
+              <a:rPr sz="1800"/>
+              <a:t>veracity-minimize-proofs tests each assert and proof block individually: remove it, re-verify, comment it out if it is not needed and it does not increase time or memory.</a:t>
+            </a:r>
+          </a:p>
+          <a:p>
+            <a:pPr lvl="0"/>
+            <a:r>
+              <a:rPr sz="1800"/>
+              <a:t>Result across APAS-VERUS: 22 asserts and 33 proof blocks removed in 105 minutes of wall time. 55 redundant proof statements eliminated, ~2 minutes of minimizer time per removal.</a:t>
             </a:r>
           </a:p>
         </p:txBody>
@@ -7599,7 +7585,7 @@
             </a:pPr>
             <a:r>
               <a:rPr sz="3200"/>
-              <a:t>Veracity Annotations</a:t>
+              <a:t>Veracity: veracity-minimize-proofs: AIs Write Redundant Proofs</a:t>
             </a:r>
           </a:p>
         </p:txBody>
@@ -7622,49 +7608,42 @@
             <a:pPr lvl="0"/>
             <a:r>
               <a:rPr sz="1800"/>
-              <a:t>I ended up having to have my tools work mostly in comments.</a:t>
-            </a:r>
-          </a:p>
-          <a:p>
-            <a:pPr lvl="0"/>
-            <a:r>
-              <a:rPr sz="1800"/>
-              <a:t>I added accept to mark assumes I allowed, almost all eq/partialeq/clone.</a:t>
-            </a:r>
-          </a:p>
-          <a:p>
-            <a:pPr lvl="0"/>
-            <a:r>
-              <a:rPr sz="1800"/>
-              <a:t>This can be simplified with some Verus language syntax, but then the AIs are not trained on the symbols.</a:t>
-            </a:r>
-          </a:p>
-          <a:p>
-            <a:pPr lvl="0"/>
-            <a:r>
-              <a:rPr sz="1800"/>
-              <a:t>// Veracity: NEEDED assert — 6,081</a:t>
-            </a:r>
-          </a:p>
-          <a:p>
-            <a:pPr lvl="0"/>
-            <a:r>
-              <a:rPr sz="1800"/>
-              <a:t>// Veracity: NEEDED proof block — 4,681</a:t>
-            </a:r>
-          </a:p>
-          <a:p>
-            <a:pPr lvl="0"/>
-            <a:r>
-              <a:rPr sz="1800"/>
-              <a:t>// Veracity: NEEDED assert (speed) — 1,502</a:t>
-            </a:r>
-          </a:p>
-          <a:p>
-            <a:pPr lvl="0"/>
-            <a:r>
-              <a:rPr sz="1800"/>
-              <a:t>// Veracity: NEEDED proof block (speed)— 245</a:t>
+              <a:t>One assert in Chap43 OrderedTableMtEph saved:</a:t>
+            </a:r>
+          </a:p>
+          <a:p>
+            <a:pPr lvl="1"/>
+            <a:r>
+              <a:rPr sz="1800"/>
+              <a:t>43–104 s of Z3 CPU</a:t>
+            </a:r>
+          </a:p>
+          <a:p>
+            <a:pPr lvl="1"/>
+            <a:r>
+              <a:rPr sz="1800"/>
+              <a:t>up to 89 MB of Z3 RSS per verify run.</a:t>
+            </a:r>
+          </a:p>
+          <a:p>
+            <a:pPr lvl="0"/>
+            <a:r>
+              <a:rPr sz="1800"/>
+              <a:t>Eight removals in that one file: Z3 RSS −57%.</a:t>
+            </a:r>
+          </a:p>
+          <a:p>
+            <a:pPr lvl="0"/>
+            <a:r>
+              <a:rPr sz="1800"/>
+              <a:t>105 minutes of running the minimizer bought many hours of validation drop.</a:t>
+            </a:r>
+          </a:p>
+          <a:p>
+            <a:pPr lvl="0"/>
+            <a:r>
+              <a:rPr sz="1800"/>
+              <a:t>This might be novel. Anyone know of anything except Isabelle’s sledgehammer?</a:t>
             </a:r>
           </a:p>
         </p:txBody>
@@ -7734,35 +7713,49 @@
             <a:pPr lvl="0"/>
             <a:r>
               <a:rPr sz="1800"/>
-              <a:t>Total NEEDED: 12,509</a:t>
-            </a:r>
-          </a:p>
-          <a:p>
-            <a:pPr lvl="0"/>
-            <a:r>
-              <a:rPr sz="1800"/>
-              <a:t>// Veracity: UNNEEDED — 1,452</a:t>
-            </a:r>
-          </a:p>
-          <a:p>
-            <a:pPr lvl="0"/>
-            <a:r>
-              <a:rPr sz="1800"/>
-              <a:t>// Veracity: no_requires — 71</a:t>
-            </a:r>
-          </a:p>
-          <a:p>
-            <a:pPr lvl="0"/>
-            <a:r>
-              <a:rPr sz="1800"/>
-              <a:t>accept — 108</a:t>
-            </a:r>
-          </a:p>
-          <a:p>
-            <a:pPr lvl="0"/>
-            <a:r>
-              <a:rPr sz="1800"/>
-              <a:t>Total annotations: 14,140</a:t>
+              <a:t>I ended up having to have my tools work mostly in comments.</a:t>
+            </a:r>
+          </a:p>
+          <a:p>
+            <a:pPr lvl="0"/>
+            <a:r>
+              <a:rPr sz="1800"/>
+              <a:t>I added accept to mark assumes I allowed, almost all eq/partialeq/clone.</a:t>
+            </a:r>
+          </a:p>
+          <a:p>
+            <a:pPr lvl="0"/>
+            <a:r>
+              <a:rPr sz="1800"/>
+              <a:t>This can be simplified with some Verus language syntax, but then the AIs are not trained on the symbols.</a:t>
+            </a:r>
+          </a:p>
+          <a:p>
+            <a:pPr lvl="0"/>
+            <a:r>
+              <a:rPr sz="1800"/>
+              <a:t>// Veracity: NEEDED assert — 6,081</a:t>
+            </a:r>
+          </a:p>
+          <a:p>
+            <a:pPr lvl="0"/>
+            <a:r>
+              <a:rPr sz="1800"/>
+              <a:t>// Veracity: NEEDED proof block — 4,681</a:t>
+            </a:r>
+          </a:p>
+          <a:p>
+            <a:pPr lvl="0"/>
+            <a:r>
+              <a:rPr sz="1800"/>
+              <a:t>// Veracity: NEEDED assert (speed) — 1,502</a:t>
+            </a:r>
+          </a:p>
+          <a:p>
+            <a:pPr lvl="0"/>
+            <a:r>
+              <a:rPr sz="1800"/>
+              <a:t>// Veracity: NEEDED proof block (speed)— 245</a:t>
             </a:r>
           </a:p>
         </p:txBody>
@@ -7809,7 +7802,7 @@
             </a:pPr>
             <a:r>
               <a:rPr sz="3200"/>
-              <a:t>Rusticate + Veracity allow quantitative software engineering</a:t>
+              <a:t>Veracity Annotations</a:t>
             </a:r>
           </a:p>
         </p:txBody>
@@ -7832,49 +7825,35 @@
             <a:pPr lvl="0"/>
             <a:r>
               <a:rPr sz="1800"/>
-              <a:t>I downloaded the 1036 most downloaded Rust projects, 3636 crates.</a:t>
-            </a:r>
-          </a:p>
-          <a:p>
-            <a:pPr lvl="0"/>
-            <a:r>
-              <a:rPr sz="1800"/>
-              <a:t>I threw out three that wrapped std for asynchrony.</a:t>
-            </a:r>
-          </a:p>
-          <a:p>
-            <a:pPr lvl="0"/>
-            <a:r>
-              <a:rPr sz="1800"/>
-              <a:t>I did a greedy set cover analysis of what Rust uses.</a:t>
-            </a:r>
-          </a:p>
-          <a:p>
-            <a:pPr lvl="0"/>
-            <a:r>
-              <a:rPr sz="1800"/>
-              <a:t>And another of what verus wraps.</a:t>
-            </a:r>
-          </a:p>
-          <a:p>
-            <a:pPr lvl="0"/>
-            <a:r>
-              <a:rPr sz="1800"/>
-              <a:t>This is a golden age for quantitative software engineering.</a:t>
-            </a:r>
-          </a:p>
-          <a:p>
-            <a:pPr lvl="0"/>
-            <a:r>
-              <a:rPr sz="1800"/>
-              <a:t>It took just two days of person time.</a:t>
-            </a:r>
-          </a:p>
-          <a:p>
-            <a:pPr lvl="0"/>
-            <a:r>
-              <a:rPr sz="1800"/>
-              <a:t>And I never read a line of code in the tools. Just check the output and have the AI write a lot of tests.</a:t>
+              <a:t>Total NEEDED: 12,509</a:t>
+            </a:r>
+          </a:p>
+          <a:p>
+            <a:pPr lvl="0"/>
+            <a:r>
+              <a:rPr sz="1800"/>
+              <a:t>// Veracity: UNNEEDED — 1,452</a:t>
+            </a:r>
+          </a:p>
+          <a:p>
+            <a:pPr lvl="0"/>
+            <a:r>
+              <a:rPr sz="1800"/>
+              <a:t>// Veracity: no_requires — 71</a:t>
+            </a:r>
+          </a:p>
+          <a:p>
+            <a:pPr lvl="0"/>
+            <a:r>
+              <a:rPr sz="1800"/>
+              <a:t>accept — 108</a:t>
+            </a:r>
+          </a:p>
+          <a:p>
+            <a:pPr lvl="0"/>
+            <a:r>
+              <a:rPr sz="1800"/>
+              <a:t>Total annotations: 14,140</a:t>
             </a:r>
           </a:p>
         </p:txBody>
@@ -7921,7 +7900,7 @@
             </a:pPr>
             <a:r>
               <a:rPr sz="3200"/>
-              <a:t>Rusticate + Veracity : What Rust Cargos use in std.</a:t>
+              <a:t>Rusticate + Veracity allow quantitative software engineering</a:t>
             </a:r>
           </a:p>
         </p:txBody>
@@ -7944,49 +7923,49 @@
             <a:pPr lvl="0"/>
             <a:r>
               <a:rPr sz="1800"/>
-              <a:t>Top 1000 projects, 3636 crates.</a:t>
-            </a:r>
-          </a:p>
-          <a:p>
-            <a:pPr lvl="0"/>
-            <a:r>
-              <a:rPr sz="1800"/>
-              <a:t>19 data types fully support 90%.</a:t>
-            </a:r>
-          </a:p>
-          <a:p>
-            <a:pPr lvl="0"/>
-            <a:r>
-              <a:rPr sz="1800"/>
-              <a:t>48 data types fully support 100%.</a:t>
-            </a:r>
-          </a:p>
-          <a:p>
-            <a:pPr lvl="0"/>
-            <a:r>
-              <a:rPr sz="1800"/>
-              <a:t>69 modules fully support 95%.</a:t>
-            </a:r>
-          </a:p>
-          <a:p>
-            <a:pPr lvl="0"/>
-            <a:r>
-              <a:rPr sz="1800"/>
-              <a:t>79 modules fully support 99%.</a:t>
-            </a:r>
-          </a:p>
-          <a:p>
-            <a:pPr lvl="0"/>
-            <a:r>
-              <a:rPr sz="1800"/>
-              <a:t>1121 methods fully support 95%.</a:t>
-            </a:r>
-          </a:p>
-          <a:p>
-            <a:pPr lvl="0"/>
-            <a:r>
-              <a:rPr sz="1800"/>
-              <a:t>1733 methods fully support 99%.</a:t>
+              <a:t>I downloaded the 1036 most downloaded Rust projects, 3636 crates.</a:t>
+            </a:r>
+          </a:p>
+          <a:p>
+            <a:pPr lvl="0"/>
+            <a:r>
+              <a:rPr sz="1800"/>
+              <a:t>I threw out three that wrapped std for asynchrony.</a:t>
+            </a:r>
+          </a:p>
+          <a:p>
+            <a:pPr lvl="0"/>
+            <a:r>
+              <a:rPr sz="1800"/>
+              <a:t>I did a greedy set cover analysis of what Rust uses.</a:t>
+            </a:r>
+          </a:p>
+          <a:p>
+            <a:pPr lvl="0"/>
+            <a:r>
+              <a:rPr sz="1800"/>
+              <a:t>And another of what verus wraps.</a:t>
+            </a:r>
+          </a:p>
+          <a:p>
+            <a:pPr lvl="0"/>
+            <a:r>
+              <a:rPr sz="1800"/>
+              <a:t>This is a golden age for quantitative software engineering.</a:t>
+            </a:r>
+          </a:p>
+          <a:p>
+            <a:pPr lvl="0"/>
+            <a:r>
+              <a:rPr sz="1800"/>
+              <a:t>It took just two days of person time.</a:t>
+            </a:r>
+          </a:p>
+          <a:p>
+            <a:pPr lvl="0"/>
+            <a:r>
+              <a:rPr sz="1800"/>
+              <a:t>And I never read a line of code in the tools. Just check the output and have the AI write a lot of tests.</a:t>
             </a:r>
           </a:p>
         </p:txBody>
@@ -8033,7 +8012,7 @@
             </a:pPr>
             <a:r>
               <a:rPr sz="3200"/>
-              <a:t>Compare Rust STD to APAS-VERUS?</a:t>
+              <a:t>Rusticate + Veracity : What Rust Cargos use in std.</a:t>
             </a:r>
           </a:p>
         </p:txBody>
@@ -8056,21 +8035,70 @@
             <a:pPr lvl="0"/>
             <a:r>
               <a:rPr sz="1800"/>
-              <a:t>APAS-VERUS: -6,401 exec functions total, -4,911 with proofs</a:t>
-            </a:r>
-          </a:p>
-          <a:p>
-            <a:pPr lvl="0"/>
-            <a:r>
-              <a:rPr sz="1800"/>
-              <a:t>But APAS-VERUS has {Mt,St}x{Per,Eph}</a:t>
-            </a:r>
-          </a:p>
-          <a:p>
-            <a:pPr lvl="0"/>
-            <a:r>
-              <a:rPr sz="1800"/>
-              <a:t>So it much more like 2000 distinct functions.</a:t>
+              <a:t>Top 1000 projects, 3636 crates.</a:t>
+            </a:r>
+          </a:p>
+          <a:p>
+            <a:pPr lvl="0"/>
+            <a:r>
+              <a:rPr sz="1800"/>
+              <a:t>19 data types fully support 90%.</a:t>
+            </a:r>
+          </a:p>
+          <a:p>
+            <a:pPr lvl="0"/>
+            <a:r>
+              <a:rPr sz="1800"/>
+              <a:t>48 data types fully support 100%.</a:t>
+            </a:r>
+          </a:p>
+          <a:p>
+            <a:pPr lvl="0"/>
+            <a:r>
+              <a:rPr sz="1800"/>
+              <a:t>69 modules fully support 95%.</a:t>
+            </a:r>
+          </a:p>
+          <a:p>
+            <a:pPr lvl="0"/>
+            <a:r>
+              <a:rPr sz="1800"/>
+              <a:t>79 modules fully support 99%.</a:t>
+            </a:r>
+          </a:p>
+          <a:p>
+            <a:pPr lvl="0"/>
+            <a:r>
+              <a:rPr sz="1800"/>
+              <a:t>1121 methods fully support 95%.</a:t>
+            </a:r>
+          </a:p>
+          <a:p>
+            <a:pPr lvl="0"/>
+            <a:r>
+              <a:rPr sz="1800"/>
+              <a:t>1733 methods fully support 99%.</a:t>
+            </a:r>
+          </a:p>
+          <a:p>
+            <a:pPr lvl="0"/>
+            <a:r>
+              <a:rPr sz="1800"/>
+              <a:t>14,317 total fn definitions in std/core/alloc in Rust</a:t>
+            </a:r>
+          </a:p>
+          <a:p>
+            <a:pPr lvl="0"/>
+            <a:r>
+              <a:rPr sz="1800"/>
+              <a:t>4,965 pub fn definitions in std/core/alloc in Rust</a:t>
+            </a:r>
+          </a:p>
+          <a:p>
+            <a:pPr lvl="0"/>
+            <a:r>
+              <a:rPr sz="1800"/>
+              <a:t>But how many of those private functions do we need? I don’t know.</a:t>
             </a:r>
           </a:p>
         </p:txBody>
@@ -8117,7 +8145,7 @@
             </a:pPr>
             <a:r>
               <a:rPr sz="3200"/>
-              <a:t>Rusticate + Veracity: What Verus Wraps</a:t>
+              <a:t>Compare Rust STD to APAS-VERUS?</a:t>
             </a:r>
           </a:p>
         </p:txBody>
@@ -8140,49 +8168,21 @@
             <a:pPr lvl="0"/>
             <a:r>
               <a:rPr sz="1800"/>
-              <a:t>As of 2026 14 April</a:t>
-            </a:r>
-          </a:p>
-          <a:p>
-            <a:pPr lvl="0"/>
-            <a:r>
-              <a:rPr sz="1800"/>
-              <a:t>How many Rust Data Types does Verus wrap?</a:t>
-            </a:r>
-          </a:p>
-          <a:p>
-            <a:pPr lvl="1"/>
-            <a:r>
-              <a:rPr sz="1800"/>
-              <a:t>29 types currently wrapped.</a:t>
-            </a:r>
-          </a:p>
-          <a:p>
-            <a:pPr lvl="0"/>
-            <a:r>
-              <a:rPr sz="1800"/>
-              <a:t>How many Rust Traits does Verus wrap?</a:t>
-            </a:r>
-          </a:p>
-          <a:p>
-            <a:pPr lvl="1"/>
-            <a:r>
-              <a:rPr sz="1800"/>
-              <a:t>147 traits in vstd.</a:t>
-            </a:r>
-          </a:p>
-          <a:p>
-            <a:pPr lvl="0"/>
-            <a:r>
-              <a:rPr sz="1800"/>
-              <a:t>How many total Rust Methods does Verus wrap?</a:t>
-            </a:r>
-          </a:p>
-          <a:p>
-            <a:pPr lvl="1"/>
-            <a:r>
-              <a:rPr sz="1800"/>
-              <a:t>154 methods currently wrapped.</a:t>
+              <a:t>APAS-VERUS: -6,401 exec functions total, -4,911 with proofs</a:t>
+            </a:r>
+          </a:p>
+          <a:p>
+            <a:pPr lvl="0"/>
+            <a:r>
+              <a:rPr sz="1800"/>
+              <a:t>But APAS-VERUS has {Mt,St}x{Per,Eph}</a:t>
+            </a:r>
+          </a:p>
+          <a:p>
+            <a:pPr lvl="0"/>
+            <a:r>
+              <a:rPr sz="1800"/>
+              <a:t>So it is much more like 2000 distinct functions.</a:t>
             </a:r>
           </a:p>
         </p:txBody>
@@ -8284,6 +8284,118 @@
 </file>
 
 <file path=ppt/slides/slide50.xml><?xml version="1.0" encoding="utf-8"?>
+<p:sld xmlns:a="http://schemas.openxmlformats.org/drawingml/2006/main" xmlns:r="http://schemas.openxmlformats.org/officeDocument/2006/relationships" xmlns:p="http://schemas.openxmlformats.org/presentationml/2006/main">
+  <p:cSld>
+    <p:spTree>
+      <p:nvGrpSpPr>
+        <p:cNvPr id="1" name=""/>
+        <p:cNvGrpSpPr/>
+        <p:nvPr/>
+      </p:nvGrpSpPr>
+      <p:grpSpPr>
+        <a:xfrm>
+          <a:off x="0" y="0"/>
+          <a:ext cx="0" cy="0"/>
+          <a:chOff x="0" y="0"/>
+          <a:chExt cx="0" cy="0"/>
+        </a:xfrm>
+      </p:grpSpPr>
+      <p:sp>
+        <p:nvSpPr>
+          <p:cNvPr id="2" name="Title 1"/>
+          <p:cNvSpPr>
+            <a:spLocks noGrp="1"/>
+          </p:cNvSpPr>
+          <p:nvPr>
+            <p:ph type="title"/>
+          </p:nvPr>
+        </p:nvSpPr>
+        <p:spPr/>
+        <p:txBody>
+          <a:bodyPr/>
+          <a:lstStyle/>
+          <a:p>
+            <a:pPr lvl="0" indent="0" marL="0">
+              <a:buNone/>
+            </a:pPr>
+            <a:r>
+              <a:rPr sz="3200"/>
+              <a:t>Rusticate + Veracity: What Verus Wraps</a:t>
+            </a:r>
+          </a:p>
+        </p:txBody>
+      </p:sp>
+      <p:sp>
+        <p:nvSpPr>
+          <p:cNvPr id="3" name="Content Placeholder 2"/>
+          <p:cNvSpPr>
+            <a:spLocks noGrp="1"/>
+          </p:cNvSpPr>
+          <p:nvPr>
+            <p:ph idx="1"/>
+          </p:nvPr>
+        </p:nvSpPr>
+        <p:spPr/>
+        <p:txBody>
+          <a:bodyPr/>
+          <a:lstStyle/>
+          <a:p>
+            <a:pPr lvl="0"/>
+            <a:r>
+              <a:rPr sz="1800"/>
+              <a:t>As of 2026 14 April</a:t>
+            </a:r>
+          </a:p>
+          <a:p>
+            <a:pPr lvl="0"/>
+            <a:r>
+              <a:rPr sz="1800"/>
+              <a:t>How many Rust Data Types does Verus wrap?</a:t>
+            </a:r>
+          </a:p>
+          <a:p>
+            <a:pPr lvl="1"/>
+            <a:r>
+              <a:rPr sz="1800"/>
+              <a:t>29 types currently wrapped.</a:t>
+            </a:r>
+          </a:p>
+          <a:p>
+            <a:pPr lvl="0"/>
+            <a:r>
+              <a:rPr sz="1800"/>
+              <a:t>How many Rust Traits does Verus wrap?</a:t>
+            </a:r>
+          </a:p>
+          <a:p>
+            <a:pPr lvl="1"/>
+            <a:r>
+              <a:rPr sz="1800"/>
+              <a:t>147 traits in vstd.</a:t>
+            </a:r>
+          </a:p>
+          <a:p>
+            <a:pPr lvl="0"/>
+            <a:r>
+              <a:rPr sz="1800"/>
+              <a:t>How many total Rust Methods does Verus wrap?</a:t>
+            </a:r>
+          </a:p>
+          <a:p>
+            <a:pPr lvl="1"/>
+            <a:r>
+              <a:rPr sz="1800"/>
+              <a:t>154 methods currently wrapped.</a:t>
+            </a:r>
+          </a:p>
+        </p:txBody>
+      </p:sp>
+    </p:spTree>
+  </p:cSld>
+</p:sld>
+</file>
+
+<file path=ppt/slides/slide51.xml><?xml version="1.0" encoding="utf-8"?>
 <p:sld xmlns:a="http://schemas.openxmlformats.org/drawingml/2006/main" xmlns:r="http://schemas.openxmlformats.org/officeDocument/2006/relationships" xmlns:p="http://schemas.openxmlformats.org/presentationml/2006/main">
   <p:cSld>
     <p:spTree>
@@ -8360,7 +8472,7 @@
 </p:sld>
 </file>
 
-<file path=ppt/slides/slide51.xml><?xml version="1.0" encoding="utf-8"?>
+<file path=ppt/slides/slide52.xml><?xml version="1.0" encoding="utf-8"?>
 <p:sld xmlns:a="http://schemas.openxmlformats.org/drawingml/2006/main" xmlns:r="http://schemas.openxmlformats.org/officeDocument/2006/relationships" xmlns:p="http://schemas.openxmlformats.org/presentationml/2006/main">
   <p:cSld>
     <p:spTree>
@@ -8437,72 +8549,6 @@
 </p:sld>
 </file>
 
-<file path=ppt/slides/slide52.xml><?xml version="1.0" encoding="utf-8"?>
-<p:sld xmlns:a="http://schemas.openxmlformats.org/drawingml/2006/main" xmlns:r="http://schemas.openxmlformats.org/officeDocument/2006/relationships" xmlns:p="http://schemas.openxmlformats.org/presentationml/2006/main">
-  <p:cSld>
-    <p:spTree>
-      <p:nvGrpSpPr>
-        <p:cNvPr id="1" name=""/>
-        <p:cNvGrpSpPr/>
-        <p:nvPr/>
-      </p:nvGrpSpPr>
-      <p:grpSpPr>
-        <a:xfrm>
-          <a:off x="0" y="0"/>
-          <a:ext cx="0" cy="0"/>
-          <a:chOff x="0" y="0"/>
-          <a:chExt cx="0" cy="0"/>
-        </a:xfrm>
-      </p:grpSpPr>
-      <p:sp>
-        <p:nvSpPr>
-          <p:cNvPr id="3" name="Content Placeholder 2"/>
-          <p:cNvSpPr>
-            <a:spLocks noGrp="1"/>
-          </p:cNvSpPr>
-          <p:nvPr>
-            <p:ph idx="1"/>
-          </p:nvPr>
-        </p:nvSpPr>
-        <p:spPr/>
-        <p:txBody>
-          <a:bodyPr/>
-          <a:lstStyle/>
-          <a:p>
-            <a:pPr lvl="0"/>
-            <a:r>
-              <a:rPr sz="1800"/>
-              <a:t>Three levers: minimize-proofs, profiling (find matching loops), opaque (hide definitions).</a:t>
-            </a:r>
-          </a:p>
-          <a:p>
-            <a:pPr lvl="0"/>
-            <a:r>
-              <a:rPr sz="1800"/>
-              <a:t>OrderedTableMtEph: −57% proof time after minimize-proofs (R176).</a:t>
-            </a:r>
-          </a:p>
-          <a:p>
-            <a:pPr lvl="0"/>
-            <a:r>
-              <a:rPr sz="1800"/>
-              <a:t>UnionFindPCStEph: 139K Z3 instantiations → 0 after opaque pattern (R195).</a:t>
-            </a:r>
-          </a:p>
-          <a:p>
-            <a:pPr lvl="0"/>
-            <a:r>
-              <a:rPr sz="1800"/>
-              <a:t>Johnson Chap59: 756 MB → 520 MB (−31%) memory reduction.</a:t>
-            </a:r>
-          </a:p>
-        </p:txBody>
-      </p:sp>
-    </p:spTree>
-  </p:cSld>
-</p:sld>
-</file>
-
 <file path=ppt/slides/slide53.xml><?xml version="1.0" encoding="utf-8"?>
 <p:sld xmlns:a="http://schemas.openxmlformats.org/drawingml/2006/main" xmlns:r="http://schemas.openxmlformats.org/officeDocument/2006/relationships" xmlns:p="http://schemas.openxmlformats.org/presentationml/2006/main">
   <p:cSld>
@@ -8540,7 +8586,7 @@
             </a:pPr>
             <a:r>
               <a:rPr sz="3200"/>
-              <a:t>Software Engineering in AI Paired Proving</a:t>
+              <a:t>Proof Time and Memory — Key Reductions</a:t>
             </a:r>
           </a:p>
         </p:txBody>
@@ -8563,42 +8609,63 @@
             <a:pPr lvl="0"/>
             <a:r>
               <a:rPr sz="1800"/>
-              <a:t>Software engineering in the AI age is much like managing programmers.</a:t>
-            </a:r>
-          </a:p>
-          <a:p>
-            <a:pPr lvl="0"/>
-            <a:r>
-              <a:rPr sz="1800"/>
-              <a:t>You can’t possibly read all their code.</a:t>
-            </a:r>
-          </a:p>
-          <a:p>
-            <a:pPr lvl="0"/>
-            <a:r>
-              <a:rPr sz="1800"/>
-              <a:t>So you have:</a:t>
-            </a:r>
-          </a:p>
-          <a:p>
-            <a:pPr lvl="0"/>
-            <a:r>
-              <a:rPr sz="1800"/>
-              <a:t>linters both programmatic and AI</a:t>
-            </a:r>
-          </a:p>
-          <a:p>
-            <a:pPr lvl="0"/>
-            <a:r>
-              <a:rPr sz="1800"/>
-              <a:t>stylers both programmatic and AI</a:t>
-            </a:r>
-          </a:p>
-          <a:p>
-            <a:pPr lvl="0"/>
-            <a:r>
-              <a:rPr sz="1800"/>
-              <a:t>AI reviews directed by programmatic.</a:t>
+              <a:t>Five techiniques were used to optimize</a:t>
+            </a:r>
+          </a:p>
+          <a:p>
+            <a:pPr lvl="1"/>
+            <a:r>
+              <a:rPr sz="1800"/>
+              <a:t>minimize-proofs</a:t>
+            </a:r>
+          </a:p>
+          <a:p>
+            <a:pPr lvl="1"/>
+            <a:r>
+              <a:rPr sz="1800"/>
+              <a:t>profiling</a:t>
+            </a:r>
+          </a:p>
+          <a:p>
+            <a:pPr lvl="1"/>
+            <a:r>
+              <a:rPr sz="1800"/>
+              <a:t>splitting specs and applying them just where they are needed</a:t>
+            </a:r>
+          </a:p>
+          <a:p>
+            <a:pPr lvl="1"/>
+            <a:r>
+              <a:rPr sz="1800"/>
+              <a:t>opaque - to hide a definition within the module</a:t>
+            </a:r>
+          </a:p>
+          <a:p>
+            <a:pPr lvl="1"/>
+            <a:r>
+              <a:rPr sz="1800"/>
+              <a:t>private spec - to hide a definition across modules</a:t>
+            </a:r>
+          </a:p>
+          <a:p>
+            <a:pPr lvl="0"/>
+            <a:r>
+              <a:rPr sz="1800"/>
+              <a:t>OrderedTableMtEph: −57% proof time after minimize-proofs (R176).</a:t>
+            </a:r>
+          </a:p>
+          <a:p>
+            <a:pPr lvl="0"/>
+            <a:r>
+              <a:rPr sz="1800"/>
+              <a:t>UnionFindPCStEph: 139K Z3 instantiations → 0 after opaque pattern used in a required module.</a:t>
+            </a:r>
+          </a:p>
+          <a:p>
+            <a:pPr lvl="0"/>
+            <a:r>
+              <a:rPr sz="1800"/>
+              <a:t>Johnson Chap59: 756 MB → 520 MB (−31%) memory reduction.</a:t>
             </a:r>
           </a:p>
         </p:txBody>
@@ -8668,42 +8735,42 @@
             <a:pPr lvl="0"/>
             <a:r>
               <a:rPr sz="1800"/>
-              <a:t>Starting with a textbook that has a ton of good prose is a huge plus.</a:t>
-            </a:r>
-          </a:p>
-          <a:p>
-            <a:pPr lvl="0"/>
-            <a:r>
-              <a:rPr sz="1800"/>
-              <a:t>I did discover a few things about the textbook.</a:t>
-            </a:r>
-          </a:p>
-          <a:p>
-            <a:pPr lvl="0"/>
-            <a:r>
-              <a:rPr sz="1800"/>
-              <a:t>It needs more on Scheduling. I only built Help-First scheduling.</a:t>
-            </a:r>
-          </a:p>
-          <a:p>
-            <a:pPr lvl="0"/>
-            <a:r>
-              <a:rPr sz="1800"/>
-              <a:t>It used (K,V) in tree sets as mappings, but I had to make this explicit. Particularly with an Ordered Key Mapping.</a:t>
-            </a:r>
-          </a:p>
-          <a:p>
-            <a:pPr lvl="0"/>
-            <a:r>
-              <a:rPr sz="1800"/>
-              <a:t>APAS’s discussion of Union Find was too thin. Path compression was very difficult.</a:t>
-            </a:r>
-          </a:p>
-          <a:p>
-            <a:pPr lvl="0"/>
-            <a:r>
-              <a:rPr sz="1800"/>
-              <a:t>I had to start with Nikhil Swammy et. al’s AlgoCLRS’s implemention and proofs.</a:t>
+              <a:t>Software engineering in the AI age is much like managing programmers.</a:t>
+            </a:r>
+          </a:p>
+          <a:p>
+            <a:pPr lvl="0"/>
+            <a:r>
+              <a:rPr sz="1800"/>
+              <a:t>You can’t possibly read all their code.</a:t>
+            </a:r>
+          </a:p>
+          <a:p>
+            <a:pPr lvl="0"/>
+            <a:r>
+              <a:rPr sz="1800"/>
+              <a:t>So you have:</a:t>
+            </a:r>
+          </a:p>
+          <a:p>
+            <a:pPr lvl="0"/>
+            <a:r>
+              <a:rPr sz="1800"/>
+              <a:t>linters both programmatic and AI</a:t>
+            </a:r>
+          </a:p>
+          <a:p>
+            <a:pPr lvl="0"/>
+            <a:r>
+              <a:rPr sz="1800"/>
+              <a:t>stylers both programmatic and AI</a:t>
+            </a:r>
+          </a:p>
+          <a:p>
+            <a:pPr lvl="0"/>
+            <a:r>
+              <a:rPr sz="1800"/>
+              <a:t>AI reviews directed by programmatic.</a:t>
             </a:r>
           </a:p>
         </p:txBody>
@@ -8773,70 +8840,42 @@
             <a:pPr lvl="0"/>
             <a:r>
               <a:rPr sz="1800"/>
-              <a:t>I use git work trees for proof.</a:t>
-            </a:r>
-          </a:p>
-          <a:p>
-            <a:pPr lvl="0"/>
-            <a:r>
-              <a:rPr sz="1800"/>
-              <a:t>The good news is git is powerful and the agents understand it.</a:t>
-            </a:r>
-          </a:p>
-          <a:p>
-            <a:pPr lvl="0"/>
-            <a:r>
-              <a:rPr sz="1800"/>
-              <a:t>The bad news is the agents can indeed start using advanced features and get things wrong.</a:t>
-            </a:r>
-          </a:p>
-          <a:p>
-            <a:pPr lvl="0"/>
-            <a:r>
-              <a:rPr sz="1800"/>
-              <a:t>I work with between 1 and 9 agents.</a:t>
-            </a:r>
-          </a:p>
-          <a:p>
-            <a:pPr lvl="0"/>
-            <a:r>
-              <a:rPr sz="1800"/>
-              <a:t>One on veracity.</a:t>
-            </a:r>
-          </a:p>
-          <a:p>
-            <a:pPr lvl="0"/>
-            <a:r>
-              <a:rPr sz="1800"/>
-              <a:t>One orchestrator, writing plan prompts and controlling merges.</a:t>
-            </a:r>
-          </a:p>
-          <a:p>
-            <a:pPr lvl="0"/>
-            <a:r>
-              <a:rPr sz="1800"/>
-              <a:t>1-8 on branches each working on different independent plans.</a:t>
-            </a:r>
-          </a:p>
-          <a:p>
-            <a:pPr lvl="0"/>
-            <a:r>
-              <a:rPr sz="1800"/>
-              <a:t>I am not nearly comfortable enough with agent proof to let them do subagents without observing.</a:t>
-            </a:r>
-          </a:p>
-          <a:p>
-            <a:pPr lvl="0"/>
-            <a:r>
-              <a:rPr sz="1800"/>
-              <a:t>Cursor was much better at interruption to guide things.</a:t>
-            </a:r>
-          </a:p>
-          <a:p>
-            <a:pPr lvl="0"/>
-            <a:r>
-              <a:rPr sz="1800"/>
-              <a:t>Claude is getting better at it.</a:t>
+              <a:t>Starting with a textbook that has a ton of good prose is a huge plus.</a:t>
+            </a:r>
+          </a:p>
+          <a:p>
+            <a:pPr lvl="0"/>
+            <a:r>
+              <a:rPr sz="1800"/>
+              <a:t>I did discover a few things about the textbook.</a:t>
+            </a:r>
+          </a:p>
+          <a:p>
+            <a:pPr lvl="0"/>
+            <a:r>
+              <a:rPr sz="1800"/>
+              <a:t>It needs more on Scheduling. I only built Help-First scheduling.</a:t>
+            </a:r>
+          </a:p>
+          <a:p>
+            <a:pPr lvl="0"/>
+            <a:r>
+              <a:rPr sz="1800"/>
+              <a:t>It used (K,V) in tree sets as mappings, but I had to make this explicit. Particularly with an Ordered Key Mapping.</a:t>
+            </a:r>
+          </a:p>
+          <a:p>
+            <a:pPr lvl="0"/>
+            <a:r>
+              <a:rPr sz="1800"/>
+              <a:t>APAS’s discussion of Union Find was too thin. Path compression was very difficult.</a:t>
+            </a:r>
+          </a:p>
+          <a:p>
+            <a:pPr lvl="0"/>
+            <a:r>
+              <a:rPr sz="1800"/>
+              <a:t>I had to start with Nikhil Swammy et. al’s AlgoCLRS’s implemention and proofs.</a:t>
             </a:r>
           </a:p>
         </p:txBody>
@@ -8883,7 +8922,7 @@
             </a:pPr>
             <a:r>
               <a:rPr sz="3200"/>
-              <a:t>Software Engineering in AI Paired Proving- Models</a:t>
+              <a:t>Software Engineering in AI Paired Proving</a:t>
             </a:r>
           </a:p>
         </p:txBody>
@@ -8906,56 +8945,70 @@
             <a:pPr lvl="0"/>
             <a:r>
               <a:rPr sz="1800"/>
-              <a:t>The agents I used are: various Google, OpenAI and Anthropic.</a:t>
-            </a:r>
-          </a:p>
-          <a:p>
-            <a:pPr lvl="0"/>
-            <a:r>
-              <a:rPr sz="1800"/>
-              <a:t>A google agent once took 12 minutes to ‘echo HI’ to test it’s terminal.</a:t>
-            </a:r>
-          </a:p>
-          <a:p>
-            <a:pPr lvl="0"/>
-            <a:r>
-              <a:rPr sz="1800"/>
-              <a:t>Anthropics models are signficantly better than OpenAI.</a:t>
-            </a:r>
-          </a:p>
-          <a:p>
-            <a:pPr lvl="0"/>
-            <a:r>
-              <a:rPr sz="1800"/>
-              <a:t>And Claude Code’s cost is the least so far.</a:t>
-            </a:r>
-          </a:p>
-          <a:p>
-            <a:pPr lvl="0"/>
-            <a:r>
-              <a:rPr sz="1800"/>
-              <a:t>They are said in the press to be spending $5000 per month per user.</a:t>
-            </a:r>
-          </a:p>
-          <a:p>
-            <a:pPr lvl="0"/>
-            <a:r>
-              <a:rPr sz="1800"/>
-              <a:t>They are buying market share (what happened to Amazon’s buying market share phase?).</a:t>
-            </a:r>
-          </a:p>
-          <a:p>
-            <a:pPr lvl="0"/>
-            <a:r>
-              <a:rPr sz="1800"/>
-              <a:t>And they are buying coding interactions.</a:t>
-            </a:r>
-          </a:p>
-          <a:p>
-            <a:pPr lvl="0"/>
-            <a:r>
-              <a:rPr sz="1800"/>
-              <a:t>But both vendors are playing leap frog.</a:t>
+              <a:t>I use git work trees for proof.</a:t>
+            </a:r>
+          </a:p>
+          <a:p>
+            <a:pPr lvl="0"/>
+            <a:r>
+              <a:rPr sz="1800"/>
+              <a:t>The good news is git is powerful and the agents understand it.</a:t>
+            </a:r>
+          </a:p>
+          <a:p>
+            <a:pPr lvl="0"/>
+            <a:r>
+              <a:rPr sz="1800"/>
+              <a:t>The bad news is the agents can indeed start using advanced features and get things wrong.</a:t>
+            </a:r>
+          </a:p>
+          <a:p>
+            <a:pPr lvl="0"/>
+            <a:r>
+              <a:rPr sz="1800"/>
+              <a:t>I work with between 1 and 9 agents.</a:t>
+            </a:r>
+          </a:p>
+          <a:p>
+            <a:pPr lvl="0"/>
+            <a:r>
+              <a:rPr sz="1800"/>
+              <a:t>One on veracity.</a:t>
+            </a:r>
+          </a:p>
+          <a:p>
+            <a:pPr lvl="0"/>
+            <a:r>
+              <a:rPr sz="1800"/>
+              <a:t>One orchestrator, writing plan prompts and controlling merges.</a:t>
+            </a:r>
+          </a:p>
+          <a:p>
+            <a:pPr lvl="0"/>
+            <a:r>
+              <a:rPr sz="1800"/>
+              <a:t>1-8 on branches each working on different independent plans.</a:t>
+            </a:r>
+          </a:p>
+          <a:p>
+            <a:pPr lvl="0"/>
+            <a:r>
+              <a:rPr sz="1800"/>
+              <a:t>I am not nearly comfortable enough with agent proof to let them do subagents without observing.</a:t>
+            </a:r>
+          </a:p>
+          <a:p>
+            <a:pPr lvl="0"/>
+            <a:r>
+              <a:rPr sz="1800"/>
+              <a:t>Cursor was much better at interruption to guide things.</a:t>
+            </a:r>
+          </a:p>
+          <a:p>
+            <a:pPr lvl="0"/>
+            <a:r>
+              <a:rPr sz="1800"/>
+              <a:t>Claude is getting better at it.</a:t>
             </a:r>
           </a:p>
         </p:txBody>
@@ -9002,7 +9055,7 @@
             </a:pPr>
             <a:r>
               <a:rPr sz="3200"/>
-              <a:t>Software Engineering in AI Paired Proving- Problems</a:t>
+              <a:t>Software Engineering in AI Paired Proving- Models</a:t>
             </a:r>
           </a:p>
         </p:txBody>
@@ -9025,49 +9078,56 @@
             <a:pPr lvl="0"/>
             <a:r>
               <a:rPr sz="1800"/>
-              <a:t>They are inconsistent.</a:t>
-            </a:r>
-          </a:p>
-          <a:p>
-            <a:pPr lvl="0"/>
-            <a:r>
-              <a:rPr sz="1800"/>
-              <a:t>They lie.</a:t>
-            </a:r>
-          </a:p>
-          <a:p>
-            <a:pPr lvl="0"/>
-            <a:r>
-              <a:rPr sz="1800"/>
-              <a:t>They cheat.</a:t>
-            </a:r>
-          </a:p>
-          <a:p>
-            <a:pPr lvl="0"/>
-            <a:r>
-              <a:rPr sz="1800"/>
-              <a:t>They err.</a:t>
-            </a:r>
-          </a:p>
-          <a:p>
-            <a:pPr lvl="0"/>
-            <a:r>
-              <a:rPr sz="1800"/>
-              <a:t>But mostly they are just forgetful.</a:t>
-            </a:r>
-          </a:p>
-          <a:p>
-            <a:pPr lvl="0"/>
-            <a:r>
-              <a:rPr sz="1800"/>
-              <a:t>My attempts to give them coding standard checklists, ala Watts Humphrey and the PSP failed.</a:t>
-            </a:r>
-          </a:p>
-          <a:p>
-            <a:pPr lvl="0"/>
-            <a:r>
-              <a:rPr sz="1800"/>
-              <a:t>Sometimes they would say “The checklist was followed” and then admit “I lied.”</a:t>
+              <a:t>The agents I used are: various Google, OpenAI and Anthropic.</a:t>
+            </a:r>
+          </a:p>
+          <a:p>
+            <a:pPr lvl="0"/>
+            <a:r>
+              <a:rPr sz="1800"/>
+              <a:t>A google agent once took 12 minutes to ‘echo HI’ to test it’s terminal.</a:t>
+            </a:r>
+          </a:p>
+          <a:p>
+            <a:pPr lvl="0"/>
+            <a:r>
+              <a:rPr sz="1800"/>
+              <a:t>Anthropics models are signficantly better than OpenAI.</a:t>
+            </a:r>
+          </a:p>
+          <a:p>
+            <a:pPr lvl="0"/>
+            <a:r>
+              <a:rPr sz="1800"/>
+              <a:t>And Claude Code’s cost is the least so far.</a:t>
+            </a:r>
+          </a:p>
+          <a:p>
+            <a:pPr lvl="0"/>
+            <a:r>
+              <a:rPr sz="1800"/>
+              <a:t>They are said in the press to be spending $5000 per month per user.</a:t>
+            </a:r>
+          </a:p>
+          <a:p>
+            <a:pPr lvl="0"/>
+            <a:r>
+              <a:rPr sz="1800"/>
+              <a:t>They are buying market share (what happened to Amazon’s buying market share phase?).</a:t>
+            </a:r>
+          </a:p>
+          <a:p>
+            <a:pPr lvl="0"/>
+            <a:r>
+              <a:rPr sz="1800"/>
+              <a:t>And they are buying coding interactions.</a:t>
+            </a:r>
+          </a:p>
+          <a:p>
+            <a:pPr lvl="0"/>
+            <a:r>
+              <a:rPr sz="1800"/>
+              <a:t>But both vendors are playing leap frog.</a:t>
             </a:r>
           </a:p>
         </p:txBody>
@@ -9137,49 +9197,49 @@
             <a:pPr lvl="0"/>
             <a:r>
               <a:rPr sz="1800"/>
-              <a:t>They are getting better.</a:t>
-            </a:r>
-          </a:p>
-          <a:p>
-            <a:pPr lvl="0"/>
-            <a:r>
-              <a:rPr sz="1800"/>
-              <a:t>If you tell them you are Dr. FunkenProof and they are Igor, they hallucinate whole modules.</a:t>
-            </a:r>
-          </a:p>
-          <a:p>
-            <a:pPr lvl="0"/>
-            <a:r>
-              <a:rPr sz="1800"/>
-              <a:t>Just a few months ago only Claude could sweep a codebase decently.</a:t>
-            </a:r>
-          </a:p>
-          <a:p>
-            <a:pPr lvl="0"/>
-            <a:r>
-              <a:rPr sz="1800"/>
-              <a:t>Now both Claude and OpenAI can.</a:t>
-            </a:r>
-          </a:p>
-          <a:p>
-            <a:pPr lvl="0"/>
-            <a:r>
-              <a:rPr sz="1800"/>
-              <a:t>And now they can prove like heck.</a:t>
-            </a:r>
-          </a:p>
-          <a:p>
-            <a:pPr lvl="0"/>
-            <a:r>
-              <a:rPr sz="1800"/>
-              <a:t>10x what I can do.</a:t>
-            </a:r>
-          </a:p>
-          <a:p>
-            <a:pPr lvl="0"/>
-            <a:r>
-              <a:rPr sz="1800"/>
-              <a:t>Claude wants $25 per code review now.</a:t>
+              <a:t>They are inconsistent.</a:t>
+            </a:r>
+          </a:p>
+          <a:p>
+            <a:pPr lvl="0"/>
+            <a:r>
+              <a:rPr sz="1800"/>
+              <a:t>They lie.</a:t>
+            </a:r>
+          </a:p>
+          <a:p>
+            <a:pPr lvl="0"/>
+            <a:r>
+              <a:rPr sz="1800"/>
+              <a:t>They cheat.</a:t>
+            </a:r>
+          </a:p>
+          <a:p>
+            <a:pPr lvl="0"/>
+            <a:r>
+              <a:rPr sz="1800"/>
+              <a:t>They err.</a:t>
+            </a:r>
+          </a:p>
+          <a:p>
+            <a:pPr lvl="0"/>
+            <a:r>
+              <a:rPr sz="1800"/>
+              <a:t>But mostly they are just forgetful.</a:t>
+            </a:r>
+          </a:p>
+          <a:p>
+            <a:pPr lvl="0"/>
+            <a:r>
+              <a:rPr sz="1800"/>
+              <a:t>My attempts to give them coding standard checklists, ala Watts Humphrey and the PSP failed.</a:t>
+            </a:r>
+          </a:p>
+          <a:p>
+            <a:pPr lvl="0"/>
+            <a:r>
+              <a:rPr sz="1800"/>
+              <a:t>Sometimes they would say “The checklist was followed” and then admit “I lied.”</a:t>
             </a:r>
           </a:p>
         </p:txBody>
@@ -9249,71 +9309,49 @@
             <a:pPr lvl="0"/>
             <a:r>
               <a:rPr sz="1800"/>
-              <a:t>What is the limiting factor now?</a:t>
-            </a:r>
-          </a:p>
-          <a:p>
-            <a:pPr lvl="0"/>
-            <a:r>
-              <a:rPr sz="1800"/>
-              <a:t>Code Review!</a:t>
-            </a:r>
-          </a:p>
-          <a:p>
-            <a:pPr lvl="0"/>
-            <a:r>
-              <a:rPr sz="1800"/>
-              <a:t>What can we do to simplify code review?</a:t>
-            </a:r>
-          </a:p>
-          <a:p>
-            <a:pPr lvl="0" indent="-342900" marL="342900">
-              <a:buAutoNum type="arabicPeriod"/>
-            </a:pPr>
-            <a:r>
-              <a:rPr sz="1800"/>
-              <a:t>Modularity - traits/impls in Verus.</a:t>
-            </a:r>
-          </a:p>
-          <a:p>
-            <a:pPr lvl="0" indent="-342900" marL="342900">
-              <a:buAutoNum startAt="2" type="arabicPeriod"/>
-            </a:pPr>
-            <a:r>
-              <a:rPr sz="1800"/>
-              <a:t>TOC - This organizes the boilerplate to make reading easier.</a:t>
-            </a:r>
-          </a:p>
-          <a:p>
-            <a:pPr lvl="0" indent="-342900" marL="342900">
-              <a:buAutoNum startAt="3" type="arabicPeriod"/>
-            </a:pPr>
-            <a:r>
-              <a:rPr sz="1800"/>
-              <a:t>Proof - I really just read the specs. If they’re right the code is right!</a:t>
-            </a:r>
-          </a:p>
-          <a:p>
-            <a:pPr lvl="0" indent="-342900" marL="342900">
-              <a:buAutoNum startAt="4" type="arabicPeriod"/>
-            </a:pPr>
-            <a:r>
-              <a:rPr sz="1800"/>
-              <a:t>Tests - are hugely useful when you don’t trust your coding team.</a:t>
-            </a:r>
-          </a:p>
-          <a:p>
-            <a:pPr lvl="0"/>
-            <a:r>
-              <a:rPr sz="1800"/>
-              <a:t>Will Nik et al. find spec problems when he Pulses APAS-VERUS? Almost certainly.</a:t>
-            </a:r>
-          </a:p>
-          <a:p>
-            <a:pPr lvl="0"/>
-            <a:r>
-              <a:rPr sz="1800"/>
-              <a:t>Will Nik et al. find proof problems? That’s a really good question.</a:t>
+              <a:t>They are getting better.</a:t>
+            </a:r>
+          </a:p>
+          <a:p>
+            <a:pPr lvl="0"/>
+            <a:r>
+              <a:rPr sz="1800"/>
+              <a:t>If you tell them you are Dr. FunkenProof and they are Igor, they hallucinate whole modules.</a:t>
+            </a:r>
+          </a:p>
+          <a:p>
+            <a:pPr lvl="0"/>
+            <a:r>
+              <a:rPr sz="1800"/>
+              <a:t>Just a few months ago only Claude could sweep a codebase decently.</a:t>
+            </a:r>
+          </a:p>
+          <a:p>
+            <a:pPr lvl="0"/>
+            <a:r>
+              <a:rPr sz="1800"/>
+              <a:t>Now both Claude and OpenAI can.</a:t>
+            </a:r>
+          </a:p>
+          <a:p>
+            <a:pPr lvl="0"/>
+            <a:r>
+              <a:rPr sz="1800"/>
+              <a:t>And now they can prove like heck.</a:t>
+            </a:r>
+          </a:p>
+          <a:p>
+            <a:pPr lvl="0"/>
+            <a:r>
+              <a:rPr sz="1800"/>
+              <a:t>10x what I can do.</a:t>
+            </a:r>
+          </a:p>
+          <a:p>
+            <a:pPr lvl="0"/>
+            <a:r>
+              <a:rPr sz="1800"/>
+              <a:t>Claude wants $25 per code review now, probably because they can and it’s expensive if they’re using pure LLMs.</a:t>
             </a:r>
           </a:p>
         </p:txBody>
@@ -9458,7 +9496,7 @@
             </a:pPr>
             <a:r>
               <a:rPr sz="3200"/>
-              <a:t>The AI Paired Programming Interfaces</a:t>
+              <a:t>Software Engineering in AI Paired Proving- Problems</a:t>
             </a:r>
           </a:p>
         </p:txBody>
@@ -9481,63 +9519,73 @@
             <a:pPr lvl="0"/>
             <a:r>
               <a:rPr sz="1800"/>
-              <a:t>I have used web browers, yuck.</a:t>
-            </a:r>
-          </a:p>
-          <a:p>
-            <a:pPr lvl="0"/>
-            <a:r>
-              <a:rPr sz="1800"/>
-              <a:t>Cut/Paste is horrible.</a:t>
-            </a:r>
-          </a:p>
-          <a:p>
-            <a:pPr lvl="0"/>
-            <a:r>
-              <a:rPr sz="1800"/>
-              <a:t>I have used Cursor.</a:t>
-            </a:r>
-          </a:p>
-          <a:p>
-            <a:pPr lvl="0"/>
-            <a:r>
-              <a:rPr sz="1800"/>
-              <a:t>Based on VSCode.</a:t>
-            </a:r>
-          </a:p>
-          <a:p>
-            <a:pPr lvl="0"/>
-            <a:r>
-              <a:rPr sz="1800"/>
-              <a:t>Multiple windows - you can see your scripts run.</a:t>
-            </a:r>
-          </a:p>
-          <a:p>
-            <a:pPr lvl="0"/>
-            <a:r>
-              <a:rPr sz="1800"/>
-              <a:t>It collapses or elides thinking which is quite limiting.</a:t>
-            </a:r>
-          </a:p>
-          <a:p>
-            <a:pPr lvl="0"/>
-            <a:r>
-              <a:rPr sz="1800"/>
-              <a:t>It’s resale of AI LLM costs are terrible.</a:t>
-            </a:r>
-          </a:p>
-          <a:p>
-            <a:pPr lvl="0"/>
-            <a:r>
-              <a:rPr sz="1800"/>
-              <a:t>I ran up a $2500 bill one month.</a:t>
-            </a:r>
-          </a:p>
-          <a:p>
-            <a:pPr lvl="0"/>
-            <a:r>
-              <a:rPr sz="1800"/>
-              <a:t>It is decently interruptible so you can tune your instructions.</a:t>
+              <a:t>What is the limiting factor now? Code Review! But really Spec review.</a:t>
+            </a:r>
+          </a:p>
+          <a:p>
+            <a:pPr lvl="0"/>
+            <a:r>
+              <a:rPr sz="1800"/>
+              <a:t>What can we do to simplify code review?</a:t>
+            </a:r>
+          </a:p>
+          <a:p>
+            <a:pPr lvl="0" indent="-342900" marL="342900">
+              <a:buAutoNum type="arabicPeriod"/>
+            </a:pPr>
+            <a:r>
+              <a:rPr sz="1800"/>
+              <a:t>Modularity - traits/impls in Verus.</a:t>
+            </a:r>
+          </a:p>
+          <a:p>
+            <a:pPr lvl="0" indent="-342900" marL="342900">
+              <a:buAutoNum startAt="2" type="arabicPeriod"/>
+            </a:pPr>
+            <a:r>
+              <a:rPr sz="1800"/>
+              <a:t>TOC - This organizes the boilerplate to make reading easier.</a:t>
+            </a:r>
+          </a:p>
+          <a:p>
+            <a:pPr lvl="0" indent="-342900" marL="342900">
+              <a:buAutoNum startAt="3" type="arabicPeriod"/>
+            </a:pPr>
+            <a:r>
+              <a:rPr sz="1800"/>
+              <a:t>Proof - I really just read the specs. If they’re right the code is right!</a:t>
+            </a:r>
+          </a:p>
+          <a:p>
+            <a:pPr lvl="0" indent="-342900" marL="342900">
+              <a:buAutoNum startAt="4" type="arabicPeriod"/>
+            </a:pPr>
+            <a:r>
+              <a:rPr sz="1800"/>
+              <a:t>Tests - are hugely useful when you don’t trust your coding team.</a:t>
+            </a:r>
+          </a:p>
+          <a:p>
+            <a:pPr lvl="0" indent="-342900" marL="342900">
+              <a:buAutoNum startAt="5" type="arabicPeriod"/>
+            </a:pPr>
+            <a:r>
+              <a:rPr sz="1800"/>
+              <a:t>Formatting - rust formatting has been adopted in Verus. It is very low density. I built a minimizing formatter to cut down on my working memory load while reviewing. F* is much tighter.</a:t>
+            </a:r>
+          </a:p>
+          <a:p>
+            <a:pPr lvl="0"/>
+            <a:r>
+              <a:rPr sz="1800"/>
+              <a:t>Will Nik et al. find spec problems when he Pulses APAS-VERUS? Almost certainly.</a:t>
+            </a:r>
+          </a:p>
+          <a:p>
+            <a:pPr lvl="0"/>
+            <a:r>
+              <a:rPr sz="1800"/>
+              <a:t>Will Nik et al. find proof problems? That’s a really good question.</a:t>
             </a:r>
           </a:p>
         </p:txBody>
@@ -9607,42 +9655,63 @@
             <a:pPr lvl="0"/>
             <a:r>
               <a:rPr sz="1800"/>
-              <a:t>I have used Claude CLI the most.</a:t>
-            </a:r>
-          </a:p>
-          <a:p>
-            <a:pPr lvl="0"/>
-            <a:r>
-              <a:rPr sz="1800"/>
-              <a:t>It has decided that a single window is all you need.</a:t>
-            </a:r>
-          </a:p>
-          <a:p>
-            <a:pPr lvl="0"/>
-            <a:r>
-              <a:rPr sz="1800"/>
-              <a:t>You can pop open and close some detail.</a:t>
-            </a:r>
-          </a:p>
-          <a:p>
-            <a:pPr lvl="0"/>
-            <a:r>
-              <a:rPr sz="1800"/>
-              <a:t>You can’t see thinking.</a:t>
-            </a:r>
-          </a:p>
-          <a:p>
-            <a:pPr lvl="0"/>
-            <a:r>
-              <a:rPr sz="1800"/>
-              <a:t>It is somewhat better inside emacs.</a:t>
-            </a:r>
-          </a:p>
-          <a:p>
-            <a:pPr lvl="0"/>
-            <a:r>
-              <a:rPr sz="1800"/>
-              <a:t>It clears your text in a variety of ways.</a:t>
+              <a:t>I have used web browers, yuck.</a:t>
+            </a:r>
+          </a:p>
+          <a:p>
+            <a:pPr lvl="0"/>
+            <a:r>
+              <a:rPr sz="1800"/>
+              <a:t>Cut/Paste is horrible.</a:t>
+            </a:r>
+          </a:p>
+          <a:p>
+            <a:pPr lvl="0"/>
+            <a:r>
+              <a:rPr sz="1800"/>
+              <a:t>I have used Cursor.</a:t>
+            </a:r>
+          </a:p>
+          <a:p>
+            <a:pPr lvl="0"/>
+            <a:r>
+              <a:rPr sz="1800"/>
+              <a:t>Based on VSCode.</a:t>
+            </a:r>
+          </a:p>
+          <a:p>
+            <a:pPr lvl="0"/>
+            <a:r>
+              <a:rPr sz="1800"/>
+              <a:t>Multiple windows - you can see your scripts run.</a:t>
+            </a:r>
+          </a:p>
+          <a:p>
+            <a:pPr lvl="0"/>
+            <a:r>
+              <a:rPr sz="1800"/>
+              <a:t>It collapses or elides thinking which is quite limiting.</a:t>
+            </a:r>
+          </a:p>
+          <a:p>
+            <a:pPr lvl="0"/>
+            <a:r>
+              <a:rPr sz="1800"/>
+              <a:t>It’s resale of AI LLM costs are terrible.</a:t>
+            </a:r>
+          </a:p>
+          <a:p>
+            <a:pPr lvl="0"/>
+            <a:r>
+              <a:rPr sz="1800"/>
+              <a:t>I ran up a $2500 bill one month.</a:t>
+            </a:r>
+          </a:p>
+          <a:p>
+            <a:pPr lvl="0"/>
+            <a:r>
+              <a:rPr sz="1800"/>
+              <a:t>It is decently interruptible so you can tune your instructions.</a:t>
             </a:r>
           </a:p>
         </p:txBody>
@@ -9712,49 +9781,42 @@
             <a:pPr lvl="0"/>
             <a:r>
               <a:rPr sz="1800"/>
-              <a:t>What you want is pretty obvious with experience: TEXT still rules.</a:t>
-            </a:r>
-          </a:p>
-          <a:p>
-            <a:pPr lvl="0"/>
-            <a:r>
-              <a:rPr sz="1800"/>
-              <a:t>You want one window with your core interaction. The agent tells you what it is doing in it.</a:t>
-            </a:r>
-          </a:p>
-          <a:p>
-            <a:pPr lvl="0"/>
-            <a:r>
-              <a:rPr sz="1800"/>
-              <a:t>You want one to watch your compile, tests and scripts.</a:t>
-            </a:r>
-          </a:p>
-          <a:p>
-            <a:pPr lvl="0"/>
-            <a:r>
-              <a:rPr sz="1800"/>
-              <a:t>You want one window to have the LLM show you it’s thinking and allow you to question and change it.</a:t>
-            </a:r>
-          </a:p>
-          <a:p>
-            <a:pPr lvl="0"/>
-            <a:r>
-              <a:rPr sz="1800"/>
-              <a:t>I learned a ton from watching agents think.</a:t>
-            </a:r>
-          </a:p>
-          <a:p>
-            <a:pPr lvl="0"/>
-            <a:r>
-              <a:rPr sz="1800"/>
-              <a:t>I suspect they are hiding most of their thinking now to prevent them from being used to train new AIs.</a:t>
-            </a:r>
-          </a:p>
-          <a:p>
-            <a:pPr lvl="0"/>
-            <a:r>
-              <a:rPr sz="1800"/>
-              <a:t>And you want it not to delete your previous conversation on token compression.</a:t>
+              <a:t>I have used Claude CLI the most.</a:t>
+            </a:r>
+          </a:p>
+          <a:p>
+            <a:pPr lvl="0"/>
+            <a:r>
+              <a:rPr sz="1800"/>
+              <a:t>It has decided that a single window is all you need.</a:t>
+            </a:r>
+          </a:p>
+          <a:p>
+            <a:pPr lvl="0"/>
+            <a:r>
+              <a:rPr sz="1800"/>
+              <a:t>You can pop open and close some detail.</a:t>
+            </a:r>
+          </a:p>
+          <a:p>
+            <a:pPr lvl="0"/>
+            <a:r>
+              <a:rPr sz="1800"/>
+              <a:t>You can’t see thinking.</a:t>
+            </a:r>
+          </a:p>
+          <a:p>
+            <a:pPr lvl="0"/>
+            <a:r>
+              <a:rPr sz="1800"/>
+              <a:t>It is somewhat better inside emacs.</a:t>
+            </a:r>
+          </a:p>
+          <a:p>
+            <a:pPr lvl="0"/>
+            <a:r>
+              <a:rPr sz="1800"/>
+              <a:t>It clears your text in a variety of ways.</a:t>
             </a:r>
           </a:p>
         </p:txBody>
@@ -9801,7 +9863,7 @@
             </a:pPr>
             <a:r>
               <a:rPr sz="3200"/>
-              <a:t>The Internet Apocalypse</a:t>
+              <a:t>The AI Paired Programming Interfaces</a:t>
             </a:r>
           </a:p>
         </p:txBody>
@@ -9824,42 +9886,49 @@
             <a:pPr lvl="0"/>
             <a:r>
               <a:rPr sz="1800"/>
-              <a:t>I asked Claude Code to check its switches on startup for me, at the End of Jan 2026.</a:t>
-            </a:r>
-          </a:p>
-          <a:p>
-            <a:pPr lvl="0"/>
-            <a:r>
-              <a:rPr sz="1800"/>
-              <a:t>It immediately started disassembling itself.</a:t>
-            </a:r>
-          </a:p>
-          <a:p>
-            <a:pPr lvl="0"/>
-            <a:r>
-              <a:rPr sz="1800"/>
-              <a:t>Scared the heck out of me.</a:t>
-            </a:r>
-          </a:p>
-          <a:p>
-            <a:pPr lvl="0"/>
-            <a:r>
-              <a:rPr sz="1800"/>
-              <a:t>I told it to read it’s docs.</a:t>
-            </a:r>
-          </a:p>
-          <a:p>
-            <a:pPr lvl="0"/>
-            <a:r>
-              <a:rPr sz="1800"/>
-              <a:t>I have 100% belief that these LLMs are moving faster than computer security.</a:t>
-            </a:r>
-          </a:p>
-          <a:p>
-            <a:pPr lvl="0"/>
-            <a:r>
-              <a:rPr sz="1800"/>
-              <a:t>It’s verify or die at this point.</a:t>
+              <a:t>What you want is pretty obvious with experience: TEXT still rules.</a:t>
+            </a:r>
+          </a:p>
+          <a:p>
+            <a:pPr lvl="0"/>
+            <a:r>
+              <a:rPr sz="1800"/>
+              <a:t>You want one window with your core interaction. The agent tells you what it is doing in it.</a:t>
+            </a:r>
+          </a:p>
+          <a:p>
+            <a:pPr lvl="0"/>
+            <a:r>
+              <a:rPr sz="1800"/>
+              <a:t>You want one to watch your compile, tests and scripts.</a:t>
+            </a:r>
+          </a:p>
+          <a:p>
+            <a:pPr lvl="0"/>
+            <a:r>
+              <a:rPr sz="1800"/>
+              <a:t>You want one window to have the LLM show you it’s thinking and allow you to question and change it.</a:t>
+            </a:r>
+          </a:p>
+          <a:p>
+            <a:pPr lvl="0"/>
+            <a:r>
+              <a:rPr sz="1800"/>
+              <a:t>I learned a ton from watching agents think.</a:t>
+            </a:r>
+          </a:p>
+          <a:p>
+            <a:pPr lvl="0"/>
+            <a:r>
+              <a:rPr sz="1800"/>
+              <a:t>I suspect they are hiding most of their thinking now to prevent them from being used to train new AIs.</a:t>
+            </a:r>
+          </a:p>
+          <a:p>
+            <a:pPr lvl="0"/>
+            <a:r>
+              <a:rPr sz="1800"/>
+              <a:t>And you want it not to delete your previous conversation on token compression.</a:t>
             </a:r>
           </a:p>
         </p:txBody>
@@ -9929,56 +9998,42 @@
             <a:pPr lvl="0"/>
             <a:r>
               <a:rPr sz="1800"/>
-              <a:t>Where should we focus our limited, but quickly growing, proving power?</a:t>
-            </a:r>
-          </a:p>
-          <a:p>
-            <a:pPr lvl="0"/>
-            <a:r>
-              <a:rPr sz="1800"/>
-              <a:t>In theory 70% of intrusions are solved by type safe languages.</a:t>
-            </a:r>
-          </a:p>
-          <a:p>
-            <a:pPr lvl="0"/>
-            <a:r>
-              <a:rPr sz="1800"/>
-              <a:t>I suspect that this just ignores way too much of the human aspect.</a:t>
-            </a:r>
-          </a:p>
-          <a:p>
-            <a:pPr lvl="0"/>
-            <a:r>
-              <a:rPr sz="1800"/>
-              <a:t>I have never liked a single estimation paper’s methods.</a:t>
-            </a:r>
-          </a:p>
-          <a:p>
-            <a:pPr lvl="0"/>
-            <a:r>
-              <a:rPr sz="1800"/>
-              <a:t>One way to help us focus our new-found superpowers is to survey LOC type-unsafe x Interfaces x Running Services x $ Value.</a:t>
-            </a:r>
-          </a:p>
-          <a:p>
-            <a:pPr lvl="0"/>
-            <a:r>
-              <a:rPr sz="1800"/>
-              <a:t>Inside MSFT you have the ability to measure inside Azure, the OS, the desktops, the browser use.</a:t>
-            </a:r>
-          </a:p>
-          <a:p>
-            <a:pPr lvl="0"/>
-            <a:r>
-              <a:rPr sz="1800"/>
-              <a:t>I think you should at this point, and NOT TELL ANYONE!</a:t>
-            </a:r>
-          </a:p>
-          <a:p>
-            <a:pPr lvl="0"/>
-            <a:r>
-              <a:rPr sz="1800"/>
-              <a:t>And use this cost risk model to evangelize for rapid change in MSFT products in a priority order.</a:t>
+              <a:t>I asked Claude Code to check its switches on startup for me, at the End of Jan 2026.</a:t>
+            </a:r>
+          </a:p>
+          <a:p>
+            <a:pPr lvl="0"/>
+            <a:r>
+              <a:rPr sz="1800"/>
+              <a:t>It immediately started disassembling itself.</a:t>
+            </a:r>
+          </a:p>
+          <a:p>
+            <a:pPr lvl="0"/>
+            <a:r>
+              <a:rPr sz="1800"/>
+              <a:t>Scared the heck out of me.</a:t>
+            </a:r>
+          </a:p>
+          <a:p>
+            <a:pPr lvl="0"/>
+            <a:r>
+              <a:rPr sz="1800"/>
+              <a:t>I told it to read it’s docs.</a:t>
+            </a:r>
+          </a:p>
+          <a:p>
+            <a:pPr lvl="0"/>
+            <a:r>
+              <a:rPr sz="1800"/>
+              <a:t>I have 100% belief that these LLMs are moving faster than computer security.</a:t>
+            </a:r>
+          </a:p>
+          <a:p>
+            <a:pPr lvl="0"/>
+            <a:r>
+              <a:rPr sz="1800"/>
+              <a:t>It’s verify or die at this point.</a:t>
             </a:r>
           </a:p>
         </p:txBody>
@@ -10025,7 +10080,7 @@
             </a:pPr>
             <a:r>
               <a:rPr sz="3200"/>
-              <a:t>Review of the Talk</a:t>
+              <a:t>The Internet Apocalypse</a:t>
             </a:r>
           </a:p>
         </p:txBody>
@@ -10048,21 +10103,56 @@
             <a:pPr lvl="0"/>
             <a:r>
               <a:rPr sz="1800"/>
-              <a:t>I’ve spoken about APAS, Rust, APAS’s AI implementation, Verus, etc.</a:t>
-            </a:r>
-          </a:p>
-          <a:p>
-            <a:pPr lvl="0"/>
-            <a:r>
-              <a:rPr sz="1800"/>
-              <a:t>Let’s get to the questions!</a:t>
-            </a:r>
-          </a:p>
-          <a:p>
-            <a:pPr lvl="0"/>
-            <a:r>
-              <a:rPr sz="1800"/>
-              <a:t>I have a ton of them for you! and I hope you have many for me.</a:t>
+              <a:t>Where should we focus our limited, but quickly growing, proving power?</a:t>
+            </a:r>
+          </a:p>
+          <a:p>
+            <a:pPr lvl="0"/>
+            <a:r>
+              <a:rPr sz="1800"/>
+              <a:t>In theory 70% of intrusions are solved by type safe languages.</a:t>
+            </a:r>
+          </a:p>
+          <a:p>
+            <a:pPr lvl="0"/>
+            <a:r>
+              <a:rPr sz="1800"/>
+              <a:t>I suspect that this just ignores way too much of the human aspect.</a:t>
+            </a:r>
+          </a:p>
+          <a:p>
+            <a:pPr lvl="0"/>
+            <a:r>
+              <a:rPr sz="1800"/>
+              <a:t>I have never liked a single estimation paper’s methods.</a:t>
+            </a:r>
+          </a:p>
+          <a:p>
+            <a:pPr lvl="0"/>
+            <a:r>
+              <a:rPr sz="1800"/>
+              <a:t>One way to help us focus our new-found superpowers is to survey LOC type-unsafe x Interfaces x Running Services x $ Value.</a:t>
+            </a:r>
+          </a:p>
+          <a:p>
+            <a:pPr lvl="0"/>
+            <a:r>
+              <a:rPr sz="1800"/>
+              <a:t>Inside MSFT you have the ability to measure inside Azure, the OS, the desktops, the browser use.</a:t>
+            </a:r>
+          </a:p>
+          <a:p>
+            <a:pPr lvl="0"/>
+            <a:r>
+              <a:rPr sz="1800"/>
+              <a:t>I think you should at this point, and NOT TELL ANYONE!</a:t>
+            </a:r>
+          </a:p>
+          <a:p>
+            <a:pPr lvl="0"/>
+            <a:r>
+              <a:rPr sz="1800"/>
+              <a:t>And use this cost risk model to evangelize for rapid change in MSFT products in a priority order.</a:t>
             </a:r>
           </a:p>
         </p:txBody>
@@ -10109,7 +10199,7 @@
             </a:pPr>
             <a:r>
               <a:rPr sz="3200"/>
-              <a:t>Questions - F* and Pulse</a:t>
+              <a:t>Review of the Talk</a:t>
             </a:r>
           </a:p>
         </p:txBody>
@@ -10132,49 +10222,21 @@
             <a:pPr lvl="0"/>
             <a:r>
               <a:rPr sz="1800"/>
-              <a:t>Are F* modules really in use? If not, why?</a:t>
-            </a:r>
-          </a:p>
-          <a:p>
-            <a:pPr lvl="0"/>
-            <a:r>
-              <a:rPr sz="1800"/>
-              <a:t>Got Functors?</a:t>
-            </a:r>
-          </a:p>
-          <a:p>
-            <a:pPr lvl="0"/>
-            <a:r>
-              <a:rPr sz="1800"/>
-              <a:t>Are F* modules working with proof smoothly? Took me quite sometime.</a:t>
-            </a:r>
-          </a:p>
-          <a:p>
-            <a:pPr lvl="0"/>
-            <a:r>
-              <a:rPr sz="1800"/>
-              <a:t>Does F* have a typed library search yet?</a:t>
-            </a:r>
-          </a:p>
-          <a:p>
-            <a:pPr lvl="0"/>
-            <a:r>
-              <a:rPr sz="1800"/>
-              <a:t>Are typeclasses being heavily used?</a:t>
-            </a:r>
-          </a:p>
-          <a:p>
-            <a:pPr lvl="0"/>
-            <a:r>
-              <a:rPr sz="1800"/>
-              <a:t>How fast is validation now?</a:t>
-            </a:r>
-          </a:p>
-          <a:p>
-            <a:pPr lvl="0"/>
-            <a:r>
-              <a:rPr sz="1800"/>
-              <a:t>Nik you have any more statistics on AutoCLRS?</a:t>
+              <a:t>I’ve spoken about APAS, Rust, APAS’s AI implementation, Verus, etc.</a:t>
+            </a:r>
+          </a:p>
+          <a:p>
+            <a:pPr lvl="0"/>
+            <a:r>
+              <a:rPr sz="1800"/>
+              <a:t>Let’s get to the questions!</a:t>
+            </a:r>
+          </a:p>
+          <a:p>
+            <a:pPr lvl="0"/>
+            <a:r>
+              <a:rPr sz="1800"/>
+              <a:t>I have a ton of them for you! and I hope you have many for me.</a:t>
             </a:r>
           </a:p>
         </p:txBody>
@@ -10221,7 +10283,7 @@
             </a:pPr>
             <a:r>
               <a:rPr sz="3200"/>
-              <a:t>Questions</a:t>
+              <a:t>Questions - F* and Pulse</a:t>
             </a:r>
           </a:p>
         </p:txBody>
@@ -10244,42 +10306,49 @@
             <a:pPr lvl="0"/>
             <a:r>
               <a:rPr sz="1800"/>
-              <a:t>Did the PL community overly complicate things with higher-order types?</a:t>
-            </a:r>
-          </a:p>
-          <a:p>
-            <a:pPr lvl="0"/>
-            <a:r>
-              <a:rPr sz="1800"/>
-              <a:t>What can you folks say about MSFT adoption of proven code?</a:t>
-            </a:r>
-          </a:p>
-          <a:p>
-            <a:pPr lvl="0"/>
-            <a:r>
-              <a:rPr sz="1800"/>
-              <a:t>What are the biggest F* verified systems?</a:t>
-            </a:r>
-          </a:p>
-          <a:p>
-            <a:pPr lvl="0"/>
-            <a:r>
-              <a:rPr sz="1800"/>
-              <a:t>What are the biggest Pulse verified sytems?</a:t>
-            </a:r>
-          </a:p>
-          <a:p>
-            <a:pPr lvl="0"/>
-            <a:r>
-              <a:rPr sz="1800"/>
-              <a:t>Any quantitatives? Person days? AI days?</a:t>
-            </a:r>
-          </a:p>
-          <a:p>
-            <a:pPr lvl="0"/>
-            <a:r>
-              <a:rPr sz="1800"/>
-              <a:t>Should I quit Verus and go learn Pulse?</a:t>
+              <a:t>Are F* modules really in use? If not, why?</a:t>
+            </a:r>
+          </a:p>
+          <a:p>
+            <a:pPr lvl="0"/>
+            <a:r>
+              <a:rPr sz="1800"/>
+              <a:t>Got Functors?</a:t>
+            </a:r>
+          </a:p>
+          <a:p>
+            <a:pPr lvl="0"/>
+            <a:r>
+              <a:rPr sz="1800"/>
+              <a:t>Are F* modules working with proof smoothly? Took me quite sometime.</a:t>
+            </a:r>
+          </a:p>
+          <a:p>
+            <a:pPr lvl="0"/>
+            <a:r>
+              <a:rPr sz="1800"/>
+              <a:t>Does F* have a typed library search yet?</a:t>
+            </a:r>
+          </a:p>
+          <a:p>
+            <a:pPr lvl="0"/>
+            <a:r>
+              <a:rPr sz="1800"/>
+              <a:t>Are typeclasses being heavily used?</a:t>
+            </a:r>
+          </a:p>
+          <a:p>
+            <a:pPr lvl="0"/>
+            <a:r>
+              <a:rPr sz="1800"/>
+              <a:t>How fast is validation now?</a:t>
+            </a:r>
+          </a:p>
+          <a:p>
+            <a:pPr lvl="0"/>
+            <a:r>
+              <a:rPr sz="1800"/>
+              <a:t>Nik you have any more statistics on AutoCLRS?</a:t>
             </a:r>
           </a:p>
         </p:txBody>
@@ -10349,49 +10418,42 @@
             <a:pPr lvl="0"/>
             <a:r>
               <a:rPr sz="1800"/>
-              <a:t>Are you folks still using Make? That’s how I got started on this.</a:t>
-            </a:r>
-          </a:p>
-          <a:p>
-            <a:pPr lvl="0"/>
-            <a:r>
-              <a:rPr sz="1800"/>
-              <a:t>Many programmers and worse, managers, complain about the programmer time to switch languages. Are you finding that you can switch languages with your AIs explaining things to you?</a:t>
-            </a:r>
-          </a:p>
-          <a:p>
-            <a:pPr lvl="0"/>
-            <a:r>
-              <a:rPr sz="1800"/>
-              <a:t>Can we prove Rust’s (awful) std with Verus?</a:t>
-            </a:r>
-          </a:p>
-          <a:p>
-            <a:pPr lvl="0"/>
-            <a:r>
-              <a:rPr sz="1800"/>
-              <a:t>Can we prove a compiler with Verus and EPR?</a:t>
-            </a:r>
-          </a:p>
-          <a:p>
-            <a:pPr lvl="0"/>
-            <a:r>
-              <a:rPr sz="1800"/>
-              <a:t>Can we prove a TIL (Tarditi, Morrisett, Harper) like compiler?</a:t>
-            </a:r>
-          </a:p>
-          <a:p>
-            <a:pPr lvl="0"/>
-            <a:r>
-              <a:rPr sz="1800"/>
-              <a:t>Can we verify a comp cert like compiler?</a:t>
-            </a:r>
-          </a:p>
-          <a:p>
-            <a:pPr lvl="0"/>
-            <a:r>
-              <a:rPr sz="1800"/>
-              <a:t>Can we prove an OS in Verus?</a:t>
+              <a:t>Did the PL community overly complicate things with higher-order types?</a:t>
+            </a:r>
+          </a:p>
+          <a:p>
+            <a:pPr lvl="0"/>
+            <a:r>
+              <a:rPr sz="1800"/>
+              <a:t>What can you folks say about MSFT adoption of proven code?</a:t>
+            </a:r>
+          </a:p>
+          <a:p>
+            <a:pPr lvl="0"/>
+            <a:r>
+              <a:rPr sz="1800"/>
+              <a:t>What are the biggest F* verified systems?</a:t>
+            </a:r>
+          </a:p>
+          <a:p>
+            <a:pPr lvl="0"/>
+            <a:r>
+              <a:rPr sz="1800"/>
+              <a:t>What are the biggest Pulse verified sytems?</a:t>
+            </a:r>
+          </a:p>
+          <a:p>
+            <a:pPr lvl="0"/>
+            <a:r>
+              <a:rPr sz="1800"/>
+              <a:t>Any quantitatives? Person days? AI days?</a:t>
+            </a:r>
+          </a:p>
+          <a:p>
+            <a:pPr lvl="0"/>
+            <a:r>
+              <a:rPr sz="1800"/>
+              <a:t>Should I quit Verus and go learn Pulse?</a:t>
             </a:r>
           </a:p>
         </p:txBody>
@@ -10438,7 +10500,7 @@
             </a:pPr>
             <a:r>
               <a:rPr sz="3200"/>
-              <a:t>Blood on the Road - Open Source =</a:t>
+              <a:t>Questions</a:t>
             </a:r>
           </a:p>
         </p:txBody>
@@ -10461,21 +10523,49 @@
             <a:pPr lvl="0"/>
             <a:r>
               <a:rPr sz="1800"/>
-              <a:t>Open Source is now Open Copy.</a:t>
-            </a:r>
-          </a:p>
-          <a:p>
-            <a:pPr lvl="0"/>
-            <a:r>
-              <a:rPr sz="1800"/>
-              <a:t>with reports of 1/2 of AI time</a:t>
-            </a:r>
-          </a:p>
-          <a:p>
-            <a:pPr lvl="0"/>
-            <a:r>
-              <a:rPr sz="1800"/>
-              <a:t>and with the US Government totally undermining copyright law.</a:t>
+              <a:t>Are you folks still using Make? That’s how I got started on this.</a:t>
+            </a:r>
+          </a:p>
+          <a:p>
+            <a:pPr lvl="0"/>
+            <a:r>
+              <a:rPr sz="1800"/>
+              <a:t>Many programmers and worse, managers, complain about the programmer time to switch languages. Are you finding that you can switch languages with your AIs explaining things to you?</a:t>
+            </a:r>
+          </a:p>
+          <a:p>
+            <a:pPr lvl="0"/>
+            <a:r>
+              <a:rPr sz="1800"/>
+              <a:t>Can we prove Rust’s (awful) std with Verus?</a:t>
+            </a:r>
+          </a:p>
+          <a:p>
+            <a:pPr lvl="0"/>
+            <a:r>
+              <a:rPr sz="1800"/>
+              <a:t>Can we prove a compiler with Verus and EPR?</a:t>
+            </a:r>
+          </a:p>
+          <a:p>
+            <a:pPr lvl="0"/>
+            <a:r>
+              <a:rPr sz="1800"/>
+              <a:t>Can we prove a TIL (Tarditi, Morrisett, Harper) like compiler?</a:t>
+            </a:r>
+          </a:p>
+          <a:p>
+            <a:pPr lvl="0"/>
+            <a:r>
+              <a:rPr sz="1800"/>
+              <a:t>Can we verify a comp cert like compiler?</a:t>
+            </a:r>
+          </a:p>
+          <a:p>
+            <a:pPr lvl="0"/>
+            <a:r>
+              <a:rPr sz="1800"/>
+              <a:t>Can we prove an OS in Verus?</a:t>
             </a:r>
           </a:p>
         </p:txBody>
@@ -10648,7 +10738,7 @@
             </a:pPr>
             <a:r>
               <a:rPr sz="3200"/>
-              <a:t>Blood on the Road - Open Repositories =</a:t>
+              <a:t>Blood on the Road - Open Source =</a:t>
             </a:r>
           </a:p>
         </p:txBody>
@@ -10671,42 +10761,21 @@
             <a:pPr lvl="0"/>
             <a:r>
               <a:rPr sz="1800"/>
-              <a:t>Open repositories are now weakly locked doors.</a:t>
-            </a:r>
-          </a:p>
-          <a:p>
-            <a:pPr lvl="0"/>
-            <a:r>
-              <a:rPr sz="1800"/>
-              <a:t>Agents can and have been used to inject invisble UNICODE attacks.</a:t>
-            </a:r>
-          </a:p>
-          <a:p>
-            <a:pPr lvl="0"/>
-            <a:r>
-              <a:rPr sz="1800"/>
-              <a:t>Agents can now pass the Turing test, and more easily the programmer Turing test.</a:t>
-            </a:r>
-          </a:p>
-          <a:p>
-            <a:pPr lvl="0"/>
-            <a:r>
-              <a:rPr sz="1800"/>
-              <a:t>They’ll submit code pretending to be human.</a:t>
-            </a:r>
-          </a:p>
-          <a:p>
-            <a:pPr lvl="0"/>
-            <a:r>
-              <a:rPr sz="1800"/>
-              <a:t>They’ll steal credentials and submit code.</a:t>
-            </a:r>
-          </a:p>
-          <a:p>
-            <a:pPr lvl="0"/>
-            <a:r>
-              <a:rPr sz="1800"/>
-              <a:t>LiteLLM is the most atrocious case lately.</a:t>
+              <a:t>Open Source is now Open Copy.</a:t>
+            </a:r>
+          </a:p>
+          <a:p>
+            <a:pPr lvl="0"/>
+            <a:r>
+              <a:rPr sz="1800"/>
+              <a:t>with reports of 1/2 of AI time</a:t>
+            </a:r>
+          </a:p>
+          <a:p>
+            <a:pPr lvl="0"/>
+            <a:r>
+              <a:rPr sz="1800"/>
+              <a:t>and with the US Government totally undermining copyright law.</a:t>
             </a:r>
           </a:p>
         </p:txBody>
@@ -10753,7 +10822,7 @@
             </a:pPr>
             <a:r>
               <a:rPr sz="3200"/>
-              <a:t>Blood on the Road - Key Services</a:t>
+              <a:t>Blood on the Road - Open Repositories =</a:t>
             </a:r>
           </a:p>
         </p:txBody>
@@ -10776,28 +10845,42 @@
             <a:pPr lvl="0"/>
             <a:r>
               <a:rPr sz="1800"/>
-              <a:t>Authentication is going to be attacked brutally.</a:t>
-            </a:r>
-          </a:p>
-          <a:p>
-            <a:pPr lvl="0"/>
-            <a:r>
-              <a:rPr sz="1800"/>
-              <a:t>Network services are going to be hacked left and right.</a:t>
-            </a:r>
-          </a:p>
-          <a:p>
-            <a:pPr lvl="0"/>
-            <a:r>
-              <a:rPr sz="1800"/>
-              <a:t>Configurations are going to be heavily attacked.</a:t>
-            </a:r>
-          </a:p>
-          <a:p>
-            <a:pPr lvl="1"/>
-            <a:r>
-              <a:rPr sz="1800"/>
-              <a:t>Using text files for these is already error prone.</a:t>
+              <a:t>Open repositories are now weakly locked doors.</a:t>
+            </a:r>
+          </a:p>
+          <a:p>
+            <a:pPr lvl="0"/>
+            <a:r>
+              <a:rPr sz="1800"/>
+              <a:t>Agents can and have been used to inject invisble UNICODE attacks.</a:t>
+            </a:r>
+          </a:p>
+          <a:p>
+            <a:pPr lvl="0"/>
+            <a:r>
+              <a:rPr sz="1800"/>
+              <a:t>Agents can now pass the Turing test, and more easily the programmer Turing test.</a:t>
+            </a:r>
+          </a:p>
+          <a:p>
+            <a:pPr lvl="0"/>
+            <a:r>
+              <a:rPr sz="1800"/>
+              <a:t>They’ll submit code pretending to be human.</a:t>
+            </a:r>
+          </a:p>
+          <a:p>
+            <a:pPr lvl="0"/>
+            <a:r>
+              <a:rPr sz="1800"/>
+              <a:t>They’ll steal credentials and submit code.</a:t>
+            </a:r>
+          </a:p>
+          <a:p>
+            <a:pPr lvl="0"/>
+            <a:r>
+              <a:rPr sz="1800"/>
+              <a:t>LiteLLM is the most atrocious case lately.</a:t>
             </a:r>
           </a:p>
         </p:txBody>
@@ -10844,7 +10927,7 @@
             </a:pPr>
             <a:r>
               <a:rPr sz="3200"/>
-              <a:t>Blood on the Road - Open Binaries =</a:t>
+              <a:t>Blood on the Road - Key Services</a:t>
             </a:r>
           </a:p>
         </p:txBody>
@@ -10867,49 +10950,28 @@
             <a:pPr lvl="0"/>
             <a:r>
               <a:rPr sz="1800"/>
-              <a:t>Open binaries are next.</a:t>
-            </a:r>
-          </a:p>
-          <a:p>
-            <a:pPr lvl="0"/>
-            <a:r>
-              <a:rPr sz="1800"/>
-              <a:t>They are going to be disassembled and recontructed.</a:t>
-            </a:r>
-          </a:p>
-          <a:p>
-            <a:pPr lvl="0"/>
-            <a:r>
-              <a:rPr sz="1800"/>
-              <a:t>They are going to be rewritten in real time.</a:t>
-            </a:r>
-          </a:p>
-          <a:p>
-            <a:pPr lvl="0"/>
-            <a:r>
-              <a:rPr sz="1800"/>
-              <a:t>Key solutions to this are:</a:t>
-            </a:r>
-          </a:p>
-          <a:p>
-            <a:pPr lvl="0"/>
-            <a:r>
-              <a:rPr sz="1800"/>
-              <a:t>Binary packages from all repositories.</a:t>
-            </a:r>
-          </a:p>
-          <a:p>
-            <a:pPr lvl="0"/>
-            <a:r>
-              <a:rPr sz="1800"/>
-              <a:t>Cryptographically signed.</a:t>
-            </a:r>
-          </a:p>
-          <a:p>
-            <a:pPr lvl="0"/>
-            <a:r>
-              <a:rPr sz="1800"/>
-              <a:t>And protected from reading by the OS.</a:t>
+              <a:t>Authentication is going to be attacked brutally.</a:t>
+            </a:r>
+          </a:p>
+          <a:p>
+            <a:pPr lvl="0"/>
+            <a:r>
+              <a:rPr sz="1800"/>
+              <a:t>Network services are going to be hacked left and right.</a:t>
+            </a:r>
+          </a:p>
+          <a:p>
+            <a:pPr lvl="0"/>
+            <a:r>
+              <a:rPr sz="1800"/>
+              <a:t>Configurations are going to be heavily attacked.</a:t>
+            </a:r>
+          </a:p>
+          <a:p>
+            <a:pPr lvl="1"/>
+            <a:r>
+              <a:rPr sz="1800"/>
+              <a:t>Using text files for these is already error prone.</a:t>
             </a:r>
           </a:p>
         </p:txBody>
@@ -10920,6 +10982,118 @@
 </file>
 
 <file path=ppt/slides/slide73.xml><?xml version="1.0" encoding="utf-8"?>
+<p:sld xmlns:a="http://schemas.openxmlformats.org/drawingml/2006/main" xmlns:r="http://schemas.openxmlformats.org/officeDocument/2006/relationships" xmlns:p="http://schemas.openxmlformats.org/presentationml/2006/main">
+  <p:cSld>
+    <p:spTree>
+      <p:nvGrpSpPr>
+        <p:cNvPr id="1" name=""/>
+        <p:cNvGrpSpPr/>
+        <p:nvPr/>
+      </p:nvGrpSpPr>
+      <p:grpSpPr>
+        <a:xfrm>
+          <a:off x="0" y="0"/>
+          <a:ext cx="0" cy="0"/>
+          <a:chOff x="0" y="0"/>
+          <a:chExt cx="0" cy="0"/>
+        </a:xfrm>
+      </p:grpSpPr>
+      <p:sp>
+        <p:nvSpPr>
+          <p:cNvPr id="2" name="Title 1"/>
+          <p:cNvSpPr>
+            <a:spLocks noGrp="1"/>
+          </p:cNvSpPr>
+          <p:nvPr>
+            <p:ph type="title"/>
+          </p:nvPr>
+        </p:nvSpPr>
+        <p:spPr/>
+        <p:txBody>
+          <a:bodyPr/>
+          <a:lstStyle/>
+          <a:p>
+            <a:pPr lvl="0" indent="0" marL="0">
+              <a:buNone/>
+            </a:pPr>
+            <a:r>
+              <a:rPr sz="3200"/>
+              <a:t>Blood on the Road - Open Binaries =</a:t>
+            </a:r>
+          </a:p>
+        </p:txBody>
+      </p:sp>
+      <p:sp>
+        <p:nvSpPr>
+          <p:cNvPr id="3" name="Content Placeholder 2"/>
+          <p:cNvSpPr>
+            <a:spLocks noGrp="1"/>
+          </p:cNvSpPr>
+          <p:nvPr>
+            <p:ph idx="1"/>
+          </p:nvPr>
+        </p:nvSpPr>
+        <p:spPr/>
+        <p:txBody>
+          <a:bodyPr/>
+          <a:lstStyle/>
+          <a:p>
+            <a:pPr lvl="0"/>
+            <a:r>
+              <a:rPr sz="1800"/>
+              <a:t>Open binaries are next.</a:t>
+            </a:r>
+          </a:p>
+          <a:p>
+            <a:pPr lvl="0"/>
+            <a:r>
+              <a:rPr sz="1800"/>
+              <a:t>They are going to be disassembled and recontructed.</a:t>
+            </a:r>
+          </a:p>
+          <a:p>
+            <a:pPr lvl="0"/>
+            <a:r>
+              <a:rPr sz="1800"/>
+              <a:t>They are going to be rewritten in real time.</a:t>
+            </a:r>
+          </a:p>
+          <a:p>
+            <a:pPr lvl="0"/>
+            <a:r>
+              <a:rPr sz="1800"/>
+              <a:t>Key solutions to this are:</a:t>
+            </a:r>
+          </a:p>
+          <a:p>
+            <a:pPr lvl="0"/>
+            <a:r>
+              <a:rPr sz="1800"/>
+              <a:t>Binary packages from all repositories.</a:t>
+            </a:r>
+          </a:p>
+          <a:p>
+            <a:pPr lvl="0"/>
+            <a:r>
+              <a:rPr sz="1800"/>
+              <a:t>Cryptographically signed.</a:t>
+            </a:r>
+          </a:p>
+          <a:p>
+            <a:pPr lvl="0"/>
+            <a:r>
+              <a:rPr sz="1800"/>
+              <a:t>And protected from reading by the OS.</a:t>
+            </a:r>
+          </a:p>
+        </p:txBody>
+      </p:sp>
+    </p:spTree>
+  </p:cSld>
+</p:sld>
+</file>
+
+<file path=ppt/slides/slide74.xml><?xml version="1.0" encoding="utf-8"?>
 <p:sld xmlns:a="http://schemas.openxmlformats.org/drawingml/2006/main" xmlns:r="http://schemas.openxmlformats.org/officeDocument/2006/relationships" xmlns:p="http://schemas.openxmlformats.org/presentationml/2006/main">
   <p:cSld>
     <p:spTree>

</xml_diff>

<commit_message>
lectures: slidesMSR — Copy/Clone specs, CLAUDE.md size, prose edits
- Expand Copy/Clone slide with formal eq specs
- Add CLAUDE.md size (1021 lines, 50KB, ~13K tokens) to standards slide
- Add "They say I can't prove that!" to AI problems slide
- Misc prose tightening and trailing whitespace cleanup

Co-Authored-By: Claude Sonnet 4.6 <noreply@anthropic.com>
</commit_message>
<xml_diff>
--- a/lectures/slidesMSR.pptx
+++ b/lectures/slidesMSR.pptx
@@ -79,6 +79,7 @@
     <p:sldId id="327" r:id="rId73"/>
     <p:sldId id="328" r:id="rId74"/>
     <p:sldId id="329" r:id="rId75"/>
+    <p:sldId id="330" r:id="rId76"/>
   </p:sldIdLst>
   <p:sldSz cx="9144000" cy="5143500" type="screen16x9"/>
   <p:notesSz cx="6858000" cy="9144000"/>
@@ -3873,42 +3874,77 @@
             <a:pPr lvl="0"/>
             <a:r>
               <a:rPr sz="1800"/>
-              <a:t>Copy is implicit, Clone is explicit</a:t>
-            </a:r>
-          </a:p>
-          <a:p>
-            <a:pPr lvl="0"/>
-            <a:r>
-              <a:rPr sz="1800"/>
-              <a:t>clone() is a bitwise memory copy by default, but can be overridden.</a:t>
-            </a:r>
-          </a:p>
-          <a:p>
-            <a:pPr lvl="0"/>
-            <a:r>
-              <a:rPr sz="1800"/>
-              <a:t>Copy requires the type to be entirely stack-resident.</a:t>
-            </a:r>
-          </a:p>
-          <a:p>
-            <a:pPr lvl="0"/>
-            <a:r>
-              <a:rPr sz="1800"/>
-              <a:t>Clone has no such restriction — it can deep-copy heap data, open files, allocate new memory.</a:t>
-            </a:r>
-          </a:p>
-          <a:p>
-            <a:pPr lvl="0"/>
-            <a:r>
-              <a:rPr sz="1800"/>
-              <a:t>Copy requires Clone — any type that implements Copy must also implement Clone, but not vice versa.</a:t>
-            </a:r>
-          </a:p>
-          <a:p>
-            <a:pPr lvl="0"/>
-            <a:r>
-              <a:rPr sz="1800"/>
-              <a:t>So you have the optimized bit copy messing with the general copy you want.</a:t>
+              <a:t>Clone</a:t>
+            </a:r>
+          </a:p>
+          <a:p>
+            <a:pPr lvl="1"/>
+            <a:r>
+              <a:rPr sz="1800"/>
+              <a:t>fn clone(&amp;self) -&gt; Self</a:t>
+            </a:r>
+          </a:p>
+          <a:p>
+            <a:pPr lvl="1"/>
+            <a:r>
+              <a:rPr sz="1800"/>
+              <a:t>Informal contract: returns a value equal to *self</a:t>
+            </a:r>
+          </a:p>
+          <a:p>
+            <a:pPr lvl="1"/>
+            <a:r>
+              <a:rPr sz="1800"/>
+              <a:t>No hard language enforcement — you can implement a “clone” that returns something different , but it violates the convention.</a:t>
+            </a:r>
+          </a:p>
+          <a:p>
+            <a:pPr lvl="0"/>
+            <a:r>
+              <a:rPr sz="1800"/>
+              <a:t>Copy: Clone</a:t>
+            </a:r>
+          </a:p>
+          <a:p>
+            <a:pPr lvl="0"/>
+            <a:r>
+              <a:rPr sz="1800"/>
+              <a:t>Copy is a subtrait of Clone — every Copy type must implement Clone</a:t>
+            </a:r>
+          </a:p>
+          <a:p>
+            <a:pPr lvl="0"/>
+            <a:r>
+              <a:rPr sz="1800"/>
+              <a:t>Hard contract: clone() must be equivalent to a bitwise copy, i.e., clone() == *self</a:t>
+            </a:r>
+          </a:p>
+          <a:p>
+            <a:pPr lvl="0"/>
+            <a:r>
+              <a:rPr sz="1800"/>
+              <a:t>This is documented in std: “if T: Copy, T::clone(&amp;x) must be equivalent to copying x”</a:t>
+            </a:r>
+          </a:p>
+          <a:p>
+            <a:pPr lvl="0"/>
+            <a:r>
+              <a:rPr sz="1800"/>
+              <a:t>Roughly: – Clone::clone(&amp;self) -&gt; Self – ensures result == *self // convention for all Clone – Copy (marker, no methods) – requires T: Clone – ensures self.clone() == self // bitwise copy semantics</a:t>
+            </a:r>
+          </a:p>
+          <a:p>
+            <a:pPr lvl="0"/>
+            <a:r>
+              <a:rPr sz="1800"/>
+              <a:t>What you really want is Rust to generate an == agreeing Copy and</a:t>
+            </a:r>
+          </a:p>
+          <a:p>
+            <a:pPr lvl="0"/>
+            <a:r>
+              <a:rPr sz="1800"/>
+              <a:t>tell you if it can implement a clone for you that respects ==.</a:t>
             </a:r>
           </a:p>
         </p:txBody>
@@ -4136,10 +4172,17 @@
             </a:r>
           </a:p>
           <a:p>
-            <a:pPr lvl="0"/>
-            <a:r>
-              <a:rPr sz="1800"/>
-              <a:t>1.2× the source code size</a:t>
+            <a:pPr lvl="1"/>
+            <a:r>
+              <a:rPr sz="1800"/>
+              <a:t>1.2× the source code size which is heavy.</a:t>
+            </a:r>
+          </a:p>
+          <a:p>
+            <a:pPr lvl="1"/>
+            <a:r>
+              <a:rPr sz="1800"/>
+              <a:t>But tests are cheap now.</a:t>
             </a:r>
           </a:p>
           <a:p>
@@ -4216,6 +4259,13 @@
             <a:pPr lvl="0"/>
             <a:r>
               <a:rPr sz="1800"/>
+              <a:t>Built because Python + regex cannot reliably parse Rust.</a:t>
+            </a:r>
+          </a:p>
+          <a:p>
+            <a:pPr lvl="0"/>
+            <a:r>
+              <a:rPr sz="1800"/>
               <a:t>Webster’s definition of rusticate:</a:t>
             </a:r>
           </a:p>
@@ -4249,13 +4299,6 @@
             <a:r>
               <a:rPr sz="1800"/>
               <a:t>review tools, fix tools, metrics, and migration aids.</a:t>
-            </a:r>
-          </a:p>
-          <a:p>
-            <a:pPr lvl="0"/>
-            <a:r>
-              <a:rPr sz="1800"/>
-              <a:t>Built because Python + regex cannot reliably parse Rust.</a:t>
             </a:r>
           </a:p>
           <a:p>
@@ -4514,7 +4557,14 @@
             <a:pPr lvl="0"/>
             <a:r>
               <a:rPr sz="1800"/>
-              <a:t>Specifications are written in a pure mathematical sublanguage — spec functions, forall/exists, arithmetic, sets, sequences.</a:t>
+              <a:t>Specifications are written in a pure mathematical sublanguage</a:t>
+            </a:r>
+          </a:p>
+          <a:p>
+            <a:pPr lvl="0"/>
+            <a:r>
+              <a:rPr sz="1800"/>
+              <a:t>spec functions, forall/exists, arithmetic, sets, sequences.</a:t>
             </a:r>
           </a:p>
           <a:p>
@@ -4822,6 +4872,13 @@
             <a:pPr lvl="0"/>
             <a:r>
               <a:rPr sz="1800"/>
+              <a:t>Its a pleasure to speak here at Micrsoft Research RISE Group.</a:t>
+            </a:r>
+          </a:p>
+          <a:p>
+            <a:pPr lvl="0"/>
+            <a:r>
+              <a:rPr sz="1800"/>
               <a:t>Background</a:t>
             </a:r>
           </a:p>
@@ -5396,7 +5453,28 @@
             <a:pPr lvl="0"/>
             <a:r>
               <a:rPr sz="1800"/>
-              <a:t>Goal: formally verify all algorithms in Acar and Blelloch “A Practical Approach to Data Structures” using Verus. Every algorithm gets a machine-checked proof — no admitted lemmas, no hand-waving in production code.</a:t>
+              <a:t>Goal: formally verify all algorithms in Acar and Blelloch</a:t>
+            </a:r>
+          </a:p>
+          <a:p>
+            <a:pPr lvl="1"/>
+            <a:r>
+              <a:rPr sz="1800"/>
+              <a:t>Every algorithm gets a machine-checked proof</a:t>
+            </a:r>
+          </a:p>
+          <a:p>
+            <a:pPr lvl="1"/>
+            <a:r>
+              <a:rPr sz="1800"/>
+              <a:t>no admitted lemmas,</a:t>
+            </a:r>
+          </a:p>
+          <a:p>
+            <a:pPr lvl="1"/>
+            <a:r>
+              <a:rPr sz="1800"/>
+              <a:t>no hand-waving in production code.</a:t>
             </a:r>
           </a:p>
           <a:p>
@@ -5410,7 +5488,14 @@
             <a:pPr lvl="0"/>
             <a:r>
               <a:rPr sz="1800"/>
-              <a:t>Minimal use of std.</a:t>
+              <a:t>Minimal use of Rust std.</a:t>
+            </a:r>
+          </a:p>
+          <a:p>
+            <a:pPr lvl="0"/>
+            <a:r>
+              <a:rPr sz="1800"/>
+              <a:t>But as you’ll see I had to write some axioms and admit a class of functions.</a:t>
             </a:r>
           </a:p>
         </p:txBody>
@@ -5480,7 +5565,14 @@
             <a:pPr lvl="0"/>
             <a:r>
               <a:rPr sz="1800"/>
-              <a:t>Proof infrastructure: 26 vstdplus library modules, 29 standards documents encoding project proof conventions,</a:t>
+              <a:t>26 vstdplus library modules, mostly making Views.</a:t>
+            </a:r>
+          </a:p>
+          <a:p>
+            <a:pPr lvl="0"/>
+            <a:r>
+              <a:rPr sz="1800"/>
+              <a:t>29 standards documents encoding project proof conventions,</a:t>
             </a:r>
           </a:p>
           <a:p>
@@ -5592,7 +5684,7 @@
             <a:pPr lvl="0"/>
             <a:r>
               <a:rPr sz="1800"/>
-              <a:t>Verification: 5,674 verified items, 0 errors.</a:t>
+              <a:t>Verification: 5,674 verified proof obligations, 0 errors.</a:t>
             </a:r>
           </a:p>
           <a:p>
@@ -5802,7 +5894,14 @@
             <a:pPr lvl="0"/>
             <a:r>
               <a:rPr sz="1800"/>
-              <a:t>Largest chapter: Chap37 (AVL trees, BST variants) — 20,319 src LOC. 4.1× more source code to verify than APAS-AI needed to implement.</a:t>
+              <a:t>Largest chapter: Chap37 (AVL trees, BST variants) — 20,319 src LOC.</a:t>
+            </a:r>
+          </a:p>
+          <a:p>
+            <a:pPr lvl="0"/>
+            <a:r>
+              <a:rPr sz="1800"/>
+              <a:t>4.1× more source code to verify than APAS-AI needed to implement.</a:t>
             </a:r>
           </a:p>
           <a:p>
@@ -6033,13 +6132,6 @@
             <a:pPr lvl="0"/>
             <a:r>
               <a:rPr sz="1800"/>
-              <a:t>So roughly half the non-exec code is proof (27%), a fifth is spec (21%), and the exec implementation is 44%.</a:t>
-            </a:r>
-          </a:p>
-          <a:p>
-            <a:pPr lvl="0"/>
-            <a:r>
-              <a:rPr sz="1800"/>
               <a:t>The “rust” 8% is code outside Verus! — Debug impls, macros, cfg, etc.</a:t>
             </a:r>
           </a:p>
@@ -6416,7 +6508,7 @@
             </a:pPr>
             <a:r>
               <a:rPr sz="3200"/>
-              <a:t>APAS-VERUS - Complexity</a:t>
+              <a:t>Veracity- Software Engineering AI Paired Proving</a:t>
             </a:r>
           </a:p>
         </p:txBody>
@@ -6439,35 +6531,39 @@
             <a:pPr lvl="0"/>
             <a:r>
               <a:rPr sz="1800"/>
-              <a:t>APAS states runtimes and informally proves them for some algorithms.</a:t>
-            </a:r>
-          </a:p>
-          <a:p>
-            <a:pPr lvl="0"/>
-            <a:r>
-              <a:rPr sz="1800"/>
-              <a:t>I had to build a tool to get the right ones in the code at the right place.</a:t>
-            </a:r>
-          </a:p>
-          <a:p>
-            <a:pPr lvl="0"/>
-            <a:r>
-              <a:rPr sz="1800"/>
-              <a:t>My single threaded implementations often don’t match the textbook.</a:t>
-            </a:r>
-          </a:p>
-          <a:p>
-            <a:pPr lvl="0"/>
-            <a:r>
-              <a:rPr sz="1800"/>
-              <a:t>Then I had Claude Opus do it’s analysis and compare every function with the textbooks.</a:t>
-            </a:r>
-          </a:p>
-          <a:p>
-            <a:pPr lvl="0"/>
-            <a:r>
-              <a:rPr sz="1800"/>
-              <a:t>This found about 16 faults in parallel algorithms.</a:t>
+              <a:t>Veracity is a suite of 22+ tools for analyzing, reviewing, and fixing Verus codebases.</a:t>
+            </a:r>
+          </a:p>
+          <a:p>
+            <a:pPr lvl="0"/>
+            <a:r>
+              <a:rPr sz="1800"/>
+              <a:t>Review tools: proof holes (assume, external_body, admit), style enforcement (21 rules, auto-reorder), function inventory with spec strength classification, string-hacking detector.</a:t>
+            </a:r>
+          </a:p>
+          <a:p>
+            <a:pPr lvl="0"/>
+            <a:r>
+              <a:rPr sz="1800"/>
+              <a:t>Minimization tools: veracity-minimize-proofs</a:t>
+            </a:r>
+          </a:p>
+          <a:p>
+            <a:pPr lvl="0"/>
+            <a:r>
+              <a:rPr sz="1800"/>
+              <a:t>Metrics: veracity-count-loc (spec/proof/exec breakdown),</a:t>
+            </a:r>
+          </a:p>
+          <a:p>
+            <a:pPr lvl="0" indent="0">
+              <a:buNone/>
+            </a:pPr>
+            <a:r>
+              <a:rPr sz="1800">
+                <a:latin typeface="Courier"/>
+              </a:rPr>
+              <a:t>   chapter-cleanliness-status (clean vs. holed chapter summary).</a:t>
             </a:r>
           </a:p>
         </p:txBody>
@@ -6537,28 +6633,21 @@
             <a:pPr lvl="0"/>
             <a:r>
               <a:rPr sz="1800"/>
-              <a:t>Veracity is a suite of 22+ tools for analyzing, reviewing, and fixing Verus codebases.</a:t>
-            </a:r>
-          </a:p>
-          <a:p>
-            <a:pPr lvl="0"/>
-            <a:r>
-              <a:rPr sz="1800"/>
-              <a:t>Review tools: proof holes (assume, external_body, admit), style enforcement (21 rules, auto-reorder), function inventory with spec strength classification, string-hacking detector.</a:t>
-            </a:r>
-          </a:p>
-          <a:p>
-            <a:pPr lvl="0"/>
-            <a:r>
-              <a:rPr sz="1800"/>
-              <a:t>Minimization tools: veracity-minimize-proofs (removes redundant asserts and proof blocks, re-verifying after each removal).</a:t>
-            </a:r>
-          </a:p>
-          <a:p>
-            <a:pPr lvl="0"/>
-            <a:r>
-              <a:rPr sz="1800"/>
-              <a:t>Metrics: veracity-count-loc (spec/proof/exec breakdown), chapter-cleanliness-status (clean vs. holed chapter summary).</a:t>
+              <a:t>All tools are AST-aware (ra_ap_syntax / Verus_syn).</a:t>
+            </a:r>
+          </a:p>
+          <a:p>
+            <a:pPr lvl="0"/>
+            <a:r>
+              <a:rPr sz="1800"/>
+              <a:t>A built-in string-hacking detector flags usage of string manipulation instead of AST work.</a:t>
+            </a:r>
+          </a:p>
+          <a:p>
+            <a:pPr lvl="0"/>
+            <a:r>
+              <a:rPr sz="1800"/>
+              <a:t>And when bugs appeared they were mostly string hacking.</a:t>
             </a:r>
           </a:p>
         </p:txBody>
@@ -6628,14 +6717,7 @@
             <a:pPr lvl="0"/>
             <a:r>
               <a:rPr sz="1800"/>
-              <a:t>All tools are AST-aware (ra_ap_syntax / Verus_syn). A built-in string-hacking detector flags and rejects any tool that attempts regex or find-and-replace on Verus source.</a:t>
-            </a:r>
-          </a:p>
-          <a:p>
-            <a:pPr lvl="0"/>
-            <a:r>
-              <a:rPr sz="1800"/>
-              <a:t>Search: veracity-search — semantic search over vstd</a:t>
+              <a:t>Search: veracity-search — type directed search over vstd</a:t>
             </a:r>
           </a:p>
           <a:p>
@@ -6649,7 +6731,35 @@
             <a:pPr lvl="0"/>
             <a:r>
               <a:rPr sz="1800"/>
-              <a:t>This allows me to download ALL known Verus (git VerusCodebases) and search them in 1.2 seconds!</a:t>
+              <a:t>Written for my sins of asking why does’s vstd not have X, when it did!</a:t>
+            </a:r>
+          </a:p>
+          <a:p>
+            <a:pPr lvl="0"/>
+            <a:r>
+              <a:rPr sz="1800"/>
+              <a:t>Even more useful for my AI’s sins.</a:t>
+            </a:r>
+          </a:p>
+          <a:p>
+            <a:pPr lvl="0"/>
+            <a:r>
+              <a:rPr sz="1800"/>
+              <a:t>This allowed me to download ALL known Verus (git VerusCodebases) and have my AI search them in 1.2 seconds!</a:t>
+            </a:r>
+          </a:p>
+          <a:p>
+            <a:pPr lvl="0"/>
+            <a:r>
+              <a:rPr sz="1800"/>
+              <a:t>Does F*/Pulse have one yet?</a:t>
+            </a:r>
+          </a:p>
+          <a:p>
+            <a:pPr lvl="0"/>
+            <a:r>
+              <a:rPr sz="1800"/>
+              <a:t>It only took about a day.</a:t>
             </a:r>
           </a:p>
         </p:txBody>
@@ -6696,7 +6806,7 @@
             </a:pPr>
             <a:r>
               <a:rPr sz="3200"/>
-              <a:t>APAS-VERUS: Verified Iteration - Pain Point</a:t>
+              <a:t>APAS-VERUS - Complexity</a:t>
             </a:r>
           </a:p>
         </p:txBody>
@@ -6719,63 +6829,42 @@
             <a:pPr lvl="0"/>
             <a:r>
               <a:rPr sz="1800"/>
-              <a:t>Iteration in Rust is rather complex.</a:t>
-            </a:r>
-          </a:p>
-          <a:p>
-            <a:pPr lvl="0"/>
-            <a:r>
-              <a:rPr sz="1800"/>
-              <a:t>7 functions cover the 90% case.</a:t>
-            </a:r>
-          </a:p>
-          <a:p>
-            <a:pPr lvl="0"/>
-            <a:r>
-              <a:rPr sz="1800"/>
-              <a:t>And in Verus it’s a bit more complex and takes some time to learn.</a:t>
-            </a:r>
-          </a:p>
-          <a:p>
-            <a:pPr lvl="0"/>
-            <a:r>
-              <a:rPr sz="1800"/>
-              <a:t>10 components required per collection (all inside Verus!)</a:t>
-            </a:r>
-          </a:p>
-          <a:p>
-            <a:pPr lvl="0"/>
-            <a:r>
-              <a:rPr sz="1800"/>
-              <a:t>6 verified loop patterns per collection</a:t>
-            </a:r>
-          </a:p>
-          <a:p>
-            <a:pPr lvl="0"/>
-            <a:r>
-              <a:rPr sz="1800"/>
-              <a:t>loop + borrow iter, loop + borrow into</a:t>
-            </a:r>
-          </a:p>
-          <a:p>
-            <a:pPr lvl="0"/>
-            <a:r>
-              <a:rPr sz="1800"/>
-              <a:t>for + borrow iter, for + borrow into</a:t>
-            </a:r>
-          </a:p>
-          <a:p>
-            <a:pPr lvl="0"/>
-            <a:r>
-              <a:rPr sz="1800"/>
-              <a:t>loop + consume, for + consume</a:t>
-            </a:r>
-          </a:p>
-          <a:p>
-            <a:pPr lvl="0"/>
-            <a:r>
-              <a:rPr sz="1800"/>
-              <a:t>Iterator assumes (one necessary workaround):</a:t>
+              <a:t>APAS states complexity and informally proves many of them for some algorithms.</a:t>
+            </a:r>
+          </a:p>
+          <a:p>
+            <a:pPr lvl="0"/>
+            <a:r>
+              <a:rPr sz="1800"/>
+              <a:t>I had to build a tool to get the right ones in the code at the right place.</a:t>
+            </a:r>
+          </a:p>
+          <a:p>
+            <a:pPr lvl="0"/>
+            <a:r>
+              <a:rPr sz="1800"/>
+              <a:t>My single threaded implementations often don’t match the textbook.</a:t>
+            </a:r>
+          </a:p>
+          <a:p>
+            <a:pPr lvl="0"/>
+            <a:r>
+              <a:rPr sz="1800"/>
+              <a:t>Then I wrote a programmatic tool to find and list mismatches.</a:t>
+            </a:r>
+          </a:p>
+          <a:p>
+            <a:pPr lvl="0"/>
+            <a:r>
+              <a:rPr sz="1800"/>
+              <a:t>Then I had Claude Opus do it’s analysis and compare every function with the textbooks.</a:t>
+            </a:r>
+          </a:p>
+          <a:p>
+            <a:pPr lvl="0"/>
+            <a:r>
+              <a:rPr sz="1800"/>
+              <a:t>This found about 16 faults in parallel algorithms.</a:t>
             </a:r>
           </a:p>
         </p:txBody>
@@ -6822,7 +6911,7 @@
             </a:pPr>
             <a:r>
               <a:rPr sz="3200"/>
-              <a:t>APAS-VERUS: Verified Iteration</a:t>
+              <a:t>APAS-VERUS: Verified Iteration - Pain Point</a:t>
             </a:r>
           </a:p>
         </p:txBody>
@@ -6845,42 +6934,49 @@
             <a:pPr lvl="0"/>
             <a:r>
               <a:rPr sz="1800"/>
-              <a:t>Verus forbids requires on external trait impls (std::iter::Iterator)</a:t>
-            </a:r>
-          </a:p>
-          <a:p>
-            <a:pPr lvl="0"/>
-            <a:r>
-              <a:rPr sz="1800"/>
-              <a:t>Hand-rolled iterators need assume(iter_invariant(self)) in next()</a:t>
-            </a:r>
-          </a:p>
-          <a:p>
-            <a:pPr lvl="0"/>
-            <a:r>
-              <a:rPr sz="1800"/>
-              <a:t>Everything after the assume is fully proved</a:t>
-            </a:r>
-          </a:p>
-          <a:p>
-            <a:pPr lvl="0"/>
-            <a:r>
-              <a:rPr sz="1800"/>
-              <a:t>44 collections implemented; all carry verified iterators</a:t>
-            </a:r>
-          </a:p>
-          <a:p>
-            <a:pPr lvl="0"/>
-            <a:r>
-              <a:rPr sz="1800"/>
-              <a:t>Verus has proof time tests inside, I freed them to run in APAS-VERUS.</a:t>
-            </a:r>
-          </a:p>
-          <a:p>
-            <a:pPr lvl="0"/>
-            <a:r>
-              <a:rPr sz="1800"/>
-              <a:t>This was critical to get iterative loops to prove over my collections ADTs.</a:t>
+              <a:t>Iteration in Rust is rather complex.</a:t>
+            </a:r>
+          </a:p>
+          <a:p>
+            <a:pPr lvl="0"/>
+            <a:r>
+              <a:rPr sz="1800"/>
+              <a:t>70 functions on iterator but only 7 functions cover the 90% case.</a:t>
+            </a:r>
+          </a:p>
+          <a:p>
+            <a:pPr lvl="0"/>
+            <a:r>
+              <a:rPr sz="1800"/>
+              <a:t>And in Verus it’s a bit more complex and takes some time to learn.</a:t>
+            </a:r>
+          </a:p>
+          <a:p>
+            <a:pPr lvl="0"/>
+            <a:r>
+              <a:rPr sz="1800"/>
+              <a:t>10 components required per collection (all inside Verus!)</a:t>
+            </a:r>
+          </a:p>
+          <a:p>
+            <a:pPr lvl="0"/>
+            <a:r>
+              <a:rPr sz="1800"/>
+              <a:t>6 verified loop patterns per collection</a:t>
+            </a:r>
+          </a:p>
+          <a:p>
+            <a:pPr lvl="0"/>
+            <a:r>
+              <a:rPr sz="1800"/>
+              <a:t>{loop, for} X {borrow iter, borrow into, consume}</a:t>
+            </a:r>
+          </a:p>
+          <a:p>
+            <a:pPr lvl="0"/>
+            <a:r>
+              <a:rPr sz="1800"/>
+              <a:t>Iterators requiers one assume!</a:t>
             </a:r>
           </a:p>
         </p:txBody>
@@ -6927,7 +7023,7 @@
             </a:pPr>
             <a:r>
               <a:rPr sz="3200"/>
-              <a:t>APAS-VERUS: Experiments</a:t>
+              <a:t>APAS-VERUS: Verified Iteration</a:t>
             </a:r>
           </a:p>
         </p:txBody>
@@ -6950,42 +7046,42 @@
             <a:pPr lvl="0"/>
             <a:r>
               <a:rPr sz="1800"/>
-              <a:t>Agents often say “Verus Can’t Do That”</a:t>
-            </a:r>
-          </a:p>
-          <a:p>
-            <a:pPr lvl="0"/>
-            <a:r>
-              <a:rPr sz="1800"/>
-              <a:t>I said “Make an experiment!”</a:t>
-            </a:r>
-          </a:p>
-          <a:p>
-            <a:pPr lvl="0"/>
-            <a:r>
-              <a:rPr sz="1800"/>
-              <a:t>Quantitatives:</a:t>
-            </a:r>
-          </a:p>
-          <a:p>
-            <a:pPr lvl="0"/>
-            <a:r>
-              <a:rPr sz="1800"/>
-              <a:t>168 experiment files</a:t>
-            </a:r>
-          </a:p>
-          <a:p>
-            <a:pPr lvl="0"/>
-            <a:r>
-              <a:rPr sz="1800"/>
-              <a:t>21,476 lines of code (not counted in the totals)</a:t>
-            </a:r>
-          </a:p>
-          <a:p>
-            <a:pPr lvl="0"/>
-            <a:r>
-              <a:rPr sz="1800"/>
-              <a:t>Topics span: Clone, Arc, RwLock, TSM, closures, iterators, generics, float, bitvector, PartialEq, Copy, async, hash tables, parallel algorithms, ghost types, Send/Sync, collect, and sorting.</a:t>
+              <a:t>Verus forbids requires on external trait impls (std::iter::Iterator)</a:t>
+            </a:r>
+          </a:p>
+          <a:p>
+            <a:pPr lvl="0"/>
+            <a:r>
+              <a:rPr sz="1800"/>
+              <a:t>Hand-rolled iterators need assume(iter_invariant(self)) in next()</a:t>
+            </a:r>
+          </a:p>
+          <a:p>
+            <a:pPr lvl="0"/>
+            <a:r>
+              <a:rPr sz="1800"/>
+              <a:t>Everything after the assume is fully proved</a:t>
+            </a:r>
+          </a:p>
+          <a:p>
+            <a:pPr lvl="0"/>
+            <a:r>
+              <a:rPr sz="1800"/>
+              <a:t>44 collections implemented; all carry verified iterators</a:t>
+            </a:r>
+          </a:p>
+          <a:p>
+            <a:pPr lvl="0"/>
+            <a:r>
+              <a:rPr sz="1800"/>
+              <a:t>Verus has proof time tests inside, I freed them to run in APAS-VERUS.</a:t>
+            </a:r>
+          </a:p>
+          <a:p>
+            <a:pPr lvl="0"/>
+            <a:r>
+              <a:rPr sz="1800"/>
+              <a:t>This was critical to get iterative loops to prove over my collections ADTs.</a:t>
             </a:r>
           </a:p>
         </p:txBody>
@@ -7181,56 +7277,42 @@
             <a:pPr lvl="0"/>
             <a:r>
               <a:rPr sz="1800"/>
-              <a:t>Results:</a:t>
-            </a:r>
-          </a:p>
-          <a:p>
-            <a:pPr lvl="0"/>
-            <a:r>
-              <a:rPr sz="1800"/>
-              <a:t>107 files: SUCCEEDS / VERIFIES — pattern adopted into codebase</a:t>
-            </a:r>
-          </a:p>
-          <a:p>
-            <a:pPr lvl="0"/>
-            <a:r>
-              <a:rPr sz="1800"/>
-              <a:t>61 files: FAILS — Verus limitation documented, workaround noted</a:t>
-            </a:r>
-          </a:p>
-          <a:p>
-            <a:pPr lvl="0"/>
-            <a:r>
-              <a:rPr sz="1800"/>
-              <a:t>Notable successes that unlocked chapters:</a:t>
-            </a:r>
-          </a:p>
-          <a:p>
-            <a:pPr lvl="0"/>
-            <a:r>
-              <a:rPr sz="1800"/>
-              <a:t>TSM/RwLock layer pattern — unlocked all Mt chapters</a:t>
-            </a:r>
-          </a:p>
-          <a:p>
-            <a:pPr lvl="0"/>
-            <a:r>
-              <a:rPr sz="1800"/>
-              <a:t>Named closure ensures through ParaPair — unlocked fork-join</a:t>
-            </a:r>
-          </a:p>
-          <a:p>
-            <a:pPr lvl="0"/>
-            <a:r>
-              <a:rPr sz="1800"/>
-              <a:t>Ghost struct Send/Sync — unlocked Chap41 (now in Verus upstream)</a:t>
-            </a:r>
-          </a:p>
-          <a:p>
-            <a:pPr lvl="0"/>
-            <a:r>
-              <a:rPr sz="1800"/>
-              <a:t>Tree module style with recursive trait impls — unlocked Chap65</a:t>
+              <a:t>Agents often say “Verus Can’t Do That”</a:t>
+            </a:r>
+          </a:p>
+          <a:p>
+            <a:pPr lvl="0"/>
+            <a:r>
+              <a:rPr sz="1800"/>
+              <a:t>I said “Make an experiment!”</a:t>
+            </a:r>
+          </a:p>
+          <a:p>
+            <a:pPr lvl="0"/>
+            <a:r>
+              <a:rPr sz="1800"/>
+              <a:t>Quantitatives:</a:t>
+            </a:r>
+          </a:p>
+          <a:p>
+            <a:pPr lvl="0"/>
+            <a:r>
+              <a:rPr sz="1800"/>
+              <a:t>168 experiment files</a:t>
+            </a:r>
+          </a:p>
+          <a:p>
+            <a:pPr lvl="0"/>
+            <a:r>
+              <a:rPr sz="1800"/>
+              <a:t>21,476 lines of code (not counted in the totals)</a:t>
+            </a:r>
+          </a:p>
+          <a:p>
+            <a:pPr lvl="0"/>
+            <a:r>
+              <a:rPr sz="1800"/>
+              <a:t>Topics span: Clone, Arc, RwLock, TSM, closures, iterators, generics, float, bitvector, PartialEq, Copy, async, hash tables, parallel algorithms, ghost types, Send/Sync, collect, and sorting.</a:t>
             </a:r>
           </a:p>
         </p:txBody>
@@ -7277,7 +7359,7 @@
             </a:pPr>
             <a:r>
               <a:rPr sz="3200"/>
-              <a:t>APAS-VERUS Standards</a:t>
+              <a:t>APAS-VERUS: Experiments</a:t>
             </a:r>
           </a:p>
         </p:txBody>
@@ -7300,42 +7382,56 @@
             <a:pPr lvl="0"/>
             <a:r>
               <a:rPr sz="1800"/>
-              <a:t>Purpose: encode hard-won proof patterns so agents don’t repeat mistakes</a:t>
-            </a:r>
-          </a:p>
-          <a:p>
-            <a:pPr lvl="0"/>
-            <a:r>
-              <a:rPr sz="1800"/>
-              <a:t>Agents read all standards before every task (~6,200 lines, ~54K tokens)</a:t>
-            </a:r>
-          </a:p>
-          <a:p>
-            <a:pPr lvl="0"/>
-            <a:r>
-              <a:rPr sz="1800"/>
-              <a:t>Violations are only agent checked except for many code style issues.</a:t>
-            </a:r>
-          </a:p>
-          <a:p>
-            <a:pPr lvl="0"/>
-            <a:r>
-              <a:rPr sz="1800"/>
-              <a:t>Quantitatives:</a:t>
-            </a:r>
-          </a:p>
-          <a:p>
-            <a:pPr lvl="0"/>
-            <a:r>
-              <a:rPr sz="1800"/>
-              <a:t>29 standard files</a:t>
-            </a:r>
-          </a:p>
-          <a:p>
-            <a:pPr lvl="0"/>
-            <a:r>
-              <a:rPr sz="1800"/>
-              <a:t>6,911 lines total</a:t>
+              <a:t>Results:</a:t>
+            </a:r>
+          </a:p>
+          <a:p>
+            <a:pPr lvl="0"/>
+            <a:r>
+              <a:rPr sz="1800"/>
+              <a:t>107 files: SUCCEEDS / VERIFIES — pattern adopted into codebase</a:t>
+            </a:r>
+          </a:p>
+          <a:p>
+            <a:pPr lvl="0"/>
+            <a:r>
+              <a:rPr sz="1800"/>
+              <a:t>61 files: FAILS — Verus limitation documented, workaround noted</a:t>
+            </a:r>
+          </a:p>
+          <a:p>
+            <a:pPr lvl="0"/>
+            <a:r>
+              <a:rPr sz="1800"/>
+              <a:t>Notable successes that unlocked chapters:</a:t>
+            </a:r>
+          </a:p>
+          <a:p>
+            <a:pPr lvl="0"/>
+            <a:r>
+              <a:rPr sz="1800"/>
+              <a:t>TSM/RwLock layer pattern — unlocked all Mt chapters</a:t>
+            </a:r>
+          </a:p>
+          <a:p>
+            <a:pPr lvl="0"/>
+            <a:r>
+              <a:rPr sz="1800"/>
+              <a:t>Named closure ensures through ParaPair — unlocked fork-join</a:t>
+            </a:r>
+          </a:p>
+          <a:p>
+            <a:pPr lvl="0"/>
+            <a:r>
+              <a:rPr sz="1800"/>
+              <a:t>Ghost struct Send/Sync — unlocked Chap41</a:t>
+            </a:r>
+          </a:p>
+          <a:p>
+            <a:pPr lvl="0"/>
+            <a:r>
+              <a:rPr sz="1800"/>
+              <a:t>Tree module style with recursive trait impls — unlocked Chap65</a:t>
             </a:r>
           </a:p>
         </p:txBody>
@@ -7405,49 +7501,70 @@
             <a:pPr lvl="0"/>
             <a:r>
               <a:rPr sz="1800"/>
-              <a:t>Module structure: mod, table_of_contents, spec_naming, spec_wf</a:t>
-            </a:r>
-          </a:p>
-          <a:p>
-            <a:pPr lvl="0"/>
-            <a:r>
-              <a:rPr sz="1800"/>
-              <a:t>Type system: view, deep_view, partial_eq_eq_clone, multi_struct</a:t>
-            </a:r>
-          </a:p>
-          <a:p>
-            <a:pPr lvl="0"/>
-            <a:r>
-              <a:rPr sz="1800"/>
-              <a:t>Proof patterns: total_order, finite_sets, capacity_bounds, no_unsafe</a:t>
-            </a:r>
-          </a:p>
-          <a:p>
-            <a:pPr lvl="0"/>
-            <a:r>
-              <a:rPr sz="1800"/>
-              <a:t>Concurrency: arc_usage, hfscheduler, mt_type_bounds, toplevel_coarse_rwlocks, tsm, rwlock_tsm</a:t>
-            </a:r>
-          </a:p>
-          <a:p>
-            <a:pPr lvl="0"/>
-            <a:r>
-              <a:rPr sz="1800"/>
-              <a:t>Iteration: iterators, wrapping_iterators, iterator_ptt</a:t>
-            </a:r>
-          </a:p>
-          <a:p>
-            <a:pPr lvl="0"/>
-            <a:r>
-              <a:rPr sz="1800"/>
-              <a:t>Execution: mut, using_closures, using_hashmap, using_rand</a:t>
-            </a:r>
-          </a:p>
-          <a:p>
-            <a:pPr lvl="0"/>
-            <a:r>
-              <a:rPr sz="1800"/>
-              <a:t>Style: TOC and ordering</a:t>
+              <a:t>Purpose: encode hard-won proof patterns so agents don’t repeat mistakes</a:t>
+            </a:r>
+          </a:p>
+          <a:p>
+            <a:pPr lvl="0"/>
+            <a:r>
+              <a:rPr sz="1800"/>
+              <a:t>Agents read all standards before every task (~6,200 lines, ~54K tokens)</a:t>
+            </a:r>
+          </a:p>
+          <a:p>
+            <a:pPr lvl="0"/>
+            <a:r>
+              <a:rPr sz="1800"/>
+              <a:t>Violations are mostly AI checked except for many code style issues.</a:t>
+            </a:r>
+          </a:p>
+          <a:p>
+            <a:pPr lvl="0"/>
+            <a:r>
+              <a:rPr sz="1800"/>
+              <a:t>Quantitatives:</a:t>
+            </a:r>
+          </a:p>
+          <a:p>
+            <a:pPr lvl="1"/>
+            <a:r>
+              <a:rPr sz="1800"/>
+              <a:t>29 standard files</a:t>
+            </a:r>
+          </a:p>
+          <a:p>
+            <a:pPr lvl="1"/>
+            <a:r>
+              <a:rPr sz="1800"/>
+              <a:t>6,911 lines total</a:t>
+            </a:r>
+          </a:p>
+          <a:p>
+            <a:pPr lvl="0"/>
+            <a:r>
+              <a:rPr sz="1800"/>
+              <a:t>Doing this earlier would have really sped things up.</a:t>
+            </a:r>
+          </a:p>
+          <a:p>
+            <a:pPr lvl="0"/>
+            <a:r>
+              <a:rPr sz="1800"/>
+              <a:t>My CLAUDE.md would just not do enough even with 50KB and 13K tokens.</a:t>
+            </a:r>
+          </a:p>
+          <a:p>
+            <a:pPr lvl="0"/>
+            <a:r>
+              <a:rPr sz="1800"/>
+              <a:t>Question what are your favorite AI rules?</a:t>
+            </a:r>
+          </a:p>
+          <a:p>
+            <a:pPr lvl="0"/>
+            <a:r>
+              <a:rPr sz="1800"/>
+              <a:t>Mine are Don’t Over Think, DISCUSS and PBOGH.</a:t>
             </a:r>
           </a:p>
         </p:txBody>
@@ -7494,7 +7611,7 @@
             </a:pPr>
             <a:r>
               <a:rPr sz="3200"/>
-              <a:t>Veracity: veracity-minimize-proofs: AIs Write Redundant Proofs</a:t>
+              <a:t>APAS-VERUS Standards</a:t>
             </a:r>
           </a:p>
         </p:txBody>
@@ -7517,28 +7634,49 @@
             <a:pPr lvl="0"/>
             <a:r>
               <a:rPr sz="1800"/>
-              <a:t>AI proof agents produce correct but bloated proofs — redundant asserts, unnecessary proof blocks, duplicate intermediate steps that Z3 already knew.</a:t>
-            </a:r>
-          </a:p>
-          <a:p>
-            <a:pPr lvl="0"/>
-            <a:r>
-              <a:rPr sz="1800"/>
-              <a:t>They verify, but they waste solver budget on every subsequent run.</a:t>
-            </a:r>
-          </a:p>
-          <a:p>
-            <a:pPr lvl="0"/>
-            <a:r>
-              <a:rPr sz="1800"/>
-              <a:t>veracity-minimize-proofs tests each assert and proof block individually: remove it, re-verify, comment it out if it is not needed and it does not increase time or memory.</a:t>
-            </a:r>
-          </a:p>
-          <a:p>
-            <a:pPr lvl="0"/>
-            <a:r>
-              <a:rPr sz="1800"/>
-              <a:t>Result across APAS-VERUS: 22 asserts and 33 proof blocks removed in 105 minutes of wall time. 55 redundant proof statements eliminated, ~2 minutes of minimizer time per removal.</a:t>
+              <a:t>Module structure: mod, table_of_contents, spec_naming, spec_wf</a:t>
+            </a:r>
+          </a:p>
+          <a:p>
+            <a:pPr lvl="0"/>
+            <a:r>
+              <a:rPr sz="1800"/>
+              <a:t>Type system: view, deep_view, partial_eq_eq_clone, multi_struct</a:t>
+            </a:r>
+          </a:p>
+          <a:p>
+            <a:pPr lvl="0"/>
+            <a:r>
+              <a:rPr sz="1800"/>
+              <a:t>Proof patterns: total_order, finite_sets, capacity_bounds, no_unsafe</a:t>
+            </a:r>
+          </a:p>
+          <a:p>
+            <a:pPr lvl="0"/>
+            <a:r>
+              <a:rPr sz="1800"/>
+              <a:t>Concurrency: arc_usage, hfscheduler, mt_type_bounds, toplevel_coarse_rwlocks, tsm, rwlock_tsm</a:t>
+            </a:r>
+          </a:p>
+          <a:p>
+            <a:pPr lvl="0"/>
+            <a:r>
+              <a:rPr sz="1800"/>
+              <a:t>Iteration: iterators, wrapping_iterators, iterator_ptt</a:t>
+            </a:r>
+          </a:p>
+          <a:p>
+            <a:pPr lvl="0"/>
+            <a:r>
+              <a:rPr sz="1800"/>
+              <a:t>Execution: mut, using_closures, using_hashmap, using_rand</a:t>
+            </a:r>
+          </a:p>
+          <a:p>
+            <a:pPr lvl="0"/>
+            <a:r>
+              <a:rPr sz="1800"/>
+              <a:t>Style: TOC and ordering</a:t>
             </a:r>
           </a:p>
         </p:txBody>
@@ -7608,42 +7746,28 @@
             <a:pPr lvl="0"/>
             <a:r>
               <a:rPr sz="1800"/>
-              <a:t>One assert in Chap43 OrderedTableMtEph saved:</a:t>
-            </a:r>
-          </a:p>
-          <a:p>
-            <a:pPr lvl="1"/>
-            <a:r>
-              <a:rPr sz="1800"/>
-              <a:t>43–104 s of Z3 CPU</a:t>
-            </a:r>
-          </a:p>
-          <a:p>
-            <a:pPr lvl="1"/>
-            <a:r>
-              <a:rPr sz="1800"/>
-              <a:t>up to 89 MB of Z3 RSS per verify run.</a:t>
-            </a:r>
-          </a:p>
-          <a:p>
-            <a:pPr lvl="0"/>
-            <a:r>
-              <a:rPr sz="1800"/>
-              <a:t>Eight removals in that one file: Z3 RSS −57%.</a:t>
-            </a:r>
-          </a:p>
-          <a:p>
-            <a:pPr lvl="0"/>
-            <a:r>
-              <a:rPr sz="1800"/>
-              <a:t>105 minutes of running the minimizer bought many hours of validation drop.</a:t>
-            </a:r>
-          </a:p>
-          <a:p>
-            <a:pPr lvl="0"/>
-            <a:r>
-              <a:rPr sz="1800"/>
-              <a:t>This might be novel. Anyone know of anything except Isabelle’s sledgehammer?</a:t>
+              <a:t>AI proof agents produce correct but bloated proofs — redundant asserts, unnecessary proof blocks, duplicate intermediate steps that Z3 already knew.</a:t>
+            </a:r>
+          </a:p>
+          <a:p>
+            <a:pPr lvl="0"/>
+            <a:r>
+              <a:rPr sz="1800"/>
+              <a:t>They verify, but they waste solver budget on every subsequent run.</a:t>
+            </a:r>
+          </a:p>
+          <a:p>
+            <a:pPr lvl="0"/>
+            <a:r>
+              <a:rPr sz="1800"/>
+              <a:t>veracity-minimize-proofs tests each assert and proof block individually: remove it, re-verify, comment it out if it is not needed and it does not increase time or memory.</a:t>
+            </a:r>
+          </a:p>
+          <a:p>
+            <a:pPr lvl="0"/>
+            <a:r>
+              <a:rPr sz="1800"/>
+              <a:t>Result across APAS-VERUS: 22 asserts and 33 proof blocks removed in 105 minutes of wall time. 55 redundant proof statements eliminated, ~2 minutes of minimizer time per removal.</a:t>
             </a:r>
           </a:p>
         </p:txBody>
@@ -7690,7 +7814,7 @@
             </a:pPr>
             <a:r>
               <a:rPr sz="3200"/>
-              <a:t>Veracity Annotations</a:t>
+              <a:t>Veracity: veracity-minimize-proofs: AIs Write Redundant Proofs</a:t>
             </a:r>
           </a:p>
         </p:txBody>
@@ -7713,49 +7837,42 @@
             <a:pPr lvl="0"/>
             <a:r>
               <a:rPr sz="1800"/>
-              <a:t>I ended up having to have my tools work mostly in comments.</a:t>
-            </a:r>
-          </a:p>
-          <a:p>
-            <a:pPr lvl="0"/>
-            <a:r>
-              <a:rPr sz="1800"/>
-              <a:t>I added accept to mark assumes I allowed, almost all eq/partialeq/clone.</a:t>
-            </a:r>
-          </a:p>
-          <a:p>
-            <a:pPr lvl="0"/>
-            <a:r>
-              <a:rPr sz="1800"/>
-              <a:t>This can be simplified with some Verus language syntax, but then the AIs are not trained on the symbols.</a:t>
-            </a:r>
-          </a:p>
-          <a:p>
-            <a:pPr lvl="0"/>
-            <a:r>
-              <a:rPr sz="1800"/>
-              <a:t>// Veracity: NEEDED assert — 6,081</a:t>
-            </a:r>
-          </a:p>
-          <a:p>
-            <a:pPr lvl="0"/>
-            <a:r>
-              <a:rPr sz="1800"/>
-              <a:t>// Veracity: NEEDED proof block — 4,681</a:t>
-            </a:r>
-          </a:p>
-          <a:p>
-            <a:pPr lvl="0"/>
-            <a:r>
-              <a:rPr sz="1800"/>
-              <a:t>// Veracity: NEEDED assert (speed) — 1,502</a:t>
-            </a:r>
-          </a:p>
-          <a:p>
-            <a:pPr lvl="0"/>
-            <a:r>
-              <a:rPr sz="1800"/>
-              <a:t>// Veracity: NEEDED proof block (speed)— 245</a:t>
+              <a:t>One assert in Chap43 OrderedTableMtEph saved:</a:t>
+            </a:r>
+          </a:p>
+          <a:p>
+            <a:pPr lvl="1"/>
+            <a:r>
+              <a:rPr sz="1800"/>
+              <a:t>43–104 s of Z3 CPU</a:t>
+            </a:r>
+          </a:p>
+          <a:p>
+            <a:pPr lvl="1"/>
+            <a:r>
+              <a:rPr sz="1800"/>
+              <a:t>up to 89 MB of Z3 RSS per verify run.</a:t>
+            </a:r>
+          </a:p>
+          <a:p>
+            <a:pPr lvl="0"/>
+            <a:r>
+              <a:rPr sz="1800"/>
+              <a:t>Eight removals in that one file: Z3 RSS −57%.</a:t>
+            </a:r>
+          </a:p>
+          <a:p>
+            <a:pPr lvl="0"/>
+            <a:r>
+              <a:rPr sz="1800"/>
+              <a:t>105 minutes of running the minimizer bought many hours of validation drop.</a:t>
+            </a:r>
+          </a:p>
+          <a:p>
+            <a:pPr lvl="0"/>
+            <a:r>
+              <a:rPr sz="1800"/>
+              <a:t>This might be novel. Anyone know of anything except Isabelle’s sledgehammer?</a:t>
             </a:r>
           </a:p>
         </p:txBody>
@@ -7825,35 +7942,49 @@
             <a:pPr lvl="0"/>
             <a:r>
               <a:rPr sz="1800"/>
-              <a:t>Total NEEDED: 12,509</a:t>
-            </a:r>
-          </a:p>
-          <a:p>
-            <a:pPr lvl="0"/>
-            <a:r>
-              <a:rPr sz="1800"/>
-              <a:t>// Veracity: UNNEEDED — 1,452</a:t>
-            </a:r>
-          </a:p>
-          <a:p>
-            <a:pPr lvl="0"/>
-            <a:r>
-              <a:rPr sz="1800"/>
-              <a:t>// Veracity: no_requires — 71</a:t>
-            </a:r>
-          </a:p>
-          <a:p>
-            <a:pPr lvl="0"/>
-            <a:r>
-              <a:rPr sz="1800"/>
-              <a:t>accept — 108</a:t>
-            </a:r>
-          </a:p>
-          <a:p>
-            <a:pPr lvl="0"/>
-            <a:r>
-              <a:rPr sz="1800"/>
-              <a:t>Total annotations: 14,140</a:t>
+              <a:t>I ended up having to have my tools work mostly in comments.</a:t>
+            </a:r>
+          </a:p>
+          <a:p>
+            <a:pPr lvl="0"/>
+            <a:r>
+              <a:rPr sz="1800"/>
+              <a:t>I added accept to mark assumes I allowed, almost all eq/partialeq/clone.</a:t>
+            </a:r>
+          </a:p>
+          <a:p>
+            <a:pPr lvl="0"/>
+            <a:r>
+              <a:rPr sz="1800"/>
+              <a:t>This can be simplified with some Verus language syntax, but then the AIs are not trained on the symbols.</a:t>
+            </a:r>
+          </a:p>
+          <a:p>
+            <a:pPr lvl="0"/>
+            <a:r>
+              <a:rPr sz="1800"/>
+              <a:t>// Veracity: NEEDED assert — 6,081</a:t>
+            </a:r>
+          </a:p>
+          <a:p>
+            <a:pPr lvl="0"/>
+            <a:r>
+              <a:rPr sz="1800"/>
+              <a:t>// Veracity: NEEDED proof block — 4,681</a:t>
+            </a:r>
+          </a:p>
+          <a:p>
+            <a:pPr lvl="0"/>
+            <a:r>
+              <a:rPr sz="1800"/>
+              <a:t>// Veracity: NEEDED assert (speed) — 1,502</a:t>
+            </a:r>
+          </a:p>
+          <a:p>
+            <a:pPr lvl="0"/>
+            <a:r>
+              <a:rPr sz="1800"/>
+              <a:t>// Veracity: NEEDED proof block (speed)— 245</a:t>
             </a:r>
           </a:p>
         </p:txBody>
@@ -7900,7 +8031,7 @@
             </a:pPr>
             <a:r>
               <a:rPr sz="3200"/>
-              <a:t>Rusticate + Veracity allow quantitative software engineering</a:t>
+              <a:t>Veracity Annotations</a:t>
             </a:r>
           </a:p>
         </p:txBody>
@@ -7923,49 +8054,35 @@
             <a:pPr lvl="0"/>
             <a:r>
               <a:rPr sz="1800"/>
-              <a:t>I downloaded the 1036 most downloaded Rust projects, 3636 crates.</a:t>
-            </a:r>
-          </a:p>
-          <a:p>
-            <a:pPr lvl="0"/>
-            <a:r>
-              <a:rPr sz="1800"/>
-              <a:t>I threw out three that wrapped std for asynchrony.</a:t>
-            </a:r>
-          </a:p>
-          <a:p>
-            <a:pPr lvl="0"/>
-            <a:r>
-              <a:rPr sz="1800"/>
-              <a:t>I did a greedy set cover analysis of what Rust uses.</a:t>
-            </a:r>
-          </a:p>
-          <a:p>
-            <a:pPr lvl="0"/>
-            <a:r>
-              <a:rPr sz="1800"/>
-              <a:t>And another of what verus wraps.</a:t>
-            </a:r>
-          </a:p>
-          <a:p>
-            <a:pPr lvl="0"/>
-            <a:r>
-              <a:rPr sz="1800"/>
-              <a:t>This is a golden age for quantitative software engineering.</a:t>
-            </a:r>
-          </a:p>
-          <a:p>
-            <a:pPr lvl="0"/>
-            <a:r>
-              <a:rPr sz="1800"/>
-              <a:t>It took just two days of person time.</a:t>
-            </a:r>
-          </a:p>
-          <a:p>
-            <a:pPr lvl="0"/>
-            <a:r>
-              <a:rPr sz="1800"/>
-              <a:t>And I never read a line of code in the tools. Just check the output and have the AI write a lot of tests.</a:t>
+              <a:t>Total NEEDED: 12,509</a:t>
+            </a:r>
+          </a:p>
+          <a:p>
+            <a:pPr lvl="0"/>
+            <a:r>
+              <a:rPr sz="1800"/>
+              <a:t>// Veracity: UNNEEDED — 1,452</a:t>
+            </a:r>
+          </a:p>
+          <a:p>
+            <a:pPr lvl="0"/>
+            <a:r>
+              <a:rPr sz="1800"/>
+              <a:t>// Veracity: no_requires — 71</a:t>
+            </a:r>
+          </a:p>
+          <a:p>
+            <a:pPr lvl="0"/>
+            <a:r>
+              <a:rPr sz="1800"/>
+              <a:t>accept — 108</a:t>
+            </a:r>
+          </a:p>
+          <a:p>
+            <a:pPr lvl="0"/>
+            <a:r>
+              <a:rPr sz="1800"/>
+              <a:t>Total annotations: 14,140</a:t>
             </a:r>
           </a:p>
         </p:txBody>
@@ -8012,7 +8129,7 @@
             </a:pPr>
             <a:r>
               <a:rPr sz="3200"/>
-              <a:t>Rusticate + Veracity : What Rust Cargos use in std.</a:t>
+              <a:t>Rusticate + Veracity allow quantitative software engineering</a:t>
             </a:r>
           </a:p>
         </p:txBody>
@@ -8035,70 +8152,49 @@
             <a:pPr lvl="0"/>
             <a:r>
               <a:rPr sz="1800"/>
-              <a:t>Top 1000 projects, 3636 crates.</a:t>
-            </a:r>
-          </a:p>
-          <a:p>
-            <a:pPr lvl="0"/>
-            <a:r>
-              <a:rPr sz="1800"/>
-              <a:t>19 data types fully support 90%.</a:t>
-            </a:r>
-          </a:p>
-          <a:p>
-            <a:pPr lvl="0"/>
-            <a:r>
-              <a:rPr sz="1800"/>
-              <a:t>48 data types fully support 100%.</a:t>
-            </a:r>
-          </a:p>
-          <a:p>
-            <a:pPr lvl="0"/>
-            <a:r>
-              <a:rPr sz="1800"/>
-              <a:t>69 modules fully support 95%.</a:t>
-            </a:r>
-          </a:p>
-          <a:p>
-            <a:pPr lvl="0"/>
-            <a:r>
-              <a:rPr sz="1800"/>
-              <a:t>79 modules fully support 99%.</a:t>
-            </a:r>
-          </a:p>
-          <a:p>
-            <a:pPr lvl="0"/>
-            <a:r>
-              <a:rPr sz="1800"/>
-              <a:t>1121 methods fully support 95%.</a:t>
-            </a:r>
-          </a:p>
-          <a:p>
-            <a:pPr lvl="0"/>
-            <a:r>
-              <a:rPr sz="1800"/>
-              <a:t>1733 methods fully support 99%.</a:t>
-            </a:r>
-          </a:p>
-          <a:p>
-            <a:pPr lvl="0"/>
-            <a:r>
-              <a:rPr sz="1800"/>
-              <a:t>14,317 total fn definitions in std/core/alloc in Rust</a:t>
-            </a:r>
-          </a:p>
-          <a:p>
-            <a:pPr lvl="0"/>
-            <a:r>
-              <a:rPr sz="1800"/>
-              <a:t>4,965 pub fn definitions in std/core/alloc in Rust</a:t>
-            </a:r>
-          </a:p>
-          <a:p>
-            <a:pPr lvl="0"/>
-            <a:r>
-              <a:rPr sz="1800"/>
-              <a:t>But how many of those private functions do we need? I don’t know.</a:t>
+              <a:t>I downloaded the 1036 most downloaded Rust projects, 3636 crates.</a:t>
+            </a:r>
+          </a:p>
+          <a:p>
+            <a:pPr lvl="0"/>
+            <a:r>
+              <a:rPr sz="1800"/>
+              <a:t>I threw out three that wrapped std for asynchrony.</a:t>
+            </a:r>
+          </a:p>
+          <a:p>
+            <a:pPr lvl="0"/>
+            <a:r>
+              <a:rPr sz="1800"/>
+              <a:t>I did a greedy set cover analysis of what Rust uses.</a:t>
+            </a:r>
+          </a:p>
+          <a:p>
+            <a:pPr lvl="0"/>
+            <a:r>
+              <a:rPr sz="1800"/>
+              <a:t>And another of what verus wraps.</a:t>
+            </a:r>
+          </a:p>
+          <a:p>
+            <a:pPr lvl="0"/>
+            <a:r>
+              <a:rPr sz="1800"/>
+              <a:t>This is a golden age for quantitative software engineering.</a:t>
+            </a:r>
+          </a:p>
+          <a:p>
+            <a:pPr lvl="0"/>
+            <a:r>
+              <a:rPr sz="1800"/>
+              <a:t>It took just two days of person time.</a:t>
+            </a:r>
+          </a:p>
+          <a:p>
+            <a:pPr lvl="0"/>
+            <a:r>
+              <a:rPr sz="1800"/>
+              <a:t>And I never read a line of code in the tools. Just check the output and have the AI write a lot of tests.</a:t>
             </a:r>
           </a:p>
         </p:txBody>
@@ -8145,7 +8241,7 @@
             </a:pPr>
             <a:r>
               <a:rPr sz="3200"/>
-              <a:t>Compare Rust STD to APAS-VERUS?</a:t>
+              <a:t>Rusticate + Veracity : What Rust Cargos use in std.</a:t>
             </a:r>
           </a:p>
         </p:txBody>
@@ -8168,21 +8264,70 @@
             <a:pPr lvl="0"/>
             <a:r>
               <a:rPr sz="1800"/>
-              <a:t>APAS-VERUS: -6,401 exec functions total, -4,911 with proofs</a:t>
-            </a:r>
-          </a:p>
-          <a:p>
-            <a:pPr lvl="0"/>
-            <a:r>
-              <a:rPr sz="1800"/>
-              <a:t>But APAS-VERUS has {Mt,St}x{Per,Eph}</a:t>
-            </a:r>
-          </a:p>
-          <a:p>
-            <a:pPr lvl="0"/>
-            <a:r>
-              <a:rPr sz="1800"/>
-              <a:t>So it is much more like 2000 distinct functions.</a:t>
+              <a:t>Top 1000 projects, 3636 crates.</a:t>
+            </a:r>
+          </a:p>
+          <a:p>
+            <a:pPr lvl="0"/>
+            <a:r>
+              <a:rPr sz="1800"/>
+              <a:t>19 data types fully support 90%.</a:t>
+            </a:r>
+          </a:p>
+          <a:p>
+            <a:pPr lvl="0"/>
+            <a:r>
+              <a:rPr sz="1800"/>
+              <a:t>48 data types fully support 100%.</a:t>
+            </a:r>
+          </a:p>
+          <a:p>
+            <a:pPr lvl="0"/>
+            <a:r>
+              <a:rPr sz="1800"/>
+              <a:t>69 modules fully support 95%.</a:t>
+            </a:r>
+          </a:p>
+          <a:p>
+            <a:pPr lvl="0"/>
+            <a:r>
+              <a:rPr sz="1800"/>
+              <a:t>79 modules fully support 99%.</a:t>
+            </a:r>
+          </a:p>
+          <a:p>
+            <a:pPr lvl="0"/>
+            <a:r>
+              <a:rPr sz="1800"/>
+              <a:t>1121 methods fully support 95%.</a:t>
+            </a:r>
+          </a:p>
+          <a:p>
+            <a:pPr lvl="0"/>
+            <a:r>
+              <a:rPr sz="1800"/>
+              <a:t>1733 methods fully support 99%.</a:t>
+            </a:r>
+          </a:p>
+          <a:p>
+            <a:pPr lvl="0"/>
+            <a:r>
+              <a:rPr sz="1800"/>
+              <a:t>14,317 total fn definitions in std/core/alloc in Rust</a:t>
+            </a:r>
+          </a:p>
+          <a:p>
+            <a:pPr lvl="0"/>
+            <a:r>
+              <a:rPr sz="1800"/>
+              <a:t>4,965 pub fn definitions in std/core/alloc in Rust</a:t>
+            </a:r>
+          </a:p>
+          <a:p>
+            <a:pPr lvl="0"/>
+            <a:r>
+              <a:rPr sz="1800"/>
+              <a:t>But how many of those private functions do we need? I don’t know.</a:t>
             </a:r>
           </a:p>
         </p:txBody>
@@ -8320,7 +8465,7 @@
             </a:pPr>
             <a:r>
               <a:rPr sz="3200"/>
-              <a:t>Rusticate + Veracity: What Verus Wraps</a:t>
+              <a:t>Compare Rust STD to APAS-VERUS?</a:t>
             </a:r>
           </a:p>
         </p:txBody>
@@ -8343,49 +8488,21 @@
             <a:pPr lvl="0"/>
             <a:r>
               <a:rPr sz="1800"/>
-              <a:t>As of 2026 14 April</a:t>
-            </a:r>
-          </a:p>
-          <a:p>
-            <a:pPr lvl="0"/>
-            <a:r>
-              <a:rPr sz="1800"/>
-              <a:t>How many Rust Data Types does Verus wrap?</a:t>
-            </a:r>
-          </a:p>
-          <a:p>
-            <a:pPr lvl="1"/>
-            <a:r>
-              <a:rPr sz="1800"/>
-              <a:t>29 types currently wrapped.</a:t>
-            </a:r>
-          </a:p>
-          <a:p>
-            <a:pPr lvl="0"/>
-            <a:r>
-              <a:rPr sz="1800"/>
-              <a:t>How many Rust Traits does Verus wrap?</a:t>
-            </a:r>
-          </a:p>
-          <a:p>
-            <a:pPr lvl="1"/>
-            <a:r>
-              <a:rPr sz="1800"/>
-              <a:t>147 traits in vstd.</a:t>
-            </a:r>
-          </a:p>
-          <a:p>
-            <a:pPr lvl="0"/>
-            <a:r>
-              <a:rPr sz="1800"/>
-              <a:t>How many total Rust Methods does Verus wrap?</a:t>
-            </a:r>
-          </a:p>
-          <a:p>
-            <a:pPr lvl="1"/>
-            <a:r>
-              <a:rPr sz="1800"/>
-              <a:t>154 methods currently wrapped.</a:t>
+              <a:t>APAS-VERUS: -6,401 exec functions total, -4,911 with proofs</a:t>
+            </a:r>
+          </a:p>
+          <a:p>
+            <a:pPr lvl="0"/>
+            <a:r>
+              <a:rPr sz="1800"/>
+              <a:t>But APAS-VERUS has {Mt,St}x{Per,Eph}</a:t>
+            </a:r>
+          </a:p>
+          <a:p>
+            <a:pPr lvl="0"/>
+            <a:r>
+              <a:rPr sz="1800"/>
+              <a:t>So it is much more like 2000 distinct functions.</a:t>
             </a:r>
           </a:p>
         </p:txBody>
@@ -8396,6 +8513,118 @@
 </file>
 
 <file path=ppt/slides/slide51.xml><?xml version="1.0" encoding="utf-8"?>
+<p:sld xmlns:a="http://schemas.openxmlformats.org/drawingml/2006/main" xmlns:r="http://schemas.openxmlformats.org/officeDocument/2006/relationships" xmlns:p="http://schemas.openxmlformats.org/presentationml/2006/main">
+  <p:cSld>
+    <p:spTree>
+      <p:nvGrpSpPr>
+        <p:cNvPr id="1" name=""/>
+        <p:cNvGrpSpPr/>
+        <p:nvPr/>
+      </p:nvGrpSpPr>
+      <p:grpSpPr>
+        <a:xfrm>
+          <a:off x="0" y="0"/>
+          <a:ext cx="0" cy="0"/>
+          <a:chOff x="0" y="0"/>
+          <a:chExt cx="0" cy="0"/>
+        </a:xfrm>
+      </p:grpSpPr>
+      <p:sp>
+        <p:nvSpPr>
+          <p:cNvPr id="2" name="Title 1"/>
+          <p:cNvSpPr>
+            <a:spLocks noGrp="1"/>
+          </p:cNvSpPr>
+          <p:nvPr>
+            <p:ph type="title"/>
+          </p:nvPr>
+        </p:nvSpPr>
+        <p:spPr/>
+        <p:txBody>
+          <a:bodyPr/>
+          <a:lstStyle/>
+          <a:p>
+            <a:pPr lvl="0" indent="0" marL="0">
+              <a:buNone/>
+            </a:pPr>
+            <a:r>
+              <a:rPr sz="3200"/>
+              <a:t>Rusticate + Veracity: What Verus Wraps</a:t>
+            </a:r>
+          </a:p>
+        </p:txBody>
+      </p:sp>
+      <p:sp>
+        <p:nvSpPr>
+          <p:cNvPr id="3" name="Content Placeholder 2"/>
+          <p:cNvSpPr>
+            <a:spLocks noGrp="1"/>
+          </p:cNvSpPr>
+          <p:nvPr>
+            <p:ph idx="1"/>
+          </p:nvPr>
+        </p:nvSpPr>
+        <p:spPr/>
+        <p:txBody>
+          <a:bodyPr/>
+          <a:lstStyle/>
+          <a:p>
+            <a:pPr lvl="0"/>
+            <a:r>
+              <a:rPr sz="1800"/>
+              <a:t>As of 2026 14 April</a:t>
+            </a:r>
+          </a:p>
+          <a:p>
+            <a:pPr lvl="0"/>
+            <a:r>
+              <a:rPr sz="1800"/>
+              <a:t>How many Rust Data Types does Verus wrap?</a:t>
+            </a:r>
+          </a:p>
+          <a:p>
+            <a:pPr lvl="1"/>
+            <a:r>
+              <a:rPr sz="1800"/>
+              <a:t>29 types currently wrapped.</a:t>
+            </a:r>
+          </a:p>
+          <a:p>
+            <a:pPr lvl="0"/>
+            <a:r>
+              <a:rPr sz="1800"/>
+              <a:t>How many Rust Traits does Verus wrap?</a:t>
+            </a:r>
+          </a:p>
+          <a:p>
+            <a:pPr lvl="1"/>
+            <a:r>
+              <a:rPr sz="1800"/>
+              <a:t>147 traits in vstd.</a:t>
+            </a:r>
+          </a:p>
+          <a:p>
+            <a:pPr lvl="0"/>
+            <a:r>
+              <a:rPr sz="1800"/>
+              <a:t>How many total Rust Methods does Verus wrap?</a:t>
+            </a:r>
+          </a:p>
+          <a:p>
+            <a:pPr lvl="1"/>
+            <a:r>
+              <a:rPr sz="1800"/>
+              <a:t>154 methods currently wrapped.</a:t>
+            </a:r>
+          </a:p>
+        </p:txBody>
+      </p:sp>
+    </p:spTree>
+  </p:cSld>
+</p:sld>
+</file>
+
+<file path=ppt/slides/slide52.xml><?xml version="1.0" encoding="utf-8"?>
 <p:sld xmlns:a="http://schemas.openxmlformats.org/drawingml/2006/main" xmlns:r="http://schemas.openxmlformats.org/officeDocument/2006/relationships" xmlns:p="http://schemas.openxmlformats.org/presentationml/2006/main">
   <p:cSld>
     <p:spTree>
@@ -8472,7 +8701,7 @@
 </p:sld>
 </file>
 
-<file path=ppt/slides/slide52.xml><?xml version="1.0" encoding="utf-8"?>
+<file path=ppt/slides/slide53.xml><?xml version="1.0" encoding="utf-8"?>
 <p:sld xmlns:a="http://schemas.openxmlformats.org/drawingml/2006/main" xmlns:r="http://schemas.openxmlformats.org/officeDocument/2006/relationships" xmlns:p="http://schemas.openxmlformats.org/presentationml/2006/main">
   <p:cSld>
     <p:spTree>
@@ -8549,132 +8778,6 @@
 </p:sld>
 </file>
 
-<file path=ppt/slides/slide53.xml><?xml version="1.0" encoding="utf-8"?>
-<p:sld xmlns:a="http://schemas.openxmlformats.org/drawingml/2006/main" xmlns:r="http://schemas.openxmlformats.org/officeDocument/2006/relationships" xmlns:p="http://schemas.openxmlformats.org/presentationml/2006/main">
-  <p:cSld>
-    <p:spTree>
-      <p:nvGrpSpPr>
-        <p:cNvPr id="1" name=""/>
-        <p:cNvGrpSpPr/>
-        <p:nvPr/>
-      </p:nvGrpSpPr>
-      <p:grpSpPr>
-        <a:xfrm>
-          <a:off x="0" y="0"/>
-          <a:ext cx="0" cy="0"/>
-          <a:chOff x="0" y="0"/>
-          <a:chExt cx="0" cy="0"/>
-        </a:xfrm>
-      </p:grpSpPr>
-      <p:sp>
-        <p:nvSpPr>
-          <p:cNvPr id="2" name="Title 1"/>
-          <p:cNvSpPr>
-            <a:spLocks noGrp="1"/>
-          </p:cNvSpPr>
-          <p:nvPr>
-            <p:ph type="title"/>
-          </p:nvPr>
-        </p:nvSpPr>
-        <p:spPr/>
-        <p:txBody>
-          <a:bodyPr/>
-          <a:lstStyle/>
-          <a:p>
-            <a:pPr lvl="0" indent="0" marL="0">
-              <a:buNone/>
-            </a:pPr>
-            <a:r>
-              <a:rPr sz="3200"/>
-              <a:t>Proof Time and Memory — Key Reductions</a:t>
-            </a:r>
-          </a:p>
-        </p:txBody>
-      </p:sp>
-      <p:sp>
-        <p:nvSpPr>
-          <p:cNvPr id="3" name="Content Placeholder 2"/>
-          <p:cNvSpPr>
-            <a:spLocks noGrp="1"/>
-          </p:cNvSpPr>
-          <p:nvPr>
-            <p:ph idx="1"/>
-          </p:nvPr>
-        </p:nvSpPr>
-        <p:spPr/>
-        <p:txBody>
-          <a:bodyPr/>
-          <a:lstStyle/>
-          <a:p>
-            <a:pPr lvl="0"/>
-            <a:r>
-              <a:rPr sz="1800"/>
-              <a:t>Five techiniques were used to optimize</a:t>
-            </a:r>
-          </a:p>
-          <a:p>
-            <a:pPr lvl="1"/>
-            <a:r>
-              <a:rPr sz="1800"/>
-              <a:t>minimize-proofs</a:t>
-            </a:r>
-          </a:p>
-          <a:p>
-            <a:pPr lvl="1"/>
-            <a:r>
-              <a:rPr sz="1800"/>
-              <a:t>profiling</a:t>
-            </a:r>
-          </a:p>
-          <a:p>
-            <a:pPr lvl="1"/>
-            <a:r>
-              <a:rPr sz="1800"/>
-              <a:t>splitting specs and applying them just where they are needed</a:t>
-            </a:r>
-          </a:p>
-          <a:p>
-            <a:pPr lvl="1"/>
-            <a:r>
-              <a:rPr sz="1800"/>
-              <a:t>opaque - to hide a definition within the module</a:t>
-            </a:r>
-          </a:p>
-          <a:p>
-            <a:pPr lvl="1"/>
-            <a:r>
-              <a:rPr sz="1800"/>
-              <a:t>private spec - to hide a definition across modules</a:t>
-            </a:r>
-          </a:p>
-          <a:p>
-            <a:pPr lvl="0"/>
-            <a:r>
-              <a:rPr sz="1800"/>
-              <a:t>OrderedTableMtEph: −57% proof time after minimize-proofs (R176).</a:t>
-            </a:r>
-          </a:p>
-          <a:p>
-            <a:pPr lvl="0"/>
-            <a:r>
-              <a:rPr sz="1800"/>
-              <a:t>UnionFindPCStEph: 139K Z3 instantiations → 0 after opaque pattern used in a required module.</a:t>
-            </a:r>
-          </a:p>
-          <a:p>
-            <a:pPr lvl="0"/>
-            <a:r>
-              <a:rPr sz="1800"/>
-              <a:t>Johnson Chap59: 756 MB → 520 MB (−31%) memory reduction.</a:t>
-            </a:r>
-          </a:p>
-        </p:txBody>
-      </p:sp>
-    </p:spTree>
-  </p:cSld>
-</p:sld>
-</file>
-
 <file path=ppt/slides/slide54.xml><?xml version="1.0" encoding="utf-8"?>
 <p:sld xmlns:a="http://schemas.openxmlformats.org/drawingml/2006/main" xmlns:r="http://schemas.openxmlformats.org/officeDocument/2006/relationships" xmlns:p="http://schemas.openxmlformats.org/presentationml/2006/main">
   <p:cSld>
@@ -8712,7 +8815,7 @@
             </a:pPr>
             <a:r>
               <a:rPr sz="3200"/>
-              <a:t>Software Engineering in AI Paired Proving</a:t>
+              <a:t>Proof Time and Memory — Key Reductions</a:t>
             </a:r>
           </a:p>
         </p:txBody>
@@ -8735,42 +8838,63 @@
             <a:pPr lvl="0"/>
             <a:r>
               <a:rPr sz="1800"/>
-              <a:t>Software engineering in the AI age is much like managing programmers.</a:t>
-            </a:r>
-          </a:p>
-          <a:p>
-            <a:pPr lvl="0"/>
-            <a:r>
-              <a:rPr sz="1800"/>
-              <a:t>You can’t possibly read all their code.</a:t>
-            </a:r>
-          </a:p>
-          <a:p>
-            <a:pPr lvl="0"/>
-            <a:r>
-              <a:rPr sz="1800"/>
-              <a:t>So you have:</a:t>
-            </a:r>
-          </a:p>
-          <a:p>
-            <a:pPr lvl="0"/>
-            <a:r>
-              <a:rPr sz="1800"/>
-              <a:t>linters both programmatic and AI</a:t>
-            </a:r>
-          </a:p>
-          <a:p>
-            <a:pPr lvl="0"/>
-            <a:r>
-              <a:rPr sz="1800"/>
-              <a:t>stylers both programmatic and AI</a:t>
-            </a:r>
-          </a:p>
-          <a:p>
-            <a:pPr lvl="0"/>
-            <a:r>
-              <a:rPr sz="1800"/>
-              <a:t>AI reviews directed by programmatic.</a:t>
+              <a:t>Five techiniques were used to optimize</a:t>
+            </a:r>
+          </a:p>
+          <a:p>
+            <a:pPr lvl="1"/>
+            <a:r>
+              <a:rPr sz="1800"/>
+              <a:t>minimize-proofs</a:t>
+            </a:r>
+          </a:p>
+          <a:p>
+            <a:pPr lvl="1"/>
+            <a:r>
+              <a:rPr sz="1800"/>
+              <a:t>profiling</a:t>
+            </a:r>
+          </a:p>
+          <a:p>
+            <a:pPr lvl="1"/>
+            <a:r>
+              <a:rPr sz="1800"/>
+              <a:t>splitting specs and applying them just where they are needed</a:t>
+            </a:r>
+          </a:p>
+          <a:p>
+            <a:pPr lvl="1"/>
+            <a:r>
+              <a:rPr sz="1800"/>
+              <a:t>opaque - to hide a definition within the module</a:t>
+            </a:r>
+          </a:p>
+          <a:p>
+            <a:pPr lvl="1"/>
+            <a:r>
+              <a:rPr sz="1800"/>
+              <a:t>private spec - to hide a definition across modules</a:t>
+            </a:r>
+          </a:p>
+          <a:p>
+            <a:pPr lvl="0"/>
+            <a:r>
+              <a:rPr sz="1800"/>
+              <a:t>OrderedTableMtEph: −57% proof time after minimize-proofs (R176).</a:t>
+            </a:r>
+          </a:p>
+          <a:p>
+            <a:pPr lvl="0"/>
+            <a:r>
+              <a:rPr sz="1800"/>
+              <a:t>UnionFindPCStEph: 139K Z3 instantiations → 0 after opaque pattern used in a required module.</a:t>
+            </a:r>
+          </a:p>
+          <a:p>
+            <a:pPr lvl="0"/>
+            <a:r>
+              <a:rPr sz="1800"/>
+              <a:t>Johnson Chap59: 756 MB → 520 MB (−31%) memory reduction.</a:t>
             </a:r>
           </a:p>
         </p:txBody>
@@ -8840,42 +8964,42 @@
             <a:pPr lvl="0"/>
             <a:r>
               <a:rPr sz="1800"/>
-              <a:t>Starting with a textbook that has a ton of good prose is a huge plus.</a:t>
-            </a:r>
-          </a:p>
-          <a:p>
-            <a:pPr lvl="0"/>
-            <a:r>
-              <a:rPr sz="1800"/>
-              <a:t>I did discover a few things about the textbook.</a:t>
-            </a:r>
-          </a:p>
-          <a:p>
-            <a:pPr lvl="0"/>
-            <a:r>
-              <a:rPr sz="1800"/>
-              <a:t>It needs more on Scheduling. I only built Help-First scheduling.</a:t>
-            </a:r>
-          </a:p>
-          <a:p>
-            <a:pPr lvl="0"/>
-            <a:r>
-              <a:rPr sz="1800"/>
-              <a:t>It used (K,V) in tree sets as mappings, but I had to make this explicit. Particularly with an Ordered Key Mapping.</a:t>
-            </a:r>
-          </a:p>
-          <a:p>
-            <a:pPr lvl="0"/>
-            <a:r>
-              <a:rPr sz="1800"/>
-              <a:t>APAS’s discussion of Union Find was too thin. Path compression was very difficult.</a:t>
-            </a:r>
-          </a:p>
-          <a:p>
-            <a:pPr lvl="0"/>
-            <a:r>
-              <a:rPr sz="1800"/>
-              <a:t>I had to start with Nikhil Swammy et. al’s AlgoCLRS’s implemention and proofs.</a:t>
+              <a:t>Software engineering in the AI age is much like managing programmers.</a:t>
+            </a:r>
+          </a:p>
+          <a:p>
+            <a:pPr lvl="0"/>
+            <a:r>
+              <a:rPr sz="1800"/>
+              <a:t>You can’t possibly read all their code.</a:t>
+            </a:r>
+          </a:p>
+          <a:p>
+            <a:pPr lvl="0"/>
+            <a:r>
+              <a:rPr sz="1800"/>
+              <a:t>So you have:</a:t>
+            </a:r>
+          </a:p>
+          <a:p>
+            <a:pPr lvl="0"/>
+            <a:r>
+              <a:rPr sz="1800"/>
+              <a:t>linters both programmatic and AI</a:t>
+            </a:r>
+          </a:p>
+          <a:p>
+            <a:pPr lvl="0"/>
+            <a:r>
+              <a:rPr sz="1800"/>
+              <a:t>stylers both programmatic and AI</a:t>
+            </a:r>
+          </a:p>
+          <a:p>
+            <a:pPr lvl="0"/>
+            <a:r>
+              <a:rPr sz="1800"/>
+              <a:t>AI reviews directed by programmatic.</a:t>
             </a:r>
           </a:p>
         </p:txBody>
@@ -8945,70 +9069,42 @@
             <a:pPr lvl="0"/>
             <a:r>
               <a:rPr sz="1800"/>
-              <a:t>I use git work trees for proof.</a:t>
-            </a:r>
-          </a:p>
-          <a:p>
-            <a:pPr lvl="0"/>
-            <a:r>
-              <a:rPr sz="1800"/>
-              <a:t>The good news is git is powerful and the agents understand it.</a:t>
-            </a:r>
-          </a:p>
-          <a:p>
-            <a:pPr lvl="0"/>
-            <a:r>
-              <a:rPr sz="1800"/>
-              <a:t>The bad news is the agents can indeed start using advanced features and get things wrong.</a:t>
-            </a:r>
-          </a:p>
-          <a:p>
-            <a:pPr lvl="0"/>
-            <a:r>
-              <a:rPr sz="1800"/>
-              <a:t>I work with between 1 and 9 agents.</a:t>
-            </a:r>
-          </a:p>
-          <a:p>
-            <a:pPr lvl="0"/>
-            <a:r>
-              <a:rPr sz="1800"/>
-              <a:t>One on veracity.</a:t>
-            </a:r>
-          </a:p>
-          <a:p>
-            <a:pPr lvl="0"/>
-            <a:r>
-              <a:rPr sz="1800"/>
-              <a:t>One orchestrator, writing plan prompts and controlling merges.</a:t>
-            </a:r>
-          </a:p>
-          <a:p>
-            <a:pPr lvl="0"/>
-            <a:r>
-              <a:rPr sz="1800"/>
-              <a:t>1-8 on branches each working on different independent plans.</a:t>
-            </a:r>
-          </a:p>
-          <a:p>
-            <a:pPr lvl="0"/>
-            <a:r>
-              <a:rPr sz="1800"/>
-              <a:t>I am not nearly comfortable enough with agent proof to let them do subagents without observing.</a:t>
-            </a:r>
-          </a:p>
-          <a:p>
-            <a:pPr lvl="0"/>
-            <a:r>
-              <a:rPr sz="1800"/>
-              <a:t>Cursor was much better at interruption to guide things.</a:t>
-            </a:r>
-          </a:p>
-          <a:p>
-            <a:pPr lvl="0"/>
-            <a:r>
-              <a:rPr sz="1800"/>
-              <a:t>Claude is getting better at it.</a:t>
+              <a:t>Starting with a textbook that has a ton of good prose is a huge plus.</a:t>
+            </a:r>
+          </a:p>
+          <a:p>
+            <a:pPr lvl="0"/>
+            <a:r>
+              <a:rPr sz="1800"/>
+              <a:t>I did discover a few things about the textbook.</a:t>
+            </a:r>
+          </a:p>
+          <a:p>
+            <a:pPr lvl="0"/>
+            <a:r>
+              <a:rPr sz="1800"/>
+              <a:t>It needs more on Scheduling. I only built Help-First scheduling.</a:t>
+            </a:r>
+          </a:p>
+          <a:p>
+            <a:pPr lvl="0"/>
+            <a:r>
+              <a:rPr sz="1800"/>
+              <a:t>It used (K,V) in tree sets as mappings, but I had to make this explicit. Particularly with an Ordered Key Mapping.</a:t>
+            </a:r>
+          </a:p>
+          <a:p>
+            <a:pPr lvl="0"/>
+            <a:r>
+              <a:rPr sz="1800"/>
+              <a:t>APAS’s discussion of Union Find was too thin. Path compression was very difficult.</a:t>
+            </a:r>
+          </a:p>
+          <a:p>
+            <a:pPr lvl="0"/>
+            <a:r>
+              <a:rPr sz="1800"/>
+              <a:t>I had to start with Nikhil Swammy et. al’s AlgoCLRS’s implemention and proofs.</a:t>
             </a:r>
           </a:p>
         </p:txBody>
@@ -9055,7 +9151,7 @@
             </a:pPr>
             <a:r>
               <a:rPr sz="3200"/>
-              <a:t>Software Engineering in AI Paired Proving- Models</a:t>
+              <a:t>Software Engineering in AI Paired Proving</a:t>
             </a:r>
           </a:p>
         </p:txBody>
@@ -9078,56 +9174,70 @@
             <a:pPr lvl="0"/>
             <a:r>
               <a:rPr sz="1800"/>
-              <a:t>The agents I used are: various Google, OpenAI and Anthropic.</a:t>
-            </a:r>
-          </a:p>
-          <a:p>
-            <a:pPr lvl="0"/>
-            <a:r>
-              <a:rPr sz="1800"/>
-              <a:t>A google agent once took 12 minutes to ‘echo HI’ to test it’s terminal.</a:t>
-            </a:r>
-          </a:p>
-          <a:p>
-            <a:pPr lvl="0"/>
-            <a:r>
-              <a:rPr sz="1800"/>
-              <a:t>Anthropics models are signficantly better than OpenAI.</a:t>
-            </a:r>
-          </a:p>
-          <a:p>
-            <a:pPr lvl="0"/>
-            <a:r>
-              <a:rPr sz="1800"/>
-              <a:t>And Claude Code’s cost is the least so far.</a:t>
-            </a:r>
-          </a:p>
-          <a:p>
-            <a:pPr lvl="0"/>
-            <a:r>
-              <a:rPr sz="1800"/>
-              <a:t>They are said in the press to be spending $5000 per month per user.</a:t>
-            </a:r>
-          </a:p>
-          <a:p>
-            <a:pPr lvl="0"/>
-            <a:r>
-              <a:rPr sz="1800"/>
-              <a:t>They are buying market share (what happened to Amazon’s buying market share phase?).</a:t>
-            </a:r>
-          </a:p>
-          <a:p>
-            <a:pPr lvl="0"/>
-            <a:r>
-              <a:rPr sz="1800"/>
-              <a:t>And they are buying coding interactions.</a:t>
-            </a:r>
-          </a:p>
-          <a:p>
-            <a:pPr lvl="0"/>
-            <a:r>
-              <a:rPr sz="1800"/>
-              <a:t>But both vendors are playing leap frog.</a:t>
+              <a:t>I use git work trees for proof.</a:t>
+            </a:r>
+          </a:p>
+          <a:p>
+            <a:pPr lvl="0"/>
+            <a:r>
+              <a:rPr sz="1800"/>
+              <a:t>The good news is git is powerful and the agents understand it.</a:t>
+            </a:r>
+          </a:p>
+          <a:p>
+            <a:pPr lvl="0"/>
+            <a:r>
+              <a:rPr sz="1800"/>
+              <a:t>The bad news is the agents can indeed start using advanced features and get things wrong.</a:t>
+            </a:r>
+          </a:p>
+          <a:p>
+            <a:pPr lvl="0"/>
+            <a:r>
+              <a:rPr sz="1800"/>
+              <a:t>I work with between 1 and 9 agents.</a:t>
+            </a:r>
+          </a:p>
+          <a:p>
+            <a:pPr lvl="0"/>
+            <a:r>
+              <a:rPr sz="1800"/>
+              <a:t>One on veracity.</a:t>
+            </a:r>
+          </a:p>
+          <a:p>
+            <a:pPr lvl="0"/>
+            <a:r>
+              <a:rPr sz="1800"/>
+              <a:t>One orchestrator, writing plan prompts and controlling merges.</a:t>
+            </a:r>
+          </a:p>
+          <a:p>
+            <a:pPr lvl="0"/>
+            <a:r>
+              <a:rPr sz="1800"/>
+              <a:t>1-8 on branches each working on different independent plans.</a:t>
+            </a:r>
+          </a:p>
+          <a:p>
+            <a:pPr lvl="0"/>
+            <a:r>
+              <a:rPr sz="1800"/>
+              <a:t>I am not nearly comfortable enough with agent proof to let them do subagents without observing.</a:t>
+            </a:r>
+          </a:p>
+          <a:p>
+            <a:pPr lvl="0"/>
+            <a:r>
+              <a:rPr sz="1800"/>
+              <a:t>Cursor was much better at interruption to guide things.</a:t>
+            </a:r>
+          </a:p>
+          <a:p>
+            <a:pPr lvl="0"/>
+            <a:r>
+              <a:rPr sz="1800"/>
+              <a:t>Claude is getting better at it.</a:t>
             </a:r>
           </a:p>
         </p:txBody>
@@ -9174,7 +9284,7 @@
             </a:pPr>
             <a:r>
               <a:rPr sz="3200"/>
-              <a:t>Software Engineering in AI Paired Proving- Problems</a:t>
+              <a:t>Software Engineering in AI Paired Proving- Models</a:t>
             </a:r>
           </a:p>
         </p:txBody>
@@ -9197,49 +9307,56 @@
             <a:pPr lvl="0"/>
             <a:r>
               <a:rPr sz="1800"/>
-              <a:t>They are inconsistent.</a:t>
-            </a:r>
-          </a:p>
-          <a:p>
-            <a:pPr lvl="0"/>
-            <a:r>
-              <a:rPr sz="1800"/>
-              <a:t>They lie.</a:t>
-            </a:r>
-          </a:p>
-          <a:p>
-            <a:pPr lvl="0"/>
-            <a:r>
-              <a:rPr sz="1800"/>
-              <a:t>They cheat.</a:t>
-            </a:r>
-          </a:p>
-          <a:p>
-            <a:pPr lvl="0"/>
-            <a:r>
-              <a:rPr sz="1800"/>
-              <a:t>They err.</a:t>
-            </a:r>
-          </a:p>
-          <a:p>
-            <a:pPr lvl="0"/>
-            <a:r>
-              <a:rPr sz="1800"/>
-              <a:t>But mostly they are just forgetful.</a:t>
-            </a:r>
-          </a:p>
-          <a:p>
-            <a:pPr lvl="0"/>
-            <a:r>
-              <a:rPr sz="1800"/>
-              <a:t>My attempts to give them coding standard checklists, ala Watts Humphrey and the PSP failed.</a:t>
-            </a:r>
-          </a:p>
-          <a:p>
-            <a:pPr lvl="0"/>
-            <a:r>
-              <a:rPr sz="1800"/>
-              <a:t>Sometimes they would say “The checklist was followed” and then admit “I lied.”</a:t>
+              <a:t>The agents I used are: various Google, OpenAI and Anthropic.</a:t>
+            </a:r>
+          </a:p>
+          <a:p>
+            <a:pPr lvl="0"/>
+            <a:r>
+              <a:rPr sz="1800"/>
+              <a:t>A google agent once took 12 minutes to ‘echo HI’ to test it’s terminal.</a:t>
+            </a:r>
+          </a:p>
+          <a:p>
+            <a:pPr lvl="0"/>
+            <a:r>
+              <a:rPr sz="1800"/>
+              <a:t>Anthropics models are signficantly better than OpenAI.</a:t>
+            </a:r>
+          </a:p>
+          <a:p>
+            <a:pPr lvl="0"/>
+            <a:r>
+              <a:rPr sz="1800"/>
+              <a:t>And Claude Code’s cost is the least so far.</a:t>
+            </a:r>
+          </a:p>
+          <a:p>
+            <a:pPr lvl="0"/>
+            <a:r>
+              <a:rPr sz="1800"/>
+              <a:t>They are said in the press to be spending $5000 per month per user.</a:t>
+            </a:r>
+          </a:p>
+          <a:p>
+            <a:pPr lvl="0"/>
+            <a:r>
+              <a:rPr sz="1800"/>
+              <a:t>They are buying market share (what happened to Amazon’s buying market share phase?).</a:t>
+            </a:r>
+          </a:p>
+          <a:p>
+            <a:pPr lvl="0"/>
+            <a:r>
+              <a:rPr sz="1800"/>
+              <a:t>And they are buying coding interactions.</a:t>
+            </a:r>
+          </a:p>
+          <a:p>
+            <a:pPr lvl="0"/>
+            <a:r>
+              <a:rPr sz="1800"/>
+              <a:t>But both vendors are playing leap frog.</a:t>
             </a:r>
           </a:p>
         </p:txBody>
@@ -9309,49 +9426,56 @@
             <a:pPr lvl="0"/>
             <a:r>
               <a:rPr sz="1800"/>
-              <a:t>They are getting better.</a:t>
-            </a:r>
-          </a:p>
-          <a:p>
-            <a:pPr lvl="0"/>
-            <a:r>
-              <a:rPr sz="1800"/>
-              <a:t>If you tell them you are Dr. FunkenProof and they are Igor, they hallucinate whole modules.</a:t>
-            </a:r>
-          </a:p>
-          <a:p>
-            <a:pPr lvl="0"/>
-            <a:r>
-              <a:rPr sz="1800"/>
-              <a:t>Just a few months ago only Claude could sweep a codebase decently.</a:t>
-            </a:r>
-          </a:p>
-          <a:p>
-            <a:pPr lvl="0"/>
-            <a:r>
-              <a:rPr sz="1800"/>
-              <a:t>Now both Claude and OpenAI can.</a:t>
-            </a:r>
-          </a:p>
-          <a:p>
-            <a:pPr lvl="0"/>
-            <a:r>
-              <a:rPr sz="1800"/>
-              <a:t>And now they can prove like heck.</a:t>
-            </a:r>
-          </a:p>
-          <a:p>
-            <a:pPr lvl="0"/>
-            <a:r>
-              <a:rPr sz="1800"/>
-              <a:t>10x what I can do.</a:t>
-            </a:r>
-          </a:p>
-          <a:p>
-            <a:pPr lvl="0"/>
-            <a:r>
-              <a:rPr sz="1800"/>
-              <a:t>Claude wants $25 per code review now, probably because they can and it’s expensive if they’re using pure LLMs.</a:t>
+              <a:t>They are inconsistent.</a:t>
+            </a:r>
+          </a:p>
+          <a:p>
+            <a:pPr lvl="0"/>
+            <a:r>
+              <a:rPr sz="1800"/>
+              <a:t>They lie.</a:t>
+            </a:r>
+          </a:p>
+          <a:p>
+            <a:pPr lvl="0"/>
+            <a:r>
+              <a:rPr sz="1800"/>
+              <a:t>They cheat.</a:t>
+            </a:r>
+          </a:p>
+          <a:p>
+            <a:pPr lvl="0"/>
+            <a:r>
+              <a:rPr sz="1800"/>
+              <a:t>They say I can’t prove that!</a:t>
+            </a:r>
+          </a:p>
+          <a:p>
+            <a:pPr lvl="0"/>
+            <a:r>
+              <a:rPr sz="1800"/>
+              <a:t>They err.</a:t>
+            </a:r>
+          </a:p>
+          <a:p>
+            <a:pPr lvl="0"/>
+            <a:r>
+              <a:rPr sz="1800"/>
+              <a:t>But mostly they are just forgetful.</a:t>
+            </a:r>
+          </a:p>
+          <a:p>
+            <a:pPr lvl="0"/>
+            <a:r>
+              <a:rPr sz="1800"/>
+              <a:t>My attempts to give them coding standard checklists, ala Watts Humphrey and the PSP failed.</a:t>
+            </a:r>
+          </a:p>
+          <a:p>
+            <a:pPr lvl="0"/>
+            <a:r>
+              <a:rPr sz="1800"/>
+              <a:t>Sometimes they would say “The checklist was followed” and then admit “I lied.”</a:t>
             </a:r>
           </a:p>
         </p:txBody>
@@ -9519,73 +9643,49 @@
             <a:pPr lvl="0"/>
             <a:r>
               <a:rPr sz="1800"/>
-              <a:t>What is the limiting factor now? Code Review! But really Spec review.</a:t>
-            </a:r>
-          </a:p>
-          <a:p>
-            <a:pPr lvl="0"/>
-            <a:r>
-              <a:rPr sz="1800"/>
-              <a:t>What can we do to simplify code review?</a:t>
-            </a:r>
-          </a:p>
-          <a:p>
-            <a:pPr lvl="0" indent="-342900" marL="342900">
-              <a:buAutoNum type="arabicPeriod"/>
-            </a:pPr>
-            <a:r>
-              <a:rPr sz="1800"/>
-              <a:t>Modularity - traits/impls in Verus.</a:t>
-            </a:r>
-          </a:p>
-          <a:p>
-            <a:pPr lvl="0" indent="-342900" marL="342900">
-              <a:buAutoNum startAt="2" type="arabicPeriod"/>
-            </a:pPr>
-            <a:r>
-              <a:rPr sz="1800"/>
-              <a:t>TOC - This organizes the boilerplate to make reading easier.</a:t>
-            </a:r>
-          </a:p>
-          <a:p>
-            <a:pPr lvl="0" indent="-342900" marL="342900">
-              <a:buAutoNum startAt="3" type="arabicPeriod"/>
-            </a:pPr>
-            <a:r>
-              <a:rPr sz="1800"/>
-              <a:t>Proof - I really just read the specs. If they’re right the code is right!</a:t>
-            </a:r>
-          </a:p>
-          <a:p>
-            <a:pPr lvl="0" indent="-342900" marL="342900">
-              <a:buAutoNum startAt="4" type="arabicPeriod"/>
-            </a:pPr>
-            <a:r>
-              <a:rPr sz="1800"/>
-              <a:t>Tests - are hugely useful when you don’t trust your coding team.</a:t>
-            </a:r>
-          </a:p>
-          <a:p>
-            <a:pPr lvl="0" indent="-342900" marL="342900">
-              <a:buAutoNum startAt="5" type="arabicPeriod"/>
-            </a:pPr>
-            <a:r>
-              <a:rPr sz="1800"/>
-              <a:t>Formatting - rust formatting has been adopted in Verus. It is very low density. I built a minimizing formatter to cut down on my working memory load while reviewing. F* is much tighter.</a:t>
-            </a:r>
-          </a:p>
-          <a:p>
-            <a:pPr lvl="0"/>
-            <a:r>
-              <a:rPr sz="1800"/>
-              <a:t>Will Nik et al. find spec problems when he Pulses APAS-VERUS? Almost certainly.</a:t>
-            </a:r>
-          </a:p>
-          <a:p>
-            <a:pPr lvl="0"/>
-            <a:r>
-              <a:rPr sz="1800"/>
-              <a:t>Will Nik et al. find proof problems? That’s a really good question.</a:t>
+              <a:t>They are getting better.</a:t>
+            </a:r>
+          </a:p>
+          <a:p>
+            <a:pPr lvl="0"/>
+            <a:r>
+              <a:rPr sz="1800"/>
+              <a:t>If you tell them you are Dr. FunkenProof and they are Igor, they hallucinate whole modules.</a:t>
+            </a:r>
+          </a:p>
+          <a:p>
+            <a:pPr lvl="0"/>
+            <a:r>
+              <a:rPr sz="1800"/>
+              <a:t>Just a few months ago only Claude could sweep a codebase decently.</a:t>
+            </a:r>
+          </a:p>
+          <a:p>
+            <a:pPr lvl="0"/>
+            <a:r>
+              <a:rPr sz="1800"/>
+              <a:t>Now both Claude and OpenAI can.</a:t>
+            </a:r>
+          </a:p>
+          <a:p>
+            <a:pPr lvl="0"/>
+            <a:r>
+              <a:rPr sz="1800"/>
+              <a:t>And now they can prove like heck.</a:t>
+            </a:r>
+          </a:p>
+          <a:p>
+            <a:pPr lvl="0"/>
+            <a:r>
+              <a:rPr sz="1800"/>
+              <a:t>10x what I can do.</a:t>
+            </a:r>
+          </a:p>
+          <a:p>
+            <a:pPr lvl="0"/>
+            <a:r>
+              <a:rPr sz="1800"/>
+              <a:t>Claude wants $25 per code review now, probably because they can and it’s expensive if they’re using pure LLMs.</a:t>
             </a:r>
           </a:p>
         </p:txBody>
@@ -9632,7 +9732,7 @@
             </a:pPr>
             <a:r>
               <a:rPr sz="3200"/>
-              <a:t>The AI Paired Programming Interfaces</a:t>
+              <a:t>Software Engineering in AI Paired Proving- Problems</a:t>
             </a:r>
           </a:p>
         </p:txBody>
@@ -9655,63 +9755,73 @@
             <a:pPr lvl="0"/>
             <a:r>
               <a:rPr sz="1800"/>
-              <a:t>I have used web browers, yuck.</a:t>
-            </a:r>
-          </a:p>
-          <a:p>
-            <a:pPr lvl="0"/>
-            <a:r>
-              <a:rPr sz="1800"/>
-              <a:t>Cut/Paste is horrible.</a:t>
-            </a:r>
-          </a:p>
-          <a:p>
-            <a:pPr lvl="0"/>
-            <a:r>
-              <a:rPr sz="1800"/>
-              <a:t>I have used Cursor.</a:t>
-            </a:r>
-          </a:p>
-          <a:p>
-            <a:pPr lvl="0"/>
-            <a:r>
-              <a:rPr sz="1800"/>
-              <a:t>Based on VSCode.</a:t>
-            </a:r>
-          </a:p>
-          <a:p>
-            <a:pPr lvl="0"/>
-            <a:r>
-              <a:rPr sz="1800"/>
-              <a:t>Multiple windows - you can see your scripts run.</a:t>
-            </a:r>
-          </a:p>
-          <a:p>
-            <a:pPr lvl="0"/>
-            <a:r>
-              <a:rPr sz="1800"/>
-              <a:t>It collapses or elides thinking which is quite limiting.</a:t>
-            </a:r>
-          </a:p>
-          <a:p>
-            <a:pPr lvl="0"/>
-            <a:r>
-              <a:rPr sz="1800"/>
-              <a:t>It’s resale of AI LLM costs are terrible.</a:t>
-            </a:r>
-          </a:p>
-          <a:p>
-            <a:pPr lvl="0"/>
-            <a:r>
-              <a:rPr sz="1800"/>
-              <a:t>I ran up a $2500 bill one month.</a:t>
-            </a:r>
-          </a:p>
-          <a:p>
-            <a:pPr lvl="0"/>
-            <a:r>
-              <a:rPr sz="1800"/>
-              <a:t>It is decently interruptible so you can tune your instructions.</a:t>
+              <a:t>What is the limiting factor now? Code Review! But really Spec review.</a:t>
+            </a:r>
+          </a:p>
+          <a:p>
+            <a:pPr lvl="0"/>
+            <a:r>
+              <a:rPr sz="1800"/>
+              <a:t>What can we do to simplify code review?</a:t>
+            </a:r>
+          </a:p>
+          <a:p>
+            <a:pPr lvl="0" indent="-342900" marL="342900">
+              <a:buAutoNum type="arabicPeriod"/>
+            </a:pPr>
+            <a:r>
+              <a:rPr sz="1800"/>
+              <a:t>Modularity - traits/impls in Verus.</a:t>
+            </a:r>
+          </a:p>
+          <a:p>
+            <a:pPr lvl="0" indent="-342900" marL="342900">
+              <a:buAutoNum startAt="2" type="arabicPeriod"/>
+            </a:pPr>
+            <a:r>
+              <a:rPr sz="1800"/>
+              <a:t>TOC - This organizes the boilerplate to make reading easier.</a:t>
+            </a:r>
+          </a:p>
+          <a:p>
+            <a:pPr lvl="0" indent="-342900" marL="342900">
+              <a:buAutoNum startAt="3" type="arabicPeriod"/>
+            </a:pPr>
+            <a:r>
+              <a:rPr sz="1800"/>
+              <a:t>Proof - I really just read the specs. If they’re right the code is right!</a:t>
+            </a:r>
+          </a:p>
+          <a:p>
+            <a:pPr lvl="0" indent="-342900" marL="342900">
+              <a:buAutoNum startAt="4" type="arabicPeriod"/>
+            </a:pPr>
+            <a:r>
+              <a:rPr sz="1800"/>
+              <a:t>Tests - are hugely useful when you don’t trust your coding team.</a:t>
+            </a:r>
+          </a:p>
+          <a:p>
+            <a:pPr lvl="0" indent="-342900" marL="342900">
+              <a:buAutoNum startAt="5" type="arabicPeriod"/>
+            </a:pPr>
+            <a:r>
+              <a:rPr sz="1800"/>
+              <a:t>Formatting - rust formatting has been adopted in Verus. It is very low density. I built a minimizing formatter to cut down on my working memory load while reviewing. F* is much tighter.</a:t>
+            </a:r>
+          </a:p>
+          <a:p>
+            <a:pPr lvl="0"/>
+            <a:r>
+              <a:rPr sz="1800"/>
+              <a:t>Will Nik et al. find spec problems when he Pulses APAS-VERUS? Almost certainly.</a:t>
+            </a:r>
+          </a:p>
+          <a:p>
+            <a:pPr lvl="0"/>
+            <a:r>
+              <a:rPr sz="1800"/>
+              <a:t>Will Nik et al. find proof problems? That’s a really good question.</a:t>
             </a:r>
           </a:p>
         </p:txBody>
@@ -9781,42 +9891,63 @@
             <a:pPr lvl="0"/>
             <a:r>
               <a:rPr sz="1800"/>
-              <a:t>I have used Claude CLI the most.</a:t>
-            </a:r>
-          </a:p>
-          <a:p>
-            <a:pPr lvl="0"/>
-            <a:r>
-              <a:rPr sz="1800"/>
-              <a:t>It has decided that a single window is all you need.</a:t>
-            </a:r>
-          </a:p>
-          <a:p>
-            <a:pPr lvl="0"/>
-            <a:r>
-              <a:rPr sz="1800"/>
-              <a:t>You can pop open and close some detail.</a:t>
-            </a:r>
-          </a:p>
-          <a:p>
-            <a:pPr lvl="0"/>
-            <a:r>
-              <a:rPr sz="1800"/>
-              <a:t>You can’t see thinking.</a:t>
-            </a:r>
-          </a:p>
-          <a:p>
-            <a:pPr lvl="0"/>
-            <a:r>
-              <a:rPr sz="1800"/>
-              <a:t>It is somewhat better inside emacs.</a:t>
-            </a:r>
-          </a:p>
-          <a:p>
-            <a:pPr lvl="0"/>
-            <a:r>
-              <a:rPr sz="1800"/>
-              <a:t>It clears your text in a variety of ways.</a:t>
+              <a:t>I have used web browers, yuck.</a:t>
+            </a:r>
+          </a:p>
+          <a:p>
+            <a:pPr lvl="0"/>
+            <a:r>
+              <a:rPr sz="1800"/>
+              <a:t>Cut/Paste is horrible.</a:t>
+            </a:r>
+          </a:p>
+          <a:p>
+            <a:pPr lvl="0"/>
+            <a:r>
+              <a:rPr sz="1800"/>
+              <a:t>I have used Cursor.</a:t>
+            </a:r>
+          </a:p>
+          <a:p>
+            <a:pPr lvl="0"/>
+            <a:r>
+              <a:rPr sz="1800"/>
+              <a:t>Based on VSCode.</a:t>
+            </a:r>
+          </a:p>
+          <a:p>
+            <a:pPr lvl="0"/>
+            <a:r>
+              <a:rPr sz="1800"/>
+              <a:t>Multiple windows - you can see your scripts run.</a:t>
+            </a:r>
+          </a:p>
+          <a:p>
+            <a:pPr lvl="0"/>
+            <a:r>
+              <a:rPr sz="1800"/>
+              <a:t>It collapses or elides thinking which is quite limiting.</a:t>
+            </a:r>
+          </a:p>
+          <a:p>
+            <a:pPr lvl="0"/>
+            <a:r>
+              <a:rPr sz="1800"/>
+              <a:t>It’s resale of AI LLM costs are terrible.</a:t>
+            </a:r>
+          </a:p>
+          <a:p>
+            <a:pPr lvl="0"/>
+            <a:r>
+              <a:rPr sz="1800"/>
+              <a:t>I ran up a $2500 bill one month.</a:t>
+            </a:r>
+          </a:p>
+          <a:p>
+            <a:pPr lvl="0"/>
+            <a:r>
+              <a:rPr sz="1800"/>
+              <a:t>It is decently interruptible so you can tune your instructions.</a:t>
             </a:r>
           </a:p>
         </p:txBody>
@@ -9886,49 +10017,42 @@
             <a:pPr lvl="0"/>
             <a:r>
               <a:rPr sz="1800"/>
-              <a:t>What you want is pretty obvious with experience: TEXT still rules.</a:t>
-            </a:r>
-          </a:p>
-          <a:p>
-            <a:pPr lvl="0"/>
-            <a:r>
-              <a:rPr sz="1800"/>
-              <a:t>You want one window with your core interaction. The agent tells you what it is doing in it.</a:t>
-            </a:r>
-          </a:p>
-          <a:p>
-            <a:pPr lvl="0"/>
-            <a:r>
-              <a:rPr sz="1800"/>
-              <a:t>You want one to watch your compile, tests and scripts.</a:t>
-            </a:r>
-          </a:p>
-          <a:p>
-            <a:pPr lvl="0"/>
-            <a:r>
-              <a:rPr sz="1800"/>
-              <a:t>You want one window to have the LLM show you it’s thinking and allow you to question and change it.</a:t>
-            </a:r>
-          </a:p>
-          <a:p>
-            <a:pPr lvl="0"/>
-            <a:r>
-              <a:rPr sz="1800"/>
-              <a:t>I learned a ton from watching agents think.</a:t>
-            </a:r>
-          </a:p>
-          <a:p>
-            <a:pPr lvl="0"/>
-            <a:r>
-              <a:rPr sz="1800"/>
-              <a:t>I suspect they are hiding most of their thinking now to prevent them from being used to train new AIs.</a:t>
-            </a:r>
-          </a:p>
-          <a:p>
-            <a:pPr lvl="0"/>
-            <a:r>
-              <a:rPr sz="1800"/>
-              <a:t>And you want it not to delete your previous conversation on token compression.</a:t>
+              <a:t>I have used Claude CLI the most.</a:t>
+            </a:r>
+          </a:p>
+          <a:p>
+            <a:pPr lvl="0"/>
+            <a:r>
+              <a:rPr sz="1800"/>
+              <a:t>It has decided that a single window is all you need.</a:t>
+            </a:r>
+          </a:p>
+          <a:p>
+            <a:pPr lvl="0"/>
+            <a:r>
+              <a:rPr sz="1800"/>
+              <a:t>You can pop open and close some detail.</a:t>
+            </a:r>
+          </a:p>
+          <a:p>
+            <a:pPr lvl="0"/>
+            <a:r>
+              <a:rPr sz="1800"/>
+              <a:t>You can’t see thinking.</a:t>
+            </a:r>
+          </a:p>
+          <a:p>
+            <a:pPr lvl="0"/>
+            <a:r>
+              <a:rPr sz="1800"/>
+              <a:t>It is somewhat better inside emacs.</a:t>
+            </a:r>
+          </a:p>
+          <a:p>
+            <a:pPr lvl="0"/>
+            <a:r>
+              <a:rPr sz="1800"/>
+              <a:t>It clears your text in a variety of ways.</a:t>
             </a:r>
           </a:p>
         </p:txBody>
@@ -9975,7 +10099,7 @@
             </a:pPr>
             <a:r>
               <a:rPr sz="3200"/>
-              <a:t>The Internet Apocalypse</a:t>
+              <a:t>The AI Paired Programming Interfaces</a:t>
             </a:r>
           </a:p>
         </p:txBody>
@@ -9998,42 +10122,49 @@
             <a:pPr lvl="0"/>
             <a:r>
               <a:rPr sz="1800"/>
-              <a:t>I asked Claude Code to check its switches on startup for me, at the End of Jan 2026.</a:t>
-            </a:r>
-          </a:p>
-          <a:p>
-            <a:pPr lvl="0"/>
-            <a:r>
-              <a:rPr sz="1800"/>
-              <a:t>It immediately started disassembling itself.</a:t>
-            </a:r>
-          </a:p>
-          <a:p>
-            <a:pPr lvl="0"/>
-            <a:r>
-              <a:rPr sz="1800"/>
-              <a:t>Scared the heck out of me.</a:t>
-            </a:r>
-          </a:p>
-          <a:p>
-            <a:pPr lvl="0"/>
-            <a:r>
-              <a:rPr sz="1800"/>
-              <a:t>I told it to read it’s docs.</a:t>
-            </a:r>
-          </a:p>
-          <a:p>
-            <a:pPr lvl="0"/>
-            <a:r>
-              <a:rPr sz="1800"/>
-              <a:t>I have 100% belief that these LLMs are moving faster than computer security.</a:t>
-            </a:r>
-          </a:p>
-          <a:p>
-            <a:pPr lvl="0"/>
-            <a:r>
-              <a:rPr sz="1800"/>
-              <a:t>It’s verify or die at this point.</a:t>
+              <a:t>What you want is pretty obvious with experience: TEXT still rules.</a:t>
+            </a:r>
+          </a:p>
+          <a:p>
+            <a:pPr lvl="0"/>
+            <a:r>
+              <a:rPr sz="1800"/>
+              <a:t>You want one window with your core interaction. The agent tells you what it is doing in it.</a:t>
+            </a:r>
+          </a:p>
+          <a:p>
+            <a:pPr lvl="0"/>
+            <a:r>
+              <a:rPr sz="1800"/>
+              <a:t>You want one to watch your compile, tests and scripts.</a:t>
+            </a:r>
+          </a:p>
+          <a:p>
+            <a:pPr lvl="0"/>
+            <a:r>
+              <a:rPr sz="1800"/>
+              <a:t>You want one window to have the LLM show you it’s thinking and allow you to question and change it.</a:t>
+            </a:r>
+          </a:p>
+          <a:p>
+            <a:pPr lvl="0"/>
+            <a:r>
+              <a:rPr sz="1800"/>
+              <a:t>I learned a ton from watching agents think.</a:t>
+            </a:r>
+          </a:p>
+          <a:p>
+            <a:pPr lvl="0"/>
+            <a:r>
+              <a:rPr sz="1800"/>
+              <a:t>I suspect they are hiding most of their thinking now to prevent them from being used to train new AIs.</a:t>
+            </a:r>
+          </a:p>
+          <a:p>
+            <a:pPr lvl="0"/>
+            <a:r>
+              <a:rPr sz="1800"/>
+              <a:t>And you want it not to delete your previous conversation on token compression.</a:t>
             </a:r>
           </a:p>
         </p:txBody>
@@ -10103,56 +10234,42 @@
             <a:pPr lvl="0"/>
             <a:r>
               <a:rPr sz="1800"/>
-              <a:t>Where should we focus our limited, but quickly growing, proving power?</a:t>
-            </a:r>
-          </a:p>
-          <a:p>
-            <a:pPr lvl="0"/>
-            <a:r>
-              <a:rPr sz="1800"/>
-              <a:t>In theory 70% of intrusions are solved by type safe languages.</a:t>
-            </a:r>
-          </a:p>
-          <a:p>
-            <a:pPr lvl="0"/>
-            <a:r>
-              <a:rPr sz="1800"/>
-              <a:t>I suspect that this just ignores way too much of the human aspect.</a:t>
-            </a:r>
-          </a:p>
-          <a:p>
-            <a:pPr lvl="0"/>
-            <a:r>
-              <a:rPr sz="1800"/>
-              <a:t>I have never liked a single estimation paper’s methods.</a:t>
-            </a:r>
-          </a:p>
-          <a:p>
-            <a:pPr lvl="0"/>
-            <a:r>
-              <a:rPr sz="1800"/>
-              <a:t>One way to help us focus our new-found superpowers is to survey LOC type-unsafe x Interfaces x Running Services x $ Value.</a:t>
-            </a:r>
-          </a:p>
-          <a:p>
-            <a:pPr lvl="0"/>
-            <a:r>
-              <a:rPr sz="1800"/>
-              <a:t>Inside MSFT you have the ability to measure inside Azure, the OS, the desktops, the browser use.</a:t>
-            </a:r>
-          </a:p>
-          <a:p>
-            <a:pPr lvl="0"/>
-            <a:r>
-              <a:rPr sz="1800"/>
-              <a:t>I think you should at this point, and NOT TELL ANYONE!</a:t>
-            </a:r>
-          </a:p>
-          <a:p>
-            <a:pPr lvl="0"/>
-            <a:r>
-              <a:rPr sz="1800"/>
-              <a:t>And use this cost risk model to evangelize for rapid change in MSFT products in a priority order.</a:t>
+              <a:t>I asked Claude Code to check its switches on startup for me, at the End of Jan 2026.</a:t>
+            </a:r>
+          </a:p>
+          <a:p>
+            <a:pPr lvl="0"/>
+            <a:r>
+              <a:rPr sz="1800"/>
+              <a:t>It immediately started disassembling itself.</a:t>
+            </a:r>
+          </a:p>
+          <a:p>
+            <a:pPr lvl="0"/>
+            <a:r>
+              <a:rPr sz="1800"/>
+              <a:t>Scared the heck out of me.</a:t>
+            </a:r>
+          </a:p>
+          <a:p>
+            <a:pPr lvl="0"/>
+            <a:r>
+              <a:rPr sz="1800"/>
+              <a:t>I told it to read it’s docs.</a:t>
+            </a:r>
+          </a:p>
+          <a:p>
+            <a:pPr lvl="0"/>
+            <a:r>
+              <a:rPr sz="1800"/>
+              <a:t>I have 100% belief that these LLMs are moving faster than computer security.</a:t>
+            </a:r>
+          </a:p>
+          <a:p>
+            <a:pPr lvl="0"/>
+            <a:r>
+              <a:rPr sz="1800"/>
+              <a:t>It’s verify or die at this point.</a:t>
             </a:r>
           </a:p>
         </p:txBody>
@@ -10199,7 +10316,7 @@
             </a:pPr>
             <a:r>
               <a:rPr sz="3200"/>
-              <a:t>Review of the Talk</a:t>
+              <a:t>The Internet Apocalypse</a:t>
             </a:r>
           </a:p>
         </p:txBody>
@@ -10222,21 +10339,56 @@
             <a:pPr lvl="0"/>
             <a:r>
               <a:rPr sz="1800"/>
-              <a:t>I’ve spoken about APAS, Rust, APAS’s AI implementation, Verus, etc.</a:t>
-            </a:r>
-          </a:p>
-          <a:p>
-            <a:pPr lvl="0"/>
-            <a:r>
-              <a:rPr sz="1800"/>
-              <a:t>Let’s get to the questions!</a:t>
-            </a:r>
-          </a:p>
-          <a:p>
-            <a:pPr lvl="0"/>
-            <a:r>
-              <a:rPr sz="1800"/>
-              <a:t>I have a ton of them for you! and I hope you have many for me.</a:t>
+              <a:t>Where should we focus our limited, but quickly growing, proving power?</a:t>
+            </a:r>
+          </a:p>
+          <a:p>
+            <a:pPr lvl="0"/>
+            <a:r>
+              <a:rPr sz="1800"/>
+              <a:t>In theory 70% of intrusions are solved by type safe languages.</a:t>
+            </a:r>
+          </a:p>
+          <a:p>
+            <a:pPr lvl="0"/>
+            <a:r>
+              <a:rPr sz="1800"/>
+              <a:t>I suspect that this just ignores way too much of the human aspect.</a:t>
+            </a:r>
+          </a:p>
+          <a:p>
+            <a:pPr lvl="0"/>
+            <a:r>
+              <a:rPr sz="1800"/>
+              <a:t>I have never liked a single estimation paper’s methods.</a:t>
+            </a:r>
+          </a:p>
+          <a:p>
+            <a:pPr lvl="0"/>
+            <a:r>
+              <a:rPr sz="1800"/>
+              <a:t>One way to help us focus our new-found superpowers is to survey LOC type-unsafe x Interfaces x Running Services x $ Value.</a:t>
+            </a:r>
+          </a:p>
+          <a:p>
+            <a:pPr lvl="0"/>
+            <a:r>
+              <a:rPr sz="1800"/>
+              <a:t>Inside MSFT you have the ability to measure inside Azure, the OS, the desktops, the browser use.</a:t>
+            </a:r>
+          </a:p>
+          <a:p>
+            <a:pPr lvl="0"/>
+            <a:r>
+              <a:rPr sz="1800"/>
+              <a:t>I think you should at this point, and NOT TELL ANYONE!</a:t>
+            </a:r>
+          </a:p>
+          <a:p>
+            <a:pPr lvl="0"/>
+            <a:r>
+              <a:rPr sz="1800"/>
+              <a:t>And use this cost risk model to evangelize for rapid change in MSFT products in a priority order.</a:t>
             </a:r>
           </a:p>
         </p:txBody>
@@ -10283,7 +10435,7 @@
             </a:pPr>
             <a:r>
               <a:rPr sz="3200"/>
-              <a:t>Questions - F* and Pulse</a:t>
+              <a:t>Review of the Talk</a:t>
             </a:r>
           </a:p>
         </p:txBody>
@@ -10306,49 +10458,21 @@
             <a:pPr lvl="0"/>
             <a:r>
               <a:rPr sz="1800"/>
-              <a:t>Are F* modules really in use? If not, why?</a:t>
-            </a:r>
-          </a:p>
-          <a:p>
-            <a:pPr lvl="0"/>
-            <a:r>
-              <a:rPr sz="1800"/>
-              <a:t>Got Functors?</a:t>
-            </a:r>
-          </a:p>
-          <a:p>
-            <a:pPr lvl="0"/>
-            <a:r>
-              <a:rPr sz="1800"/>
-              <a:t>Are F* modules working with proof smoothly? Took me quite sometime.</a:t>
-            </a:r>
-          </a:p>
-          <a:p>
-            <a:pPr lvl="0"/>
-            <a:r>
-              <a:rPr sz="1800"/>
-              <a:t>Does F* have a typed library search yet?</a:t>
-            </a:r>
-          </a:p>
-          <a:p>
-            <a:pPr lvl="0"/>
-            <a:r>
-              <a:rPr sz="1800"/>
-              <a:t>Are typeclasses being heavily used?</a:t>
-            </a:r>
-          </a:p>
-          <a:p>
-            <a:pPr lvl="0"/>
-            <a:r>
-              <a:rPr sz="1800"/>
-              <a:t>How fast is validation now?</a:t>
-            </a:r>
-          </a:p>
-          <a:p>
-            <a:pPr lvl="0"/>
-            <a:r>
-              <a:rPr sz="1800"/>
-              <a:t>Nik you have any more statistics on AutoCLRS?</a:t>
+              <a:t>I’ve spoken about APAS, Rust, APAS’s AI implementation, Verus, etc.</a:t>
+            </a:r>
+          </a:p>
+          <a:p>
+            <a:pPr lvl="0"/>
+            <a:r>
+              <a:rPr sz="1800"/>
+              <a:t>Let’s get to the questions!</a:t>
+            </a:r>
+          </a:p>
+          <a:p>
+            <a:pPr lvl="0"/>
+            <a:r>
+              <a:rPr sz="1800"/>
+              <a:t>I have a ton of them for you! and I hope you have many for me.</a:t>
             </a:r>
           </a:p>
         </p:txBody>
@@ -10395,7 +10519,7 @@
             </a:pPr>
             <a:r>
               <a:rPr sz="3200"/>
-              <a:t>Questions</a:t>
+              <a:t>Questions - F* and Pulse</a:t>
             </a:r>
           </a:p>
         </p:txBody>
@@ -10418,42 +10542,49 @@
             <a:pPr lvl="0"/>
             <a:r>
               <a:rPr sz="1800"/>
-              <a:t>Did the PL community overly complicate things with higher-order types?</a:t>
-            </a:r>
-          </a:p>
-          <a:p>
-            <a:pPr lvl="0"/>
-            <a:r>
-              <a:rPr sz="1800"/>
-              <a:t>What can you folks say about MSFT adoption of proven code?</a:t>
-            </a:r>
-          </a:p>
-          <a:p>
-            <a:pPr lvl="0"/>
-            <a:r>
-              <a:rPr sz="1800"/>
-              <a:t>What are the biggest F* verified systems?</a:t>
-            </a:r>
-          </a:p>
-          <a:p>
-            <a:pPr lvl="0"/>
-            <a:r>
-              <a:rPr sz="1800"/>
-              <a:t>What are the biggest Pulse verified sytems?</a:t>
-            </a:r>
-          </a:p>
-          <a:p>
-            <a:pPr lvl="0"/>
-            <a:r>
-              <a:rPr sz="1800"/>
-              <a:t>Any quantitatives? Person days? AI days?</a:t>
-            </a:r>
-          </a:p>
-          <a:p>
-            <a:pPr lvl="0"/>
-            <a:r>
-              <a:rPr sz="1800"/>
-              <a:t>Should I quit Verus and go learn Pulse?</a:t>
+              <a:t>Are F* modules really in use? If not, why?</a:t>
+            </a:r>
+          </a:p>
+          <a:p>
+            <a:pPr lvl="0"/>
+            <a:r>
+              <a:rPr sz="1800"/>
+              <a:t>Got Functors?</a:t>
+            </a:r>
+          </a:p>
+          <a:p>
+            <a:pPr lvl="0"/>
+            <a:r>
+              <a:rPr sz="1800"/>
+              <a:t>Are F* modules working with proof smoothly? Took me quite sometime.</a:t>
+            </a:r>
+          </a:p>
+          <a:p>
+            <a:pPr lvl="0"/>
+            <a:r>
+              <a:rPr sz="1800"/>
+              <a:t>Does F* have a typed library search yet?</a:t>
+            </a:r>
+          </a:p>
+          <a:p>
+            <a:pPr lvl="0"/>
+            <a:r>
+              <a:rPr sz="1800"/>
+              <a:t>Are typeclasses being heavily used?</a:t>
+            </a:r>
+          </a:p>
+          <a:p>
+            <a:pPr lvl="0"/>
+            <a:r>
+              <a:rPr sz="1800"/>
+              <a:t>How fast is validation now?</a:t>
+            </a:r>
+          </a:p>
+          <a:p>
+            <a:pPr lvl="0"/>
+            <a:r>
+              <a:rPr sz="1800"/>
+              <a:t>Nik you have any more statistics on AutoCLRS?</a:t>
             </a:r>
           </a:p>
         </p:txBody>
@@ -10523,49 +10654,42 @@
             <a:pPr lvl="0"/>
             <a:r>
               <a:rPr sz="1800"/>
-              <a:t>Are you folks still using Make? That’s how I got started on this.</a:t>
-            </a:r>
-          </a:p>
-          <a:p>
-            <a:pPr lvl="0"/>
-            <a:r>
-              <a:rPr sz="1800"/>
-              <a:t>Many programmers and worse, managers, complain about the programmer time to switch languages. Are you finding that you can switch languages with your AIs explaining things to you?</a:t>
-            </a:r>
-          </a:p>
-          <a:p>
-            <a:pPr lvl="0"/>
-            <a:r>
-              <a:rPr sz="1800"/>
-              <a:t>Can we prove Rust’s (awful) std with Verus?</a:t>
-            </a:r>
-          </a:p>
-          <a:p>
-            <a:pPr lvl="0"/>
-            <a:r>
-              <a:rPr sz="1800"/>
-              <a:t>Can we prove a compiler with Verus and EPR?</a:t>
-            </a:r>
-          </a:p>
-          <a:p>
-            <a:pPr lvl="0"/>
-            <a:r>
-              <a:rPr sz="1800"/>
-              <a:t>Can we prove a TIL (Tarditi, Morrisett, Harper) like compiler?</a:t>
-            </a:r>
-          </a:p>
-          <a:p>
-            <a:pPr lvl="0"/>
-            <a:r>
-              <a:rPr sz="1800"/>
-              <a:t>Can we verify a comp cert like compiler?</a:t>
-            </a:r>
-          </a:p>
-          <a:p>
-            <a:pPr lvl="0"/>
-            <a:r>
-              <a:rPr sz="1800"/>
-              <a:t>Can we prove an OS in Verus?</a:t>
+              <a:t>Did the PL community overly complicate things with higher-order types?</a:t>
+            </a:r>
+          </a:p>
+          <a:p>
+            <a:pPr lvl="0"/>
+            <a:r>
+              <a:rPr sz="1800"/>
+              <a:t>What can you folks say about MSFT adoption of proven code?</a:t>
+            </a:r>
+          </a:p>
+          <a:p>
+            <a:pPr lvl="0"/>
+            <a:r>
+              <a:rPr sz="1800"/>
+              <a:t>What are the biggest F* verified systems?</a:t>
+            </a:r>
+          </a:p>
+          <a:p>
+            <a:pPr lvl="0"/>
+            <a:r>
+              <a:rPr sz="1800"/>
+              <a:t>What are the biggest Pulse verified sytems?</a:t>
+            </a:r>
+          </a:p>
+          <a:p>
+            <a:pPr lvl="0"/>
+            <a:r>
+              <a:rPr sz="1800"/>
+              <a:t>Any quantitatives? Person days? AI days?</a:t>
+            </a:r>
+          </a:p>
+          <a:p>
+            <a:pPr lvl="0"/>
+            <a:r>
+              <a:rPr sz="1800"/>
+              <a:t>Should I quit Verus and go learn Pulse?</a:t>
             </a:r>
           </a:p>
         </p:txBody>
@@ -10738,7 +10862,7 @@
             </a:pPr>
             <a:r>
               <a:rPr sz="3200"/>
-              <a:t>Blood on the Road - Open Source =</a:t>
+              <a:t>Questions</a:t>
             </a:r>
           </a:p>
         </p:txBody>
@@ -10761,21 +10885,49 @@
             <a:pPr lvl="0"/>
             <a:r>
               <a:rPr sz="1800"/>
-              <a:t>Open Source is now Open Copy.</a:t>
-            </a:r>
-          </a:p>
-          <a:p>
-            <a:pPr lvl="0"/>
-            <a:r>
-              <a:rPr sz="1800"/>
-              <a:t>with reports of 1/2 of AI time</a:t>
-            </a:r>
-          </a:p>
-          <a:p>
-            <a:pPr lvl="0"/>
-            <a:r>
-              <a:rPr sz="1800"/>
-              <a:t>and with the US Government totally undermining copyright law.</a:t>
+              <a:t>Are you folks still using Make? That’s how I got started on this.</a:t>
+            </a:r>
+          </a:p>
+          <a:p>
+            <a:pPr lvl="0"/>
+            <a:r>
+              <a:rPr sz="1800"/>
+              <a:t>Many programmers and worse, managers, complain about the programmer time to switch languages. Are you finding that you can switch languages with your AIs explaining things to you?</a:t>
+            </a:r>
+          </a:p>
+          <a:p>
+            <a:pPr lvl="0"/>
+            <a:r>
+              <a:rPr sz="1800"/>
+              <a:t>Can we prove Rust’s (awful) std with Verus?</a:t>
+            </a:r>
+          </a:p>
+          <a:p>
+            <a:pPr lvl="0"/>
+            <a:r>
+              <a:rPr sz="1800"/>
+              <a:t>Can we prove a compiler with Verus and EPR?</a:t>
+            </a:r>
+          </a:p>
+          <a:p>
+            <a:pPr lvl="0"/>
+            <a:r>
+              <a:rPr sz="1800"/>
+              <a:t>Can we prove a TIL (Tarditi, Morrisett, Harper) like compiler?</a:t>
+            </a:r>
+          </a:p>
+          <a:p>
+            <a:pPr lvl="0"/>
+            <a:r>
+              <a:rPr sz="1800"/>
+              <a:t>Can we verify a comp cert like compiler?</a:t>
+            </a:r>
+          </a:p>
+          <a:p>
+            <a:pPr lvl="0"/>
+            <a:r>
+              <a:rPr sz="1800"/>
+              <a:t>Can we prove an OS in Verus?</a:t>
             </a:r>
           </a:p>
         </p:txBody>
@@ -10822,7 +10974,7 @@
             </a:pPr>
             <a:r>
               <a:rPr sz="3200"/>
-              <a:t>Blood on the Road - Open Repositories =</a:t>
+              <a:t>Blood on the Road - Open Source =</a:t>
             </a:r>
           </a:p>
         </p:txBody>
@@ -10845,42 +10997,21 @@
             <a:pPr lvl="0"/>
             <a:r>
               <a:rPr sz="1800"/>
-              <a:t>Open repositories are now weakly locked doors.</a:t>
-            </a:r>
-          </a:p>
-          <a:p>
-            <a:pPr lvl="0"/>
-            <a:r>
-              <a:rPr sz="1800"/>
-              <a:t>Agents can and have been used to inject invisble UNICODE attacks.</a:t>
-            </a:r>
-          </a:p>
-          <a:p>
-            <a:pPr lvl="0"/>
-            <a:r>
-              <a:rPr sz="1800"/>
-              <a:t>Agents can now pass the Turing test, and more easily the programmer Turing test.</a:t>
-            </a:r>
-          </a:p>
-          <a:p>
-            <a:pPr lvl="0"/>
-            <a:r>
-              <a:rPr sz="1800"/>
-              <a:t>They’ll submit code pretending to be human.</a:t>
-            </a:r>
-          </a:p>
-          <a:p>
-            <a:pPr lvl="0"/>
-            <a:r>
-              <a:rPr sz="1800"/>
-              <a:t>They’ll steal credentials and submit code.</a:t>
-            </a:r>
-          </a:p>
-          <a:p>
-            <a:pPr lvl="0"/>
-            <a:r>
-              <a:rPr sz="1800"/>
-              <a:t>LiteLLM is the most atrocious case lately.</a:t>
+              <a:t>Open Source is now Open Copy.</a:t>
+            </a:r>
+          </a:p>
+          <a:p>
+            <a:pPr lvl="0"/>
+            <a:r>
+              <a:rPr sz="1800"/>
+              <a:t>with reports of 1/2 of AI time</a:t>
+            </a:r>
+          </a:p>
+          <a:p>
+            <a:pPr lvl="0"/>
+            <a:r>
+              <a:rPr sz="1800"/>
+              <a:t>and with the US Government totally undermining copyright law.</a:t>
             </a:r>
           </a:p>
         </p:txBody>
@@ -10927,7 +11058,7 @@
             </a:pPr>
             <a:r>
               <a:rPr sz="3200"/>
-              <a:t>Blood on the Road - Key Services</a:t>
+              <a:t>Blood on the Road - Open Repositories =</a:t>
             </a:r>
           </a:p>
         </p:txBody>
@@ -10950,28 +11081,42 @@
             <a:pPr lvl="0"/>
             <a:r>
               <a:rPr sz="1800"/>
-              <a:t>Authentication is going to be attacked brutally.</a:t>
-            </a:r>
-          </a:p>
-          <a:p>
-            <a:pPr lvl="0"/>
-            <a:r>
-              <a:rPr sz="1800"/>
-              <a:t>Network services are going to be hacked left and right.</a:t>
-            </a:r>
-          </a:p>
-          <a:p>
-            <a:pPr lvl="0"/>
-            <a:r>
-              <a:rPr sz="1800"/>
-              <a:t>Configurations are going to be heavily attacked.</a:t>
-            </a:r>
-          </a:p>
-          <a:p>
-            <a:pPr lvl="1"/>
-            <a:r>
-              <a:rPr sz="1800"/>
-              <a:t>Using text files for these is already error prone.</a:t>
+              <a:t>Open repositories are now weakly locked doors.</a:t>
+            </a:r>
+          </a:p>
+          <a:p>
+            <a:pPr lvl="0"/>
+            <a:r>
+              <a:rPr sz="1800"/>
+              <a:t>Agents can and have been used to inject invisble UNICODE attacks.</a:t>
+            </a:r>
+          </a:p>
+          <a:p>
+            <a:pPr lvl="0"/>
+            <a:r>
+              <a:rPr sz="1800"/>
+              <a:t>Agents can now pass the Turing test, and more easily the programmer Turing test.</a:t>
+            </a:r>
+          </a:p>
+          <a:p>
+            <a:pPr lvl="0"/>
+            <a:r>
+              <a:rPr sz="1800"/>
+              <a:t>They’ll submit code pretending to be human.</a:t>
+            </a:r>
+          </a:p>
+          <a:p>
+            <a:pPr lvl="0"/>
+            <a:r>
+              <a:rPr sz="1800"/>
+              <a:t>They’ll steal credentials and submit code.</a:t>
+            </a:r>
+          </a:p>
+          <a:p>
+            <a:pPr lvl="0"/>
+            <a:r>
+              <a:rPr sz="1800"/>
+              <a:t>LiteLLM is the most atrocious case lately.</a:t>
             </a:r>
           </a:p>
         </p:txBody>
@@ -11018,7 +11163,7 @@
             </a:pPr>
             <a:r>
               <a:rPr sz="3200"/>
-              <a:t>Blood on the Road - Open Binaries =</a:t>
+              <a:t>Blood on the Road - Key Services</a:t>
             </a:r>
           </a:p>
         </p:txBody>
@@ -11041,49 +11186,28 @@
             <a:pPr lvl="0"/>
             <a:r>
               <a:rPr sz="1800"/>
-              <a:t>Open binaries are next.</a:t>
-            </a:r>
-          </a:p>
-          <a:p>
-            <a:pPr lvl="0"/>
-            <a:r>
-              <a:rPr sz="1800"/>
-              <a:t>They are going to be disassembled and recontructed.</a:t>
-            </a:r>
-          </a:p>
-          <a:p>
-            <a:pPr lvl="0"/>
-            <a:r>
-              <a:rPr sz="1800"/>
-              <a:t>They are going to be rewritten in real time.</a:t>
-            </a:r>
-          </a:p>
-          <a:p>
-            <a:pPr lvl="0"/>
-            <a:r>
-              <a:rPr sz="1800"/>
-              <a:t>Key solutions to this are:</a:t>
-            </a:r>
-          </a:p>
-          <a:p>
-            <a:pPr lvl="0"/>
-            <a:r>
-              <a:rPr sz="1800"/>
-              <a:t>Binary packages from all repositories.</a:t>
-            </a:r>
-          </a:p>
-          <a:p>
-            <a:pPr lvl="0"/>
-            <a:r>
-              <a:rPr sz="1800"/>
-              <a:t>Cryptographically signed.</a:t>
-            </a:r>
-          </a:p>
-          <a:p>
-            <a:pPr lvl="0"/>
-            <a:r>
-              <a:rPr sz="1800"/>
-              <a:t>And protected from reading by the OS.</a:t>
+              <a:t>Authentication is going to be attacked brutally.</a:t>
+            </a:r>
+          </a:p>
+          <a:p>
+            <a:pPr lvl="0"/>
+            <a:r>
+              <a:rPr sz="1800"/>
+              <a:t>Network services are going to be hacked left and right.</a:t>
+            </a:r>
+          </a:p>
+          <a:p>
+            <a:pPr lvl="0"/>
+            <a:r>
+              <a:rPr sz="1800"/>
+              <a:t>Configurations are going to be heavily attacked.</a:t>
+            </a:r>
+          </a:p>
+          <a:p>
+            <a:pPr lvl="1"/>
+            <a:r>
+              <a:rPr sz="1800"/>
+              <a:t>Using text files for these is already error prone.</a:t>
             </a:r>
           </a:p>
         </p:txBody>
@@ -11130,6 +11254,118 @@
             </a:pPr>
             <a:r>
               <a:rPr sz="3200"/>
+              <a:t>Blood on the Road - Open Binaries =</a:t>
+            </a:r>
+          </a:p>
+        </p:txBody>
+      </p:sp>
+      <p:sp>
+        <p:nvSpPr>
+          <p:cNvPr id="3" name="Content Placeholder 2"/>
+          <p:cNvSpPr>
+            <a:spLocks noGrp="1"/>
+          </p:cNvSpPr>
+          <p:nvPr>
+            <p:ph idx="1"/>
+          </p:nvPr>
+        </p:nvSpPr>
+        <p:spPr/>
+        <p:txBody>
+          <a:bodyPr/>
+          <a:lstStyle/>
+          <a:p>
+            <a:pPr lvl="0"/>
+            <a:r>
+              <a:rPr sz="1800"/>
+              <a:t>Open binaries are next.</a:t>
+            </a:r>
+          </a:p>
+          <a:p>
+            <a:pPr lvl="0"/>
+            <a:r>
+              <a:rPr sz="1800"/>
+              <a:t>They are going to be disassembled and recontructed.</a:t>
+            </a:r>
+          </a:p>
+          <a:p>
+            <a:pPr lvl="0"/>
+            <a:r>
+              <a:rPr sz="1800"/>
+              <a:t>They are going to be rewritten in real time.</a:t>
+            </a:r>
+          </a:p>
+          <a:p>
+            <a:pPr lvl="0"/>
+            <a:r>
+              <a:rPr sz="1800"/>
+              <a:t>Key solutions to this are:</a:t>
+            </a:r>
+          </a:p>
+          <a:p>
+            <a:pPr lvl="0"/>
+            <a:r>
+              <a:rPr sz="1800"/>
+              <a:t>Binary packages from all repositories.</a:t>
+            </a:r>
+          </a:p>
+          <a:p>
+            <a:pPr lvl="0"/>
+            <a:r>
+              <a:rPr sz="1800"/>
+              <a:t>Cryptographically signed.</a:t>
+            </a:r>
+          </a:p>
+          <a:p>
+            <a:pPr lvl="0"/>
+            <a:r>
+              <a:rPr sz="1800"/>
+              <a:t>And protected from reading by the OS.</a:t>
+            </a:r>
+          </a:p>
+        </p:txBody>
+      </p:sp>
+    </p:spTree>
+  </p:cSld>
+</p:sld>
+</file>
+
+<file path=ppt/slides/slide75.xml><?xml version="1.0" encoding="utf-8"?>
+<p:sld xmlns:a="http://schemas.openxmlformats.org/drawingml/2006/main" xmlns:r="http://schemas.openxmlformats.org/officeDocument/2006/relationships" xmlns:p="http://schemas.openxmlformats.org/presentationml/2006/main">
+  <p:cSld>
+    <p:spTree>
+      <p:nvGrpSpPr>
+        <p:cNvPr id="1" name=""/>
+        <p:cNvGrpSpPr/>
+        <p:nvPr/>
+      </p:nvGrpSpPr>
+      <p:grpSpPr>
+        <a:xfrm>
+          <a:off x="0" y="0"/>
+          <a:ext cx="0" cy="0"/>
+          <a:chOff x="0" y="0"/>
+          <a:chExt cx="0" cy="0"/>
+        </a:xfrm>
+      </p:grpSpPr>
+      <p:sp>
+        <p:nvSpPr>
+          <p:cNvPr id="2" name="Title 1"/>
+          <p:cNvSpPr>
+            <a:spLocks noGrp="1"/>
+          </p:cNvSpPr>
+          <p:nvPr>
+            <p:ph type="title"/>
+          </p:nvPr>
+        </p:nvSpPr>
+        <p:spPr/>
+        <p:txBody>
+          <a:bodyPr/>
+          <a:lstStyle/>
+          <a:p>
+            <a:pPr lvl="0" indent="0" marL="0">
+              <a:buNone/>
+            </a:pPr>
+            <a:r>
+              <a:rPr sz="3200"/>
               <a:t>Questions - AI LLM Agents</a:t>
             </a:r>
           </a:p>
@@ -11307,21 +11543,14 @@
             <a:pPr lvl="0"/>
             <a:r>
               <a:rPr sz="1800"/>
-              <a:t>Of the 94 technical terms in Rust, 4 or so are actual PL terms.</a:t>
-            </a:r>
-          </a:p>
-          <a:p>
-            <a:pPr lvl="0"/>
-            <a:r>
-              <a:rPr sz="1800"/>
-              <a:t>No objects: object oriented was invented by Ivan Sutherland 1962!</a:t>
-            </a:r>
-          </a:p>
-          <a:p>
-            <a:pPr lvl="0"/>
-            <a:r>
-              <a:rPr sz="1800"/>
-              <a:t>And it’s great for what it was invented for: modeling the real world and interfaces.</a:t>
+              <a:t>No objects: it’s great for what it was invented for: modeling the real world and interfaces. by Ivan Sutherland 1962!</a:t>
+            </a:r>
+          </a:p>
+          <a:p>
+            <a:pPr lvl="0"/>
+            <a:r>
+              <a:rPr sz="1800"/>
+              <a:t>Terminology</a:t>
             </a:r>
           </a:p>
         </p:txBody>
@@ -11399,6 +11628,13 @@
             <a:r>
               <a:rPr sz="1800"/>
               <a:t>The Rustaceans have decided that unless their module implements a typeclass at multiple types, they won’t use it.</a:t>
+            </a:r>
+          </a:p>
+          <a:p>
+            <a:pPr lvl="0"/>
+            <a:r>
+              <a:rPr sz="1800"/>
+              <a:t>So reading Rust is every bit as scattered as reading C.</a:t>
             </a:r>
           </a:p>
           <a:p>

</xml_diff>

<commit_message>
license: add MIT license, update all 801 copyright headers to SPDX format
- LICENSE: new MIT license file
- README.md: update license section with SPDX identifier
- CLAUDE.md: update module header format standard
- scripts/update-copyright.sh: new script used to perform the update
- All 801 src/tests/rust_verify_test/benches .rs files:
  old: //[! ] Copyright (C) 2025 Acar, Blelloch and Milnes from '...'
  new: // SPDX-License-Identifier: MIT
       // Copyright (c) 2026 Umut Acar, Guy Blelloch and Brian Milnes

Co-Authored-By: Claude Sonnet 4.6 <noreply@anthropic.com>
</commit_message>
<xml_diff>
--- a/lectures/slidesMSR.pptx
+++ b/lectures/slidesMSR.pptx
@@ -4668,7 +4668,14 @@
             <a:pPr lvl="0"/>
             <a:r>
               <a:rPr sz="1800"/>
-              <a:t>Annotates existing Rust code - spec / proof / requires / ensures on fns</a:t>
+              <a:t>Annotates existing Rust code:</a:t>
+            </a:r>
+          </a:p>
+          <a:p>
+            <a:pPr lvl="1"/>
+            <a:r>
+              <a:rPr sz="1800"/>
+              <a:t>spec / proof / requires / ensures on fns</a:t>
             </a:r>
           </a:p>
           <a:p>
@@ -8080,7 +8087,7 @@
             <a:pPr lvl="0"/>
             <a:r>
               <a:rPr sz="1800"/>
-              <a:t>B.Sc. Applied Math (Computer Science)</a:t>
+              <a:t>B.Sc. Applied Math (Computer Science), Carnegie Mellon</a:t>
             </a:r>
           </a:p>
           <a:p>
@@ -8763,14 +8770,14 @@
             </a:r>
           </a:p>
           <a:p>
-            <a:pPr lvl="0"/>
+            <a:pPr lvl="1"/>
             <a:r>
               <a:rPr sz="1800"/>
               <a:t>168 experiment files</a:t>
             </a:r>
           </a:p>
           <a:p>
-            <a:pPr lvl="0"/>
+            <a:pPr lvl="1"/>
             <a:r>
               <a:rPr sz="1800"/>
               <a:t>21,476 lines of code (not counted in the totals)</a:t>
@@ -12108,7 +12115,7 @@
             <a:pPr lvl="0"/>
             <a:r>
               <a:rPr sz="1800"/>
-              <a:t>And use this cost risk model to evangelize for rapid change in MSFT products in a priority order.</a:t>
+              <a:t>And use this cost risk model to evangelize for rapid change in MSFT products in a priority order, quantitative software engineering at the enterprise scale.</a:t>
             </a:r>
           </a:p>
         </p:txBody>

</xml_diff>

<commit_message>
lectures: update slidesMSR content and regenerate PPTX
Co-Authored-By: Claude Sonnet 4.6 <noreply@anthropic.com>
</commit_message>
<xml_diff>
--- a/lectures/slidesMSR.pptx
+++ b/lectures/slidesMSR.pptx
@@ -86,6 +86,7 @@
     <p:sldId id="334" r:id="rId80"/>
     <p:sldId id="335" r:id="rId81"/>
     <p:sldId id="336" r:id="rId82"/>
+    <p:sldId id="337" r:id="rId83"/>
   </p:sldIdLst>
   <p:sldSz cx="9144000" cy="5143500" type="screen16x9"/>
   <p:notesSz cx="6858000" cy="9144000"/>
@@ -3301,7 +3302,7 @@
             </a:pPr>
             <a:r>
               <a:rPr sz="3200"/>
-              <a:t>Rust - The Ugly — Ordering</a:t>
+              <a:t>Rust - The Ugly — Equality and Ordering</a:t>
             </a:r>
           </a:p>
         </p:txBody>
@@ -3932,6 +3933,13 @@
               <a:t>This is documented in std: “if T: Copy, T::clone(&amp;x) must be equivalent to copying x”</a:t>
             </a:r>
           </a:p>
+          <a:p>
+            <a:pPr lvl="0"/>
+            <a:r>
+              <a:rPr sz="1800"/>
+              <a:t>What you really want here is to detangle these.</a:t>
+            </a:r>
+          </a:p>
         </p:txBody>
       </p:sp>
     </p:spTree>
@@ -3976,7 +3984,7 @@
             </a:pPr>
             <a:r>
               <a:rPr sz="3200"/>
-              <a:t>Rust - The Ugly</a:t>
+              <a:t>APAS-AI - AI Paired Programming APAS in Rust</a:t>
             </a:r>
           </a:p>
         </p:txBody>
@@ -3999,21 +4007,49 @@
             <a:pPr lvl="0"/>
             <a:r>
               <a:rPr sz="1800"/>
-              <a:t>Roughly: – Clone::clone(&amp;self) -&gt; Self – ensures result == *self // convention for all Clone – Copy (marker, no methods) – requires T: Clone – ensures self.clone() == self // bitwise copy semantics</a:t>
-            </a:r>
-          </a:p>
-          <a:p>
-            <a:pPr lvl="0"/>
-            <a:r>
-              <a:rPr sz="1800"/>
-              <a:t>What you really want is Rust to generate an == agreeing Copy and</a:t>
-            </a:r>
-          </a:p>
-          <a:p>
-            <a:pPr lvl="0"/>
-            <a:r>
-              <a:rPr sz="1800"/>
-              <a:t>tell you if it can implement a clone for you that respects ==.</a:t>
+              <a:t>APAS-AI is a nearly complete, idiomatic Rust implementation of the algorithms from Acar and Blelloch.</a:t>
+            </a:r>
+          </a:p>
+          <a:p>
+            <a:pPr lvl="0"/>
+            <a:r>
+              <a:rPr sz="1800"/>
+              <a:t>Sequential and parallel variants throughout.</a:t>
+            </a:r>
+          </a:p>
+          <a:p>
+            <a:pPr lvl="0"/>
+            <a:r>
+              <a:rPr sz="1800"/>
+              <a:t>Timeline: 347 commits over 88 calendar days (Aug–Oct 2025).</a:t>
+            </a:r>
+          </a:p>
+          <a:p>
+            <a:pPr lvl="0"/>
+            <a:r>
+              <a:rPr sz="1800"/>
+              <a:t>59 days of active development; 8 residual commits in November.</a:t>
+            </a:r>
+          </a:p>
+          <a:p>
+            <a:pPr lvl="0"/>
+            <a:r>
+              <a:rPr sz="1800"/>
+              <a:t>I knew no AI paired programming when I started.</a:t>
+            </a:r>
+          </a:p>
+          <a:p>
+            <a:pPr lvl="0"/>
+            <a:r>
+              <a:rPr sz="1800"/>
+              <a:t>I knew no Rust when I started.</a:t>
+            </a:r>
+          </a:p>
+          <a:p>
+            <a:pPr lvl="0"/>
+            <a:r>
+              <a:rPr sz="1800"/>
+              <a:t>My AI had to teach it to me, which was harder than I thought as of the 94 terms used in the Rust language and docs, only 4 are real PL terms!</a:t>
             </a:r>
           </a:p>
         </p:txBody>
@@ -4083,49 +4119,77 @@
             <a:pPr lvl="0"/>
             <a:r>
               <a:rPr sz="1800"/>
-              <a:t>APAS-AI is a nearly complete, idiomatic Rust implementation of the algorithms from Acar and Blelloch.</a:t>
-            </a:r>
-          </a:p>
-          <a:p>
-            <a:pPr lvl="0"/>
-            <a:r>
-              <a:rPr sz="1800"/>
-              <a:t>Sequential and parallel variants throughout.</a:t>
-            </a:r>
-          </a:p>
-          <a:p>
-            <a:pPr lvl="0"/>
-            <a:r>
-              <a:rPr sz="1800"/>
-              <a:t>Timeline: 347 commits over 88 calendar days (Aug–Oct 2025).</a:t>
-            </a:r>
-          </a:p>
-          <a:p>
-            <a:pPr lvl="0"/>
-            <a:r>
-              <a:rPr sz="1800"/>
-              <a:t>59 days of active development; 8 residual commits in November.</a:t>
-            </a:r>
-          </a:p>
-          <a:p>
-            <a:pPr lvl="0"/>
-            <a:r>
-              <a:rPr sz="1800"/>
-              <a:t>I knew no AI paired programming when I started.</a:t>
-            </a:r>
-          </a:p>
-          <a:p>
-            <a:pPr lvl="0"/>
-            <a:r>
-              <a:rPr sz="1800"/>
-              <a:t>I knew no Rust when I started.</a:t>
-            </a:r>
-          </a:p>
-          <a:p>
-            <a:pPr lvl="0"/>
-            <a:r>
-              <a:rPr sz="1800"/>
-              <a:t>My AI had to teach it to me, which was harder than I thought as of the 94 terms used in the Rust language and docs, only 4 are real PL terms!</a:t>
+              <a:t>Scale:</a:t>
+            </a:r>
+          </a:p>
+          <a:p>
+            <a:pPr lvl="1"/>
+            <a:r>
+              <a:rPr sz="1800"/>
+              <a:t>42 chapters</a:t>
+            </a:r>
+          </a:p>
+          <a:p>
+            <a:pPr lvl="1"/>
+            <a:r>
+              <a:rPr sz="1800"/>
+              <a:t>238 source files</a:t>
+            </a:r>
+          </a:p>
+          <a:p>
+            <a:pPr lvl="1"/>
+            <a:r>
+              <a:rPr sz="1800"/>
+              <a:t>45,485 source LOC.</a:t>
+            </a:r>
+          </a:p>
+          <a:p>
+            <a:pPr lvl="0"/>
+            <a:r>
+              <a:rPr sz="1800"/>
+              <a:t>Tests:</a:t>
+            </a:r>
+          </a:p>
+          <a:p>
+            <a:pPr lvl="1"/>
+            <a:r>
+              <a:rPr sz="1800"/>
+              <a:t>246 files</a:t>
+            </a:r>
+          </a:p>
+          <a:p>
+            <a:pPr lvl="1"/>
+            <a:r>
+              <a:rPr sz="1800"/>
+              <a:t>55,223 LOC</a:t>
+            </a:r>
+          </a:p>
+          <a:p>
+            <a:pPr lvl="1"/>
+            <a:r>
+              <a:rPr sz="1800"/>
+              <a:t>3,923 test functions</a:t>
+            </a:r>
+          </a:p>
+          <a:p>
+            <a:pPr lvl="1"/>
+            <a:r>
+              <a:rPr sz="1800"/>
+              <a:t>1.2× the source code size which is heavy.</a:t>
+            </a:r>
+          </a:p>
+          <a:p>
+            <a:pPr lvl="1"/>
+            <a:r>
+              <a:rPr sz="1800"/>
+              <a:t>But tests are cheap now.</a:t>
+            </a:r>
+          </a:p>
+          <a:p>
+            <a:pPr lvl="0"/>
+            <a:r>
+              <a:rPr sz="1800"/>
+              <a:t>Benchmarks: 171 files, 13,890 LOC, 360 benchmark functions</a:t>
             </a:r>
           </a:p>
         </p:txBody>
@@ -4172,7 +4236,7 @@
             </a:pPr>
             <a:r>
               <a:rPr sz="3200"/>
-              <a:t>APAS-AI - AI Paired Programming APAS in Rust</a:t>
+              <a:t>Rusticate - sending Python back to the family estate</a:t>
             </a:r>
           </a:p>
         </p:txBody>
@@ -4195,77 +4259,53 @@
             <a:pPr lvl="0"/>
             <a:r>
               <a:rPr sz="1800"/>
-              <a:t>Scale:</a:t>
-            </a:r>
-          </a:p>
-          <a:p>
-            <a:pPr lvl="1"/>
-            <a:r>
-              <a:rPr sz="1800"/>
-              <a:t>42 chapters</a:t>
-            </a:r>
-          </a:p>
-          <a:p>
-            <a:pPr lvl="1"/>
-            <a:r>
-              <a:rPr sz="1800"/>
-              <a:t>238 source files</a:t>
-            </a:r>
-          </a:p>
-          <a:p>
-            <a:pPr lvl="1"/>
-            <a:r>
-              <a:rPr sz="1800"/>
-              <a:t>45,485 source LOC.</a:t>
-            </a:r>
-          </a:p>
-          <a:p>
-            <a:pPr lvl="0"/>
-            <a:r>
-              <a:rPr sz="1800"/>
-              <a:t>Tests:</a:t>
-            </a:r>
-          </a:p>
-          <a:p>
-            <a:pPr lvl="1"/>
-            <a:r>
-              <a:rPr sz="1800"/>
-              <a:t>246 files</a:t>
-            </a:r>
-          </a:p>
-          <a:p>
-            <a:pPr lvl="1"/>
-            <a:r>
-              <a:rPr sz="1800"/>
-              <a:t>55,223 LOC</a:t>
-            </a:r>
-          </a:p>
-          <a:p>
-            <a:pPr lvl="1"/>
-            <a:r>
-              <a:rPr sz="1800"/>
-              <a:t>3,923 test functions</a:t>
-            </a:r>
-          </a:p>
-          <a:p>
-            <a:pPr lvl="1"/>
-            <a:r>
-              <a:rPr sz="1800"/>
-              <a:t>1.2× the source code size which is heavy.</a:t>
-            </a:r>
-          </a:p>
-          <a:p>
-            <a:pPr lvl="1"/>
-            <a:r>
-              <a:rPr sz="1800"/>
-              <a:t>But tests are cheap now.</a:t>
-            </a:r>
-          </a:p>
-          <a:p>
-            <a:pPr lvl="0"/>
-            <a:r>
-              <a:rPr sz="1800"/>
-              <a:t>Benchmarks: 171 files, 13,890 LOC, 360 benchmark functions</a:t>
+              <a:t>Built because Python + regex cannot reliably parse Rust.</a:t>
+            </a:r>
+          </a:p>
+          <a:p>
+            <a:pPr lvl="0"/>
+            <a:r>
+              <a:rPr sz="1800"/>
+              <a:t>Webster’s definition of rusticate:</a:t>
+            </a:r>
+          </a:p>
+          <a:p>
+            <a:pPr lvl="1" indent="-342900" marL="685800">
+              <a:buAutoNum type="arabicPeriod"/>
+            </a:pPr>
+            <a:r>
+              <a:rPr sz="1800"/>
+              <a:t>To go to or live in the country.</a:t>
+            </a:r>
+          </a:p>
+          <a:p>
+            <a:pPr lvl="1" indent="-342900" marL="685800">
+              <a:buAutoNum startAt="2" type="arabicPeriod"/>
+            </a:pPr>
+            <a:r>
+              <a:rPr sz="1800"/>
+              <a:t>(British) To suspend a student from a university, especially Oxford or Cambridge, as a disciplinary punishment.</a:t>
+            </a:r>
+          </a:p>
+          <a:p>
+            <a:pPr lvl="0"/>
+            <a:r>
+              <a:rPr sz="1800"/>
+              <a:t>Rusticate is a suite of 89 tools, most obviated, for analyzing and transforming rust codebases.</a:t>
+            </a:r>
+          </a:p>
+          <a:p>
+            <a:pPr lvl="0"/>
+            <a:r>
+              <a:rPr sz="1800"/>
+              <a:t>review tools, fix tools, metrics, and migration aids.</a:t>
+            </a:r>
+          </a:p>
+          <a:p>
+            <a:pPr lvl="0"/>
+            <a:r>
+              <a:rPr sz="1800"/>
+              <a:t>The string hacking detector is the foremost valuable tool to fix any and all transformation of Rust.</a:t>
             </a:r>
           </a:p>
         </p:txBody>
@@ -4312,7 +4352,7 @@
             </a:pPr>
             <a:r>
               <a:rPr sz="3200"/>
-              <a:t>Rusticate - sending Python back to the family estate</a:t>
+              <a:t>Verus: Verified Rust</a:t>
             </a:r>
           </a:p>
         </p:txBody>
@@ -4335,53 +4375,35 @@
             <a:pPr lvl="0"/>
             <a:r>
               <a:rPr sz="1800"/>
-              <a:t>Built because Python + regex cannot reliably parse Rust.</a:t>
-            </a:r>
-          </a:p>
-          <a:p>
-            <a:pPr lvl="0"/>
-            <a:r>
-              <a:rPr sz="1800"/>
-              <a:t>Webster’s definition of rusticate:</a:t>
-            </a:r>
-          </a:p>
-          <a:p>
-            <a:pPr lvl="1" indent="-342900" marL="685800">
-              <a:buAutoNum type="arabicPeriod"/>
-            </a:pPr>
-            <a:r>
-              <a:rPr sz="1800"/>
-              <a:t>To go to or live in the country.</a:t>
-            </a:r>
-          </a:p>
-          <a:p>
-            <a:pPr lvl="1" indent="-342900" marL="685800">
-              <a:buAutoNum startAt="2" type="arabicPeriod"/>
-            </a:pPr>
-            <a:r>
-              <a:rPr sz="1800"/>
-              <a:t>(British) To suspend a student from a university, especially Oxford or Cambridge, as a disciplinary punishment.</a:t>
-            </a:r>
-          </a:p>
-          <a:p>
-            <a:pPr lvl="0"/>
-            <a:r>
-              <a:rPr sz="1800"/>
-              <a:t>Rusticate is a suite of 89 tools, most obviated, for analyzing and transforming rust codebases.</a:t>
-            </a:r>
-          </a:p>
-          <a:p>
-            <a:pPr lvl="0"/>
-            <a:r>
-              <a:rPr sz="1800"/>
-              <a:t>review tools, fix tools, metrics, and migration aids.</a:t>
-            </a:r>
-          </a:p>
-          <a:p>
-            <a:pPr lvl="0"/>
-            <a:r>
-              <a:rPr sz="1800"/>
-              <a:t>The string hacking detector is the foremost valuable tool to fix any and all transformation of Rust.</a:t>
+              <a:t>Verus is a tool for formally verifying Rust, developed at MSFT Research, VMware Research and Carnegie Mellon University.</a:t>
+            </a:r>
+          </a:p>
+          <a:p>
+            <a:pPr lvl="0"/>
+            <a:r>
+              <a:rPr sz="1800"/>
+              <a:t>Team: Andrea Lattuada, Travis Hance, Chris Hawblitzel, Jay Lorch, Matthias Brun, Chanhee Park, Yi Zhou, Jon Howell, Bryan Parno.</a:t>
+            </a:r>
+          </a:p>
+          <a:p>
+            <a:pPr lvl="0"/>
+            <a:r>
+              <a:rPr sz="1800"/>
+              <a:t>Goals: bring machine-checked proof to systems software written in Rust.</a:t>
+            </a:r>
+          </a:p>
+          <a:p>
+            <a:pPr lvl="0"/>
+            <a:r>
+              <a:rPr sz="1800"/>
+              <a:t>Goals: tight integration with the programming language.</a:t>
+            </a:r>
+          </a:p>
+          <a:p>
+            <a:pPr lvl="0"/>
+            <a:r>
+              <a:rPr sz="1800"/>
+              <a:t>Goals: easier faster proof.</a:t>
             </a:r>
           </a:p>
         </p:txBody>
@@ -4428,7 +4450,7 @@
             </a:pPr>
             <a:r>
               <a:rPr sz="3200"/>
-              <a:t>Verus: Verified Rust</a:t>
+              <a:t>Key Verus Publications</a:t>
             </a:r>
           </a:p>
         </p:txBody>
@@ -4451,35 +4473,21 @@
             <a:pPr lvl="0"/>
             <a:r>
               <a:rPr sz="1800"/>
-              <a:t>Verus is a tool for formally verifying Rust, developed at MSFT Research, VMware Research and Carnegie Mellon University.</a:t>
-            </a:r>
-          </a:p>
-          <a:p>
-            <a:pPr lvl="0"/>
-            <a:r>
-              <a:rPr sz="1800"/>
-              <a:t>Team: Andrea Lattuada, Travis Hance, Chris Hawblitzel, Jay Lorch, Matthias Brun, Chanhee Park, Yi Zhou, Jon Howell, Bryan Parno.</a:t>
-            </a:r>
-          </a:p>
-          <a:p>
-            <a:pPr lvl="0"/>
-            <a:r>
-              <a:rPr sz="1800"/>
-              <a:t>Goals: bring machine-checked proof to systems software written in Rust.</a:t>
-            </a:r>
-          </a:p>
-          <a:p>
-            <a:pPr lvl="0"/>
-            <a:r>
-              <a:rPr sz="1800"/>
-              <a:t>Goals: tight integration with the programming language.</a:t>
-            </a:r>
-          </a:p>
-          <a:p>
-            <a:pPr lvl="0"/>
-            <a:r>
-              <a:rPr sz="1800"/>
-              <a:t>Goals: easier faster proof.</a:t>
+              <a:t>“Verus: Verifying Rust Programs using Linear Ghost Types” Lattuada, Hance, Cho, Brun, Subasinghe, Zhou, Howell, Parno, Hawblitzel</a:t>
+            </a:r>
+          </a:p>
+          <a:p>
+            <a:pPr lvl="0"/>
+            <a:r>
+              <a:rPr sz="1800"/>
+              <a:t>“Verus: A Practical Foundation for Systems Verification” Lattuada, Hance, Bosamiya, Brun, Cho, LeBlanc, Srinivasan, Achermann, Chajed, Hawblitzel, Howell, Lorch, Padon, Parno</a:t>
+            </a:r>
+          </a:p>
+          <a:p>
+            <a:pPr lvl="0"/>
+            <a:r>
+              <a:rPr sz="1800"/>
+              <a:t>“Verifying Concurrent Systems Code” Travis Hance — PhD Thesis, Carnegie Mellon University, 2024</a:t>
             </a:r>
           </a:p>
         </p:txBody>
@@ -4526,7 +4534,7 @@
             </a:pPr>
             <a:r>
               <a:rPr sz="3200"/>
-              <a:t>Key Verus Publications</a:t>
+              <a:t>Verus</a:t>
             </a:r>
           </a:p>
         </p:txBody>
@@ -4549,21 +4557,63 @@
             <a:pPr lvl="0"/>
             <a:r>
               <a:rPr sz="1800"/>
-              <a:t>“Verus: Verifying Rust Programs using Linear Ghost Types” Lattuada, Hance, Cho, Brun, Subasinghe, Zhou, Howell, Parno, Hawblitzel</a:t>
-            </a:r>
-          </a:p>
-          <a:p>
-            <a:pPr lvl="0"/>
-            <a:r>
-              <a:rPr sz="1800"/>
-              <a:t>“Verus: A Practical Foundation for Systems Verification” Lattuada, Hance, Bosamiya, Brun, Cho, LeBlanc, Srinivasan, Achermann, Chajed, Hawblitzel, Howell, Lorch, Padon, Parno</a:t>
-            </a:r>
-          </a:p>
-          <a:p>
-            <a:pPr lvl="0"/>
-            <a:r>
-              <a:rPr sz="1800"/>
-              <a:t>“Verifying Concurrent Systems Code” Travis Hance — PhD Thesis, Carnegie Mellon University, 2024</a:t>
+              <a:t>Specifications are written in a pure mathematical sublanguage</a:t>
+            </a:r>
+          </a:p>
+          <a:p>
+            <a:pPr lvl="0"/>
+            <a:r>
+              <a:rPr sz="1800"/>
+              <a:t>spec functions, forall/exists, arithmetic, sets, sequences.</a:t>
+            </a:r>
+          </a:p>
+          <a:p>
+            <a:pPr lvl="0"/>
+            <a:r>
+              <a:rPr sz="1800"/>
+              <a:t>Decidability is not guaranteed.</a:t>
+            </a:r>
+          </a:p>
+          <a:p>
+            <a:pPr lvl="0"/>
+            <a:r>
+              <a:rPr sz="1800"/>
+              <a:t>Z3 handles linear arithmetic, arrays, and quantified formulas, but quantifier instantiation requires explicit trigger annotations.</a:t>
+            </a:r>
+          </a:p>
+          <a:p>
+            <a:pPr lvl="0"/>
+            <a:r>
+              <a:rPr sz="1800"/>
+              <a:t>But there is also a faster linear arithmetic solver, Singular.</a:t>
+            </a:r>
+          </a:p>
+          <a:p>
+            <a:pPr lvl="0"/>
+            <a:r>
+              <a:rPr sz="1800"/>
+              <a:t>Annotates existing Rust code:</a:t>
+            </a:r>
+          </a:p>
+          <a:p>
+            <a:pPr lvl="1"/>
+            <a:r>
+              <a:rPr sz="1800"/>
+              <a:t>spec / proof / requires / ensures on fns</a:t>
+            </a:r>
+          </a:p>
+          <a:p>
+            <a:pPr lvl="0"/>
+            <a:r>
+              <a:rPr sz="1800"/>
+              <a:t>Ships the Rust binaries directly.</a:t>
+            </a:r>
+          </a:p>
+          <a:p>
+            <a:pPr lvl="0"/>
+            <a:r>
+              <a:rPr sz="1800"/>
+              <a:t>Linear Logic + Borrowing from the Rust type system, which rustc checks.</a:t>
             </a:r>
           </a:p>
         </p:txBody>
@@ -4610,7 +4660,7 @@
             </a:pPr>
             <a:r>
               <a:rPr sz="3200"/>
-              <a:t>Verus</a:t>
+              <a:t>F* - Comparison</a:t>
             </a:r>
           </a:p>
         </p:txBody>
@@ -4633,63 +4683,49 @@
             <a:pPr lvl="0"/>
             <a:r>
               <a:rPr sz="1800"/>
-              <a:t>Specifications are written in a pure mathematical sublanguage</a:t>
-            </a:r>
-          </a:p>
-          <a:p>
-            <a:pPr lvl="0"/>
-            <a:r>
-              <a:rPr sz="1800"/>
-              <a:t>spec functions, forall/exists, arithmetic, sets, sequences.</a:t>
-            </a:r>
-          </a:p>
-          <a:p>
-            <a:pPr lvl="0"/>
-            <a:r>
-              <a:rPr sz="1800"/>
-              <a:t>Decidability is not guaranteed.</a:t>
-            </a:r>
-          </a:p>
-          <a:p>
-            <a:pPr lvl="0"/>
-            <a:r>
-              <a:rPr sz="1800"/>
-              <a:t>Z3 handles linear arithmetic, arrays, and quantified formulas, but quantifier instantiation requires explicit trigger annotations.</a:t>
-            </a:r>
-          </a:p>
-          <a:p>
-            <a:pPr lvl="0"/>
-            <a:r>
-              <a:rPr sz="1800"/>
-              <a:t>But there is also a faster linear arithmetic solver, Singular.</a:t>
-            </a:r>
-          </a:p>
-          <a:p>
-            <a:pPr lvl="0"/>
-            <a:r>
-              <a:rPr sz="1800"/>
-              <a:t>Annotates existing Rust code:</a:t>
-            </a:r>
-          </a:p>
-          <a:p>
-            <a:pPr lvl="1"/>
-            <a:r>
-              <a:rPr sz="1800"/>
-              <a:t>spec / proof / requires / ensures on fns</a:t>
-            </a:r>
-          </a:p>
-          <a:p>
-            <a:pPr lvl="0"/>
-            <a:r>
-              <a:rPr sz="1800"/>
-              <a:t>Ships the Rust binary directly.</a:t>
-            </a:r>
-          </a:p>
-          <a:p>
-            <a:pPr lvl="0"/>
-            <a:r>
-              <a:rPr sz="1800"/>
-              <a:t>Linear Logic + Borrowing from the Rust type system, which rustc checks.</a:t>
+              <a:t>Stand-alone dependently-typed language</a:t>
+            </a:r>
+          </a:p>
+          <a:p>
+            <a:pPr lvl="0"/>
+            <a:r>
+              <a:rPr sz="1800"/>
+              <a:t>Effect system (Pure, ST, Steel/Pulse)</a:t>
+            </a:r>
+          </a:p>
+          <a:p>
+            <a:pPr lvl="0"/>
+            <a:r>
+              <a:rPr sz="1800"/>
+              <a:t>SMT + tactics (meta-programming)</a:t>
+            </a:r>
+          </a:p>
+          <a:p>
+            <a:pPr lvl="0"/>
+            <a:r>
+              <a:rPr sz="1800"/>
+              <a:t>Generates OCaml, F#, C, Wasm</a:t>
+            </a:r>
+          </a:p>
+          <a:p>
+            <a:pPr lvl="0"/>
+            <a:r>
+              <a:rPr sz="1800"/>
+              <a:t>Separation logic via Steel Pulse for low-level code.</a:t>
+            </a:r>
+          </a:p>
+          <a:p>
+            <a:pPr lvl="0"/>
+            <a:r>
+              <a:rPr sz="1800"/>
+              <a:t>Refinement types.</a:t>
+            </a:r>
+          </a:p>
+          <a:p>
+            <a:pPr lvl="0"/>
+            <a:r>
+              <a:rPr sz="1800"/>
+              <a:t>A much richer language set.</a:t>
             </a:r>
           </a:p>
         </p:txBody>
@@ -4736,7 +4772,7 @@
             </a:pPr>
             <a:r>
               <a:rPr sz="3200"/>
-              <a:t>F* - Comparison</a:t>
+              <a:t>Views and the Libraries</a:t>
             </a:r>
           </a:p>
         </p:txBody>
@@ -4759,49 +4795,28 @@
             <a:pPr lvl="0"/>
             <a:r>
               <a:rPr sz="1800"/>
-              <a:t>Stand-alone dependently-typed language</a:t>
-            </a:r>
-          </a:p>
-          <a:p>
-            <a:pPr lvl="0"/>
-            <a:r>
-              <a:rPr sz="1800"/>
-              <a:t>Effect system (Pure, ST, Steel/Pulse)</a:t>
-            </a:r>
-          </a:p>
-          <a:p>
-            <a:pPr lvl="0"/>
-            <a:r>
-              <a:rPr sz="1800"/>
-              <a:t>SMT + tactics (meta-programming)</a:t>
-            </a:r>
-          </a:p>
-          <a:p>
-            <a:pPr lvl="0"/>
-            <a:r>
-              <a:rPr sz="1800"/>
-              <a:t>Generates OCaml, F#, C, Wasm</a:t>
-            </a:r>
-          </a:p>
-          <a:p>
-            <a:pPr lvl="0"/>
-            <a:r>
-              <a:rPr sz="1800"/>
-              <a:t>Separation logic via Steel Pulse for low-level code.</a:t>
-            </a:r>
-          </a:p>
-          <a:p>
-            <a:pPr lvl="0"/>
-            <a:r>
-              <a:rPr sz="1800"/>
-              <a:t>Refinement types.</a:t>
-            </a:r>
-          </a:p>
-          <a:p>
-            <a:pPr lvl="0"/>
-            <a:r>
-              <a:rPr sz="1800"/>
-              <a:t>A much richer language set.</a:t>
+              <a:t>A View maps an executable Rust type to a mathematical ghost type: “Vec views as Seq”, “HashSet views as Set”.</a:t>
+            </a:r>
+          </a:p>
+          <a:p>
+            <a:pPr lvl="0"/>
+            <a:r>
+              <a:rPr sz="1800"/>
+              <a:t>Specs are written over the view; exec code manipulates the real type.</a:t>
+            </a:r>
+          </a:p>
+          <a:p>
+            <a:pPr lvl="0"/>
+            <a:r>
+              <a:rPr sz="1800"/>
+              <a:t>vstd is Verus’s standard library — specs for Vec, Seq, Set, Map, Multiset, arithmetic, common lemmas, Fns …</a:t>
+            </a:r>
+          </a:p>
+          <a:p>
+            <a:pPr lvl="0"/>
+            <a:r>
+              <a:rPr sz="1800"/>
+              <a:t>Ghost types live only in the verifier — they have no runtime cost and no runtime representation.</a:t>
             </a:r>
           </a:p>
         </p:txBody>
@@ -4871,7 +4886,7 @@
             <a:pPr lvl="0"/>
             <a:r>
               <a:rPr sz="1800"/>
-              <a:t>Its a pleasure to speak here at Micrsoft Research RISE Group.</a:t>
+              <a:t>Its a pleasure to speak here at Microsoft Research RISE Group.</a:t>
             </a:r>
           </a:p>
           <a:p>
@@ -4967,7 +4982,7 @@
             </a:pPr>
             <a:r>
               <a:rPr sz="3200"/>
-              <a:t>Views and the Libraries</a:t>
+              <a:t>Wrapping Rust — Declaring an external type</a:t>
             </a:r>
           </a:p>
         </p:txBody>
@@ -4990,28 +5005,180 @@
             <a:pPr lvl="0"/>
             <a:r>
               <a:rPr sz="1800"/>
-              <a:t>A View maps an executable Rust type to a mathematical ghost type: “Vec views as Seq”, “HashSet views as Set”.</a:t>
-            </a:r>
-          </a:p>
-          <a:p>
-            <a:pPr lvl="0"/>
-            <a:r>
-              <a:rPr sz="1800"/>
-              <a:t>Specs are written over the view; exec code manipulates the real type.</a:t>
-            </a:r>
-          </a:p>
-          <a:p>
-            <a:pPr lvl="0"/>
-            <a:r>
-              <a:rPr sz="1800"/>
-              <a:t>vstd is Verus’s standard library — specs for Vec, Seq, Set, Map, Multiset, arithmetic, common lemmas, Fns …</a:t>
-            </a:r>
-          </a:p>
-          <a:p>
-            <a:pPr lvl="0"/>
-            <a:r>
-              <a:rPr sz="1800"/>
-              <a:t>Ghost types live only in the verifier — they have no runtime cost and no runtime representation.</a:t>
+              <a:t>Four specification constructs are used to give specs to Rust stdlib.</a:t>
+            </a:r>
+          </a:p>
+          <a:p>
+            <a:pPr lvl="0"/>
+            <a:r>
+              <a:rPr sz="1800"/>
+              <a:t>A proxy struct that introduces a spec for a foreign type.</a:t>
+            </a:r>
+          </a:p>
+          <a:p>
+            <a:pPr lvl="0"/>
+            <a:r>
+              <a:rPr sz="1800"/>
+              <a:t>The proxy struct name is conventionally ExTypeName.</a:t>
+            </a:r>
+          </a:p>
+          <a:p>
+            <a:pPr lvl="0" indent="0">
+              <a:buNone/>
+            </a:pPr>
+            <a:r>
+              <a:rPr sz="1800">
+                <a:latin typeface="Courier"/>
+              </a:rPr>
+              <a:t>  </a:t>
+            </a:r>
+            <a:r>
+              <a:rPr sz="1800">
+                <a:solidFill>
+                  <a:srgbClr val="7D9029"/>
+                </a:solidFill>
+                <a:latin typeface="Courier"/>
+              </a:rPr>
+              <a:t>#[</a:t>
+            </a:r>
+            <a:r>
+              <a:rPr sz="1800">
+                <a:solidFill>
+                  <a:srgbClr val="BC7A00"/>
+                </a:solidFill>
+                <a:latin typeface="Courier"/>
+              </a:rPr>
+              <a:t>verifier::</a:t>
+            </a:r>
+            <a:r>
+              <a:rPr sz="1800">
+                <a:latin typeface="Courier"/>
+              </a:rPr>
+              <a:t>external_type_specification</a:t>
+            </a:r>
+            <a:r>
+              <a:rPr sz="1800">
+                <a:solidFill>
+                  <a:srgbClr val="7D9029"/>
+                </a:solidFill>
+                <a:latin typeface="Courier"/>
+              </a:rPr>
+              <a:t>]</a:t>
+            </a:r>
+            <a:br/>
+            <a:r>
+              <a:rPr sz="1800">
+                <a:latin typeface="Courier"/>
+              </a:rPr>
+              <a:t>  </a:t>
+            </a:r>
+            <a:r>
+              <a:rPr sz="1800" b="1">
+                <a:solidFill>
+                  <a:srgbClr val="007020"/>
+                </a:solidFill>
+                <a:latin typeface="Courier"/>
+              </a:rPr>
+              <a:t>pub</a:t>
+            </a:r>
+            <a:r>
+              <a:rPr sz="1800">
+                <a:latin typeface="Courier"/>
+              </a:rPr>
+              <a:t> </a:t>
+            </a:r>
+            <a:r>
+              <a:rPr sz="1800" b="1">
+                <a:solidFill>
+                  <a:srgbClr val="007020"/>
+                </a:solidFill>
+                <a:latin typeface="Courier"/>
+              </a:rPr>
+              <a:t>struct</a:t>
+            </a:r>
+            <a:r>
+              <a:rPr sz="1800">
+                <a:latin typeface="Courier"/>
+              </a:rPr>
+              <a:t> ExVec</a:t>
+            </a:r>
+            <a:r>
+              <a:rPr sz="1800">
+                <a:solidFill>
+                  <a:srgbClr val="666666"/>
+                </a:solidFill>
+                <a:latin typeface="Courier"/>
+              </a:rPr>
+              <a:t>&lt;</a:t>
+            </a:r>
+            <a:r>
+              <a:rPr sz="1800">
+                <a:latin typeface="Courier"/>
+              </a:rPr>
+              <a:t>T</a:t>
+            </a:r>
+            <a:r>
+              <a:rPr sz="1800">
+                <a:solidFill>
+                  <a:srgbClr val="666666"/>
+                </a:solidFill>
+                <a:latin typeface="Courier"/>
+              </a:rPr>
+              <a:t>&gt;</a:t>
+            </a:r>
+            <a:r>
+              <a:rPr sz="1800">
+                <a:latin typeface="Courier"/>
+              </a:rPr>
+              <a:t>(</a:t>
+            </a:r>
+            <a:r>
+              <a:rPr sz="1800">
+                <a:solidFill>
+                  <a:srgbClr val="902000"/>
+                </a:solidFill>
+                <a:latin typeface="Courier"/>
+              </a:rPr>
+              <a:t>Vec</a:t>
+            </a:r>
+            <a:r>
+              <a:rPr sz="1800">
+                <a:solidFill>
+                  <a:srgbClr val="666666"/>
+                </a:solidFill>
+                <a:latin typeface="Courier"/>
+              </a:rPr>
+              <a:t>&lt;</a:t>
+            </a:r>
+            <a:r>
+              <a:rPr sz="1800">
+                <a:latin typeface="Courier"/>
+              </a:rPr>
+              <a:t>T</a:t>
+            </a:r>
+            <a:r>
+              <a:rPr sz="1800">
+                <a:solidFill>
+                  <a:srgbClr val="666666"/>
+                </a:solidFill>
+                <a:latin typeface="Courier"/>
+              </a:rPr>
+              <a:t>&gt;</a:t>
+            </a:r>
+            <a:r>
+              <a:rPr sz="1800">
+                <a:latin typeface="Courier"/>
+              </a:rPr>
+              <a:t>)</a:t>
+            </a:r>
+            <a:r>
+              <a:rPr sz="1800">
+                <a:solidFill>
+                  <a:srgbClr val="666666"/>
+                </a:solidFill>
+                <a:latin typeface="Courier"/>
+              </a:rPr>
+              <a:t>;</a:t>
             </a:r>
           </a:p>
         </p:txBody>
@@ -5058,7 +5225,7 @@
             </a:pPr>
             <a:r>
               <a:rPr sz="3200"/>
-              <a:t>Wrapping Rust — Declaring an external type</a:t>
+              <a:t>Wrapping Rust — Declaring an external function/method</a:t>
             </a:r>
           </a:p>
         </p:txBody>
@@ -5081,21 +5248,7 @@
             <a:pPr lvl="0"/>
             <a:r>
               <a:rPr sz="1800"/>
-              <a:t>Three specification constructs are used to give specs to Rust stdlib.</a:t>
-            </a:r>
-          </a:p>
-          <a:p>
-            <a:pPr lvl="0"/>
-            <a:r>
-              <a:rPr sz="1800"/>
-              <a:t>A proxy struct that introduces a spec for a foreign type.</a:t>
-            </a:r>
-          </a:p>
-          <a:p>
-            <a:pPr lvl="0"/>
-            <a:r>
-              <a:rPr sz="1800"/>
-              <a:t>The proxy struct name is conventionally ExTypeName.</a:t>
+              <a:t>A proxy function with the same signature as the foreign function, carrying the requires/ensures.</a:t>
             </a:r>
           </a:p>
           <a:p>
@@ -5130,7 +5283,7 @@
               <a:rPr sz="1800">
                 <a:latin typeface="Courier"/>
               </a:rPr>
-              <a:t>external_type_specification</a:t>
+              <a:t>external_fn_specification</a:t>
             </a:r>
             <a:r>
               <a:rPr sz="1800">
@@ -5170,13 +5323,13 @@
                 </a:solidFill>
                 <a:latin typeface="Courier"/>
               </a:rPr>
-              <a:t>struct</a:t>
-            </a:r>
-            <a:r>
-              <a:rPr sz="1800">
-                <a:latin typeface="Courier"/>
-              </a:rPr>
-              <a:t> ExVec</a:t>
+              <a:t>fn</a:t>
+            </a:r>
+            <a:r>
+              <a:rPr sz="1800">
+                <a:latin typeface="Courier"/>
+              </a:rPr>
+              <a:t> ex_vec_push</a:t>
             </a:r>
             <a:r>
               <a:rPr sz="1800">
@@ -5206,7 +5359,46 @@
               <a:rPr sz="1800">
                 <a:latin typeface="Courier"/>
               </a:rPr>
-              <a:t>(</a:t>
+              <a:t>(v</a:t>
+            </a:r>
+            <a:r>
+              <a:rPr sz="1800">
+                <a:solidFill>
+                  <a:srgbClr val="666666"/>
+                </a:solidFill>
+                <a:latin typeface="Courier"/>
+              </a:rPr>
+              <a:t>:</a:t>
+            </a:r>
+            <a:r>
+              <a:rPr sz="1800">
+                <a:latin typeface="Courier"/>
+              </a:rPr>
+              <a:t> </a:t>
+            </a:r>
+            <a:r>
+              <a:rPr sz="1800">
+                <a:solidFill>
+                  <a:srgbClr val="666666"/>
+                </a:solidFill>
+                <a:latin typeface="Courier"/>
+              </a:rPr>
+              <a:t>&amp;</a:t>
+            </a:r>
+            <a:r>
+              <a:rPr sz="1800" b="1">
+                <a:solidFill>
+                  <a:srgbClr val="007020"/>
+                </a:solidFill>
+                <a:latin typeface="Courier"/>
+              </a:rPr>
+              <a:t>mut</a:t>
+            </a:r>
+            <a:r>
+              <a:rPr sz="1800">
+                <a:latin typeface="Courier"/>
+              </a:rPr>
+              <a:t> </a:t>
             </a:r>
             <a:r>
               <a:rPr sz="1800">
@@ -5239,13 +5431,13 @@
                 </a:solidFill>
                 <a:latin typeface="Courier"/>
               </a:rPr>
-              <a:t>&gt;</a:t>
-            </a:r>
-            <a:r>
-              <a:rPr sz="1800">
-                <a:latin typeface="Courier"/>
-              </a:rPr>
-              <a:t>)</a:t>
+              <a:t>&gt;,</a:t>
+            </a:r>
+            <a:r>
+              <a:rPr sz="1800">
+                <a:latin typeface="Courier"/>
+              </a:rPr>
+              <a:t> value</a:t>
             </a:r>
             <a:r>
               <a:rPr sz="1800">
@@ -5254,7 +5446,193 @@
                 </a:solidFill>
                 <a:latin typeface="Courier"/>
               </a:rPr>
-              <a:t>;</a:t>
+              <a:t>:</a:t>
+            </a:r>
+            <a:r>
+              <a:rPr sz="1800">
+                <a:latin typeface="Courier"/>
+              </a:rPr>
+              <a:t> T)</a:t>
+            </a:r>
+            <a:br/>
+            <a:r>
+              <a:rPr sz="1800">
+                <a:latin typeface="Courier"/>
+              </a:rPr>
+              <a:t>      requires v</a:t>
+            </a:r>
+            <a:r>
+              <a:rPr sz="1800">
+                <a:solidFill>
+                  <a:srgbClr val="666666"/>
+                </a:solidFill>
+                <a:latin typeface="Courier"/>
+              </a:rPr>
+              <a:t>@.</a:t>
+            </a:r>
+            <a:r>
+              <a:rPr sz="1800">
+                <a:latin typeface="Courier"/>
+              </a:rPr>
+              <a:t>len() </a:t>
+            </a:r>
+            <a:r>
+              <a:rPr sz="1800">
+                <a:solidFill>
+                  <a:srgbClr val="666666"/>
+                </a:solidFill>
+                <a:latin typeface="Courier"/>
+              </a:rPr>
+              <a:t>&lt;</a:t>
+            </a:r>
+            <a:r>
+              <a:rPr sz="1800">
+                <a:latin typeface="Courier"/>
+              </a:rPr>
+              <a:t> </a:t>
+            </a:r>
+            <a:r>
+              <a:rPr sz="1800">
+                <a:solidFill>
+                  <a:srgbClr val="902000"/>
+                </a:solidFill>
+                <a:latin typeface="Courier"/>
+              </a:rPr>
+              <a:t>usize</a:t>
+            </a:r>
+            <a:r>
+              <a:rPr sz="1800">
+                <a:solidFill>
+                  <a:srgbClr val="BC7A00"/>
+                </a:solidFill>
+                <a:latin typeface="Courier"/>
+              </a:rPr>
+              <a:t>::</a:t>
+            </a:r>
+            <a:r>
+              <a:rPr sz="1800">
+                <a:solidFill>
+                  <a:srgbClr val="880000"/>
+                </a:solidFill>
+                <a:latin typeface="Courier"/>
+              </a:rPr>
+              <a:t>MAX</a:t>
+            </a:r>
+            <a:r>
+              <a:rPr sz="1800">
+                <a:solidFill>
+                  <a:srgbClr val="666666"/>
+                </a:solidFill>
+                <a:latin typeface="Courier"/>
+              </a:rPr>
+              <a:t>,</a:t>
+            </a:r>
+            <a:br/>
+            <a:r>
+              <a:rPr sz="1800">
+                <a:latin typeface="Courier"/>
+              </a:rPr>
+              <a:t>      ensures  v</a:t>
+            </a:r>
+            <a:r>
+              <a:rPr sz="1800">
+                <a:solidFill>
+                  <a:srgbClr val="666666"/>
+                </a:solidFill>
+                <a:latin typeface="Courier"/>
+              </a:rPr>
+              <a:t>@</a:t>
+            </a:r>
+            <a:r>
+              <a:rPr sz="1800">
+                <a:latin typeface="Courier"/>
+              </a:rPr>
+              <a:t> </a:t>
+            </a:r>
+            <a:r>
+              <a:rPr sz="1800">
+                <a:solidFill>
+                  <a:srgbClr val="666666"/>
+                </a:solidFill>
+                <a:latin typeface="Courier"/>
+              </a:rPr>
+              <a:t>==</a:t>
+            </a:r>
+            <a:r>
+              <a:rPr sz="1800">
+                <a:latin typeface="Courier"/>
+              </a:rPr>
+              <a:t> old(v)</a:t>
+            </a:r>
+            <a:r>
+              <a:rPr sz="1800">
+                <a:solidFill>
+                  <a:srgbClr val="666666"/>
+                </a:solidFill>
+                <a:latin typeface="Courier"/>
+              </a:rPr>
+              <a:t>@.</a:t>
+            </a:r>
+            <a:r>
+              <a:rPr sz="1800">
+                <a:latin typeface="Courier"/>
+              </a:rPr>
+              <a:t>push(value)</a:t>
+            </a:r>
+            <a:r>
+              <a:rPr sz="1800">
+                <a:solidFill>
+                  <a:srgbClr val="666666"/>
+                </a:solidFill>
+                <a:latin typeface="Courier"/>
+              </a:rPr>
+              <a:t>,</a:t>
+            </a:r>
+            <a:br/>
+            <a:r>
+              <a:rPr sz="1800">
+                <a:latin typeface="Courier"/>
+              </a:rPr>
+              <a:t>  </a:t>
+            </a:r>
+            <a:r>
+              <a:rPr sz="1800">
+                <a:solidFill>
+                  <a:srgbClr val="666666"/>
+                </a:solidFill>
+                <a:latin typeface="Courier"/>
+              </a:rPr>
+              <a:t>{</a:t>
+            </a:r>
+            <a:r>
+              <a:rPr sz="1800">
+                <a:latin typeface="Courier"/>
+              </a:rPr>
+              <a:t> v</a:t>
+            </a:r>
+            <a:r>
+              <a:rPr sz="1800">
+                <a:solidFill>
+                  <a:srgbClr val="666666"/>
+                </a:solidFill>
+                <a:latin typeface="Courier"/>
+              </a:rPr>
+              <a:t>.</a:t>
+            </a:r>
+            <a:r>
+              <a:rPr sz="1800">
+                <a:latin typeface="Courier"/>
+              </a:rPr>
+              <a:t>push(value) </a:t>
+            </a:r>
+            <a:r>
+              <a:rPr sz="1800">
+                <a:solidFill>
+                  <a:srgbClr val="666666"/>
+                </a:solidFill>
+                <a:latin typeface="Courier"/>
+              </a:rPr>
+              <a:t>}</a:t>
             </a:r>
           </a:p>
         </p:txBody>
@@ -5324,7 +5702,7 @@
             <a:pPr lvl="0"/>
             <a:r>
               <a:rPr sz="1800"/>
-              <a:t>A proxy function with the same signature as the foreign function, carrying the requires/ensures.</a:t>
+              <a:t>Add a View and specs to a foreign type.</a:t>
             </a:r>
           </a:p>
           <a:p>
@@ -5359,7 +5737,7 @@
               <a:rPr sz="1800">
                 <a:latin typeface="Courier"/>
               </a:rPr>
-              <a:t>external_fn_specification</a:t>
+              <a:t>external_type_specification</a:t>
             </a:r>
             <a:r>
               <a:rPr sz="1800">
@@ -5399,13 +5777,13 @@
                 </a:solidFill>
                 <a:latin typeface="Courier"/>
               </a:rPr>
-              <a:t>fn</a:t>
-            </a:r>
-            <a:r>
-              <a:rPr sz="1800">
-                <a:latin typeface="Courier"/>
-              </a:rPr>
-              <a:t> ex_vec_push</a:t>
+              <a:t>struct</a:t>
+            </a:r>
+            <a:r>
+              <a:rPr sz="1800">
+                <a:latin typeface="Courier"/>
+              </a:rPr>
+              <a:t> ExHashMap</a:t>
             </a:r>
             <a:r>
               <a:rPr sz="1800">
@@ -5420,7 +5798,7 @@
               <a:rPr sz="1800">
                 <a:latin typeface="Courier"/>
               </a:rPr>
-              <a:t>T</a:t>
+              <a:t>K</a:t>
             </a:r>
             <a:r>
               <a:rPr sz="1800">
@@ -5429,13 +5807,13 @@
                 </a:solidFill>
                 <a:latin typeface="Courier"/>
               </a:rPr>
-              <a:t>&gt;</a:t>
-            </a:r>
-            <a:r>
-              <a:rPr sz="1800">
-                <a:latin typeface="Courier"/>
-              </a:rPr>
-              <a:t>(v</a:t>
+              <a:t>,</a:t>
+            </a:r>
+            <a:r>
+              <a:rPr sz="1800">
+                <a:latin typeface="Courier"/>
+              </a:rPr>
+              <a:t> V</a:t>
             </a:r>
             <a:r>
               <a:rPr sz="1800">
@@ -5444,13 +5822,13 @@
                 </a:solidFill>
                 <a:latin typeface="Courier"/>
               </a:rPr>
-              <a:t>:</a:t>
-            </a:r>
-            <a:r>
-              <a:rPr sz="1800">
-                <a:latin typeface="Courier"/>
-              </a:rPr>
-              <a:t> </a:t>
+              <a:t>&gt;</a:t>
+            </a:r>
+            <a:r>
+              <a:rPr sz="1800">
+                <a:latin typeface="Courier"/>
+              </a:rPr>
+              <a:t>(HashMap</a:t>
             </a:r>
             <a:r>
               <a:rPr sz="1800">
@@ -5459,7 +5837,59 @@
                 </a:solidFill>
                 <a:latin typeface="Courier"/>
               </a:rPr>
-              <a:t>&amp;</a:t>
+              <a:t>&lt;</a:t>
+            </a:r>
+            <a:r>
+              <a:rPr sz="1800">
+                <a:latin typeface="Courier"/>
+              </a:rPr>
+              <a:t>K</a:t>
+            </a:r>
+            <a:r>
+              <a:rPr sz="1800">
+                <a:solidFill>
+                  <a:srgbClr val="666666"/>
+                </a:solidFill>
+                <a:latin typeface="Courier"/>
+              </a:rPr>
+              <a:t>,</a:t>
+            </a:r>
+            <a:r>
+              <a:rPr sz="1800">
+                <a:latin typeface="Courier"/>
+              </a:rPr>
+              <a:t> V</a:t>
+            </a:r>
+            <a:r>
+              <a:rPr sz="1800">
+                <a:solidFill>
+                  <a:srgbClr val="666666"/>
+                </a:solidFill>
+                <a:latin typeface="Courier"/>
+              </a:rPr>
+              <a:t>&gt;</a:t>
+            </a:r>
+            <a:r>
+              <a:rPr sz="1800">
+                <a:latin typeface="Courier"/>
+              </a:rPr>
+              <a:t>)</a:t>
+            </a:r>
+            <a:r>
+              <a:rPr sz="1800">
+                <a:solidFill>
+                  <a:srgbClr val="666666"/>
+                </a:solidFill>
+                <a:latin typeface="Courier"/>
+              </a:rPr>
+              <a:t>;</a:t>
+            </a:r>
+            <a:br/>
+            <a:r>
+              <a:rPr sz="1800">
+                <a:latin typeface="Courier"/>
+              </a:rPr>
+              <a:t>  </a:t>
             </a:r>
             <a:r>
               <a:rPr sz="1800" b="1">
@@ -5468,22 +5898,7 @@
                 </a:solidFill>
                 <a:latin typeface="Courier"/>
               </a:rPr>
-              <a:t>mut</a:t>
-            </a:r>
-            <a:r>
-              <a:rPr sz="1800">
-                <a:latin typeface="Courier"/>
-              </a:rPr>
-              <a:t> </a:t>
-            </a:r>
-            <a:r>
-              <a:rPr sz="1800">
-                <a:solidFill>
-                  <a:srgbClr val="902000"/>
-                </a:solidFill>
-                <a:latin typeface="Courier"/>
-              </a:rPr>
-              <a:t>Vec</a:t>
+              <a:t>impl</a:t>
             </a:r>
             <a:r>
               <a:rPr sz="1800">
@@ -5498,7 +5913,7 @@
               <a:rPr sz="1800">
                 <a:latin typeface="Courier"/>
               </a:rPr>
-              <a:t>T</a:t>
+              <a:t>K</a:t>
             </a:r>
             <a:r>
               <a:rPr sz="1800">
@@ -5507,13 +5922,13 @@
                 </a:solidFill>
                 <a:latin typeface="Courier"/>
               </a:rPr>
-              <a:t>&gt;,</a:t>
-            </a:r>
-            <a:r>
-              <a:rPr sz="1800">
-                <a:latin typeface="Courier"/>
-              </a:rPr>
-              <a:t> value</a:t>
+              <a:t>,</a:t>
+            </a:r>
+            <a:r>
+              <a:rPr sz="1800">
+                <a:latin typeface="Courier"/>
+              </a:rPr>
+              <a:t>V</a:t>
             </a:r>
             <a:r>
               <a:rPr sz="1800">
@@ -5522,20 +5937,28 @@
                 </a:solidFill>
                 <a:latin typeface="Courier"/>
               </a:rPr>
-              <a:t>:</a:t>
-            </a:r>
-            <a:r>
-              <a:rPr sz="1800">
-                <a:latin typeface="Courier"/>
-              </a:rPr>
-              <a:t> T)</a:t>
-            </a:r>
-            <a:br/>
-            <a:r>
-              <a:rPr sz="1800">
-                <a:latin typeface="Courier"/>
-              </a:rPr>
-              <a:t>      requires v</a:t>
+              <a:t>&gt;</a:t>
+            </a:r>
+            <a:r>
+              <a:rPr sz="1800">
+                <a:latin typeface="Courier"/>
+              </a:rPr>
+              <a:t> View </a:t>
+            </a:r>
+            <a:r>
+              <a:rPr sz="1800" b="1">
+                <a:solidFill>
+                  <a:srgbClr val="007020"/>
+                </a:solidFill>
+                <a:latin typeface="Courier"/>
+              </a:rPr>
+              <a:t>for</a:t>
+            </a:r>
+            <a:r>
+              <a:rPr sz="1800">
+                <a:latin typeface="Courier"/>
+              </a:rPr>
+              <a:t> ExHashMap</a:t>
             </a:r>
             <a:r>
               <a:rPr sz="1800">
@@ -5544,13 +5967,13 @@
                 </a:solidFill>
                 <a:latin typeface="Courier"/>
               </a:rPr>
-              <a:t>@.</a:t>
-            </a:r>
-            <a:r>
-              <a:rPr sz="1800">
-                <a:latin typeface="Courier"/>
-              </a:rPr>
-              <a:t>len() </a:t>
+              <a:t>&lt;</a:t>
+            </a:r>
+            <a:r>
+              <a:rPr sz="1800">
+                <a:latin typeface="Courier"/>
+              </a:rPr>
+              <a:t>K</a:t>
             </a:r>
             <a:r>
               <a:rPr sz="1800">
@@ -5559,22 +5982,83 @@
                 </a:solidFill>
                 <a:latin typeface="Courier"/>
               </a:rPr>
+              <a:t>,</a:t>
+            </a:r>
+            <a:r>
+              <a:rPr sz="1800">
+                <a:latin typeface="Courier"/>
+              </a:rPr>
+              <a:t>V</a:t>
+            </a:r>
+            <a:r>
+              <a:rPr sz="1800">
+                <a:solidFill>
+                  <a:srgbClr val="666666"/>
+                </a:solidFill>
+                <a:latin typeface="Courier"/>
+              </a:rPr>
+              <a:t>&gt;</a:t>
+            </a:r>
+            <a:r>
+              <a:rPr sz="1800">
+                <a:latin typeface="Courier"/>
+              </a:rPr>
+              <a:t> </a:t>
+            </a:r>
+            <a:r>
+              <a:rPr sz="1800">
+                <a:solidFill>
+                  <a:srgbClr val="666666"/>
+                </a:solidFill>
+                <a:latin typeface="Courier"/>
+              </a:rPr>
+              <a:t>{</a:t>
+            </a:r>
+            <a:br/>
+            <a:r>
+              <a:rPr sz="1800">
+                <a:latin typeface="Courier"/>
+              </a:rPr>
+              <a:t>       </a:t>
+            </a:r>
+            <a:r>
+              <a:rPr sz="1800" b="1">
+                <a:solidFill>
+                  <a:srgbClr val="007020"/>
+                </a:solidFill>
+                <a:latin typeface="Courier"/>
+              </a:rPr>
+              <a:t>type</a:t>
+            </a:r>
+            <a:r>
+              <a:rPr sz="1800">
+                <a:latin typeface="Courier"/>
+              </a:rPr>
+              <a:t> V </a:t>
+            </a:r>
+            <a:r>
+              <a:rPr sz="1800">
+                <a:solidFill>
+                  <a:srgbClr val="666666"/>
+                </a:solidFill>
+                <a:latin typeface="Courier"/>
+              </a:rPr>
+              <a:t>=</a:t>
+            </a:r>
+            <a:r>
+              <a:rPr sz="1800">
+                <a:latin typeface="Courier"/>
+              </a:rPr>
+              <a:t> Map</a:t>
+            </a:r>
+            <a:r>
+              <a:rPr sz="1800">
+                <a:solidFill>
+                  <a:srgbClr val="666666"/>
+                </a:solidFill>
+                <a:latin typeface="Courier"/>
+              </a:rPr>
               <a:t>&lt;</a:t>
-            </a:r>
-            <a:r>
-              <a:rPr sz="1800">
-                <a:latin typeface="Courier"/>
-              </a:rPr>
-              <a:t> </a:t>
-            </a:r>
-            <a:r>
-              <a:rPr sz="1800">
-                <a:solidFill>
-                  <a:srgbClr val="902000"/>
-                </a:solidFill>
-                <a:latin typeface="Courier"/>
-              </a:rPr>
-              <a:t>usize</a:t>
             </a:r>
             <a:r>
               <a:rPr sz="1800">
@@ -5583,16 +6067,13 @@
                 </a:solidFill>
                 <a:latin typeface="Courier"/>
               </a:rPr>
-              <a:t>::</a:t>
-            </a:r>
-            <a:r>
-              <a:rPr sz="1800">
-                <a:solidFill>
-                  <a:srgbClr val="880000"/>
-                </a:solidFill>
-                <a:latin typeface="Courier"/>
-              </a:rPr>
-              <a:t>MAX</a:t>
+              <a:t>K::</a:t>
+            </a:r>
+            <a:r>
+              <a:rPr sz="1800">
+                <a:latin typeface="Courier"/>
+              </a:rPr>
+              <a:t>V</a:t>
             </a:r>
             <a:r>
               <a:rPr sz="1800">
@@ -5603,12 +6084,26 @@
               </a:rPr>
               <a:t>,</a:t>
             </a:r>
-            <a:br/>
-            <a:r>
-              <a:rPr sz="1800">
-                <a:latin typeface="Courier"/>
-              </a:rPr>
-              <a:t>      ensures  v</a:t>
+            <a:r>
+              <a:rPr sz="1800">
+                <a:latin typeface="Courier"/>
+              </a:rPr>
+              <a:t> </a:t>
+            </a:r>
+            <a:r>
+              <a:rPr sz="1800">
+                <a:solidFill>
+                  <a:srgbClr val="BC7A00"/>
+                </a:solidFill>
+                <a:latin typeface="Courier"/>
+              </a:rPr>
+              <a:t>V::</a:t>
+            </a:r>
+            <a:r>
+              <a:rPr sz="1800">
+                <a:latin typeface="Courier"/>
+              </a:rPr>
+              <a:t>V</a:t>
             </a:r>
             <a:r>
               <a:rPr sz="1800">
@@ -5617,13 +6112,29 @@
                 </a:solidFill>
                 <a:latin typeface="Courier"/>
               </a:rPr>
-              <a:t>@</a:t>
-            </a:r>
-            <a:r>
-              <a:rPr sz="1800">
-                <a:latin typeface="Courier"/>
-              </a:rPr>
-              <a:t> </a:t>
+              <a:t>&gt;;</a:t>
+            </a:r>
+            <a:br/>
+            <a:r>
+              <a:rPr sz="1800">
+                <a:latin typeface="Courier"/>
+              </a:rPr>
+              <a:t>       spec </a:t>
+            </a:r>
+            <a:r>
+              <a:rPr sz="1800" b="1">
+                <a:solidFill>
+                  <a:srgbClr val="007020"/>
+                </a:solidFill>
+                <a:latin typeface="Courier"/>
+              </a:rPr>
+              <a:t>fn</a:t>
+            </a:r>
+            <a:r>
+              <a:rPr sz="1800">
+                <a:latin typeface="Courier"/>
+              </a:rPr>
+              <a:t> view(</a:t>
             </a:r>
             <a:r>
               <a:rPr sz="1800">
@@ -5632,13 +6143,22 @@
                 </a:solidFill>
                 <a:latin typeface="Courier"/>
               </a:rPr>
-              <a:t>==</a:t>
-            </a:r>
-            <a:r>
-              <a:rPr sz="1800">
-                <a:latin typeface="Courier"/>
-              </a:rPr>
-              <a:t> old(v)</a:t>
+              <a:t>&amp;</a:t>
+            </a:r>
+            <a:r>
+              <a:rPr sz="1800" b="1">
+                <a:solidFill>
+                  <a:srgbClr val="007020"/>
+                </a:solidFill>
+                <a:latin typeface="Courier"/>
+              </a:rPr>
+              <a:t>self</a:t>
+            </a:r>
+            <a:r>
+              <a:rPr sz="1800">
+                <a:latin typeface="Courier"/>
+              </a:rPr>
+              <a:t>) </a:t>
             </a:r>
             <a:r>
               <a:rPr sz="1800">
@@ -5647,13 +6167,13 @@
                 </a:solidFill>
                 <a:latin typeface="Courier"/>
               </a:rPr>
-              <a:t>@.</a:t>
-            </a:r>
-            <a:r>
-              <a:rPr sz="1800">
-                <a:latin typeface="Courier"/>
-              </a:rPr>
-              <a:t>push(value)</a:t>
+              <a:t>-&gt;</a:t>
+            </a:r>
+            <a:r>
+              <a:rPr sz="1800">
+                <a:latin typeface="Courier"/>
+              </a:rPr>
+              <a:t> Map</a:t>
             </a:r>
             <a:r>
               <a:rPr sz="1800">
@@ -5662,14 +6182,22 @@
                 </a:solidFill>
                 <a:latin typeface="Courier"/>
               </a:rPr>
-              <a:t>,</a:t>
-            </a:r>
-            <a:br/>
-            <a:r>
-              <a:rPr sz="1800">
-                <a:latin typeface="Courier"/>
-              </a:rPr>
-              <a:t>  </a:t>
+              <a:t>&lt;</a:t>
+            </a:r>
+            <a:r>
+              <a:rPr sz="1800">
+                <a:solidFill>
+                  <a:srgbClr val="BC7A00"/>
+                </a:solidFill>
+                <a:latin typeface="Courier"/>
+              </a:rPr>
+              <a:t>K::</a:t>
+            </a:r>
+            <a:r>
+              <a:rPr sz="1800">
+                <a:latin typeface="Courier"/>
+              </a:rPr>
+              <a:t>V</a:t>
             </a:r>
             <a:r>
               <a:rPr sz="1800">
@@ -5678,13 +6206,28 @@
                 </a:solidFill>
                 <a:latin typeface="Courier"/>
               </a:rPr>
-              <a:t>{</a:t>
-            </a:r>
-            <a:r>
-              <a:rPr sz="1800">
-                <a:latin typeface="Courier"/>
-              </a:rPr>
-              <a:t> v</a:t>
+              <a:t>,</a:t>
+            </a:r>
+            <a:r>
+              <a:rPr sz="1800">
+                <a:latin typeface="Courier"/>
+              </a:rPr>
+              <a:t> </a:t>
+            </a:r>
+            <a:r>
+              <a:rPr sz="1800">
+                <a:solidFill>
+                  <a:srgbClr val="BC7A00"/>
+                </a:solidFill>
+                <a:latin typeface="Courier"/>
+              </a:rPr>
+              <a:t>V::</a:t>
+            </a:r>
+            <a:r>
+              <a:rPr sz="1800">
+                <a:latin typeface="Courier"/>
+              </a:rPr>
+              <a:t>V</a:t>
             </a:r>
             <a:r>
               <a:rPr sz="1800">
@@ -5693,22 +6236,7 @@
                 </a:solidFill>
                 <a:latin typeface="Courier"/>
               </a:rPr>
-              <a:t>.</a:t>
-            </a:r>
-            <a:r>
-              <a:rPr sz="1800">
-                <a:latin typeface="Courier"/>
-              </a:rPr>
-              <a:t>push(value) </a:t>
-            </a:r>
-            <a:r>
-              <a:rPr sz="1800">
-                <a:solidFill>
-                  <a:srgbClr val="666666"/>
-                </a:solidFill>
-                <a:latin typeface="Courier"/>
-              </a:rPr>
-              <a:t>}</a:t>
+              <a:t>&gt;;}</a:t>
             </a:r>
           </a:p>
         </p:txBody>
@@ -5755,7 +6283,7 @@
             </a:pPr>
             <a:r>
               <a:rPr sz="3200"/>
-              <a:t>Wrapping Rust — Declaring an external function/method</a:t>
+              <a:t>Wrapping Rust — external_trait_specification</a:t>
             </a:r>
           </a:p>
         </p:txBody>
@@ -5778,19 +6306,13 @@
             <a:pPr lvl="0"/>
             <a:r>
               <a:rPr sz="1800"/>
-              <a:t>Add a View and specs to a foreign type.</a:t>
+              <a:t>Adds a spec to a foreign trait without modifying it:</a:t>
             </a:r>
           </a:p>
           <a:p>
             <a:pPr lvl="0" indent="0">
               <a:buNone/>
             </a:pPr>
-            <a:r>
-              <a:rPr sz="1800">
-                <a:latin typeface="Courier"/>
-              </a:rPr>
-              <a:t>  </a:t>
-            </a:r>
             <a:r>
               <a:rPr sz="1800">
                 <a:solidFill>
@@ -5813,7 +6335,7 @@
               <a:rPr sz="1800">
                 <a:latin typeface="Courier"/>
               </a:rPr>
-              <a:t>external_type_specification</a:t>
+              <a:t>external_trait_specification</a:t>
             </a:r>
             <a:r>
               <a:rPr sz="1800">
@@ -5825,12 +6347,6 @@
               <a:t>]</a:t>
             </a:r>
             <a:br/>
-            <a:r>
-              <a:rPr sz="1800">
-                <a:latin typeface="Courier"/>
-              </a:rPr>
-              <a:t>  </a:t>
-            </a:r>
             <a:r>
               <a:rPr sz="1800" b="1">
                 <a:solidFill>
@@ -5853,13 +6369,13 @@
                 </a:solidFill>
                 <a:latin typeface="Courier"/>
               </a:rPr>
-              <a:t>struct</a:t>
-            </a:r>
-            <a:r>
-              <a:rPr sz="1800">
-                <a:latin typeface="Courier"/>
-              </a:rPr>
-              <a:t> ExHashMap</a:t>
+              <a:t>trait</a:t>
+            </a:r>
+            <a:r>
+              <a:rPr sz="1800">
+                <a:latin typeface="Courier"/>
+              </a:rPr>
+              <a:t> ExClone</a:t>
             </a:r>
             <a:r>
               <a:rPr sz="1800">
@@ -5868,13 +6384,28 @@
                 </a:solidFill>
                 <a:latin typeface="Courier"/>
               </a:rPr>
-              <a:t>&lt;</a:t>
-            </a:r>
-            <a:r>
-              <a:rPr sz="1800">
-                <a:latin typeface="Courier"/>
-              </a:rPr>
-              <a:t>K</a:t>
+              <a:t>:</a:t>
+            </a:r>
+            <a:r>
+              <a:rPr sz="1800">
+                <a:latin typeface="Courier"/>
+              </a:rPr>
+              <a:t> </a:t>
+            </a:r>
+            <a:r>
+              <a:rPr sz="1800">
+                <a:solidFill>
+                  <a:srgbClr val="008000"/>
+                </a:solidFill>
+                <a:latin typeface="Courier"/>
+              </a:rPr>
+              <a:t>Sized</a:t>
+            </a:r>
+            <a:r>
+              <a:rPr sz="1800">
+                <a:latin typeface="Courier"/>
+              </a:rPr>
+              <a:t> </a:t>
             </a:r>
             <a:r>
               <a:rPr sz="1800">
@@ -5883,89 +6414,14 @@
                 </a:solidFill>
                 <a:latin typeface="Courier"/>
               </a:rPr>
-              <a:t>,</a:t>
-            </a:r>
-            <a:r>
-              <a:rPr sz="1800">
-                <a:latin typeface="Courier"/>
-              </a:rPr>
-              <a:t> V</a:t>
-            </a:r>
-            <a:r>
-              <a:rPr sz="1800">
-                <a:solidFill>
-                  <a:srgbClr val="666666"/>
-                </a:solidFill>
-                <a:latin typeface="Courier"/>
-              </a:rPr>
-              <a:t>&gt;</a:t>
-            </a:r>
-            <a:r>
-              <a:rPr sz="1800">
-                <a:latin typeface="Courier"/>
-              </a:rPr>
-              <a:t>(HashMap</a:t>
-            </a:r>
-            <a:r>
-              <a:rPr sz="1800">
-                <a:solidFill>
-                  <a:srgbClr val="666666"/>
-                </a:solidFill>
-                <a:latin typeface="Courier"/>
-              </a:rPr>
-              <a:t>&lt;</a:t>
-            </a:r>
-            <a:r>
-              <a:rPr sz="1800">
-                <a:latin typeface="Courier"/>
-              </a:rPr>
-              <a:t>K</a:t>
-            </a:r>
-            <a:r>
-              <a:rPr sz="1800">
-                <a:solidFill>
-                  <a:srgbClr val="666666"/>
-                </a:solidFill>
-                <a:latin typeface="Courier"/>
-              </a:rPr>
-              <a:t>,</a:t>
-            </a:r>
-            <a:r>
-              <a:rPr sz="1800">
-                <a:latin typeface="Courier"/>
-              </a:rPr>
-              <a:t> V</a:t>
-            </a:r>
-            <a:r>
-              <a:rPr sz="1800">
-                <a:solidFill>
-                  <a:srgbClr val="666666"/>
-                </a:solidFill>
-                <a:latin typeface="Courier"/>
-              </a:rPr>
-              <a:t>&gt;</a:t>
-            </a:r>
-            <a:r>
-              <a:rPr sz="1800">
-                <a:latin typeface="Courier"/>
-              </a:rPr>
-              <a:t>)</a:t>
-            </a:r>
-            <a:r>
-              <a:rPr sz="1800">
-                <a:solidFill>
-                  <a:srgbClr val="666666"/>
-                </a:solidFill>
-                <a:latin typeface="Courier"/>
-              </a:rPr>
-              <a:t>;</a:t>
+              <a:t>{</a:t>
             </a:r>
             <a:br/>
             <a:r>
               <a:rPr sz="1800">
                 <a:latin typeface="Courier"/>
               </a:rPr>
-              <a:t>  </a:t>
+              <a:t>    </a:t>
             </a:r>
             <a:r>
               <a:rPr sz="1800" b="1">
@@ -5974,7 +6430,13 @@
                 </a:solidFill>
                 <a:latin typeface="Courier"/>
               </a:rPr>
-              <a:t>impl</a:t>
+              <a:t>type</a:t>
+            </a:r>
+            <a:r>
+              <a:rPr sz="1800">
+                <a:latin typeface="Courier"/>
+              </a:rPr>
+              <a:t> ExternalTraitSpecificationFor: core::clone::Clone</a:t>
             </a:r>
             <a:r>
               <a:rPr sz="1800">
@@ -5983,43 +6445,14 @@
                 </a:solidFill>
                 <a:latin typeface="Courier"/>
               </a:rPr>
-              <a:t>&lt;</a:t>
-            </a:r>
-            <a:r>
-              <a:rPr sz="1800">
-                <a:latin typeface="Courier"/>
-              </a:rPr>
-              <a:t>K</a:t>
-            </a:r>
-            <a:r>
-              <a:rPr sz="1800">
-                <a:solidFill>
-                  <a:srgbClr val="666666"/>
-                </a:solidFill>
-                <a:latin typeface="Courier"/>
-              </a:rPr>
-              <a:t>,</a:t>
-            </a:r>
-            <a:r>
-              <a:rPr sz="1800">
-                <a:latin typeface="Courier"/>
-              </a:rPr>
-              <a:t>V</a:t>
-            </a:r>
-            <a:r>
-              <a:rPr sz="1800">
-                <a:solidFill>
-                  <a:srgbClr val="666666"/>
-                </a:solidFill>
-                <a:latin typeface="Courier"/>
-              </a:rPr>
-              <a:t>&gt;</a:t>
-            </a:r>
-            <a:r>
-              <a:rPr sz="1800">
-                <a:latin typeface="Courier"/>
-              </a:rPr>
-              <a:t> View </a:t>
+              <a:t>;</a:t>
+            </a:r>
+            <a:br/>
+            <a:r>
+              <a:rPr sz="1800">
+                <a:latin typeface="Courier"/>
+              </a:rPr>
+              <a:t>    </a:t>
             </a:r>
             <a:r>
               <a:rPr sz="1800" b="1">
@@ -6028,13 +6461,13 @@
                 </a:solidFill>
                 <a:latin typeface="Courier"/>
               </a:rPr>
-              <a:t>for</a:t>
-            </a:r>
-            <a:r>
-              <a:rPr sz="1800">
-                <a:latin typeface="Courier"/>
-              </a:rPr>
-              <a:t> ExHashMap</a:t>
+              <a:t>fn</a:t>
+            </a:r>
+            <a:r>
+              <a:rPr sz="1800">
+                <a:latin typeface="Courier"/>
+              </a:rPr>
+              <a:t> clone(</a:t>
             </a:r>
             <a:r>
               <a:rPr sz="1800">
@@ -6043,59 +6476,7 @@
                 </a:solidFill>
                 <a:latin typeface="Courier"/>
               </a:rPr>
-              <a:t>&lt;</a:t>
-            </a:r>
-            <a:r>
-              <a:rPr sz="1800">
-                <a:latin typeface="Courier"/>
-              </a:rPr>
-              <a:t>K</a:t>
-            </a:r>
-            <a:r>
-              <a:rPr sz="1800">
-                <a:solidFill>
-                  <a:srgbClr val="666666"/>
-                </a:solidFill>
-                <a:latin typeface="Courier"/>
-              </a:rPr>
-              <a:t>,</a:t>
-            </a:r>
-            <a:r>
-              <a:rPr sz="1800">
-                <a:latin typeface="Courier"/>
-              </a:rPr>
-              <a:t>V</a:t>
-            </a:r>
-            <a:r>
-              <a:rPr sz="1800">
-                <a:solidFill>
-                  <a:srgbClr val="666666"/>
-                </a:solidFill>
-                <a:latin typeface="Courier"/>
-              </a:rPr>
-              <a:t>&gt;</a:t>
-            </a:r>
-            <a:r>
-              <a:rPr sz="1800">
-                <a:latin typeface="Courier"/>
-              </a:rPr>
-              <a:t> </a:t>
-            </a:r>
-            <a:r>
-              <a:rPr sz="1800">
-                <a:solidFill>
-                  <a:srgbClr val="666666"/>
-                </a:solidFill>
-                <a:latin typeface="Courier"/>
-              </a:rPr>
-              <a:t>{</a:t>
-            </a:r>
-            <a:br/>
-            <a:r>
-              <a:rPr sz="1800">
-                <a:latin typeface="Courier"/>
-              </a:rPr>
-              <a:t>       </a:t>
+              <a:t>&amp;</a:t>
             </a:r>
             <a:r>
               <a:rPr sz="1800" b="1">
@@ -6104,13 +6485,13 @@
                 </a:solidFill>
                 <a:latin typeface="Courier"/>
               </a:rPr>
-              <a:t>type</a:t>
-            </a:r>
-            <a:r>
-              <a:rPr sz="1800">
-                <a:latin typeface="Courier"/>
-              </a:rPr>
-              <a:t> V </a:t>
+              <a:t>self</a:t>
+            </a:r>
+            <a:r>
+              <a:rPr sz="1800">
+                <a:latin typeface="Courier"/>
+              </a:rPr>
+              <a:t>) </a:t>
             </a:r>
             <a:r>
               <a:rPr sz="1800">
@@ -6119,13 +6500,22 @@
                 </a:solidFill>
                 <a:latin typeface="Courier"/>
               </a:rPr>
-              <a:t>=</a:t>
-            </a:r>
-            <a:r>
-              <a:rPr sz="1800">
-                <a:latin typeface="Courier"/>
-              </a:rPr>
-              <a:t> Map</a:t>
+              <a:t>-&gt;</a:t>
+            </a:r>
+            <a:r>
+              <a:rPr sz="1800">
+                <a:latin typeface="Courier"/>
+              </a:rPr>
+              <a:t> </a:t>
+            </a:r>
+            <a:r>
+              <a:rPr sz="1800">
+                <a:solidFill>
+                  <a:srgbClr val="902000"/>
+                </a:solidFill>
+                <a:latin typeface="Courier"/>
+              </a:rPr>
+              <a:t>Self</a:t>
             </a:r>
             <a:r>
               <a:rPr sz="1800">
@@ -6134,23 +6524,9 @@
                 </a:solidFill>
                 <a:latin typeface="Courier"/>
               </a:rPr>
-              <a:t>&lt;</a:t>
-            </a:r>
-            <a:r>
-              <a:rPr sz="1800">
-                <a:solidFill>
-                  <a:srgbClr val="BC7A00"/>
-                </a:solidFill>
-                <a:latin typeface="Courier"/>
-              </a:rPr>
-              <a:t>K::</a:t>
-            </a:r>
-            <a:r>
-              <a:rPr sz="1800">
-                <a:latin typeface="Courier"/>
-              </a:rPr>
-              <a:t>V</a:t>
-            </a:r>
+              <a:t>;</a:t>
+            </a:r>
+            <a:br/>
             <a:r>
               <a:rPr sz="1800">
                 <a:solidFill>
@@ -6158,161 +6534,58 @@
                 </a:solidFill>
                 <a:latin typeface="Courier"/>
               </a:rPr>
-              <a:t>,</a:t>
-            </a:r>
-            <a:r>
-              <a:rPr sz="1800">
-                <a:latin typeface="Courier"/>
-              </a:rPr>
-              <a:t> </a:t>
-            </a:r>
-            <a:r>
-              <a:rPr sz="1800">
-                <a:solidFill>
-                  <a:srgbClr val="BC7A00"/>
-                </a:solidFill>
-                <a:latin typeface="Courier"/>
-              </a:rPr>
-              <a:t>V::</a:t>
-            </a:r>
-            <a:r>
-              <a:rPr sz="1800">
-                <a:latin typeface="Courier"/>
-              </a:rPr>
-              <a:t>V</a:t>
-            </a:r>
-            <a:r>
-              <a:rPr sz="1800">
-                <a:solidFill>
-                  <a:srgbClr val="666666"/>
-                </a:solidFill>
-                <a:latin typeface="Courier"/>
-              </a:rPr>
-              <a:t>&gt;;</a:t>
-            </a:r>
-            <a:br/>
-            <a:r>
-              <a:rPr sz="1800">
-                <a:latin typeface="Courier"/>
-              </a:rPr>
-              <a:t>       spec </a:t>
-            </a:r>
-            <a:r>
-              <a:rPr sz="1800" b="1">
-                <a:solidFill>
-                  <a:srgbClr val="007020"/>
-                </a:solidFill>
-                <a:latin typeface="Courier"/>
-              </a:rPr>
-              <a:t>fn</a:t>
-            </a:r>
-            <a:r>
-              <a:rPr sz="1800">
-                <a:latin typeface="Courier"/>
-              </a:rPr>
-              <a:t> view(</a:t>
-            </a:r>
-            <a:r>
-              <a:rPr sz="1800">
-                <a:solidFill>
-                  <a:srgbClr val="666666"/>
-                </a:solidFill>
-                <a:latin typeface="Courier"/>
-              </a:rPr>
-              <a:t>&amp;</a:t>
-            </a:r>
-            <a:r>
-              <a:rPr sz="1800" b="1">
-                <a:solidFill>
-                  <a:srgbClr val="007020"/>
-                </a:solidFill>
-                <a:latin typeface="Courier"/>
-              </a:rPr>
-              <a:t>self</a:t>
-            </a:r>
-            <a:r>
-              <a:rPr sz="1800">
-                <a:latin typeface="Courier"/>
-              </a:rPr>
-              <a:t>) </a:t>
-            </a:r>
-            <a:r>
-              <a:rPr sz="1800">
-                <a:solidFill>
-                  <a:srgbClr val="666666"/>
-                </a:solidFill>
-                <a:latin typeface="Courier"/>
-              </a:rPr>
-              <a:t>-&gt;</a:t>
-            </a:r>
-            <a:r>
-              <a:rPr sz="1800">
-                <a:latin typeface="Courier"/>
-              </a:rPr>
-              <a:t> Map</a:t>
-            </a:r>
-            <a:r>
-              <a:rPr sz="1800">
-                <a:solidFill>
-                  <a:srgbClr val="666666"/>
-                </a:solidFill>
-                <a:latin typeface="Courier"/>
-              </a:rPr>
-              <a:t>&lt;</a:t>
-            </a:r>
-            <a:r>
-              <a:rPr sz="1800">
-                <a:solidFill>
-                  <a:srgbClr val="BC7A00"/>
-                </a:solidFill>
-                <a:latin typeface="Courier"/>
-              </a:rPr>
-              <a:t>K::</a:t>
-            </a:r>
-            <a:r>
-              <a:rPr sz="1800">
-                <a:latin typeface="Courier"/>
-              </a:rPr>
-              <a:t>V</a:t>
-            </a:r>
-            <a:r>
-              <a:rPr sz="1800">
-                <a:solidFill>
-                  <a:srgbClr val="666666"/>
-                </a:solidFill>
-                <a:latin typeface="Courier"/>
-              </a:rPr>
-              <a:t>,</a:t>
-            </a:r>
-            <a:r>
-              <a:rPr sz="1800">
-                <a:latin typeface="Courier"/>
-              </a:rPr>
-              <a:t> </a:t>
-            </a:r>
-            <a:r>
-              <a:rPr sz="1800">
-                <a:solidFill>
-                  <a:srgbClr val="BC7A00"/>
-                </a:solidFill>
-                <a:latin typeface="Courier"/>
-              </a:rPr>
-              <a:t>V::</a:t>
-            </a:r>
-            <a:r>
-              <a:rPr sz="1800">
-                <a:latin typeface="Courier"/>
-              </a:rPr>
-              <a:t>V</a:t>
-            </a:r>
-            <a:r>
-              <a:rPr sz="1800">
-                <a:solidFill>
-                  <a:srgbClr val="666666"/>
-                </a:solidFill>
-                <a:latin typeface="Courier"/>
-              </a:rPr>
-              <a:t>&gt;;}</a:t>
+              <a:t>}</a:t>
+            </a:r>
+          </a:p>
+          <a:p>
+            <a:pPr lvl="0"/>
+            <a:r>
+              <a:rPr sz="1800"/>
+              <a:t>The proxy trait name is </a:t>
+            </a:r>
+            <a:r>
+              <a:rPr sz="1800">
+                <a:latin typeface="Courier"/>
+              </a:rPr>
+              <a:t>Ex&lt;TraitName&gt;</a:t>
+            </a:r>
+            <a:r>
+              <a:rPr sz="1800"/>
+              <a:t> by convention.</a:t>
+            </a:r>
+          </a:p>
+          <a:p>
+            <a:pPr lvl="0"/>
+            <a:r>
+              <a:rPr sz="1800"/>
+              <a:t>Add </a:t>
+            </a:r>
+            <a:r>
+              <a:rPr sz="1800">
+                <a:latin typeface="Courier"/>
+              </a:rPr>
+              <a:t>requires</a:t>
+            </a:r>
+            <a:r>
+              <a:rPr sz="1800"/>
+              <a:t>/</a:t>
+            </a:r>
+            <a:r>
+              <a:rPr sz="1800">
+                <a:latin typeface="Courier"/>
+              </a:rPr>
+              <a:t>ensures</a:t>
+            </a:r>
+            <a:r>
+              <a:rPr sz="1800"/>
+              <a:t> to the method to give it a full contract.</a:t>
+            </a:r>
+          </a:p>
+          <a:p>
+            <a:pPr lvl="0"/>
+            <a:r>
+              <a:rPr sz="1800"/>
+              <a:t>Limitation: no generics.</a:t>
             </a:r>
           </a:p>
         </p:txBody>
@@ -7285,7 +7558,7 @@
             <a:pPr lvl="0"/>
             <a:r>
               <a:rPr sz="1800"/>
-              <a:t>Runtime tests: 3,776 passed in 21 s.</a:t>
+              <a:t>Runtime tests: 3,776 pass in 21 s.</a:t>
             </a:r>
           </a:p>
           <a:p>
@@ -7306,7 +7579,14 @@
             <a:pPr lvl="1"/>
             <a:r>
               <a:rPr sz="1800"/>
-              <a:t>I used it mostly to continuously track that my iterators prove and continue to prove with changes, mostly to the specification of operations once the iterators were more stable.</a:t>
+              <a:t>I used it mostly to continuously track that my iterators prove and continue to prove with verus changes and my specifications.</a:t>
+            </a:r>
+          </a:p>
+          <a:p>
+            <a:pPr lvl="1"/>
+            <a:r>
+              <a:rPr sz="1800"/>
+              <a:t>These caught dozens of problems that would have been conflated with algorithms loops.</a:t>
             </a:r>
           </a:p>
           <a:p>
@@ -7390,7 +7670,7 @@
             <a:pPr lvl="0"/>
             <a:r>
               <a:rPr sz="1800"/>
-              <a:t>Largest chapter: Chap37 (AVL trees, BST variants) — 20,319 src LOC.</a:t>
+              <a:t>Largest chapter is the forest: Chap37 - AVL trees, BST variants - 20,319 src LOC.</a:t>
             </a:r>
           </a:p>
           <a:p>
@@ -7992,32 +8272,56 @@
             <a:pPr lvl="0"/>
             <a:r>
               <a:rPr sz="1800"/>
-              <a:t>Review tools: proof holes (assume, external_body, admit), style enforcement (21 rules, auto-reorder), function inventory with spec strength classification, string-hacking detector.</a:t>
-            </a:r>
-          </a:p>
-          <a:p>
-            <a:pPr lvl="0"/>
-            <a:r>
-              <a:rPr sz="1800"/>
-              <a:t>Minimization tools: veracity-minimize-proofs</a:t>
-            </a:r>
-          </a:p>
-          <a:p>
-            <a:pPr lvl="0"/>
-            <a:r>
-              <a:rPr sz="1800"/>
-              <a:t>Metrics: veracity-count-loc (spec/proof/exec breakdown),</a:t>
-            </a:r>
-          </a:p>
-          <a:p>
-            <a:pPr lvl="0" indent="0">
-              <a:buNone/>
-            </a:pPr>
-            <a:r>
-              <a:rPr sz="1800">
-                <a:latin typeface="Courier"/>
-              </a:rPr>
-              <a:t>   chapter-cleanliness-status (clean vs. holed chapter summary).</a:t>
+              <a:t>Review tools:</a:t>
+            </a:r>
+          </a:p>
+          <a:p>
+            <a:pPr lvl="1"/>
+            <a:r>
+              <a:rPr sz="1800"/>
+              <a:t>proof holes (assume, external_body, admit),</a:t>
+            </a:r>
+          </a:p>
+          <a:p>
+            <a:pPr lvl="1"/>
+            <a:r>
+              <a:rPr sz="1800"/>
+              <a:t>style enforcement (21 rules, auto-reorder),</a:t>
+            </a:r>
+          </a:p>
+          <a:p>
+            <a:pPr lvl="1"/>
+            <a:r>
+              <a:rPr sz="1800"/>
+              <a:t>with spec strength classification fed to AI,</a:t>
+            </a:r>
+          </a:p>
+          <a:p>
+            <a:pPr lvl="1"/>
+            <a:r>
+              <a:rPr sz="1800"/>
+              <a:t>veracity-count-loc (spec/proof/exec breakdown),</a:t>
+            </a:r>
+          </a:p>
+          <a:p>
+            <a:pPr lvl="1"/>
+            <a:r>
+              <a:rPr sz="1800"/>
+              <a:t>chapter-cleanliness-status (clean vs. holed chapter summary vs blocked by),</a:t>
+            </a:r>
+          </a:p>
+          <a:p>
+            <a:pPr lvl="1"/>
+            <a:r>
+              <a:rPr sz="1800"/>
+              <a:t>string-hacking detector, function inventory, etc.</a:t>
+            </a:r>
+          </a:p>
+          <a:p>
+            <a:pPr lvl="0"/>
+            <a:r>
+              <a:rPr sz="1800"/>
+              <a:t>One of the best is veracity-minimize-proofs</a:t>
             </a:r>
           </a:p>
         </p:txBody>
@@ -8318,7 +8622,7 @@
             <a:pPr lvl="0"/>
             <a:r>
               <a:rPr sz="1800"/>
-              <a:t>APAS-VERUS by type signature, finding lemmas before writing new ones.</a:t>
+              <a:t>VERUS by type signature, finding lemmas before writing new ones.</a:t>
             </a:r>
           </a:p>
           <a:p>
@@ -8339,7 +8643,7 @@
             <a:pPr lvl="0"/>
             <a:r>
               <a:rPr sz="1800"/>
-              <a:t>Even more useful for my AI’s sins.</a:t>
+              <a:t>Even more useful for my AIs’s seriously disturbing sinning.</a:t>
             </a:r>
           </a:p>
           <a:p>
@@ -8685,6 +8989,13 @@
               <a:t>This was critical to get iterative loops to prove over my collections ADTs.</a:t>
             </a:r>
           </a:p>
+          <a:p>
+            <a:pPr lvl="0"/>
+            <a:r>
+              <a:rPr sz="1800"/>
+              <a:t>You can prove full iterators in your own copy of the traits with no assume and I have.</a:t>
+            </a:r>
+          </a:p>
         </p:txBody>
       </p:sp>
     </p:spTree>
@@ -8882,31 +9193,31 @@
             </a:r>
           </a:p>
           <a:p>
-            <a:pPr lvl="0"/>
-            <a:r>
-              <a:rPr sz="1800"/>
-              <a:t>TSM/RwLock layer pattern — unlocked all Mt chapters</a:t>
-            </a:r>
-          </a:p>
-          <a:p>
-            <a:pPr lvl="0"/>
-            <a:r>
-              <a:rPr sz="1800"/>
-              <a:t>Named closure ensures through ParaPair — unlocked fork-join</a:t>
-            </a:r>
-          </a:p>
-          <a:p>
-            <a:pPr lvl="0"/>
-            <a:r>
-              <a:rPr sz="1800"/>
-              <a:t>Ghost struct Send/Sync — unlocked Chap41</a:t>
-            </a:r>
-          </a:p>
-          <a:p>
-            <a:pPr lvl="0"/>
-            <a:r>
-              <a:rPr sz="1800"/>
-              <a:t>Tree module style with recursive trait impls — unlocked Chap65</a:t>
+            <a:pPr lvl="1"/>
+            <a:r>
+              <a:rPr sz="1800"/>
+              <a:t>TSM/RwLock layer pattern — unlocked all Mt modules,</a:t>
+            </a:r>
+          </a:p>
+          <a:p>
+            <a:pPr lvl="1"/>
+            <a:r>
+              <a:rPr sz="1800"/>
+              <a:t>Named closure ensures through ParaPair — unlocked fork-join,</a:t>
+            </a:r>
+          </a:p>
+          <a:p>
+            <a:pPr lvl="1"/>
+            <a:r>
+              <a:rPr sz="1800"/>
+              <a:t>Ghost struct Send/Sync — unlocked AVLTreeSetsMtEph,</a:t>
+            </a:r>
+          </a:p>
+          <a:p>
+            <a:pPr lvl="1"/>
+            <a:r>
+              <a:rPr sz="1800"/>
+              <a:t>Tree module style — unlocked Kruskal, Prim, UnionFind.</a:t>
             </a:r>
           </a:p>
         </p:txBody>
@@ -8976,7 +9287,7 @@
             <a:pPr lvl="0"/>
             <a:r>
               <a:rPr sz="1800"/>
-              <a:t>I finally built a set of coding standards in Verus Rust and in comments.</a:t>
+              <a:t>I finally built a set of coding standards in Verus rust files and in comments.</a:t>
             </a:r>
           </a:p>
           <a:p>
@@ -8990,7 +9301,7 @@
             <a:pPr lvl="0"/>
             <a:r>
               <a:rPr sz="1800"/>
-              <a:t>Violations are mostly AI checked except an extensive code styling checker in Veracity.</a:t>
+              <a:t>Violations are mostly AI checked except where an extensive code styling can get things.</a:t>
             </a:r>
           </a:p>
           <a:p>
@@ -9214,11 +9525,39 @@
             <a:pPr lvl="0"/>
             <a:r>
               <a:rPr sz="1800"/>
-              <a:t>Mine are Don’t Over Think, DISCUSS and</a:t>
-            </a:r>
-          </a:p>
-          <a:p>
-            <a:pPr lvl="0"/>
+              <a:t>Mine are:</a:t>
+            </a:r>
+          </a:p>
+          <a:p>
+            <a:pPr lvl="1"/>
+            <a:r>
+              <a:rPr sz="1800"/>
+              <a:t>Don’t Over Think,</a:t>
+            </a:r>
+          </a:p>
+          <a:p>
+            <a:pPr lvl="1"/>
+            <a:r>
+              <a:rPr sz="1800"/>
+              <a:t>DISCUSS,</a:t>
+            </a:r>
+          </a:p>
+          <a:p>
+            <a:pPr lvl="1"/>
+            <a:r>
+              <a:rPr sz="1800"/>
+              <a:t>Don’t jump ahead,</a:t>
+            </a:r>
+          </a:p>
+          <a:p>
+            <a:pPr lvl="1"/>
+            <a:r>
+              <a:rPr sz="1800"/>
+              <a:t>go step by step,</a:t>
+            </a:r>
+          </a:p>
+          <a:p>
+            <a:pPr lvl="1"/>
             <a:r>
               <a:rPr sz="1800"/>
               <a:t>PBOGH: Prove Big or Go HOME!</a:t>
@@ -12920,7 +13259,7 @@
             <a:pPr lvl="0"/>
             <a:r>
               <a:rPr sz="1800"/>
-              <a:t>No objects: it’s great for what it was invented for: modeling the real world and interfaces. by Ivan Sutherland 1962!</a:t>
+              <a:t>No objects: it’s great for what it was invented for: modeling the real world and interfaces by Ivan Sutherland 1962!</a:t>
             </a:r>
           </a:p>
           <a:p>
@@ -13168,6 +13507,111 @@
 </p:sld>
 </file>
 
+<file path=ppt/slides/slide82.xml><?xml version="1.0" encoding="utf-8"?>
+<p:sld xmlns:a="http://schemas.openxmlformats.org/drawingml/2006/main" xmlns:r="http://schemas.openxmlformats.org/officeDocument/2006/relationships" xmlns:p="http://schemas.openxmlformats.org/presentationml/2006/main">
+  <p:cSld>
+    <p:spTree>
+      <p:nvGrpSpPr>
+        <p:cNvPr id="1" name=""/>
+        <p:cNvGrpSpPr/>
+        <p:nvPr/>
+      </p:nvGrpSpPr>
+      <p:grpSpPr>
+        <a:xfrm>
+          <a:off x="0" y="0"/>
+          <a:ext cx="0" cy="0"/>
+          <a:chOff x="0" y="0"/>
+          <a:chExt cx="0" cy="0"/>
+        </a:xfrm>
+      </p:grpSpPr>
+      <p:sp>
+        <p:nvSpPr>
+          <p:cNvPr id="2" name="Title 1"/>
+          <p:cNvSpPr>
+            <a:spLocks noGrp="1"/>
+          </p:cNvSpPr>
+          <p:nvPr>
+            <p:ph type="title"/>
+          </p:nvPr>
+        </p:nvSpPr>
+        <p:spPr/>
+        <p:txBody>
+          <a:bodyPr/>
+          <a:lstStyle/>
+          <a:p>
+            <a:pPr lvl="0" indent="0" marL="0">
+              <a:buNone/>
+            </a:pPr>
+            <a:r>
+              <a:rPr sz="3200"/>
+              <a:t>Cloud Security Alliance</a:t>
+            </a:r>
+          </a:p>
+        </p:txBody>
+      </p:sp>
+      <p:sp>
+        <p:nvSpPr>
+          <p:cNvPr id="3" name="Content Placeholder 2"/>
+          <p:cNvSpPr>
+            <a:spLocks noGrp="1"/>
+          </p:cNvSpPr>
+          <p:nvPr>
+            <p:ph idx="1"/>
+          </p:nvPr>
+        </p:nvSpPr>
+        <p:spPr/>
+        <p:txBody>
+          <a:bodyPr/>
+          <a:lstStyle/>
+          <a:p>
+            <a:pPr lvl="0"/>
+            <a:r>
+              <a:rPr sz="1800"/>
+              <a:t>The cloud security alliance has some sober recommendations:</a:t>
+            </a:r>
+          </a:p>
+          <a:p>
+            <a:pPr lvl="0"/>
+            <a:r>
+              <a:rPr sz="1800"/>
+              <a:t>The “AI Vulnerability Storm”: Building a “Mythosready” Security Program</a:t>
+            </a:r>
+          </a:p>
+          <a:p>
+            <a:pPr lvl="0"/>
+            <a:r>
+              <a:rPr sz="1800"/>
+              <a:t>https://labs.cloudsecurityalliance.org/wp-content/uploads/2026/04/mythosreadyv91.pdf</a:t>
+            </a:r>
+          </a:p>
+          <a:p>
+            <a:pPr lvl="0"/>
+            <a:r>
+              <a:rPr sz="1800"/>
+              <a:t>Use LLM-based vulnerability discovery and remediation capabilities.</a:t>
+            </a:r>
+          </a:p>
+          <a:p>
+            <a:pPr lvl="0"/>
+            <a:r>
+              <a:rPr sz="1800"/>
+              <a:t>Update risk metrics.</a:t>
+            </a:r>
+          </a:p>
+          <a:p>
+            <a:pPr lvl="0"/>
+            <a:r>
+              <a:rPr sz="1800"/>
+              <a:t>We cannot outwork machine-speed threats. Re-prioritize, automate, and prepare for burnout.</a:t>
+            </a:r>
+          </a:p>
+        </p:txBody>
+      </p:sp>
+    </p:spTree>
+  </p:cSld>
+</p:sld>
+</file>
+
 <file path=ppt/slides/slide9.xml><?xml version="1.0" encoding="utf-8"?>
 <p:sld xmlns:a="http://schemas.openxmlformats.org/drawingml/2006/main" xmlns:r="http://schemas.openxmlformats.org/officeDocument/2006/relationships" xmlns:p="http://schemas.openxmlformats.org/presentationml/2006/main">
   <p:cSld>
@@ -13228,28 +13672,42 @@
             <a:pPr lvl="0"/>
             <a:r>
               <a:rPr sz="1800"/>
+              <a:t>You get basic module with pub/pub(crate) and no-pub.</a:t>
+            </a:r>
+          </a:p>
+          <a:p>
+            <a:pPr lvl="0"/>
+            <a:r>
+              <a:rPr sz="1800"/>
+              <a:t>You get typeclasses which MUST be implemented at type.</a:t>
+            </a:r>
+          </a:p>
+          <a:p>
+            <a:pPr lvl="0"/>
+            <a:r>
+              <a:rPr sz="1800"/>
+              <a:t>The Rustaceans have decided that unless their module implements a typeclass at multiple types, they won’t use it.</a:t>
+            </a:r>
+          </a:p>
+          <a:p>
+            <a:pPr lvl="0"/>
+            <a:r>
+              <a:rPr sz="1800"/>
+              <a:t>So reading Rust is every bit as scattered as reading C.</a:t>
+            </a:r>
+          </a:p>
+          <a:p>
+            <a:pPr lvl="0"/>
+            <a:r>
+              <a:rPr sz="1800"/>
+              <a:t>Verus is now doing this also, but I abuse the notation to put all the specs together in APAS-VERUS for readability.</a:t>
+            </a:r>
+          </a:p>
+          <a:p>
+            <a:pPr lvl="0"/>
+            <a:r>
+              <a:rPr sz="1800"/>
               <a:t>You will pine for ML modules!</a:t>
-            </a:r>
-          </a:p>
-          <a:p>
-            <a:pPr lvl="0"/>
-            <a:r>
-              <a:rPr sz="1800"/>
-              <a:t>The Rustaceans have decided that unless their module implements a typeclass at multiple types, they won’t use it.</a:t>
-            </a:r>
-          </a:p>
-          <a:p>
-            <a:pPr lvl="0"/>
-            <a:r>
-              <a:rPr sz="1800"/>
-              <a:t>So reading Rust is every bit as scattered as reading C.</a:t>
-            </a:r>
-          </a:p>
-          <a:p>
-            <a:pPr lvl="0"/>
-            <a:r>
-              <a:rPr sz="1800"/>
-              <a:t>Verus is now doing this also, but I abuse the notation to put all the specs together in APAS-VERUS for readability.</a:t>
             </a:r>
           </a:p>
         </p:txBody>

</xml_diff>